<commit_message>
Enhance demo app and pitch walkthrough
</commit_message>
<xml_diff>
--- a/presentation/HIP_MARKETS_DECK.pptx
+++ b/presentation/HIP_MARKETS_DECK.pptx
@@ -18,6 +18,11 @@
     <p:sldId id="266" r:id="rId13"/>
     <p:sldId id="267" r:id="rId14"/>
     <p:sldId id="268" r:id="rId15"/>
+    <p:sldId id="269" r:id="rId16"/>
+    <p:sldId id="270" r:id="rId17"/>
+    <p:sldId id="271" r:id="rId18"/>
+    <p:sldId id="272" r:id="rId19"/>
+    <p:sldId id="273" r:id="rId20"/>
   </p:sldIdLst>
   <p:sldSz cx="12192000" cy="6858000" type="wide"/>
   <p:notesSz cx="6858000" cy="9144000"/>
@@ -173,7 +178,7 @@
                   <a:srgbClr val="D7E3EA"/>
                 </a:solidFill>
               </a:rPr>
-              <a:t>Pool HYPE. Launch markets. Share builder fees.</a:t>
+              <a:t>Fund the market operator. Share the builder fees.</a:t>
             </a:r>
           </a:p>
         </p:txBody>
@@ -267,7 +272,7 @@
                   <a:srgbClr val="F4F7F8"/>
                 </a:solidFill>
               </a:rPr>
-              <a:t>Market Expansion</a:t>
+              <a:t>Demo 5: Operator Monitor</a:t>
             </a:r>
           </a:p>
         </p:txBody>
@@ -301,46 +306,20 @@
                   <a:srgbClr val="D7E3EA"/>
                 </a:solidFill>
               </a:rPr>
-              <a:t>Phase 1: oracle-simple markets.</a:t>
-            </a:r>
-          </a:p>
-          <a:p>
-            <a:pPr marL="285750" indent="-171450">
-              <a:buChar char="•"/>
-            </a:pPr>
-            <a:r>
-              <a:rPr lang="en-US" sz="2100">
-                <a:solidFill>
-                  <a:srgbClr val="D7E3EA"/>
-                </a:solidFill>
-              </a:rPr>
-              <a:t>Phase 2: liquid RWA markets.</a:t>
-            </a:r>
-          </a:p>
-          <a:p>
-            <a:pPr marL="285750" indent="-171450">
-              <a:buChar char="•"/>
-            </a:pPr>
-            <a:r>
-              <a:rPr lang="en-US" sz="2100">
-                <a:solidFill>
-                  <a:srgbClr val="D7E3EA"/>
-                </a:solidFill>
-              </a:rPr>
-              <a:t>Phase 3: commodities and indices after licensing.</a:t>
-            </a:r>
-          </a:p>
-          <a:p>
-            <a:pPr marL="285750" indent="-171450">
-              <a:buChar char="•"/>
-            </a:pPr>
-            <a:r>
-              <a:rPr lang="en-US" sz="2100">
-                <a:solidFill>
-                  <a:srgbClr val="D7E3EA"/>
-                </a:solidFill>
-              </a:rPr>
-              <a:t>Phase 4: HIP-4 outcome markets if mechanics mature.</a:t>
+              <a:t>Right rail keeps operational risk visible.</a:t>
+            </a:r>
+          </a:p>
+          <a:p>
+            <a:pPr marL="285750" indent="-171450">
+              <a:buChar char="•"/>
+            </a:pPr>
+            <a:r>
+              <a:rPr lang="en-US" sz="2100">
+                <a:solidFill>
+                  <a:srgbClr val="D7E3EA"/>
+                </a:solidFill>
+              </a:rPr>
+              <a:t>Fee recipient, oracle updater, slashing reserve, OI utilization, and incident runbook.</a:t>
             </a:r>
           </a:p>
         </p:txBody>
@@ -434,7 +413,7 @@
                   <a:srgbClr val="F4F7F8"/>
                 </a:solidFill>
               </a:rPr>
-              <a:t>Competitive Position</a:t>
+              <a:t>System Flow</a:t>
             </a:r>
           </a:p>
         </p:txBody>
@@ -468,33 +447,59 @@
                   <a:srgbClr val="D7E3EA"/>
                 </a:solidFill>
               </a:rPr>
-              <a:t>trade.xyz and HyENA prove HIP-3 operator demand.</a:t>
-            </a:r>
-          </a:p>
-          <a:p>
-            <a:pPr marL="285750" indent="-171450">
-              <a:buChar char="•"/>
-            </a:pPr>
-            <a:r>
-              <a:rPr lang="en-US" sz="2100">
-                <a:solidFill>
-                  <a:srgbClr val="D7E3EA"/>
-                </a:solidFill>
-              </a:rPr>
-              <a:t>HIP.markets adds community-funded deployer stake plus fee sharing.</a:t>
-            </a:r>
-          </a:p>
-          <a:p>
-            <a:pPr marL="285750" indent="-171450">
-              <a:buChar char="•"/>
-            </a:pPr>
-            <a:r>
-              <a:rPr lang="en-US" sz="2100">
-                <a:solidFill>
-                  <a:srgbClr val="D7E3EA"/>
-                </a:solidFill>
-              </a:rPr>
-              <a:t>At launch, HIP.markets is the operator.</a:t>
+              <a:t>1. HYPE holders deposit into vault.</a:t>
+            </a:r>
+          </a:p>
+          <a:p>
+            <a:pPr marL="285750" indent="-171450">
+              <a:buChar char="•"/>
+            </a:pPr>
+            <a:r>
+              <a:rPr lang="en-US" sz="2100">
+                <a:solidFill>
+                  <a:srgbClr val="D7E3EA"/>
+                </a:solidFill>
+              </a:rPr>
+              <a:t>2. Vault backs HIP.markets deployer stake.</a:t>
+            </a:r>
+          </a:p>
+          <a:p>
+            <a:pPr marL="285750" indent="-171450">
+              <a:buChar char="•"/>
+            </a:pPr>
+            <a:r>
+              <a:rPr lang="en-US" sz="2100">
+                <a:solidFill>
+                  <a:srgbClr val="D7E3EA"/>
+                </a:solidFill>
+              </a:rPr>
+              <a:t>3. HIP.markets launches first three HIP-3 markets.</a:t>
+            </a:r>
+          </a:p>
+          <a:p>
+            <a:pPr marL="285750" indent="-171450">
+              <a:buChar char="•"/>
+            </a:pPr>
+            <a:r>
+              <a:rPr lang="en-US" sz="2100">
+                <a:solidFill>
+                  <a:srgbClr val="D7E3EA"/>
+                </a:solidFill>
+              </a:rPr>
+              <a:t>4. Traders generate fees.</a:t>
+            </a:r>
+          </a:p>
+          <a:p>
+            <a:pPr marL="285750" indent="-171450">
+              <a:buChar char="•"/>
+            </a:pPr>
+            <a:r>
+              <a:rPr lang="en-US" sz="2100">
+                <a:solidFill>
+                  <a:srgbClr val="D7E3EA"/>
+                </a:solidFill>
+              </a:rPr>
+              <a:t>5. Net fees distribute to stakers.</a:t>
             </a:r>
           </a:p>
         </p:txBody>
@@ -588,7 +593,7 @@
                   <a:srgbClr val="F4F7F8"/>
                 </a:solidFill>
               </a:rPr>
-              <a:t>Ask</a:t>
+              <a:t>Economics</a:t>
             </a:r>
           </a:p>
         </p:txBody>
@@ -622,59 +627,33 @@
                   <a:srgbClr val="D7E3EA"/>
                 </a:solidFill>
               </a:rPr>
-              <a:t>HYPE holders for capped beta.</a:t>
-            </a:r>
-          </a:p>
-          <a:p>
-            <a:pPr marL="285750" indent="-171450">
-              <a:buChar char="•"/>
-            </a:pPr>
-            <a:r>
-              <a:rPr lang="en-US" sz="2100">
-                <a:solidFill>
-                  <a:srgbClr val="D7E3EA"/>
-                </a:solidFill>
-              </a:rPr>
-              <a:t>Market makers for first markets.</a:t>
-            </a:r>
-          </a:p>
-          <a:p>
-            <a:pPr marL="285750" indent="-171450">
-              <a:buChar char="•"/>
-            </a:pPr>
-            <a:r>
-              <a:rPr lang="en-US" sz="2100">
-                <a:solidFill>
-                  <a:srgbClr val="D7E3EA"/>
-                </a:solidFill>
-              </a:rPr>
-              <a:t>Oracle/data partners.</a:t>
-            </a:r>
-          </a:p>
-          <a:p>
-            <a:pPr marL="285750" indent="-171450">
-              <a:buChar char="•"/>
-            </a:pPr>
-            <a:r>
-              <a:rPr lang="en-US" sz="2100">
-                <a:solidFill>
-                  <a:srgbClr val="D7E3EA"/>
-                </a:solidFill>
-              </a:rPr>
-              <a:t>Security reviewers.</a:t>
-            </a:r>
-          </a:p>
-          <a:p>
-            <a:pPr marL="285750" indent="-171450">
-              <a:buChar char="•"/>
-            </a:pPr>
-            <a:r>
-              <a:rPr lang="en-US" sz="2100">
-                <a:solidFill>
-                  <a:srgbClr val="D7E3EA"/>
-                </a:solidFill>
-              </a:rPr>
-              <a:t>Hyperliquid ecosystem feedback.</a:t>
+              <a:t>Base model: 500k HYPE, $50M daily volume, 6 bps fee, 50% deployer share.</a:t>
+            </a:r>
+          </a:p>
+          <a:p>
+            <a:pPr marL="285750" indent="-171450">
+              <a:buChar char="•"/>
+            </a:pPr>
+            <a:r>
+              <a:rPr lang="en-US" sz="2100">
+                <a:solidFill>
+                  <a:srgbClr val="D7E3EA"/>
+                </a:solidFill>
+              </a:rPr>
+              <a:t>After 40% operating/protocol/reserve deductions: approximately 15% net APR.</a:t>
+            </a:r>
+          </a:p>
+          <a:p>
+            <a:pPr marL="285750" indent="-171450">
+              <a:buChar char="•"/>
+            </a:pPr>
+            <a:r>
+              <a:rPr lang="en-US" sz="2100">
+                <a:solidFill>
+                  <a:srgbClr val="D7E3EA"/>
+                </a:solidFill>
+              </a:rPr>
+              <a:t>Sensitivity matters more than headline APR.</a:t>
             </a:r>
           </a:p>
         </p:txBody>
@@ -768,7 +747,7 @@
                   <a:srgbClr val="F4F7F8"/>
                 </a:solidFill>
               </a:rPr>
-              <a:t>Closing</a:t>
+              <a:t>Risk Controls</a:t>
             </a:r>
           </a:p>
         </p:txBody>
@@ -802,33 +781,33 @@
                   <a:srgbClr val="D7E3EA"/>
                 </a:solidFill>
               </a:rPr>
-              <a:t>HIP.markets turns HYPE holders into economic backers of new Hyperliquid markets.</a:t>
-            </a:r>
-          </a:p>
-          <a:p>
-            <a:pPr marL="285750" indent="-171450">
-              <a:buChar char="•"/>
-            </a:pPr>
-            <a:r>
-              <a:rPr lang="en-US" sz="2100">
-                <a:solidFill>
-                  <a:srgbClr val="D7E3EA"/>
-                </a:solidFill>
-              </a:rPr>
-              <a:t>The first job is not maximizing APR.</a:t>
-            </a:r>
-          </a:p>
-          <a:p>
-            <a:pPr marL="285750" indent="-171450">
-              <a:buChar char="•"/>
-            </a:pPr>
-            <a:r>
-              <a:rPr lang="en-US" sz="2100">
-                <a:solidFill>
-                  <a:srgbClr val="D7E3EA"/>
-                </a:solidFill>
-              </a:rPr>
-              <a:t>The first job is operating markets safely.</a:t>
+              <a:t>Start with oracle-simple markets.</a:t>
+            </a:r>
+          </a:p>
+          <a:p>
+            <a:pPr marL="285750" indent="-171450">
+              <a:buChar char="•"/>
+            </a:pPr>
+            <a:r>
+              <a:rPr lang="en-US" sz="2100">
+                <a:solidFill>
+                  <a:srgbClr val="D7E3EA"/>
+                </a:solidFill>
+              </a:rPr>
+              <a:t>Avoid extra ticker auction costs at launch.</a:t>
+            </a:r>
+          </a:p>
+          <a:p>
+            <a:pPr marL="285750" indent="-171450">
+              <a:buChar char="•"/>
+            </a:pPr>
+            <a:r>
+              <a:rPr lang="en-US" sz="2100">
+                <a:solidFill>
+                  <a:srgbClr val="D7E3EA"/>
+                </a:solidFill>
+              </a:rPr>
+              <a:t>Cap open interest, publish addresses, maintain reserve, pause deposits during incidents.</a:t>
             </a:r>
           </a:p>
         </p:txBody>
@@ -860,6 +839,828 @@
                 </a:solidFill>
               </a:rPr>
               <a:t>HIP.markets hackathon submission  |  13</a:t>
+            </a:r>
+          </a:p>
+        </p:txBody>
+      </p:sp>
+    </p:spTree>
+  </p:cSld>
+  <p:clrMapOvr>
+    <a:masterClrMapping/>
+  </p:clrMapOvr>
+</p:sld>
+</file>
+
+<file path=ppt/slides/slide14.xml><?xml version="1.0" encoding="utf-8"?>
+<p:sld xmlns:a="http://schemas.openxmlformats.org/drawingml/2006/main" xmlns:r="http://schemas.openxmlformats.org/officeDocument/2006/relationships" xmlns:p="http://schemas.openxmlformats.org/presentationml/2006/main">
+  <p:cSld>
+    <p:bg>
+      <p:bgPr>
+        <a:solidFill>
+          <a:srgbClr val="080A0D"/>
+        </a:solidFill>
+      </p:bgPr>
+    </p:bg>
+    <p:spTree>
+      <p:nvGrpSpPr>
+        <p:cNvPr id="1" name=""/>
+        <p:cNvGrpSpPr/>
+        <p:nvPr/>
+      </p:nvGrpSpPr>
+      <p:grpSpPr>
+        <a:xfrm>
+          <a:off x="0" y="0"/>
+          <a:ext cx="0" cy="0"/>
+          <a:chOff x="0" y="0"/>
+          <a:chExt cx="0" cy="0"/>
+        </a:xfrm>
+      </p:grpSpPr>
+      <p:sp>
+        <p:nvSpPr>
+          <p:cNvPr id="2" name="Title"/>
+          <p:cNvSpPr txBox="1"/>
+          <p:nvPr/>
+        </p:nvSpPr>
+        <p:spPr>
+          <a:xfrm>
+            <a:off x="609600" y="640080"/>
+            <a:ext cx="7924800" cy="1005840"/>
+          </a:xfrm>
+          <a:prstGeom prst="rect">
+            <a:avLst/>
+          </a:prstGeom>
+          <a:noFill/>
+        </p:spPr>
+        <p:txBody>
+          <a:bodyPr wrap="square"/>
+          <a:lstStyle/>
+          <a:p>
+            <a:r>
+              <a:rPr lang="en-US" sz="4300" b="1">
+                <a:solidFill>
+                  <a:srgbClr val="F4F7F8"/>
+                </a:solidFill>
+              </a:rPr>
+              <a:t>MVP</a:t>
+            </a:r>
+          </a:p>
+        </p:txBody>
+      </p:sp>
+      <p:sp>
+        <p:nvSpPr>
+          <p:cNvPr id="3" name="Body"/>
+          <p:cNvSpPr txBox="1"/>
+          <p:nvPr/>
+        </p:nvSpPr>
+        <p:spPr>
+          <a:xfrm>
+            <a:off x="914400" y="1905000"/>
+            <a:ext cx="7924800" cy="3657600"/>
+          </a:xfrm>
+          <a:prstGeom prst="rect">
+            <a:avLst/>
+          </a:prstGeom>
+          <a:noFill/>
+        </p:spPr>
+        <p:txBody>
+          <a:bodyPr wrap="square"/>
+          <a:lstStyle/>
+          <a:p>
+            <a:pPr marL="285750" indent="-171450">
+              <a:buChar char="•"/>
+            </a:pPr>
+            <a:r>
+              <a:rPr lang="en-US" sz="2100">
+                <a:solidFill>
+                  <a:srgbClr val="D7E3EA"/>
+                </a:solidFill>
+              </a:rPr>
+              <a:t>One HIP.markets-operated DEX.</a:t>
+            </a:r>
+          </a:p>
+          <a:p>
+            <a:pPr marL="285750" indent="-171450">
+              <a:buChar char="•"/>
+            </a:pPr>
+            <a:r>
+              <a:rPr lang="en-US" sz="2100">
+                <a:solidFill>
+                  <a:srgbClr val="D7E3EA"/>
+                </a:solidFill>
+              </a:rPr>
+              <a:t>One HYPE vault.</a:t>
+            </a:r>
+          </a:p>
+          <a:p>
+            <a:pPr marL="285750" indent="-171450">
+              <a:buChar char="•"/>
+            </a:pPr>
+            <a:r>
+              <a:rPr lang="en-US" sz="2100">
+                <a:solidFill>
+                  <a:srgbClr val="D7E3EA"/>
+                </a:solidFill>
+              </a:rPr>
+              <a:t>First three markets.</a:t>
+            </a:r>
+          </a:p>
+          <a:p>
+            <a:pPr marL="285750" indent="-171450">
+              <a:buChar char="•"/>
+            </a:pPr>
+            <a:r>
+              <a:rPr lang="en-US" sz="2100">
+                <a:solidFill>
+                  <a:srgbClr val="D7E3EA"/>
+                </a:solidFill>
+              </a:rPr>
+              <a:t>Weekly distributions.</a:t>
+            </a:r>
+          </a:p>
+          <a:p>
+            <a:pPr marL="285750" indent="-171450">
+              <a:buChar char="•"/>
+            </a:pPr>
+            <a:r>
+              <a:rPr lang="en-US" sz="2100">
+                <a:solidFill>
+                  <a:srgbClr val="D7E3EA"/>
+                </a:solidFill>
+              </a:rPr>
+              <a:t>Public dashboard.</a:t>
+            </a:r>
+          </a:p>
+          <a:p>
+            <a:pPr marL="285750" indent="-171450">
+              <a:buChar char="•"/>
+            </a:pPr>
+            <a:r>
+              <a:rPr lang="en-US" sz="2100">
+                <a:solidFill>
+                  <a:srgbClr val="D7E3EA"/>
+                </a:solidFill>
+              </a:rPr>
+              <a:t>No third-party operator financing.</a:t>
+            </a:r>
+          </a:p>
+        </p:txBody>
+      </p:sp>
+      <p:sp>
+        <p:nvSpPr>
+          <p:cNvPr id="4" name="Footer"/>
+          <p:cNvSpPr txBox="1"/>
+          <p:nvPr/>
+        </p:nvSpPr>
+        <p:spPr>
+          <a:xfrm>
+            <a:off x="609600" y="6400800"/>
+            <a:ext cx="7924800" cy="300000"/>
+          </a:xfrm>
+          <a:prstGeom prst="rect">
+            <a:avLst/>
+          </a:prstGeom>
+          <a:noFill/>
+        </p:spPr>
+        <p:txBody>
+          <a:bodyPr wrap="square"/>
+          <a:lstStyle/>
+          <a:p>
+            <a:r>
+              <a:rPr lang="en-US" sz="1000">
+                <a:solidFill>
+                  <a:srgbClr val="35D29A"/>
+                </a:solidFill>
+              </a:rPr>
+              <a:t>HIP.markets hackathon submission  |  14</a:t>
+            </a:r>
+          </a:p>
+        </p:txBody>
+      </p:sp>
+    </p:spTree>
+  </p:cSld>
+  <p:clrMapOvr>
+    <a:masterClrMapping/>
+  </p:clrMapOvr>
+</p:sld>
+</file>
+
+<file path=ppt/slides/slide15.xml><?xml version="1.0" encoding="utf-8"?>
+<p:sld xmlns:a="http://schemas.openxmlformats.org/drawingml/2006/main" xmlns:r="http://schemas.openxmlformats.org/officeDocument/2006/relationships" xmlns:p="http://schemas.openxmlformats.org/presentationml/2006/main">
+  <p:cSld>
+    <p:bg>
+      <p:bgPr>
+        <a:solidFill>
+          <a:srgbClr val="080A0D"/>
+        </a:solidFill>
+      </p:bgPr>
+    </p:bg>
+    <p:spTree>
+      <p:nvGrpSpPr>
+        <p:cNvPr id="1" name=""/>
+        <p:cNvGrpSpPr/>
+        <p:nvPr/>
+      </p:nvGrpSpPr>
+      <p:grpSpPr>
+        <a:xfrm>
+          <a:off x="0" y="0"/>
+          <a:ext cx="0" cy="0"/>
+          <a:chOff x="0" y="0"/>
+          <a:chExt cx="0" cy="0"/>
+        </a:xfrm>
+      </p:grpSpPr>
+      <p:sp>
+        <p:nvSpPr>
+          <p:cNvPr id="2" name="Title"/>
+          <p:cNvSpPr txBox="1"/>
+          <p:nvPr/>
+        </p:nvSpPr>
+        <p:spPr>
+          <a:xfrm>
+            <a:off x="609600" y="640080"/>
+            <a:ext cx="7924800" cy="1005840"/>
+          </a:xfrm>
+          <a:prstGeom prst="rect">
+            <a:avLst/>
+          </a:prstGeom>
+          <a:noFill/>
+        </p:spPr>
+        <p:txBody>
+          <a:bodyPr wrap="square"/>
+          <a:lstStyle/>
+          <a:p>
+            <a:r>
+              <a:rPr lang="en-US" sz="4300" b="1">
+                <a:solidFill>
+                  <a:srgbClr val="F4F7F8"/>
+                </a:solidFill>
+              </a:rPr>
+              <a:t>Roadmap</a:t>
+            </a:r>
+          </a:p>
+        </p:txBody>
+      </p:sp>
+      <p:sp>
+        <p:nvSpPr>
+          <p:cNvPr id="3" name="Body"/>
+          <p:cNvSpPr txBox="1"/>
+          <p:nvPr/>
+        </p:nvSpPr>
+        <p:spPr>
+          <a:xfrm>
+            <a:off x="914400" y="1905000"/>
+            <a:ext cx="7924800" cy="3657600"/>
+          </a:xfrm>
+          <a:prstGeom prst="rect">
+            <a:avLst/>
+          </a:prstGeom>
+          <a:noFill/>
+        </p:spPr>
+        <p:txBody>
+          <a:bodyPr wrap="square"/>
+          <a:lstStyle/>
+          <a:p>
+            <a:pPr marL="285750" indent="-171450">
+              <a:buChar char="•"/>
+            </a:pPr>
+            <a:r>
+              <a:rPr lang="en-US" sz="2100">
+                <a:solidFill>
+                  <a:srgbClr val="D7E3EA"/>
+                </a:solidFill>
+              </a:rPr>
+              <a:t>V1: prove operator vault and fee sharing.</a:t>
+            </a:r>
+          </a:p>
+          <a:p>
+            <a:pPr marL="285750" indent="-171450">
+              <a:buChar char="•"/>
+            </a:pPr>
+            <a:r>
+              <a:rPr lang="en-US" sz="2100">
+                <a:solidFill>
+                  <a:srgbClr val="D7E3EA"/>
+                </a:solidFill>
+              </a:rPr>
+              <a:t>V2: more HIP.markets market vaults and automated fee verification.</a:t>
+            </a:r>
+          </a:p>
+          <a:p>
+            <a:pPr marL="285750" indent="-171450">
+              <a:buChar char="•"/>
+            </a:pPr>
+            <a:r>
+              <a:rPr lang="en-US" sz="2100">
+                <a:solidFill>
+                  <a:srgbClr val="D7E3EA"/>
+                </a:solidFill>
+              </a:rPr>
+              <a:t>V3: risk tranching, secondary shares, HIP-4, possible third-party financing.</a:t>
+            </a:r>
+          </a:p>
+        </p:txBody>
+      </p:sp>
+      <p:sp>
+        <p:nvSpPr>
+          <p:cNvPr id="4" name="Footer"/>
+          <p:cNvSpPr txBox="1"/>
+          <p:nvPr/>
+        </p:nvSpPr>
+        <p:spPr>
+          <a:xfrm>
+            <a:off x="609600" y="6400800"/>
+            <a:ext cx="7924800" cy="300000"/>
+          </a:xfrm>
+          <a:prstGeom prst="rect">
+            <a:avLst/>
+          </a:prstGeom>
+          <a:noFill/>
+        </p:spPr>
+        <p:txBody>
+          <a:bodyPr wrap="square"/>
+          <a:lstStyle/>
+          <a:p>
+            <a:r>
+              <a:rPr lang="en-US" sz="1000">
+                <a:solidFill>
+                  <a:srgbClr val="35D29A"/>
+                </a:solidFill>
+              </a:rPr>
+              <a:t>HIP.markets hackathon submission  |  15</a:t>
+            </a:r>
+          </a:p>
+        </p:txBody>
+      </p:sp>
+    </p:spTree>
+  </p:cSld>
+  <p:clrMapOvr>
+    <a:masterClrMapping/>
+  </p:clrMapOvr>
+</p:sld>
+</file>
+
+<file path=ppt/slides/slide16.xml><?xml version="1.0" encoding="utf-8"?>
+<p:sld xmlns:a="http://schemas.openxmlformats.org/drawingml/2006/main" xmlns:r="http://schemas.openxmlformats.org/officeDocument/2006/relationships" xmlns:p="http://schemas.openxmlformats.org/presentationml/2006/main">
+  <p:cSld>
+    <p:bg>
+      <p:bgPr>
+        <a:solidFill>
+          <a:srgbClr val="080A0D"/>
+        </a:solidFill>
+      </p:bgPr>
+    </p:bg>
+    <p:spTree>
+      <p:nvGrpSpPr>
+        <p:cNvPr id="1" name=""/>
+        <p:cNvGrpSpPr/>
+        <p:nvPr/>
+      </p:nvGrpSpPr>
+      <p:grpSpPr>
+        <a:xfrm>
+          <a:off x="0" y="0"/>
+          <a:ext cx="0" cy="0"/>
+          <a:chOff x="0" y="0"/>
+          <a:chExt cx="0" cy="0"/>
+        </a:xfrm>
+      </p:grpSpPr>
+      <p:sp>
+        <p:nvSpPr>
+          <p:cNvPr id="2" name="Title"/>
+          <p:cNvSpPr txBox="1"/>
+          <p:nvPr/>
+        </p:nvSpPr>
+        <p:spPr>
+          <a:xfrm>
+            <a:off x="609600" y="640080"/>
+            <a:ext cx="7924800" cy="1005840"/>
+          </a:xfrm>
+          <a:prstGeom prst="rect">
+            <a:avLst/>
+          </a:prstGeom>
+          <a:noFill/>
+        </p:spPr>
+        <p:txBody>
+          <a:bodyPr wrap="square"/>
+          <a:lstStyle/>
+          <a:p>
+            <a:r>
+              <a:rPr lang="en-US" sz="4300" b="1">
+                <a:solidFill>
+                  <a:srgbClr val="F4F7F8"/>
+                </a:solidFill>
+              </a:rPr>
+              <a:t>Competitive Position</a:t>
+            </a:r>
+          </a:p>
+        </p:txBody>
+      </p:sp>
+      <p:sp>
+        <p:nvSpPr>
+          <p:cNvPr id="3" name="Body"/>
+          <p:cNvSpPr txBox="1"/>
+          <p:nvPr/>
+        </p:nvSpPr>
+        <p:spPr>
+          <a:xfrm>
+            <a:off x="914400" y="1905000"/>
+            <a:ext cx="7924800" cy="3657600"/>
+          </a:xfrm>
+          <a:prstGeom prst="rect">
+            <a:avLst/>
+          </a:prstGeom>
+          <a:noFill/>
+        </p:spPr>
+        <p:txBody>
+          <a:bodyPr wrap="square"/>
+          <a:lstStyle/>
+          <a:p>
+            <a:pPr marL="285750" indent="-171450">
+              <a:buChar char="•"/>
+            </a:pPr>
+            <a:r>
+              <a:rPr lang="en-US" sz="2100">
+                <a:solidFill>
+                  <a:srgbClr val="D7E3EA"/>
+                </a:solidFill>
+              </a:rPr>
+              <a:t>trade.xyz and HyENA operate markets directly.</a:t>
+            </a:r>
+          </a:p>
+          <a:p>
+            <a:pPr marL="285750" indent="-171450">
+              <a:buChar char="•"/>
+            </a:pPr>
+            <a:r>
+              <a:rPr lang="en-US" sz="2100">
+                <a:solidFill>
+                  <a:srgbClr val="D7E3EA"/>
+                </a:solidFill>
+              </a:rPr>
+              <a:t>HIP.markets also operates markets directly, but adds user-funded HYPE stake and transparent fee sharing.</a:t>
+            </a:r>
+          </a:p>
+          <a:p>
+            <a:pPr marL="285750" indent="-171450">
+              <a:buChar char="•"/>
+            </a:pPr>
+            <a:r>
+              <a:rPr lang="en-US" sz="2100">
+                <a:solidFill>
+                  <a:srgbClr val="D7E3EA"/>
+                </a:solidFill>
+              </a:rPr>
+              <a:t>The wedge is making HYPE holders economic backers of the operator.</a:t>
+            </a:r>
+          </a:p>
+        </p:txBody>
+      </p:sp>
+      <p:sp>
+        <p:nvSpPr>
+          <p:cNvPr id="4" name="Footer"/>
+          <p:cNvSpPr txBox="1"/>
+          <p:nvPr/>
+        </p:nvSpPr>
+        <p:spPr>
+          <a:xfrm>
+            <a:off x="609600" y="6400800"/>
+            <a:ext cx="7924800" cy="300000"/>
+          </a:xfrm>
+          <a:prstGeom prst="rect">
+            <a:avLst/>
+          </a:prstGeom>
+          <a:noFill/>
+        </p:spPr>
+        <p:txBody>
+          <a:bodyPr wrap="square"/>
+          <a:lstStyle/>
+          <a:p>
+            <a:r>
+              <a:rPr lang="en-US" sz="1000">
+                <a:solidFill>
+                  <a:srgbClr val="35D29A"/>
+                </a:solidFill>
+              </a:rPr>
+              <a:t>HIP.markets hackathon submission  |  16</a:t>
+            </a:r>
+          </a:p>
+        </p:txBody>
+      </p:sp>
+    </p:spTree>
+  </p:cSld>
+  <p:clrMapOvr>
+    <a:masterClrMapping/>
+  </p:clrMapOvr>
+</p:sld>
+</file>
+
+<file path=ppt/slides/slide17.xml><?xml version="1.0" encoding="utf-8"?>
+<p:sld xmlns:a="http://schemas.openxmlformats.org/drawingml/2006/main" xmlns:r="http://schemas.openxmlformats.org/officeDocument/2006/relationships" xmlns:p="http://schemas.openxmlformats.org/presentationml/2006/main">
+  <p:cSld>
+    <p:bg>
+      <p:bgPr>
+        <a:solidFill>
+          <a:srgbClr val="080A0D"/>
+        </a:solidFill>
+      </p:bgPr>
+    </p:bg>
+    <p:spTree>
+      <p:nvGrpSpPr>
+        <p:cNvPr id="1" name=""/>
+        <p:cNvGrpSpPr/>
+        <p:nvPr/>
+      </p:nvGrpSpPr>
+      <p:grpSpPr>
+        <a:xfrm>
+          <a:off x="0" y="0"/>
+          <a:ext cx="0" cy="0"/>
+          <a:chOff x="0" y="0"/>
+          <a:chExt cx="0" cy="0"/>
+        </a:xfrm>
+      </p:grpSpPr>
+      <p:sp>
+        <p:nvSpPr>
+          <p:cNvPr id="2" name="Title"/>
+          <p:cNvSpPr txBox="1"/>
+          <p:nvPr/>
+        </p:nvSpPr>
+        <p:spPr>
+          <a:xfrm>
+            <a:off x="609600" y="640080"/>
+            <a:ext cx="7924800" cy="1005840"/>
+          </a:xfrm>
+          <a:prstGeom prst="rect">
+            <a:avLst/>
+          </a:prstGeom>
+          <a:noFill/>
+        </p:spPr>
+        <p:txBody>
+          <a:bodyPr wrap="square"/>
+          <a:lstStyle/>
+          <a:p>
+            <a:r>
+              <a:rPr lang="en-US" sz="4300" b="1">
+                <a:solidFill>
+                  <a:srgbClr val="F4F7F8"/>
+                </a:solidFill>
+              </a:rPr>
+              <a:t>Ask</a:t>
+            </a:r>
+          </a:p>
+        </p:txBody>
+      </p:sp>
+      <p:sp>
+        <p:nvSpPr>
+          <p:cNvPr id="3" name="Body"/>
+          <p:cNvSpPr txBox="1"/>
+          <p:nvPr/>
+        </p:nvSpPr>
+        <p:spPr>
+          <a:xfrm>
+            <a:off x="914400" y="1905000"/>
+            <a:ext cx="7924800" cy="3657600"/>
+          </a:xfrm>
+          <a:prstGeom prst="rect">
+            <a:avLst/>
+          </a:prstGeom>
+          <a:noFill/>
+        </p:spPr>
+        <p:txBody>
+          <a:bodyPr wrap="square"/>
+          <a:lstStyle/>
+          <a:p>
+            <a:pPr marL="285750" indent="-171450">
+              <a:buChar char="•"/>
+            </a:pPr>
+            <a:r>
+              <a:rPr lang="en-US" sz="2100">
+                <a:solidFill>
+                  <a:srgbClr val="D7E3EA"/>
+                </a:solidFill>
+              </a:rPr>
+              <a:t>HYPE holders for capped beta.</a:t>
+            </a:r>
+          </a:p>
+          <a:p>
+            <a:pPr marL="285750" indent="-171450">
+              <a:buChar char="•"/>
+            </a:pPr>
+            <a:r>
+              <a:rPr lang="en-US" sz="2100">
+                <a:solidFill>
+                  <a:srgbClr val="D7E3EA"/>
+                </a:solidFill>
+              </a:rPr>
+              <a:t>Market makers for first markets.</a:t>
+            </a:r>
+          </a:p>
+          <a:p>
+            <a:pPr marL="285750" indent="-171450">
+              <a:buChar char="•"/>
+            </a:pPr>
+            <a:r>
+              <a:rPr lang="en-US" sz="2100">
+                <a:solidFill>
+                  <a:srgbClr val="D7E3EA"/>
+                </a:solidFill>
+              </a:rPr>
+              <a:t>Oracle and data partners.</a:t>
+            </a:r>
+          </a:p>
+          <a:p>
+            <a:pPr marL="285750" indent="-171450">
+              <a:buChar char="•"/>
+            </a:pPr>
+            <a:r>
+              <a:rPr lang="en-US" sz="2100">
+                <a:solidFill>
+                  <a:srgbClr val="D7E3EA"/>
+                </a:solidFill>
+              </a:rPr>
+              <a:t>Security reviewers.</a:t>
+            </a:r>
+          </a:p>
+          <a:p>
+            <a:pPr marL="285750" indent="-171450">
+              <a:buChar char="•"/>
+            </a:pPr>
+            <a:r>
+              <a:rPr lang="en-US" sz="2100">
+                <a:solidFill>
+                  <a:srgbClr val="D7E3EA"/>
+                </a:solidFill>
+              </a:rPr>
+              <a:t>Hyperliquid feedback on custody and fee routing.</a:t>
+            </a:r>
+          </a:p>
+        </p:txBody>
+      </p:sp>
+      <p:sp>
+        <p:nvSpPr>
+          <p:cNvPr id="4" name="Footer"/>
+          <p:cNvSpPr txBox="1"/>
+          <p:nvPr/>
+        </p:nvSpPr>
+        <p:spPr>
+          <a:xfrm>
+            <a:off x="609600" y="6400800"/>
+            <a:ext cx="7924800" cy="300000"/>
+          </a:xfrm>
+          <a:prstGeom prst="rect">
+            <a:avLst/>
+          </a:prstGeom>
+          <a:noFill/>
+        </p:spPr>
+        <p:txBody>
+          <a:bodyPr wrap="square"/>
+          <a:lstStyle/>
+          <a:p>
+            <a:r>
+              <a:rPr lang="en-US" sz="1000">
+                <a:solidFill>
+                  <a:srgbClr val="35D29A"/>
+                </a:solidFill>
+              </a:rPr>
+              <a:t>HIP.markets hackathon submission  |  17</a:t>
+            </a:r>
+          </a:p>
+        </p:txBody>
+      </p:sp>
+    </p:spTree>
+  </p:cSld>
+  <p:clrMapOvr>
+    <a:masterClrMapping/>
+  </p:clrMapOvr>
+</p:sld>
+</file>
+
+<file path=ppt/slides/slide18.xml><?xml version="1.0" encoding="utf-8"?>
+<p:sld xmlns:a="http://schemas.openxmlformats.org/drawingml/2006/main" xmlns:r="http://schemas.openxmlformats.org/officeDocument/2006/relationships" xmlns:p="http://schemas.openxmlformats.org/presentationml/2006/main">
+  <p:cSld>
+    <p:bg>
+      <p:bgPr>
+        <a:solidFill>
+          <a:srgbClr val="080A0D"/>
+        </a:solidFill>
+      </p:bgPr>
+    </p:bg>
+    <p:spTree>
+      <p:nvGrpSpPr>
+        <p:cNvPr id="1" name=""/>
+        <p:cNvGrpSpPr/>
+        <p:nvPr/>
+      </p:nvGrpSpPr>
+      <p:grpSpPr>
+        <a:xfrm>
+          <a:off x="0" y="0"/>
+          <a:ext cx="0" cy="0"/>
+          <a:chOff x="0" y="0"/>
+          <a:chExt cx="0" cy="0"/>
+        </a:xfrm>
+      </p:grpSpPr>
+      <p:sp>
+        <p:nvSpPr>
+          <p:cNvPr id="2" name="Title"/>
+          <p:cNvSpPr txBox="1"/>
+          <p:nvPr/>
+        </p:nvSpPr>
+        <p:spPr>
+          <a:xfrm>
+            <a:off x="609600" y="640080"/>
+            <a:ext cx="7924800" cy="1005840"/>
+          </a:xfrm>
+          <a:prstGeom prst="rect">
+            <a:avLst/>
+          </a:prstGeom>
+          <a:noFill/>
+        </p:spPr>
+        <p:txBody>
+          <a:bodyPr wrap="square"/>
+          <a:lstStyle/>
+          <a:p>
+            <a:r>
+              <a:rPr lang="en-US" sz="4300" b="1">
+                <a:solidFill>
+                  <a:srgbClr val="F4F7F8"/>
+                </a:solidFill>
+              </a:rPr>
+              <a:t>Closing</a:t>
+            </a:r>
+          </a:p>
+        </p:txBody>
+      </p:sp>
+      <p:sp>
+        <p:nvSpPr>
+          <p:cNvPr id="3" name="Body"/>
+          <p:cNvSpPr txBox="1"/>
+          <p:nvPr/>
+        </p:nvSpPr>
+        <p:spPr>
+          <a:xfrm>
+            <a:off x="914400" y="1905000"/>
+            <a:ext cx="7924800" cy="3657600"/>
+          </a:xfrm>
+          <a:prstGeom prst="rect">
+            <a:avLst/>
+          </a:prstGeom>
+          <a:noFill/>
+        </p:spPr>
+        <p:txBody>
+          <a:bodyPr wrap="square"/>
+          <a:lstStyle/>
+          <a:p>
+            <a:pPr marL="285750" indent="-171450">
+              <a:buChar char="•"/>
+            </a:pPr>
+            <a:r>
+              <a:rPr lang="en-US" sz="2100">
+                <a:solidFill>
+                  <a:srgbClr val="D7E3EA"/>
+                </a:solidFill>
+              </a:rPr>
+              <a:t>HIP.markets turns builder-deployed markets into a community-backed operator business.</a:t>
+            </a:r>
+          </a:p>
+          <a:p>
+            <a:pPr marL="285750" indent="-171450">
+              <a:buChar char="•"/>
+            </a:pPr>
+            <a:r>
+              <a:rPr lang="en-US" sz="2100">
+                <a:solidFill>
+                  <a:srgbClr val="D7E3EA"/>
+                </a:solidFill>
+              </a:rPr>
+              <a:t>The first job is operating markets safely.</a:t>
+            </a:r>
+          </a:p>
+        </p:txBody>
+      </p:sp>
+      <p:sp>
+        <p:nvSpPr>
+          <p:cNvPr id="4" name="Footer"/>
+          <p:cNvSpPr txBox="1"/>
+          <p:nvPr/>
+        </p:nvSpPr>
+        <p:spPr>
+          <a:xfrm>
+            <a:off x="609600" y="6400800"/>
+            <a:ext cx="7924800" cy="300000"/>
+          </a:xfrm>
+          <a:prstGeom prst="rect">
+            <a:avLst/>
+          </a:prstGeom>
+          <a:noFill/>
+        </p:spPr>
+        <p:txBody>
+          <a:bodyPr wrap="square"/>
+          <a:lstStyle/>
+          <a:p>
+            <a:r>
+              <a:rPr lang="en-US" sz="1000">
+                <a:solidFill>
+                  <a:srgbClr val="35D29A"/>
+                </a:solidFill>
+              </a:rPr>
+              <a:t>HIP.markets hackathon submission  |  18</a:t>
             </a:r>
           </a:p>
         </p:txBody>
@@ -969,20 +1770,20 @@
                   <a:srgbClr val="D7E3EA"/>
                 </a:solidFill>
               </a:rPr>
-              <a:t>Builders need capital. HYPE holders need transparent market-growth yield.</a:t>
-            </a:r>
-          </a:p>
-          <a:p>
-            <a:pPr marL="285750" indent="-171450">
-              <a:buChar char="•"/>
-            </a:pPr>
-            <a:r>
-              <a:rPr lang="en-US" sz="2100">
-                <a:solidFill>
-                  <a:srgbClr val="D7E3EA"/>
-                </a:solidFill>
-              </a:rPr>
-              <a:t>Oracle and slashing risks are hard to price.</a:t>
+              <a:t>Stake is only the start: operators also need oracles, liquidity, risk controls, and fee accounting.</a:t>
+            </a:r>
+          </a:p>
+          <a:p>
+            <a:pPr marL="285750" indent="-171450">
+              <a:buChar char="•"/>
+            </a:pPr>
+            <a:r>
+              <a:rPr lang="en-US" sz="2100">
+                <a:solidFill>
+                  <a:srgbClr val="D7E3EA"/>
+                </a:solidFill>
+              </a:rPr>
+              <a:t>Stakers need slashing risk beside APR.</a:t>
             </a:r>
           </a:p>
         </p:txBody>
@@ -1076,7 +1877,7 @@
                   <a:srgbClr val="F4F7F8"/>
                 </a:solidFill>
               </a:rPr>
-              <a:t>The Insight</a:t>
+              <a:t>Product Thesis</a:t>
             </a:r>
           </a:p>
         </p:txBody>
@@ -1110,20 +1911,33 @@
                   <a:srgbClr val="D7E3EA"/>
                 </a:solidFill>
               </a:rPr>
-              <a:t>The 500,000 HYPE stake is the security layer for a market operator.</a:t>
-            </a:r>
-          </a:p>
-          <a:p>
-            <a:pPr marL="285750" indent="-171450">
-              <a:buChar char="•"/>
-            </a:pPr>
-            <a:r>
-              <a:rPr lang="en-US" sz="2100">
-                <a:solidFill>
-                  <a:srgbClr val="D7E3EA"/>
-                </a:solidFill>
-              </a:rPr>
-              <a:t>If HYPE holders fund that stake, they should share in builder fees.</a:t>
+              <a:t>HIP.markets is not passive liquid staking.</a:t>
+            </a:r>
+          </a:p>
+          <a:p>
+            <a:pPr marL="285750" indent="-171450">
+              <a:buChar char="•"/>
+            </a:pPr>
+            <a:r>
+              <a:rPr lang="en-US" sz="2100">
+                <a:solidFill>
+                  <a:srgbClr val="D7E3EA"/>
+                </a:solidFill>
+              </a:rPr>
+              <a:t>HIP.markets is the operator.</a:t>
+            </a:r>
+          </a:p>
+          <a:p>
+            <a:pPr marL="285750" indent="-171450">
+              <a:buChar char="•"/>
+            </a:pPr>
+            <a:r>
+              <a:rPr lang="en-US" sz="2100">
+                <a:solidFill>
+                  <a:srgbClr val="D7E3EA"/>
+                </a:solidFill>
+              </a:rPr>
+              <a:t>Users back the HIP.markets deployer stake and share net deployer fees.</a:t>
             </a:r>
           </a:p>
         </p:txBody>
@@ -1217,7 +2031,7 @@
                   <a:srgbClr val="F4F7F8"/>
                 </a:solidFill>
               </a:rPr>
-              <a:t>Product</a:t>
+              <a:t>Why Trade.xyz Matters</a:t>
             </a:r>
           </a:p>
         </p:txBody>
@@ -1251,33 +2065,20 @@
                   <a:srgbClr val="D7E3EA"/>
                 </a:solidFill>
               </a:rPr>
-              <a:t>HIP.markets is both a HyperEVM HYPE vault and a HIP-3 operator.</a:t>
-            </a:r>
-          </a:p>
-          <a:p>
-            <a:pPr marL="285750" indent="-171450">
-              <a:buChar char="•"/>
-            </a:pPr>
-            <a:r>
-              <a:rPr lang="en-US" sz="2100">
-                <a:solidFill>
-                  <a:srgbClr val="D7E3EA"/>
-                </a:solidFill>
-              </a:rPr>
-              <a:t>Deposits back the HIP.markets deployer stake.</a:t>
-            </a:r>
-          </a:p>
-          <a:p>
-            <a:pPr marL="285750" indent="-171450">
-              <a:buChar char="•"/>
-            </a:pPr>
-            <a:r>
-              <a:rPr lang="en-US" sz="2100">
-                <a:solidFill>
-                  <a:srgbClr val="D7E3EA"/>
-                </a:solidFill>
-              </a:rPr>
-              <a:t>Net deployer fees flow back to stakers.</a:t>
+              <a:t>trade.xyz proves HIP-3 can support serious market operators.</a:t>
+            </a:r>
+          </a:p>
+          <a:p>
+            <a:pPr marL="285750" indent="-171450">
+              <a:buChar char="•"/>
+            </a:pPr>
+            <a:r>
+              <a:rPr lang="en-US" sz="2100">
+                <a:solidFill>
+                  <a:srgbClr val="D7E3EA"/>
+                </a:solidFill>
+              </a:rPr>
+              <a:t>Useful UI patterns: market rail, order ticket, positions tabs, account modes, Ghost Mode observability, explicit warnings.</a:t>
             </a:r>
           </a:p>
         </p:txBody>
@@ -1371,7 +2172,7 @@
                   <a:srgbClr val="F4F7F8"/>
                 </a:solidFill>
               </a:rPr>
-              <a:t>System Flow</a:t>
+              <a:t>UX Translation</a:t>
             </a:r>
           </a:p>
         </p:txBody>
@@ -1405,59 +2206,46 @@
                   <a:srgbClr val="D7E3EA"/>
                 </a:solidFill>
               </a:rPr>
-              <a:t>1. HYPE holders deposit into vault.</a:t>
-            </a:r>
-          </a:p>
-          <a:p>
-            <a:pPr marL="285750" indent="-171450">
-              <a:buChar char="•"/>
-            </a:pPr>
-            <a:r>
-              <a:rPr lang="en-US" sz="2100">
-                <a:solidFill>
-                  <a:srgbClr val="D7E3EA"/>
-                </a:solidFill>
-              </a:rPr>
-              <a:t>2. Vault backs deployer stake.</a:t>
-            </a:r>
-          </a:p>
-          <a:p>
-            <a:pPr marL="285750" indent="-171450">
-              <a:buChar char="•"/>
-            </a:pPr>
-            <a:r>
-              <a:rPr lang="en-US" sz="2100">
-                <a:solidFill>
-                  <a:srgbClr val="D7E3EA"/>
-                </a:solidFill>
-              </a:rPr>
-              <a:t>3. HIP.markets runs markets and oracles.</a:t>
-            </a:r>
-          </a:p>
-          <a:p>
-            <a:pPr marL="285750" indent="-171450">
-              <a:buChar char="•"/>
-            </a:pPr>
-            <a:r>
-              <a:rPr lang="en-US" sz="2100">
-                <a:solidFill>
-                  <a:srgbClr val="D7E3EA"/>
-                </a:solidFill>
-              </a:rPr>
-              <a:t>4. Traders generate fees.</a:t>
-            </a:r>
-          </a:p>
-          <a:p>
-            <a:pPr marL="285750" indent="-171450">
-              <a:buChar char="•"/>
-            </a:pPr>
-            <a:r>
-              <a:rPr lang="en-US" sz="2100">
-                <a:solidFill>
-                  <a:srgbClr val="D7E3EA"/>
-                </a:solidFill>
-              </a:rPr>
-              <a:t>5. Net fees distribute to stakers.</a:t>
+              <a:t>Market rail -&gt; first-three-market launch rail.</a:t>
+            </a:r>
+          </a:p>
+          <a:p>
+            <a:pPr marL="285750" indent="-171450">
+              <a:buChar char="•"/>
+            </a:pPr>
+            <a:r>
+              <a:rPr lang="en-US" sz="2100">
+                <a:solidFill>
+                  <a:srgbClr val="D7E3EA"/>
+                </a:solidFill>
+              </a:rPr>
+              <a:t>Order ticket -&gt; HYPE deposit ticket.</a:t>
+            </a:r>
+          </a:p>
+          <a:p>
+            <a:pPr marL="285750" indent="-171450">
+              <a:buChar char="•"/>
+            </a:pPr>
+            <a:r>
+              <a:rPr lang="en-US" sz="2100">
+                <a:solidFill>
+                  <a:srgbClr val="D7E3EA"/>
+                </a:solidFill>
+              </a:rPr>
+              <a:t>Positions panel -&gt; vault shares, fee history, oracle updates, market launches.</a:t>
+            </a:r>
+          </a:p>
+          <a:p>
+            <a:pPr marL="285750" indent="-171450">
+              <a:buChar char="•"/>
+            </a:pPr>
+            <a:r>
+              <a:rPr lang="en-US" sz="2100">
+                <a:solidFill>
+                  <a:srgbClr val="D7E3EA"/>
+                </a:solidFill>
+              </a:rPr>
+              <a:t>Ghost Mode -&gt; operator monitor.</a:t>
             </a:r>
           </a:p>
         </p:txBody>
@@ -1551,7 +2339,7 @@
                   <a:srgbClr val="F4F7F8"/>
                 </a:solidFill>
               </a:rPr>
-              <a:t>Why Not Liquid Staking?</a:t>
+              <a:t>Demo 1: Operator Vault</a:t>
             </a:r>
           </a:p>
         </p:txBody>
@@ -1585,33 +2373,20 @@
                   <a:srgbClr val="D7E3EA"/>
                 </a:solidFill>
               </a:rPr>
-              <a:t>Liquid staking earns validator-style yield.</a:t>
-            </a:r>
-          </a:p>
-          <a:p>
-            <a:pPr marL="285750" indent="-171450">
-              <a:buChar char="•"/>
-            </a:pPr>
-            <a:r>
-              <a:rPr lang="en-US" sz="2100">
-                <a:solidFill>
-                  <a:srgbClr val="D7E3EA"/>
-                </a:solidFill>
-              </a:rPr>
-              <a:t>HIP.markets earns market-operator revenue.</a:t>
-            </a:r>
-          </a:p>
-          <a:p>
-            <a:pPr marL="285750" indent="-171450">
-              <a:buChar char="•"/>
-            </a:pPr>
-            <a:r>
-              <a:rPr lang="en-US" sz="2100">
-                <a:solidFill>
-                  <a:srgbClr val="D7E3EA"/>
-                </a:solidFill>
-              </a:rPr>
-              <a:t>Risks: oracle, liquidity, slashing, market selection, fee shortfall.</a:t>
+              <a:t>First screen is the usable operator console, not a landing page.</a:t>
+            </a:r>
+          </a:p>
+          <a:p>
+            <a:pPr marL="285750" indent="-171450">
+              <a:buChar char="•"/>
+            </a:pPr>
+            <a:r>
+              <a:rPr lang="en-US" sz="2100">
+                <a:solidFill>
+                  <a:srgbClr val="D7E3EA"/>
+                </a:solidFill>
+              </a:rPr>
+              <a:t>Shows vault capacity, APR, oracle cadence, risk state, and 500k HYPE requirement.</a:t>
             </a:r>
           </a:p>
         </p:txBody>
@@ -1705,7 +2480,7 @@
                   <a:srgbClr val="F4F7F8"/>
                 </a:solidFill>
               </a:rPr>
-              <a:t>MVP</a:t>
+              <a:t>Demo 2: Fee Model</a:t>
             </a:r>
           </a:p>
         </p:txBody>
@@ -1739,72 +2514,20 @@
                   <a:srgbClr val="D7E3EA"/>
                 </a:solidFill>
               </a:rPr>
-              <a:t>One HIP.markets-operated DEX.</a:t>
-            </a:r>
-          </a:p>
-          <a:p>
-            <a:pPr marL="285750" indent="-171450">
-              <a:buChar char="•"/>
-            </a:pPr>
-            <a:r>
-              <a:rPr lang="en-US" sz="2100">
-                <a:solidFill>
-                  <a:srgbClr val="D7E3EA"/>
-                </a:solidFill>
-              </a:rPr>
-              <a:t>One HYPE vault.</a:t>
-            </a:r>
-          </a:p>
-          <a:p>
-            <a:pPr marL="285750" indent="-171450">
-              <a:buChar char="•"/>
-            </a:pPr>
-            <a:r>
-              <a:rPr lang="en-US" sz="2100">
-                <a:solidFill>
-                  <a:srgbClr val="D7E3EA"/>
-                </a:solidFill>
-              </a:rPr>
-              <a:t>First three tickers.</a:t>
-            </a:r>
-          </a:p>
-          <a:p>
-            <a:pPr marL="285750" indent="-171450">
-              <a:buChar char="•"/>
-            </a:pPr>
-            <a:r>
-              <a:rPr lang="en-US" sz="2100">
-                <a:solidFill>
-                  <a:srgbClr val="D7E3EA"/>
-                </a:solidFill>
-              </a:rPr>
-              <a:t>Conservative caps.</a:t>
-            </a:r>
-          </a:p>
-          <a:p>
-            <a:pPr marL="285750" indent="-171450">
-              <a:buChar char="•"/>
-            </a:pPr>
-            <a:r>
-              <a:rPr lang="en-US" sz="2100">
-                <a:solidFill>
-                  <a:srgbClr val="D7E3EA"/>
-                </a:solidFill>
-              </a:rPr>
-              <a:t>Weekly fee distributions.</a:t>
-            </a:r>
-          </a:p>
-          <a:p>
-            <a:pPr marL="285750" indent="-171450">
-              <a:buChar char="•"/>
-            </a:pPr>
-            <a:r>
-              <a:rPr lang="en-US" sz="2100">
-                <a:solidFill>
-                  <a:srgbClr val="D7E3EA"/>
-                </a:solidFill>
-              </a:rPr>
-              <a:t>Public oracle and risk dashboard.</a:t>
+              <a:t>Judges can change HYPE price, staked HYPE, daily volume, fee bps, builder share, operating fee, protocol fee, and reserve.</a:t>
+            </a:r>
+          </a:p>
+          <a:p>
+            <a:pPr marL="285750" indent="-171450">
+              <a:buChar char="•"/>
+            </a:pPr>
+            <a:r>
+              <a:rPr lang="en-US" sz="2100">
+                <a:solidFill>
+                  <a:srgbClr val="D7E3EA"/>
+                </a:solidFill>
+              </a:rPr>
+              <a:t>APR updates instantly.</a:t>
             </a:r>
           </a:p>
         </p:txBody>
@@ -1898,7 +2621,7 @@
                   <a:srgbClr val="F4F7F8"/>
                 </a:solidFill>
               </a:rPr>
-              <a:t>Economics</a:t>
+              <a:t>Demo 3: Deposit Ticket</a:t>
             </a:r>
           </a:p>
         </p:txBody>
@@ -1932,33 +2655,20 @@
                   <a:srgbClr val="D7E3EA"/>
                 </a:solidFill>
               </a:rPr>
-              <a:t>APR depends on volume, fee rate, deployer share, costs, reserves, and HYPE price.</a:t>
-            </a:r>
-          </a:p>
-          <a:p>
-            <a:pPr marL="285750" indent="-171450">
-              <a:buChar char="•"/>
-            </a:pPr>
-            <a:r>
-              <a:rPr lang="en-US" sz="2100">
-                <a:solidFill>
-                  <a:srgbClr val="D7E3EA"/>
-                </a:solidFill>
-              </a:rPr>
-              <a:t>Base case: 500k HYPE, $50M daily volume, 6 bps fee, 50% deployer share.</a:t>
-            </a:r>
-          </a:p>
-          <a:p>
-            <a:pPr marL="285750" indent="-171450">
-              <a:buChar char="•"/>
-            </a:pPr>
-            <a:r>
-              <a:rPr lang="en-US" sz="2100">
-                <a:solidFill>
-                  <a:srgbClr val="D7E3EA"/>
-                </a:solidFill>
-              </a:rPr>
-              <a:t>After 40% deductions: approximately 15% APR.</a:t>
+              <a:t>Mirrors a trading order pane.</a:t>
+            </a:r>
+          </a:p>
+          <a:p>
+            <a:pPr marL="285750" indent="-171450">
+              <a:buChar char="•"/>
+            </a:pPr>
+            <a:r>
+              <a:rPr lang="en-US" sz="2100">
+                <a:solidFill>
+                  <a:srgbClr val="D7E3EA"/>
+                </a:solidFill>
+              </a:rPr>
+              <a:t>Amount input, deposit/withdraw mode, fee summary, user rewards estimate, and slashing warning.</a:t>
             </a:r>
           </a:p>
         </p:txBody>
@@ -2052,7 +2762,7 @@
                   <a:srgbClr val="F4F7F8"/>
                 </a:solidFill>
               </a:rPr>
-              <a:t>Risk Controls</a:t>
+              <a:t>Demo 4: Audit Tabs</a:t>
             </a:r>
           </a:p>
         </p:txBody>
@@ -2086,72 +2796,33 @@
                   <a:srgbClr val="D7E3EA"/>
                 </a:solidFill>
               </a:rPr>
-              <a:t>Launch simple markets first.</a:t>
-            </a:r>
-          </a:p>
-          <a:p>
-            <a:pPr marL="285750" indent="-171450">
-              <a:buChar char="•"/>
-            </a:pPr>
-            <a:r>
-              <a:rPr lang="en-US" sz="2100">
-                <a:solidFill>
-                  <a:srgbClr val="D7E3EA"/>
-                </a:solidFill>
-              </a:rPr>
-              <a:t>Use redundant oracle feeds.</a:t>
-            </a:r>
-          </a:p>
-          <a:p>
-            <a:pPr marL="285750" indent="-171450">
-              <a:buChar char="•"/>
-            </a:pPr>
-            <a:r>
-              <a:rPr lang="en-US" sz="2100">
-                <a:solidFill>
-                  <a:srgbClr val="D7E3EA"/>
-                </a:solidFill>
-              </a:rPr>
-              <a:t>Cap open interest.</a:t>
-            </a:r>
-          </a:p>
-          <a:p>
-            <a:pPr marL="285750" indent="-171450">
-              <a:buChar char="•"/>
-            </a:pPr>
-            <a:r>
-              <a:rPr lang="en-US" sz="2100">
-                <a:solidFill>
-                  <a:srgbClr val="D7E3EA"/>
-                </a:solidFill>
-              </a:rPr>
-              <a:t>Publish addresses.</a:t>
-            </a:r>
-          </a:p>
-          <a:p>
-            <a:pPr marL="285750" indent="-171450">
-              <a:buChar char="•"/>
-            </a:pPr>
-            <a:r>
-              <a:rPr lang="en-US" sz="2100">
-                <a:solidFill>
-                  <a:srgbClr val="D7E3EA"/>
-                </a:solidFill>
-              </a:rPr>
-              <a:t>Maintain slashing reserve.</a:t>
-            </a:r>
-          </a:p>
-          <a:p>
-            <a:pPr marL="285750" indent="-171450">
-              <a:buChar char="•"/>
-            </a:pPr>
-            <a:r>
-              <a:rPr lang="en-US" sz="2100">
-                <a:solidFill>
-                  <a:srgbClr val="D7E3EA"/>
-                </a:solidFill>
-              </a:rPr>
-              <a:t>Pause deposits during incidents.</a:t>
+              <a:t>Vault shares show depositor state.</a:t>
+            </a:r>
+          </a:p>
+          <a:p>
+            <a:pPr marL="285750" indent="-171450">
+              <a:buChar char="•"/>
+            </a:pPr>
+            <a:r>
+              <a:rPr lang="en-US" sz="2100">
+                <a:solidFill>
+                  <a:srgbClr val="D7E3EA"/>
+                </a:solidFill>
+              </a:rPr>
+              <a:t>Fee history shows how builder fees become distributions.</a:t>
+            </a:r>
+          </a:p>
+          <a:p>
+            <a:pPr marL="285750" indent="-171450">
+              <a:buChar char="•"/>
+            </a:pPr>
+            <a:r>
+              <a:rPr lang="en-US" sz="2100">
+                <a:solidFill>
+                  <a:srgbClr val="D7E3EA"/>
+                </a:solidFill>
+              </a:rPr>
+              <a:t>Oracle updates and market launches expose operator readiness.</a:t>
             </a:r>
           </a:p>
         </p:txBody>

</xml_diff>

<commit_message>
Enhance deck with Trade XYZ benchmark and demo visuals
</commit_message>
<xml_diff>
--- a/presentation/HIP_MARKETS_DECK.pptx
+++ b/presentation/HIP_MARKETS_DECK.pptx
@@ -23,6 +23,10 @@
     <p:sldId id="271" r:id="rId18"/>
     <p:sldId id="272" r:id="rId19"/>
     <p:sldId id="273" r:id="rId20"/>
+    <p:sldId id="274" r:id="rId21"/>
+    <p:sldId id="275" r:id="rId22"/>
+    <p:sldId id="276" r:id="rId23"/>
+    <p:sldId id="277" r:id="rId24"/>
   </p:sldIdLst>
   <p:sldSz cx="12192000" cy="6858000" type="wide"/>
   <p:notesSz cx="6858000" cy="9144000"/>
@@ -113,20 +117,20 @@
         </p:nvSpPr>
         <p:spPr>
           <a:xfrm>
-            <a:off x="609600" y="640080"/>
-            <a:ext cx="7924800" cy="1005840"/>
-          </a:xfrm>
-          <a:prstGeom prst="rect">
-            <a:avLst/>
-          </a:prstGeom>
-          <a:noFill/>
-        </p:spPr>
-        <p:txBody>
-          <a:bodyPr wrap="square"/>
-          <a:lstStyle/>
-          <a:p>
-            <a:r>
-              <a:rPr lang="en-US" sz="4300" b="1">
+            <a:off x="609600" y="610000"/>
+            <a:ext cx="10300000" cy="850000"/>
+          </a:xfrm>
+          <a:prstGeom prst="rect">
+            <a:avLst/>
+          </a:prstGeom>
+          <a:noFill/>
+        </p:spPr>
+        <p:txBody>
+          <a:bodyPr wrap="square"/>
+          <a:lstStyle/>
+          <a:p>
+            <a:r>
+              <a:rPr lang="en-US" sz="4100" b="1">
                 <a:solidFill>
                   <a:srgbClr val="F4F7F8"/>
                 </a:solidFill>
@@ -145,7 +149,7 @@
         <p:spPr>
           <a:xfrm>
             <a:off x="914400" y="1905000"/>
-            <a:ext cx="7924800" cy="3657600"/>
+            <a:ext cx="9800000" cy="3900000"/>
           </a:xfrm>
           <a:prstGeom prst="rect">
             <a:avLst/>
@@ -192,7 +196,7 @@
         <p:spPr>
           <a:xfrm>
             <a:off x="609600" y="6400800"/>
-            <a:ext cx="7924800" cy="300000"/>
+            <a:ext cx="10500000" cy="300000"/>
           </a:xfrm>
           <a:prstGeom prst="rect">
             <a:avLst/>
@@ -254,25 +258,25 @@
         </p:nvSpPr>
         <p:spPr>
           <a:xfrm>
-            <a:off x="609600" y="640080"/>
-            <a:ext cx="7924800" cy="1005840"/>
-          </a:xfrm>
-          <a:prstGeom prst="rect">
-            <a:avLst/>
-          </a:prstGeom>
-          <a:noFill/>
-        </p:spPr>
-        <p:txBody>
-          <a:bodyPr wrap="square"/>
-          <a:lstStyle/>
-          <a:p>
-            <a:r>
-              <a:rPr lang="en-US" sz="4300" b="1">
+            <a:off x="609600" y="610000"/>
+            <a:ext cx="10300000" cy="850000"/>
+          </a:xfrm>
+          <a:prstGeom prst="rect">
+            <a:avLst/>
+          </a:prstGeom>
+          <a:noFill/>
+        </p:spPr>
+        <p:txBody>
+          <a:bodyPr wrap="square"/>
+          <a:lstStyle/>
+          <a:p>
+            <a:r>
+              <a:rPr lang="en-US" sz="4100" b="1">
                 <a:solidFill>
                   <a:srgbClr val="F4F7F8"/>
                 </a:solidFill>
               </a:rPr>
-              <a:t>Demo 5: Operator Monitor</a:t>
+              <a:t>Demo Walkthrough</a:t>
             </a:r>
           </a:p>
         </p:txBody>
@@ -285,45 +289,67 @@
         </p:nvSpPr>
         <p:spPr>
           <a:xfrm>
-            <a:off x="914400" y="1905000"/>
-            <a:ext cx="7924800" cy="3657600"/>
-          </a:xfrm>
-          <a:prstGeom prst="rect">
-            <a:avLst/>
-          </a:prstGeom>
-          <a:noFill/>
-        </p:spPr>
-        <p:txBody>
-          <a:bodyPr wrap="square"/>
-          <a:lstStyle/>
-          <a:p>
-            <a:pPr marL="285750" indent="-171450">
-              <a:buChar char="•"/>
-            </a:pPr>
-            <a:r>
-              <a:rPr lang="en-US" sz="2100">
-                <a:solidFill>
-                  <a:srgbClr val="D7E3EA"/>
-                </a:solidFill>
-              </a:rPr>
-              <a:t>Right rail keeps operational risk visible.</a:t>
-            </a:r>
-          </a:p>
-          <a:p>
-            <a:pPr marL="285750" indent="-171450">
-              <a:buChar char="•"/>
-            </a:pPr>
-            <a:r>
-              <a:rPr lang="en-US" sz="2100">
-                <a:solidFill>
-                  <a:srgbClr val="D7E3EA"/>
-                </a:solidFill>
-              </a:rPr>
-              <a:t>Fee recipient, oracle updater, slashing reserve, OI utilization, and incident runbook.</a:t>
-            </a:r>
-          </a:p>
-        </p:txBody>
-      </p:sp>
+            <a:off x="609600" y="1630000"/>
+            <a:ext cx="4600000" cy="4400000"/>
+          </a:xfrm>
+          <a:prstGeom prst="rect">
+            <a:avLst/>
+          </a:prstGeom>
+          <a:noFill/>
+        </p:spPr>
+        <p:txBody>
+          <a:bodyPr wrap="square"/>
+          <a:lstStyle/>
+          <a:p>
+            <a:pPr marL="285750" indent="-171450">
+              <a:buChar char="•"/>
+            </a:pPr>
+            <a:r>
+              <a:rPr lang="en-US" sz="2100">
+                <a:solidFill>
+                  <a:srgbClr val="D7E3EA"/>
+                </a:solidFill>
+              </a:rPr>
+              <a:t>The first screen is the usable operator console, not a landing page.</a:t>
+            </a:r>
+          </a:p>
+          <a:p>
+            <a:pPr marL="285750" indent="-171450">
+              <a:buChar char="•"/>
+            </a:pPr>
+            <a:r>
+              <a:rPr lang="en-US" sz="2100">
+                <a:solidFill>
+                  <a:srgbClr val="D7E3EA"/>
+                </a:solidFill>
+              </a:rPr>
+              <a:t>Vault capacity, APR, oracle cadence, risk state, market rail, fee model, deposit ticket, and monitor are visible in one workflow.</a:t>
+            </a:r>
+          </a:p>
+        </p:txBody>
+      </p:sp>
+      <p:pic>
+        <p:nvPicPr>
+          <p:cNvPr id="5" name="demo-dashboard.png"/>
+          <p:cNvPicPr/>
+          <p:nvPr/>
+        </p:nvPicPr>
+        <p:blipFill>
+          <a:blip r:embed="rId1"/>
+          <a:stretch>
+            <a:fillRect/>
+          </a:stretch>
+        </p:blipFill>
+        <p:spPr>
+          <a:xfrm>
+            <a:off x="5450000" y="1500000"/>
+            <a:ext cx="6130000" cy="3450000"/>
+          </a:xfrm>
+          <a:prstGeom prst="rect">
+            <a:avLst/>
+          </a:prstGeom>
+        </p:spPr>
+      </p:pic>
       <p:sp>
         <p:nvSpPr>
           <p:cNvPr id="4" name="Footer"/>
@@ -333,7 +359,7 @@
         <p:spPr>
           <a:xfrm>
             <a:off x="609600" y="6400800"/>
-            <a:ext cx="7924800" cy="300000"/>
+            <a:ext cx="10500000" cy="300000"/>
           </a:xfrm>
           <a:prstGeom prst="rect">
             <a:avLst/>
@@ -395,25 +421,25 @@
         </p:nvSpPr>
         <p:spPr>
           <a:xfrm>
-            <a:off x="609600" y="640080"/>
-            <a:ext cx="7924800" cy="1005840"/>
-          </a:xfrm>
-          <a:prstGeom prst="rect">
-            <a:avLst/>
-          </a:prstGeom>
-          <a:noFill/>
-        </p:spPr>
-        <p:txBody>
-          <a:bodyPr wrap="square"/>
-          <a:lstStyle/>
-          <a:p>
-            <a:r>
-              <a:rPr lang="en-US" sz="4300" b="1">
+            <a:off x="609600" y="610000"/>
+            <a:ext cx="10300000" cy="850000"/>
+          </a:xfrm>
+          <a:prstGeom prst="rect">
+            <a:avLst/>
+          </a:prstGeom>
+          <a:noFill/>
+        </p:spPr>
+        <p:txBody>
+          <a:bodyPr wrap="square"/>
+          <a:lstStyle/>
+          <a:p>
+            <a:r>
+              <a:rPr lang="en-US" sz="4100" b="1">
                 <a:solidFill>
                   <a:srgbClr val="F4F7F8"/>
                 </a:solidFill>
               </a:rPr>
-              <a:t>System Flow</a:t>
+              <a:t>Demo: Fee Model</a:t>
             </a:r>
           </a:p>
         </p:txBody>
@@ -427,79 +453,40 @@
         <p:spPr>
           <a:xfrm>
             <a:off x="914400" y="1905000"/>
-            <a:ext cx="7924800" cy="3657600"/>
-          </a:xfrm>
-          <a:prstGeom prst="rect">
-            <a:avLst/>
-          </a:prstGeom>
-          <a:noFill/>
-        </p:spPr>
-        <p:txBody>
-          <a:bodyPr wrap="square"/>
-          <a:lstStyle/>
-          <a:p>
-            <a:pPr marL="285750" indent="-171450">
-              <a:buChar char="•"/>
-            </a:pPr>
-            <a:r>
-              <a:rPr lang="en-US" sz="2100">
-                <a:solidFill>
-                  <a:srgbClr val="D7E3EA"/>
-                </a:solidFill>
-              </a:rPr>
-              <a:t>1. HYPE holders deposit into vault.</a:t>
-            </a:r>
-          </a:p>
-          <a:p>
-            <a:pPr marL="285750" indent="-171450">
-              <a:buChar char="•"/>
-            </a:pPr>
-            <a:r>
-              <a:rPr lang="en-US" sz="2100">
-                <a:solidFill>
-                  <a:srgbClr val="D7E3EA"/>
-                </a:solidFill>
-              </a:rPr>
-              <a:t>2. Vault backs HIP.markets deployer stake.</a:t>
-            </a:r>
-          </a:p>
-          <a:p>
-            <a:pPr marL="285750" indent="-171450">
-              <a:buChar char="•"/>
-            </a:pPr>
-            <a:r>
-              <a:rPr lang="en-US" sz="2100">
-                <a:solidFill>
-                  <a:srgbClr val="D7E3EA"/>
-                </a:solidFill>
-              </a:rPr>
-              <a:t>3. HIP.markets launches first three HIP-3 markets.</a:t>
-            </a:r>
-          </a:p>
-          <a:p>
-            <a:pPr marL="285750" indent="-171450">
-              <a:buChar char="•"/>
-            </a:pPr>
-            <a:r>
-              <a:rPr lang="en-US" sz="2100">
-                <a:solidFill>
-                  <a:srgbClr val="D7E3EA"/>
-                </a:solidFill>
-              </a:rPr>
-              <a:t>4. Traders generate fees.</a:t>
-            </a:r>
-          </a:p>
-          <a:p>
-            <a:pPr marL="285750" indent="-171450">
-              <a:buChar char="•"/>
-            </a:pPr>
-            <a:r>
-              <a:rPr lang="en-US" sz="2100">
-                <a:solidFill>
-                  <a:srgbClr val="D7E3EA"/>
-                </a:solidFill>
-              </a:rPr>
-              <a:t>5. Net fees distribute to stakers.</a:t>
+            <a:ext cx="9800000" cy="3900000"/>
+          </a:xfrm>
+          <a:prstGeom prst="rect">
+            <a:avLst/>
+          </a:prstGeom>
+          <a:noFill/>
+        </p:spPr>
+        <p:txBody>
+          <a:bodyPr wrap="square"/>
+          <a:lstStyle/>
+          <a:p>
+            <a:pPr marL="285750" indent="-171450">
+              <a:buChar char="•"/>
+            </a:pPr>
+            <a:r>
+              <a:rPr lang="en-US" sz="2100">
+                <a:solidFill>
+                  <a:srgbClr val="D7E3EA"/>
+                </a:solidFill>
+              </a:rPr>
+              <a:t>Judges can change HYPE price, staked HYPE, daily volume, fee bps, builder share, operating fee, protocol fee, and reserve.</a:t>
+            </a:r>
+          </a:p>
+          <a:p>
+            <a:pPr marL="285750" indent="-171450">
+              <a:buChar char="•"/>
+            </a:pPr>
+            <a:r>
+              <a:rPr lang="en-US" sz="2100">
+                <a:solidFill>
+                  <a:srgbClr val="D7E3EA"/>
+                </a:solidFill>
+              </a:rPr>
+              <a:t>APR updates instantly.</a:t>
             </a:r>
           </a:p>
         </p:txBody>
@@ -513,7 +500,7 @@
         <p:spPr>
           <a:xfrm>
             <a:off x="609600" y="6400800"/>
-            <a:ext cx="7924800" cy="300000"/>
+            <a:ext cx="10500000" cy="300000"/>
           </a:xfrm>
           <a:prstGeom prst="rect">
             <a:avLst/>
@@ -575,25 +562,25 @@
         </p:nvSpPr>
         <p:spPr>
           <a:xfrm>
-            <a:off x="609600" y="640080"/>
-            <a:ext cx="7924800" cy="1005840"/>
-          </a:xfrm>
-          <a:prstGeom prst="rect">
-            <a:avLst/>
-          </a:prstGeom>
-          <a:noFill/>
-        </p:spPr>
-        <p:txBody>
-          <a:bodyPr wrap="square"/>
-          <a:lstStyle/>
-          <a:p>
-            <a:r>
-              <a:rPr lang="en-US" sz="4300" b="1">
+            <a:off x="609600" y="610000"/>
+            <a:ext cx="10300000" cy="850000"/>
+          </a:xfrm>
+          <a:prstGeom prst="rect">
+            <a:avLst/>
+          </a:prstGeom>
+          <a:noFill/>
+        </p:spPr>
+        <p:txBody>
+          <a:bodyPr wrap="square"/>
+          <a:lstStyle/>
+          <a:p>
+            <a:r>
+              <a:rPr lang="en-US" sz="4100" b="1">
                 <a:solidFill>
                   <a:srgbClr val="F4F7F8"/>
                 </a:solidFill>
               </a:rPr>
-              <a:t>Economics</a:t>
+              <a:t>Demo: Deposit Ticket</a:t>
             </a:r>
           </a:p>
         </p:txBody>
@@ -607,53 +594,40 @@
         <p:spPr>
           <a:xfrm>
             <a:off x="914400" y="1905000"/>
-            <a:ext cx="7924800" cy="3657600"/>
-          </a:xfrm>
-          <a:prstGeom prst="rect">
-            <a:avLst/>
-          </a:prstGeom>
-          <a:noFill/>
-        </p:spPr>
-        <p:txBody>
-          <a:bodyPr wrap="square"/>
-          <a:lstStyle/>
-          <a:p>
-            <a:pPr marL="285750" indent="-171450">
-              <a:buChar char="•"/>
-            </a:pPr>
-            <a:r>
-              <a:rPr lang="en-US" sz="2100">
-                <a:solidFill>
-                  <a:srgbClr val="D7E3EA"/>
-                </a:solidFill>
-              </a:rPr>
-              <a:t>Base model: 500k HYPE, $50M daily volume, 6 bps fee, 50% deployer share.</a:t>
-            </a:r>
-          </a:p>
-          <a:p>
-            <a:pPr marL="285750" indent="-171450">
-              <a:buChar char="•"/>
-            </a:pPr>
-            <a:r>
-              <a:rPr lang="en-US" sz="2100">
-                <a:solidFill>
-                  <a:srgbClr val="D7E3EA"/>
-                </a:solidFill>
-              </a:rPr>
-              <a:t>After 40% operating/protocol/reserve deductions: approximately 15% net APR.</a:t>
-            </a:r>
-          </a:p>
-          <a:p>
-            <a:pPr marL="285750" indent="-171450">
-              <a:buChar char="•"/>
-            </a:pPr>
-            <a:r>
-              <a:rPr lang="en-US" sz="2100">
-                <a:solidFill>
-                  <a:srgbClr val="D7E3EA"/>
-                </a:solidFill>
-              </a:rPr>
-              <a:t>Sensitivity matters more than headline APR.</a:t>
+            <a:ext cx="9800000" cy="3900000"/>
+          </a:xfrm>
+          <a:prstGeom prst="rect">
+            <a:avLst/>
+          </a:prstGeom>
+          <a:noFill/>
+        </p:spPr>
+        <p:txBody>
+          <a:bodyPr wrap="square"/>
+          <a:lstStyle/>
+          <a:p>
+            <a:pPr marL="285750" indent="-171450">
+              <a:buChar char="•"/>
+            </a:pPr>
+            <a:r>
+              <a:rPr lang="en-US" sz="2100">
+                <a:solidFill>
+                  <a:srgbClr val="D7E3EA"/>
+                </a:solidFill>
+              </a:rPr>
+              <a:t>Mirrors a trading order pane.</a:t>
+            </a:r>
+          </a:p>
+          <a:p>
+            <a:pPr marL="285750" indent="-171450">
+              <a:buChar char="•"/>
+            </a:pPr>
+            <a:r>
+              <a:rPr lang="en-US" sz="2100">
+                <a:solidFill>
+                  <a:srgbClr val="D7E3EA"/>
+                </a:solidFill>
+              </a:rPr>
+              <a:t>Amount input, deposit/withdraw mode, fee summary, user rewards estimate, and slashing warning.</a:t>
             </a:r>
           </a:p>
         </p:txBody>
@@ -667,7 +641,7 @@
         <p:spPr>
           <a:xfrm>
             <a:off x="609600" y="6400800"/>
-            <a:ext cx="7924800" cy="300000"/>
+            <a:ext cx="10500000" cy="300000"/>
           </a:xfrm>
           <a:prstGeom prst="rect">
             <a:avLst/>
@@ -729,25 +703,25 @@
         </p:nvSpPr>
         <p:spPr>
           <a:xfrm>
-            <a:off x="609600" y="640080"/>
-            <a:ext cx="7924800" cy="1005840"/>
-          </a:xfrm>
-          <a:prstGeom prst="rect">
-            <a:avLst/>
-          </a:prstGeom>
-          <a:noFill/>
-        </p:spPr>
-        <p:txBody>
-          <a:bodyPr wrap="square"/>
-          <a:lstStyle/>
-          <a:p>
-            <a:r>
-              <a:rPr lang="en-US" sz="4300" b="1">
+            <a:off x="609600" y="610000"/>
+            <a:ext cx="10300000" cy="850000"/>
+          </a:xfrm>
+          <a:prstGeom prst="rect">
+            <a:avLst/>
+          </a:prstGeom>
+          <a:noFill/>
+        </p:spPr>
+        <p:txBody>
+          <a:bodyPr wrap="square"/>
+          <a:lstStyle/>
+          <a:p>
+            <a:r>
+              <a:rPr lang="en-US" sz="4100" b="1">
                 <a:solidFill>
                   <a:srgbClr val="F4F7F8"/>
                 </a:solidFill>
               </a:rPr>
-              <a:t>Risk Controls</a:t>
+              <a:t>Demo: Audit Ledger</a:t>
             </a:r>
           </a:p>
         </p:txBody>
@@ -760,58 +734,67 @@
         </p:nvSpPr>
         <p:spPr>
           <a:xfrm>
-            <a:off x="914400" y="1905000"/>
-            <a:ext cx="7924800" cy="3657600"/>
-          </a:xfrm>
-          <a:prstGeom prst="rect">
-            <a:avLst/>
-          </a:prstGeom>
-          <a:noFill/>
-        </p:spPr>
-        <p:txBody>
-          <a:bodyPr wrap="square"/>
-          <a:lstStyle/>
-          <a:p>
-            <a:pPr marL="285750" indent="-171450">
-              <a:buChar char="•"/>
-            </a:pPr>
-            <a:r>
-              <a:rPr lang="en-US" sz="2100">
-                <a:solidFill>
-                  <a:srgbClr val="D7E3EA"/>
-                </a:solidFill>
-              </a:rPr>
-              <a:t>Start with oracle-simple markets.</a:t>
-            </a:r>
-          </a:p>
-          <a:p>
-            <a:pPr marL="285750" indent="-171450">
-              <a:buChar char="•"/>
-            </a:pPr>
-            <a:r>
-              <a:rPr lang="en-US" sz="2100">
-                <a:solidFill>
-                  <a:srgbClr val="D7E3EA"/>
-                </a:solidFill>
-              </a:rPr>
-              <a:t>Avoid extra ticker auction costs at launch.</a:t>
-            </a:r>
-          </a:p>
-          <a:p>
-            <a:pPr marL="285750" indent="-171450">
-              <a:buChar char="•"/>
-            </a:pPr>
-            <a:r>
-              <a:rPr lang="en-US" sz="2100">
-                <a:solidFill>
-                  <a:srgbClr val="D7E3EA"/>
-                </a:solidFill>
-              </a:rPr>
-              <a:t>Cap open interest, publish addresses, maintain reserve, pause deposits during incidents.</a:t>
-            </a:r>
-          </a:p>
-        </p:txBody>
-      </p:sp>
+            <a:off x="609600" y="1630000"/>
+            <a:ext cx="4600000" cy="4400000"/>
+          </a:xfrm>
+          <a:prstGeom prst="rect">
+            <a:avLst/>
+          </a:prstGeom>
+          <a:noFill/>
+        </p:spPr>
+        <p:txBody>
+          <a:bodyPr wrap="square"/>
+          <a:lstStyle/>
+          <a:p>
+            <a:pPr marL="285750" indent="-171450">
+              <a:buChar char="•"/>
+            </a:pPr>
+            <a:r>
+              <a:rPr lang="en-US" sz="2100">
+                <a:solidFill>
+                  <a:srgbClr val="D7E3EA"/>
+                </a:solidFill>
+              </a:rPr>
+              <a:t>Fee sharing becomes an inspectable ledger.</a:t>
+            </a:r>
+          </a:p>
+          <a:p>
+            <a:pPr marL="285750" indent="-171450">
+              <a:buChar char="•"/>
+            </a:pPr>
+            <a:r>
+              <a:rPr lang="en-US" sz="2100">
+                <a:solidFill>
+                  <a:srgbClr val="D7E3EA"/>
+                </a:solidFill>
+              </a:rPr>
+              <a:t>Vault shares, fee history, oracle updates, and market launch readiness expose operator behavior.</a:t>
+            </a:r>
+          </a:p>
+        </p:txBody>
+      </p:sp>
+      <p:pic>
+        <p:nvPicPr>
+          <p:cNvPr id="5" name="demo-fee-ledger-view.png"/>
+          <p:cNvPicPr/>
+          <p:nvPr/>
+        </p:nvPicPr>
+        <p:blipFill>
+          <a:blip r:embed="rId1"/>
+          <a:stretch>
+            <a:fillRect/>
+          </a:stretch>
+        </p:blipFill>
+        <p:spPr>
+          <a:xfrm>
+            <a:off x="5450000" y="1500000"/>
+            <a:ext cx="6130000" cy="3450000"/>
+          </a:xfrm>
+          <a:prstGeom prst="rect">
+            <a:avLst/>
+          </a:prstGeom>
+        </p:spPr>
+      </p:pic>
       <p:sp>
         <p:nvSpPr>
           <p:cNvPr id="4" name="Footer"/>
@@ -821,7 +804,7 @@
         <p:spPr>
           <a:xfrm>
             <a:off x="609600" y="6400800"/>
-            <a:ext cx="7924800" cy="300000"/>
+            <a:ext cx="10500000" cy="300000"/>
           </a:xfrm>
           <a:prstGeom prst="rect">
             <a:avLst/>
@@ -883,25 +866,25 @@
         </p:nvSpPr>
         <p:spPr>
           <a:xfrm>
-            <a:off x="609600" y="640080"/>
-            <a:ext cx="7924800" cy="1005840"/>
-          </a:xfrm>
-          <a:prstGeom prst="rect">
-            <a:avLst/>
-          </a:prstGeom>
-          <a:noFill/>
-        </p:spPr>
-        <p:txBody>
-          <a:bodyPr wrap="square"/>
-          <a:lstStyle/>
-          <a:p>
-            <a:r>
-              <a:rPr lang="en-US" sz="4300" b="1">
+            <a:off x="609600" y="610000"/>
+            <a:ext cx="10300000" cy="850000"/>
+          </a:xfrm>
+          <a:prstGeom prst="rect">
+            <a:avLst/>
+          </a:prstGeom>
+          <a:noFill/>
+        </p:spPr>
+        <p:txBody>
+          <a:bodyPr wrap="square"/>
+          <a:lstStyle/>
+          <a:p>
+            <a:r>
+              <a:rPr lang="en-US" sz="4100" b="1">
                 <a:solidFill>
                   <a:srgbClr val="F4F7F8"/>
                 </a:solidFill>
               </a:rPr>
-              <a:t>MVP</a:t>
+              <a:t>System Flow</a:t>
             </a:r>
           </a:p>
         </p:txBody>
@@ -915,92 +898,79 @@
         <p:spPr>
           <a:xfrm>
             <a:off x="914400" y="1905000"/>
-            <a:ext cx="7924800" cy="3657600"/>
-          </a:xfrm>
-          <a:prstGeom prst="rect">
-            <a:avLst/>
-          </a:prstGeom>
-          <a:noFill/>
-        </p:spPr>
-        <p:txBody>
-          <a:bodyPr wrap="square"/>
-          <a:lstStyle/>
-          <a:p>
-            <a:pPr marL="285750" indent="-171450">
-              <a:buChar char="•"/>
-            </a:pPr>
-            <a:r>
-              <a:rPr lang="en-US" sz="2100">
-                <a:solidFill>
-                  <a:srgbClr val="D7E3EA"/>
-                </a:solidFill>
-              </a:rPr>
-              <a:t>One HIP.markets-operated DEX.</a:t>
-            </a:r>
-          </a:p>
-          <a:p>
-            <a:pPr marL="285750" indent="-171450">
-              <a:buChar char="•"/>
-            </a:pPr>
-            <a:r>
-              <a:rPr lang="en-US" sz="2100">
-                <a:solidFill>
-                  <a:srgbClr val="D7E3EA"/>
-                </a:solidFill>
-              </a:rPr>
-              <a:t>One HYPE vault.</a:t>
-            </a:r>
-          </a:p>
-          <a:p>
-            <a:pPr marL="285750" indent="-171450">
-              <a:buChar char="•"/>
-            </a:pPr>
-            <a:r>
-              <a:rPr lang="en-US" sz="2100">
-                <a:solidFill>
-                  <a:srgbClr val="D7E3EA"/>
-                </a:solidFill>
-              </a:rPr>
-              <a:t>First three markets.</a:t>
-            </a:r>
-          </a:p>
-          <a:p>
-            <a:pPr marL="285750" indent="-171450">
-              <a:buChar char="•"/>
-            </a:pPr>
-            <a:r>
-              <a:rPr lang="en-US" sz="2100">
-                <a:solidFill>
-                  <a:srgbClr val="D7E3EA"/>
-                </a:solidFill>
-              </a:rPr>
-              <a:t>Weekly distributions.</a:t>
-            </a:r>
-          </a:p>
-          <a:p>
-            <a:pPr marL="285750" indent="-171450">
-              <a:buChar char="•"/>
-            </a:pPr>
-            <a:r>
-              <a:rPr lang="en-US" sz="2100">
-                <a:solidFill>
-                  <a:srgbClr val="D7E3EA"/>
-                </a:solidFill>
-              </a:rPr>
-              <a:t>Public dashboard.</a:t>
-            </a:r>
-          </a:p>
-          <a:p>
-            <a:pPr marL="285750" indent="-171450">
-              <a:buChar char="•"/>
-            </a:pPr>
-            <a:r>
-              <a:rPr lang="en-US" sz="2100">
-                <a:solidFill>
-                  <a:srgbClr val="D7E3EA"/>
-                </a:solidFill>
-              </a:rPr>
-              <a:t>No third-party operator financing.</a:t>
+            <a:ext cx="9800000" cy="3900000"/>
+          </a:xfrm>
+          <a:prstGeom prst="rect">
+            <a:avLst/>
+          </a:prstGeom>
+          <a:noFill/>
+        </p:spPr>
+        <p:txBody>
+          <a:bodyPr wrap="square"/>
+          <a:lstStyle/>
+          <a:p>
+            <a:pPr marL="285750" indent="-171450">
+              <a:buChar char="•"/>
+            </a:pPr>
+            <a:r>
+              <a:rPr lang="en-US" sz="2100">
+                <a:solidFill>
+                  <a:srgbClr val="D7E3EA"/>
+                </a:solidFill>
+              </a:rPr>
+              <a:t>1. HYPE holders deposit into the HyperEVM vault.</a:t>
+            </a:r>
+          </a:p>
+          <a:p>
+            <a:pPr marL="285750" indent="-171450">
+              <a:buChar char="•"/>
+            </a:pPr>
+            <a:r>
+              <a:rPr lang="en-US" sz="2100">
+                <a:solidFill>
+                  <a:srgbClr val="D7E3EA"/>
+                </a:solidFill>
+              </a:rPr>
+              <a:t>2. Vault backs HIP.markets deployer stake.</a:t>
+            </a:r>
+          </a:p>
+          <a:p>
+            <a:pPr marL="285750" indent="-171450">
+              <a:buChar char="•"/>
+            </a:pPr>
+            <a:r>
+              <a:rPr lang="en-US" sz="2100">
+                <a:solidFill>
+                  <a:srgbClr val="D7E3EA"/>
+                </a:solidFill>
+              </a:rPr>
+              <a:t>3. HIP.markets launches the first three HIP-3 markets.</a:t>
+            </a:r>
+          </a:p>
+          <a:p>
+            <a:pPr marL="285750" indent="-171450">
+              <a:buChar char="•"/>
+            </a:pPr>
+            <a:r>
+              <a:rPr lang="en-US" sz="2100">
+                <a:solidFill>
+                  <a:srgbClr val="D7E3EA"/>
+                </a:solidFill>
+              </a:rPr>
+              <a:t>4. Traders generate fees.</a:t>
+            </a:r>
+          </a:p>
+          <a:p>
+            <a:pPr marL="285750" indent="-171450">
+              <a:buChar char="•"/>
+            </a:pPr>
+            <a:r>
+              <a:rPr lang="en-US" sz="2100">
+                <a:solidFill>
+                  <a:srgbClr val="D7E3EA"/>
+                </a:solidFill>
+              </a:rPr>
+              <a:t>5. Net fees distribute after operating, protocol, and reserve deductions.</a:t>
             </a:r>
           </a:p>
         </p:txBody>
@@ -1014,7 +984,7 @@
         <p:spPr>
           <a:xfrm>
             <a:off x="609600" y="6400800"/>
-            <a:ext cx="7924800" cy="300000"/>
+            <a:ext cx="10500000" cy="300000"/>
           </a:xfrm>
           <a:prstGeom prst="rect">
             <a:avLst/>
@@ -1076,25 +1046,25 @@
         </p:nvSpPr>
         <p:spPr>
           <a:xfrm>
-            <a:off x="609600" y="640080"/>
-            <a:ext cx="7924800" cy="1005840"/>
-          </a:xfrm>
-          <a:prstGeom prst="rect">
-            <a:avLst/>
-          </a:prstGeom>
-          <a:noFill/>
-        </p:spPr>
-        <p:txBody>
-          <a:bodyPr wrap="square"/>
-          <a:lstStyle/>
-          <a:p>
-            <a:r>
-              <a:rPr lang="en-US" sz="4300" b="1">
+            <a:off x="609600" y="610000"/>
+            <a:ext cx="10300000" cy="850000"/>
+          </a:xfrm>
+          <a:prstGeom prst="rect">
+            <a:avLst/>
+          </a:prstGeom>
+          <a:noFill/>
+        </p:spPr>
+        <p:txBody>
+          <a:bodyPr wrap="square"/>
+          <a:lstStyle/>
+          <a:p>
+            <a:r>
+              <a:rPr lang="en-US" sz="4100" b="1">
                 <a:solidFill>
                   <a:srgbClr val="F4F7F8"/>
                 </a:solidFill>
               </a:rPr>
-              <a:t>Roadmap</a:t>
+              <a:t>Economics</a:t>
             </a:r>
           </a:p>
         </p:txBody>
@@ -1108,53 +1078,66 @@
         <p:spPr>
           <a:xfrm>
             <a:off x="914400" y="1905000"/>
-            <a:ext cx="7924800" cy="3657600"/>
-          </a:xfrm>
-          <a:prstGeom prst="rect">
-            <a:avLst/>
-          </a:prstGeom>
-          <a:noFill/>
-        </p:spPr>
-        <p:txBody>
-          <a:bodyPr wrap="square"/>
-          <a:lstStyle/>
-          <a:p>
-            <a:pPr marL="285750" indent="-171450">
-              <a:buChar char="•"/>
-            </a:pPr>
-            <a:r>
-              <a:rPr lang="en-US" sz="2100">
-                <a:solidFill>
-                  <a:srgbClr val="D7E3EA"/>
-                </a:solidFill>
-              </a:rPr>
-              <a:t>V1: prove operator vault and fee sharing.</a:t>
-            </a:r>
-          </a:p>
-          <a:p>
-            <a:pPr marL="285750" indent="-171450">
-              <a:buChar char="•"/>
-            </a:pPr>
-            <a:r>
-              <a:rPr lang="en-US" sz="2100">
-                <a:solidFill>
-                  <a:srgbClr val="D7E3EA"/>
-                </a:solidFill>
-              </a:rPr>
-              <a:t>V2: more HIP.markets market vaults and automated fee verification.</a:t>
-            </a:r>
-          </a:p>
-          <a:p>
-            <a:pPr marL="285750" indent="-171450">
-              <a:buChar char="•"/>
-            </a:pPr>
-            <a:r>
-              <a:rPr lang="en-US" sz="2100">
-                <a:solidFill>
-                  <a:srgbClr val="D7E3EA"/>
-                </a:solidFill>
-              </a:rPr>
-              <a:t>V3: risk tranching, secondary shares, HIP-4, possible third-party financing.</a:t>
+            <a:ext cx="9800000" cy="3900000"/>
+          </a:xfrm>
+          <a:prstGeom prst="rect">
+            <a:avLst/>
+          </a:prstGeom>
+          <a:noFill/>
+        </p:spPr>
+        <p:txBody>
+          <a:bodyPr wrap="square"/>
+          <a:lstStyle/>
+          <a:p>
+            <a:pPr marL="285750" indent="-171450">
+              <a:buChar char="•"/>
+            </a:pPr>
+            <a:r>
+              <a:rPr lang="en-US" sz="2100">
+                <a:solidFill>
+                  <a:srgbClr val="D7E3EA"/>
+                </a:solidFill>
+              </a:rPr>
+              <a:t>Base model: 500k HYPE, $50M daily volume, 6 bps fee, 50% deployer share.</a:t>
+            </a:r>
+          </a:p>
+          <a:p>
+            <a:pPr marL="285750" indent="-171450">
+              <a:buChar char="•"/>
+            </a:pPr>
+            <a:r>
+              <a:rPr lang="en-US" sz="2100">
+                <a:solidFill>
+                  <a:srgbClr val="D7E3EA"/>
+                </a:solidFill>
+              </a:rPr>
+              <a:t>After 40% operating/protocol/reserve deductions: approximately 15% net APR.</a:t>
+            </a:r>
+          </a:p>
+          <a:p>
+            <a:pPr marL="285750" indent="-171450">
+              <a:buChar char="•"/>
+            </a:pPr>
+            <a:r>
+              <a:rPr lang="en-US" sz="2100">
+                <a:solidFill>
+                  <a:srgbClr val="D7E3EA"/>
+                </a:solidFill>
+              </a:rPr>
+              <a:t>Trade.xyz trailing fees imply approximately 3.47% gross APR on the minimum stake.</a:t>
+            </a:r>
+          </a:p>
+          <a:p>
+            <a:pPr marL="285750" indent="-171450">
+              <a:buChar char="•"/>
+            </a:pPr>
+            <a:r>
+              <a:rPr lang="en-US" sz="2100">
+                <a:solidFill>
+                  <a:srgbClr val="D7E3EA"/>
+                </a:solidFill>
+              </a:rPr>
+              <a:t>Sensitivity matters more than headline APR.</a:t>
             </a:r>
           </a:p>
         </p:txBody>
@@ -1168,7 +1151,7 @@
         <p:spPr>
           <a:xfrm>
             <a:off x="609600" y="6400800"/>
-            <a:ext cx="7924800" cy="300000"/>
+            <a:ext cx="10500000" cy="300000"/>
           </a:xfrm>
           <a:prstGeom prst="rect">
             <a:avLst/>
@@ -1230,25 +1213,25 @@
         </p:nvSpPr>
         <p:spPr>
           <a:xfrm>
-            <a:off x="609600" y="640080"/>
-            <a:ext cx="7924800" cy="1005840"/>
-          </a:xfrm>
-          <a:prstGeom prst="rect">
-            <a:avLst/>
-          </a:prstGeom>
-          <a:noFill/>
-        </p:spPr>
-        <p:txBody>
-          <a:bodyPr wrap="square"/>
-          <a:lstStyle/>
-          <a:p>
-            <a:r>
-              <a:rPr lang="en-US" sz="4300" b="1">
+            <a:off x="609600" y="610000"/>
+            <a:ext cx="10300000" cy="850000"/>
+          </a:xfrm>
+          <a:prstGeom prst="rect">
+            <a:avLst/>
+          </a:prstGeom>
+          <a:noFill/>
+        </p:spPr>
+        <p:txBody>
+          <a:bodyPr wrap="square"/>
+          <a:lstStyle/>
+          <a:p>
+            <a:r>
+              <a:rPr lang="en-US" sz="4100" b="1">
                 <a:solidFill>
                   <a:srgbClr val="F4F7F8"/>
                 </a:solidFill>
               </a:rPr>
-              <a:t>Competitive Position</a:t>
+              <a:t>Risk Controls</a:t>
             </a:r>
           </a:p>
         </p:txBody>
@@ -1262,53 +1245,53 @@
         <p:spPr>
           <a:xfrm>
             <a:off x="914400" y="1905000"/>
-            <a:ext cx="7924800" cy="3657600"/>
-          </a:xfrm>
-          <a:prstGeom prst="rect">
-            <a:avLst/>
-          </a:prstGeom>
-          <a:noFill/>
-        </p:spPr>
-        <p:txBody>
-          <a:bodyPr wrap="square"/>
-          <a:lstStyle/>
-          <a:p>
-            <a:pPr marL="285750" indent="-171450">
-              <a:buChar char="•"/>
-            </a:pPr>
-            <a:r>
-              <a:rPr lang="en-US" sz="2100">
-                <a:solidFill>
-                  <a:srgbClr val="D7E3EA"/>
-                </a:solidFill>
-              </a:rPr>
-              <a:t>trade.xyz and HyENA operate markets directly.</a:t>
-            </a:r>
-          </a:p>
-          <a:p>
-            <a:pPr marL="285750" indent="-171450">
-              <a:buChar char="•"/>
-            </a:pPr>
-            <a:r>
-              <a:rPr lang="en-US" sz="2100">
-                <a:solidFill>
-                  <a:srgbClr val="D7E3EA"/>
-                </a:solidFill>
-              </a:rPr>
-              <a:t>HIP.markets also operates markets directly, but adds user-funded HYPE stake and transparent fee sharing.</a:t>
-            </a:r>
-          </a:p>
-          <a:p>
-            <a:pPr marL="285750" indent="-171450">
-              <a:buChar char="•"/>
-            </a:pPr>
-            <a:r>
-              <a:rPr lang="en-US" sz="2100">
-                <a:solidFill>
-                  <a:srgbClr val="D7E3EA"/>
-                </a:solidFill>
-              </a:rPr>
-              <a:t>The wedge is making HYPE holders economic backers of the operator.</a:t>
+            <a:ext cx="9800000" cy="3900000"/>
+          </a:xfrm>
+          <a:prstGeom prst="rect">
+            <a:avLst/>
+          </a:prstGeom>
+          <a:noFill/>
+        </p:spPr>
+        <p:txBody>
+          <a:bodyPr wrap="square"/>
+          <a:lstStyle/>
+          <a:p>
+            <a:pPr marL="285750" indent="-171450">
+              <a:buChar char="•"/>
+            </a:pPr>
+            <a:r>
+              <a:rPr lang="en-US" sz="2100">
+                <a:solidFill>
+                  <a:srgbClr val="D7E3EA"/>
+                </a:solidFill>
+              </a:rPr>
+              <a:t>Start with oracle-simple markets.</a:t>
+            </a:r>
+          </a:p>
+          <a:p>
+            <a:pPr marL="285750" indent="-171450">
+              <a:buChar char="•"/>
+            </a:pPr>
+            <a:r>
+              <a:rPr lang="en-US" sz="2100">
+                <a:solidFill>
+                  <a:srgbClr val="D7E3EA"/>
+                </a:solidFill>
+              </a:rPr>
+              <a:t>Avoid extra ticker auction costs at launch.</a:t>
+            </a:r>
+          </a:p>
+          <a:p>
+            <a:pPr marL="285750" indent="-171450">
+              <a:buChar char="•"/>
+            </a:pPr>
+            <a:r>
+              <a:rPr lang="en-US" sz="2100">
+                <a:solidFill>
+                  <a:srgbClr val="D7E3EA"/>
+                </a:solidFill>
+              </a:rPr>
+              <a:t>Cap open interest, publish addresses, maintain reserve, pause deposits during incidents.</a:t>
             </a:r>
           </a:p>
         </p:txBody>
@@ -1322,7 +1305,7 @@
         <p:spPr>
           <a:xfrm>
             <a:off x="609600" y="6400800"/>
-            <a:ext cx="7924800" cy="300000"/>
+            <a:ext cx="10500000" cy="300000"/>
           </a:xfrm>
           <a:prstGeom prst="rect">
             <a:avLst/>
@@ -1384,25 +1367,25 @@
         </p:nvSpPr>
         <p:spPr>
           <a:xfrm>
-            <a:off x="609600" y="640080"/>
-            <a:ext cx="7924800" cy="1005840"/>
-          </a:xfrm>
-          <a:prstGeom prst="rect">
-            <a:avLst/>
-          </a:prstGeom>
-          <a:noFill/>
-        </p:spPr>
-        <p:txBody>
-          <a:bodyPr wrap="square"/>
-          <a:lstStyle/>
-          <a:p>
-            <a:r>
-              <a:rPr lang="en-US" sz="4300" b="1">
+            <a:off x="609600" y="610000"/>
+            <a:ext cx="10300000" cy="850000"/>
+          </a:xfrm>
+          <a:prstGeom prst="rect">
+            <a:avLst/>
+          </a:prstGeom>
+          <a:noFill/>
+        </p:spPr>
+        <p:txBody>
+          <a:bodyPr wrap="square"/>
+          <a:lstStyle/>
+          <a:p>
+            <a:r>
+              <a:rPr lang="en-US" sz="4100" b="1">
                 <a:solidFill>
                   <a:srgbClr val="F4F7F8"/>
                 </a:solidFill>
               </a:rPr>
-              <a:t>Ask</a:t>
+              <a:t>Cost Stack</a:t>
             </a:r>
           </a:p>
         </p:txBody>
@@ -1416,79 +1399,40 @@
         <p:spPr>
           <a:xfrm>
             <a:off x="914400" y="1905000"/>
-            <a:ext cx="7924800" cy="3657600"/>
-          </a:xfrm>
-          <a:prstGeom prst="rect">
-            <a:avLst/>
-          </a:prstGeom>
-          <a:noFill/>
-        </p:spPr>
-        <p:txBody>
-          <a:bodyPr wrap="square"/>
-          <a:lstStyle/>
-          <a:p>
-            <a:pPr marL="285750" indent="-171450">
-              <a:buChar char="•"/>
-            </a:pPr>
-            <a:r>
-              <a:rPr lang="en-US" sz="2100">
-                <a:solidFill>
-                  <a:srgbClr val="D7E3EA"/>
-                </a:solidFill>
-              </a:rPr>
-              <a:t>HYPE holders for capped beta.</a:t>
-            </a:r>
-          </a:p>
-          <a:p>
-            <a:pPr marL="285750" indent="-171450">
-              <a:buChar char="•"/>
-            </a:pPr>
-            <a:r>
-              <a:rPr lang="en-US" sz="2100">
-                <a:solidFill>
-                  <a:srgbClr val="D7E3EA"/>
-                </a:solidFill>
-              </a:rPr>
-              <a:t>Market makers for first markets.</a:t>
-            </a:r>
-          </a:p>
-          <a:p>
-            <a:pPr marL="285750" indent="-171450">
-              <a:buChar char="•"/>
-            </a:pPr>
-            <a:r>
-              <a:rPr lang="en-US" sz="2100">
-                <a:solidFill>
-                  <a:srgbClr val="D7E3EA"/>
-                </a:solidFill>
-              </a:rPr>
-              <a:t>Oracle and data partners.</a:t>
-            </a:r>
-          </a:p>
-          <a:p>
-            <a:pPr marL="285750" indent="-171450">
-              <a:buChar char="•"/>
-            </a:pPr>
-            <a:r>
-              <a:rPr lang="en-US" sz="2100">
-                <a:solidFill>
-                  <a:srgbClr val="D7E3EA"/>
-                </a:solidFill>
-              </a:rPr>
-              <a:t>Security reviewers.</a:t>
-            </a:r>
-          </a:p>
-          <a:p>
-            <a:pPr marL="285750" indent="-171450">
-              <a:buChar char="•"/>
-            </a:pPr>
-            <a:r>
-              <a:rPr lang="en-US" sz="2100">
-                <a:solidFill>
-                  <a:srgbClr val="D7E3EA"/>
-                </a:solidFill>
-              </a:rPr>
-              <a:t>Hyperliquid feedback on custody and fee routing.</a:t>
+            <a:ext cx="9800000" cy="3900000"/>
+          </a:xfrm>
+          <a:prstGeom prst="rect">
+            <a:avLst/>
+          </a:prstGeom>
+          <a:noFill/>
+        </p:spPr>
+        <p:txBody>
+          <a:bodyPr wrap="square"/>
+          <a:lstStyle/>
+          <a:p>
+            <a:pPr marL="285750" indent="-171450">
+              <a:buChar char="•"/>
+            </a:pPr>
+            <a:r>
+              <a:rPr lang="en-US" sz="2100">
+                <a:solidFill>
+                  <a:srgbClr val="D7E3EA"/>
+                </a:solidFill>
+              </a:rPr>
+              <a:t>The 500k HYPE stake is the entry ticket, not the full cost of business.</a:t>
+            </a:r>
+          </a:p>
+          <a:p>
+            <a:pPr marL="285750" indent="-171450">
+              <a:buChar char="•"/>
+            </a:pPr>
+            <a:r>
+              <a:rPr lang="en-US" sz="2100">
+                <a:solidFill>
+                  <a:srgbClr val="D7E3EA"/>
+                </a:solidFill>
+              </a:rPr>
+              <a:t>Budget for oracle relayers, licensed data, maker incentives, infrastructure, key management, audits, legal work, and incident reserves.</a:t>
             </a:r>
           </a:p>
         </p:txBody>
@@ -1502,7 +1446,7 @@
         <p:spPr>
           <a:xfrm>
             <a:off x="609600" y="6400800"/>
-            <a:ext cx="7924800" cy="300000"/>
+            <a:ext cx="10500000" cy="300000"/>
           </a:xfrm>
           <a:prstGeom prst="rect">
             <a:avLst/>
@@ -1564,25 +1508,25 @@
         </p:nvSpPr>
         <p:spPr>
           <a:xfrm>
-            <a:off x="609600" y="640080"/>
-            <a:ext cx="7924800" cy="1005840"/>
-          </a:xfrm>
-          <a:prstGeom prst="rect">
-            <a:avLst/>
-          </a:prstGeom>
-          <a:noFill/>
-        </p:spPr>
-        <p:txBody>
-          <a:bodyPr wrap="square"/>
-          <a:lstStyle/>
-          <a:p>
-            <a:r>
-              <a:rPr lang="en-US" sz="4300" b="1">
+            <a:off x="609600" y="610000"/>
+            <a:ext cx="10300000" cy="850000"/>
+          </a:xfrm>
+          <a:prstGeom prst="rect">
+            <a:avLst/>
+          </a:prstGeom>
+          <a:noFill/>
+        </p:spPr>
+        <p:txBody>
+          <a:bodyPr wrap="square"/>
+          <a:lstStyle/>
+          <a:p>
+            <a:r>
+              <a:rPr lang="en-US" sz="4100" b="1">
                 <a:solidFill>
                   <a:srgbClr val="F4F7F8"/>
                 </a:solidFill>
               </a:rPr>
-              <a:t>Closing</a:t>
+              <a:t>MVP</a:t>
             </a:r>
           </a:p>
         </p:txBody>
@@ -1596,40 +1540,92 @@
         <p:spPr>
           <a:xfrm>
             <a:off x="914400" y="1905000"/>
-            <a:ext cx="7924800" cy="3657600"/>
-          </a:xfrm>
-          <a:prstGeom prst="rect">
-            <a:avLst/>
-          </a:prstGeom>
-          <a:noFill/>
-        </p:spPr>
-        <p:txBody>
-          <a:bodyPr wrap="square"/>
-          <a:lstStyle/>
-          <a:p>
-            <a:pPr marL="285750" indent="-171450">
-              <a:buChar char="•"/>
-            </a:pPr>
-            <a:r>
-              <a:rPr lang="en-US" sz="2100">
-                <a:solidFill>
-                  <a:srgbClr val="D7E3EA"/>
-                </a:solidFill>
-              </a:rPr>
-              <a:t>HIP.markets turns builder-deployed markets into a community-backed operator business.</a:t>
-            </a:r>
-          </a:p>
-          <a:p>
-            <a:pPr marL="285750" indent="-171450">
-              <a:buChar char="•"/>
-            </a:pPr>
-            <a:r>
-              <a:rPr lang="en-US" sz="2100">
-                <a:solidFill>
-                  <a:srgbClr val="D7E3EA"/>
-                </a:solidFill>
-              </a:rPr>
-              <a:t>The first job is operating markets safely.</a:t>
+            <a:ext cx="9800000" cy="3900000"/>
+          </a:xfrm>
+          <a:prstGeom prst="rect">
+            <a:avLst/>
+          </a:prstGeom>
+          <a:noFill/>
+        </p:spPr>
+        <p:txBody>
+          <a:bodyPr wrap="square"/>
+          <a:lstStyle/>
+          <a:p>
+            <a:pPr marL="285750" indent="-171450">
+              <a:buChar char="•"/>
+            </a:pPr>
+            <a:r>
+              <a:rPr lang="en-US" sz="2100">
+                <a:solidFill>
+                  <a:srgbClr val="D7E3EA"/>
+                </a:solidFill>
+              </a:rPr>
+              <a:t>One HIP.markets-operated DEX.</a:t>
+            </a:r>
+          </a:p>
+          <a:p>
+            <a:pPr marL="285750" indent="-171450">
+              <a:buChar char="•"/>
+            </a:pPr>
+            <a:r>
+              <a:rPr lang="en-US" sz="2100">
+                <a:solidFill>
+                  <a:srgbClr val="D7E3EA"/>
+                </a:solidFill>
+              </a:rPr>
+              <a:t>One HYPE vault.</a:t>
+            </a:r>
+          </a:p>
+          <a:p>
+            <a:pPr marL="285750" indent="-171450">
+              <a:buChar char="•"/>
+            </a:pPr>
+            <a:r>
+              <a:rPr lang="en-US" sz="2100">
+                <a:solidFill>
+                  <a:srgbClr val="D7E3EA"/>
+                </a:solidFill>
+              </a:rPr>
+              <a:t>First three markets.</a:t>
+            </a:r>
+          </a:p>
+          <a:p>
+            <a:pPr marL="285750" indent="-171450">
+              <a:buChar char="•"/>
+            </a:pPr>
+            <a:r>
+              <a:rPr lang="en-US" sz="2100">
+                <a:solidFill>
+                  <a:srgbClr val="D7E3EA"/>
+                </a:solidFill>
+              </a:rPr>
+              <a:t>Weekly distributions.</a:t>
+            </a:r>
+          </a:p>
+          <a:p>
+            <a:pPr marL="285750" indent="-171450">
+              <a:buChar char="•"/>
+            </a:pPr>
+            <a:r>
+              <a:rPr lang="en-US" sz="2100">
+                <a:solidFill>
+                  <a:srgbClr val="D7E3EA"/>
+                </a:solidFill>
+              </a:rPr>
+              <a:t>Public dashboard.</a:t>
+            </a:r>
+          </a:p>
+          <a:p>
+            <a:pPr marL="285750" indent="-171450">
+              <a:buChar char="•"/>
+            </a:pPr>
+            <a:r>
+              <a:rPr lang="en-US" sz="2100">
+                <a:solidFill>
+                  <a:srgbClr val="D7E3EA"/>
+                </a:solidFill>
+              </a:rPr>
+              <a:t>No third-party operator financing.</a:t>
             </a:r>
           </a:p>
         </p:txBody>
@@ -1643,7 +1639,7 @@
         <p:spPr>
           <a:xfrm>
             <a:off x="609600" y="6400800"/>
-            <a:ext cx="7924800" cy="300000"/>
+            <a:ext cx="10500000" cy="300000"/>
           </a:xfrm>
           <a:prstGeom prst="rect">
             <a:avLst/>
@@ -1661,6 +1657,160 @@
                 </a:solidFill>
               </a:rPr>
               <a:t>HIP.markets hackathon submission  |  18</a:t>
+            </a:r>
+          </a:p>
+        </p:txBody>
+      </p:sp>
+    </p:spTree>
+  </p:cSld>
+  <p:clrMapOvr>
+    <a:masterClrMapping/>
+  </p:clrMapOvr>
+</p:sld>
+</file>
+
+<file path=ppt/slides/slide19.xml><?xml version="1.0" encoding="utf-8"?>
+<p:sld xmlns:a="http://schemas.openxmlformats.org/drawingml/2006/main" xmlns:r="http://schemas.openxmlformats.org/officeDocument/2006/relationships" xmlns:p="http://schemas.openxmlformats.org/presentationml/2006/main">
+  <p:cSld>
+    <p:bg>
+      <p:bgPr>
+        <a:solidFill>
+          <a:srgbClr val="080A0D"/>
+        </a:solidFill>
+      </p:bgPr>
+    </p:bg>
+    <p:spTree>
+      <p:nvGrpSpPr>
+        <p:cNvPr id="1" name=""/>
+        <p:cNvGrpSpPr/>
+        <p:nvPr/>
+      </p:nvGrpSpPr>
+      <p:grpSpPr>
+        <a:xfrm>
+          <a:off x="0" y="0"/>
+          <a:ext cx="0" cy="0"/>
+          <a:chOff x="0" y="0"/>
+          <a:chExt cx="0" cy="0"/>
+        </a:xfrm>
+      </p:grpSpPr>
+      <p:sp>
+        <p:nvSpPr>
+          <p:cNvPr id="2" name="Title"/>
+          <p:cNvSpPr txBox="1"/>
+          <p:nvPr/>
+        </p:nvSpPr>
+        <p:spPr>
+          <a:xfrm>
+            <a:off x="609600" y="610000"/>
+            <a:ext cx="10300000" cy="850000"/>
+          </a:xfrm>
+          <a:prstGeom prst="rect">
+            <a:avLst/>
+          </a:prstGeom>
+          <a:noFill/>
+        </p:spPr>
+        <p:txBody>
+          <a:bodyPr wrap="square"/>
+          <a:lstStyle/>
+          <a:p>
+            <a:r>
+              <a:rPr lang="en-US" sz="4100" b="1">
+                <a:solidFill>
+                  <a:srgbClr val="F4F7F8"/>
+                </a:solidFill>
+              </a:rPr>
+              <a:t>Roadmap</a:t>
+            </a:r>
+          </a:p>
+        </p:txBody>
+      </p:sp>
+      <p:sp>
+        <p:nvSpPr>
+          <p:cNvPr id="3" name="Body"/>
+          <p:cNvSpPr txBox="1"/>
+          <p:nvPr/>
+        </p:nvSpPr>
+        <p:spPr>
+          <a:xfrm>
+            <a:off x="914400" y="1905000"/>
+            <a:ext cx="9800000" cy="3900000"/>
+          </a:xfrm>
+          <a:prstGeom prst="rect">
+            <a:avLst/>
+          </a:prstGeom>
+          <a:noFill/>
+        </p:spPr>
+        <p:txBody>
+          <a:bodyPr wrap="square"/>
+          <a:lstStyle/>
+          <a:p>
+            <a:pPr marL="285750" indent="-171450">
+              <a:buChar char="•"/>
+            </a:pPr>
+            <a:r>
+              <a:rPr lang="en-US" sz="2100">
+                <a:solidFill>
+                  <a:srgbClr val="D7E3EA"/>
+                </a:solidFill>
+              </a:rPr>
+              <a:t>V1: prove operator vault and fee sharing.</a:t>
+            </a:r>
+          </a:p>
+          <a:p>
+            <a:pPr marL="285750" indent="-171450">
+              <a:buChar char="•"/>
+            </a:pPr>
+            <a:r>
+              <a:rPr lang="en-US" sz="2100">
+                <a:solidFill>
+                  <a:srgbClr val="D7E3EA"/>
+                </a:solidFill>
+              </a:rPr>
+              <a:t>V2: more HIP.markets market vaults and automated fee verification.</a:t>
+            </a:r>
+          </a:p>
+          <a:p>
+            <a:pPr marL="285750" indent="-171450">
+              <a:buChar char="•"/>
+            </a:pPr>
+            <a:r>
+              <a:rPr lang="en-US" sz="2100">
+                <a:solidFill>
+                  <a:srgbClr val="D7E3EA"/>
+                </a:solidFill>
+              </a:rPr>
+              <a:t>V3: risk tranching, secondary shares, HIP-4, possible third-party financing once the trust model is mature.</a:t>
+            </a:r>
+          </a:p>
+        </p:txBody>
+      </p:sp>
+      <p:sp>
+        <p:nvSpPr>
+          <p:cNvPr id="4" name="Footer"/>
+          <p:cNvSpPr txBox="1"/>
+          <p:nvPr/>
+        </p:nvSpPr>
+        <p:spPr>
+          <a:xfrm>
+            <a:off x="609600" y="6400800"/>
+            <a:ext cx="10500000" cy="300000"/>
+          </a:xfrm>
+          <a:prstGeom prst="rect">
+            <a:avLst/>
+          </a:prstGeom>
+          <a:noFill/>
+        </p:spPr>
+        <p:txBody>
+          <a:bodyPr wrap="square"/>
+          <a:lstStyle/>
+          <a:p>
+            <a:r>
+              <a:rPr lang="en-US" sz="1000">
+                <a:solidFill>
+                  <a:srgbClr val="35D29A"/>
+                </a:solidFill>
+              </a:rPr>
+              <a:t>HIP.markets hackathon submission  |  19</a:t>
             </a:r>
           </a:p>
         </p:txBody>
@@ -1705,20 +1855,20 @@
         </p:nvSpPr>
         <p:spPr>
           <a:xfrm>
-            <a:off x="609600" y="640080"/>
-            <a:ext cx="7924800" cy="1005840"/>
-          </a:xfrm>
-          <a:prstGeom prst="rect">
-            <a:avLst/>
-          </a:prstGeom>
-          <a:noFill/>
-        </p:spPr>
-        <p:txBody>
-          <a:bodyPr wrap="square"/>
-          <a:lstStyle/>
-          <a:p>
-            <a:r>
-              <a:rPr lang="en-US" sz="4300" b="1">
+            <a:off x="609600" y="610000"/>
+            <a:ext cx="10300000" cy="850000"/>
+          </a:xfrm>
+          <a:prstGeom prst="rect">
+            <a:avLst/>
+          </a:prstGeom>
+          <a:noFill/>
+        </p:spPr>
+        <p:txBody>
+          <a:bodyPr wrap="square"/>
+          <a:lstStyle/>
+          <a:p>
+            <a:r>
+              <a:rPr lang="en-US" sz="4100" b="1">
                 <a:solidFill>
                   <a:srgbClr val="F4F7F8"/>
                 </a:solidFill>
@@ -1737,7 +1887,7 @@
         <p:spPr>
           <a:xfrm>
             <a:off x="914400" y="1905000"/>
-            <a:ext cx="7924800" cy="3657600"/>
+            <a:ext cx="9800000" cy="3900000"/>
           </a:xfrm>
           <a:prstGeom prst="rect">
             <a:avLst/>
@@ -1797,7 +1947,7 @@
         <p:spPr>
           <a:xfrm>
             <a:off x="609600" y="6400800"/>
-            <a:ext cx="7924800" cy="300000"/>
+            <a:ext cx="10500000" cy="300000"/>
           </a:xfrm>
           <a:prstGeom prst="rect">
             <a:avLst/>
@@ -1815,6 +1965,481 @@
                 </a:solidFill>
               </a:rPr>
               <a:t>HIP.markets hackathon submission  |  02</a:t>
+            </a:r>
+          </a:p>
+        </p:txBody>
+      </p:sp>
+    </p:spTree>
+  </p:cSld>
+  <p:clrMapOvr>
+    <a:masterClrMapping/>
+  </p:clrMapOvr>
+</p:sld>
+</file>
+
+<file path=ppt/slides/slide20.xml><?xml version="1.0" encoding="utf-8"?>
+<p:sld xmlns:a="http://schemas.openxmlformats.org/drawingml/2006/main" xmlns:r="http://schemas.openxmlformats.org/officeDocument/2006/relationships" xmlns:p="http://schemas.openxmlformats.org/presentationml/2006/main">
+  <p:cSld>
+    <p:bg>
+      <p:bgPr>
+        <a:solidFill>
+          <a:srgbClr val="080A0D"/>
+        </a:solidFill>
+      </p:bgPr>
+    </p:bg>
+    <p:spTree>
+      <p:nvGrpSpPr>
+        <p:cNvPr id="1" name=""/>
+        <p:cNvGrpSpPr/>
+        <p:nvPr/>
+      </p:nvGrpSpPr>
+      <p:grpSpPr>
+        <a:xfrm>
+          <a:off x="0" y="0"/>
+          <a:ext cx="0" cy="0"/>
+          <a:chOff x="0" y="0"/>
+          <a:chExt cx="0" cy="0"/>
+        </a:xfrm>
+      </p:grpSpPr>
+      <p:sp>
+        <p:nvSpPr>
+          <p:cNvPr id="2" name="Title"/>
+          <p:cNvSpPr txBox="1"/>
+          <p:nvPr/>
+        </p:nvSpPr>
+        <p:spPr>
+          <a:xfrm>
+            <a:off x="609600" y="610000"/>
+            <a:ext cx="10300000" cy="850000"/>
+          </a:xfrm>
+          <a:prstGeom prst="rect">
+            <a:avLst/>
+          </a:prstGeom>
+          <a:noFill/>
+        </p:spPr>
+        <p:txBody>
+          <a:bodyPr wrap="square"/>
+          <a:lstStyle/>
+          <a:p>
+            <a:r>
+              <a:rPr lang="en-US" sz="4100" b="1">
+                <a:solidFill>
+                  <a:srgbClr val="F4F7F8"/>
+                </a:solidFill>
+              </a:rPr>
+              <a:t>Competitive Position</a:t>
+            </a:r>
+          </a:p>
+        </p:txBody>
+      </p:sp>
+      <p:sp>
+        <p:nvSpPr>
+          <p:cNvPr id="3" name="Body"/>
+          <p:cNvSpPr txBox="1"/>
+          <p:nvPr/>
+        </p:nvSpPr>
+        <p:spPr>
+          <a:xfrm>
+            <a:off x="914400" y="1905000"/>
+            <a:ext cx="9800000" cy="3900000"/>
+          </a:xfrm>
+          <a:prstGeom prst="rect">
+            <a:avLst/>
+          </a:prstGeom>
+          <a:noFill/>
+        </p:spPr>
+        <p:txBody>
+          <a:bodyPr wrap="square"/>
+          <a:lstStyle/>
+          <a:p>
+            <a:pPr marL="285750" indent="-171450">
+              <a:buChar char="•"/>
+            </a:pPr>
+            <a:r>
+              <a:rPr lang="en-US" sz="2100">
+                <a:solidFill>
+                  <a:srgbClr val="D7E3EA"/>
+                </a:solidFill>
+              </a:rPr>
+              <a:t>trade.xyz and HyENA operate markets directly.</a:t>
+            </a:r>
+          </a:p>
+          <a:p>
+            <a:pPr marL="285750" indent="-171450">
+              <a:buChar char="•"/>
+            </a:pPr>
+            <a:r>
+              <a:rPr lang="en-US" sz="2100">
+                <a:solidFill>
+                  <a:srgbClr val="D7E3EA"/>
+                </a:solidFill>
+              </a:rPr>
+              <a:t>HIP.markets also operates markets directly, but adds user-funded HYPE stake and transparent fee sharing.</a:t>
+            </a:r>
+          </a:p>
+          <a:p>
+            <a:pPr marL="285750" indent="-171450">
+              <a:buChar char="•"/>
+            </a:pPr>
+            <a:r>
+              <a:rPr lang="en-US" sz="2100">
+                <a:solidFill>
+                  <a:srgbClr val="D7E3EA"/>
+                </a:solidFill>
+              </a:rPr>
+              <a:t>The wedge is making HYPE holders economic backers of the operator.</a:t>
+            </a:r>
+          </a:p>
+        </p:txBody>
+      </p:sp>
+      <p:sp>
+        <p:nvSpPr>
+          <p:cNvPr id="4" name="Footer"/>
+          <p:cNvSpPr txBox="1"/>
+          <p:nvPr/>
+        </p:nvSpPr>
+        <p:spPr>
+          <a:xfrm>
+            <a:off x="609600" y="6400800"/>
+            <a:ext cx="10500000" cy="300000"/>
+          </a:xfrm>
+          <a:prstGeom prst="rect">
+            <a:avLst/>
+          </a:prstGeom>
+          <a:noFill/>
+        </p:spPr>
+        <p:txBody>
+          <a:bodyPr wrap="square"/>
+          <a:lstStyle/>
+          <a:p>
+            <a:r>
+              <a:rPr lang="en-US" sz="1000">
+                <a:solidFill>
+                  <a:srgbClr val="35D29A"/>
+                </a:solidFill>
+              </a:rPr>
+              <a:t>HIP.markets hackathon submission  |  20</a:t>
+            </a:r>
+          </a:p>
+        </p:txBody>
+      </p:sp>
+    </p:spTree>
+  </p:cSld>
+  <p:clrMapOvr>
+    <a:masterClrMapping/>
+  </p:clrMapOvr>
+</p:sld>
+</file>
+
+<file path=ppt/slides/slide21.xml><?xml version="1.0" encoding="utf-8"?>
+<p:sld xmlns:a="http://schemas.openxmlformats.org/drawingml/2006/main" xmlns:r="http://schemas.openxmlformats.org/officeDocument/2006/relationships" xmlns:p="http://schemas.openxmlformats.org/presentationml/2006/main">
+  <p:cSld>
+    <p:bg>
+      <p:bgPr>
+        <a:solidFill>
+          <a:srgbClr val="080A0D"/>
+        </a:solidFill>
+      </p:bgPr>
+    </p:bg>
+    <p:spTree>
+      <p:nvGrpSpPr>
+        <p:cNvPr id="1" name=""/>
+        <p:cNvGrpSpPr/>
+        <p:nvPr/>
+      </p:nvGrpSpPr>
+      <p:grpSpPr>
+        <a:xfrm>
+          <a:off x="0" y="0"/>
+          <a:ext cx="0" cy="0"/>
+          <a:chOff x="0" y="0"/>
+          <a:chExt cx="0" cy="0"/>
+        </a:xfrm>
+      </p:grpSpPr>
+      <p:sp>
+        <p:nvSpPr>
+          <p:cNvPr id="2" name="Title"/>
+          <p:cNvSpPr txBox="1"/>
+          <p:nvPr/>
+        </p:nvSpPr>
+        <p:spPr>
+          <a:xfrm>
+            <a:off x="609600" y="610000"/>
+            <a:ext cx="10300000" cy="850000"/>
+          </a:xfrm>
+          <a:prstGeom prst="rect">
+            <a:avLst/>
+          </a:prstGeom>
+          <a:noFill/>
+        </p:spPr>
+        <p:txBody>
+          <a:bodyPr wrap="square"/>
+          <a:lstStyle/>
+          <a:p>
+            <a:r>
+              <a:rPr lang="en-US" sz="4100" b="1">
+                <a:solidFill>
+                  <a:srgbClr val="F4F7F8"/>
+                </a:solidFill>
+              </a:rPr>
+              <a:t>Ask</a:t>
+            </a:r>
+          </a:p>
+        </p:txBody>
+      </p:sp>
+      <p:sp>
+        <p:nvSpPr>
+          <p:cNvPr id="3" name="Body"/>
+          <p:cNvSpPr txBox="1"/>
+          <p:nvPr/>
+        </p:nvSpPr>
+        <p:spPr>
+          <a:xfrm>
+            <a:off x="914400" y="1905000"/>
+            <a:ext cx="9800000" cy="3900000"/>
+          </a:xfrm>
+          <a:prstGeom prst="rect">
+            <a:avLst/>
+          </a:prstGeom>
+          <a:noFill/>
+        </p:spPr>
+        <p:txBody>
+          <a:bodyPr wrap="square"/>
+          <a:lstStyle/>
+          <a:p>
+            <a:pPr marL="285750" indent="-171450">
+              <a:buChar char="•"/>
+            </a:pPr>
+            <a:r>
+              <a:rPr lang="en-US" sz="2100">
+                <a:solidFill>
+                  <a:srgbClr val="D7E3EA"/>
+                </a:solidFill>
+              </a:rPr>
+              <a:t>HYPE holders for capped beta.</a:t>
+            </a:r>
+          </a:p>
+          <a:p>
+            <a:pPr marL="285750" indent="-171450">
+              <a:buChar char="•"/>
+            </a:pPr>
+            <a:r>
+              <a:rPr lang="en-US" sz="2100">
+                <a:solidFill>
+                  <a:srgbClr val="D7E3EA"/>
+                </a:solidFill>
+              </a:rPr>
+              <a:t>Market makers for first markets.</a:t>
+            </a:r>
+          </a:p>
+          <a:p>
+            <a:pPr marL="285750" indent="-171450">
+              <a:buChar char="•"/>
+            </a:pPr>
+            <a:r>
+              <a:rPr lang="en-US" sz="2100">
+                <a:solidFill>
+                  <a:srgbClr val="D7E3EA"/>
+                </a:solidFill>
+              </a:rPr>
+              <a:t>Oracle and data partners.</a:t>
+            </a:r>
+          </a:p>
+          <a:p>
+            <a:pPr marL="285750" indent="-171450">
+              <a:buChar char="•"/>
+            </a:pPr>
+            <a:r>
+              <a:rPr lang="en-US" sz="2100">
+                <a:solidFill>
+                  <a:srgbClr val="D7E3EA"/>
+                </a:solidFill>
+              </a:rPr>
+              <a:t>Security reviewers.</a:t>
+            </a:r>
+          </a:p>
+          <a:p>
+            <a:pPr marL="285750" indent="-171450">
+              <a:buChar char="•"/>
+            </a:pPr>
+            <a:r>
+              <a:rPr lang="en-US" sz="2100">
+                <a:solidFill>
+                  <a:srgbClr val="D7E3EA"/>
+                </a:solidFill>
+              </a:rPr>
+              <a:t>Hyperliquid feedback on custody and fee routing.</a:t>
+            </a:r>
+          </a:p>
+        </p:txBody>
+      </p:sp>
+      <p:sp>
+        <p:nvSpPr>
+          <p:cNvPr id="4" name="Footer"/>
+          <p:cNvSpPr txBox="1"/>
+          <p:nvPr/>
+        </p:nvSpPr>
+        <p:spPr>
+          <a:xfrm>
+            <a:off x="609600" y="6400800"/>
+            <a:ext cx="10500000" cy="300000"/>
+          </a:xfrm>
+          <a:prstGeom prst="rect">
+            <a:avLst/>
+          </a:prstGeom>
+          <a:noFill/>
+        </p:spPr>
+        <p:txBody>
+          <a:bodyPr wrap="square"/>
+          <a:lstStyle/>
+          <a:p>
+            <a:r>
+              <a:rPr lang="en-US" sz="1000">
+                <a:solidFill>
+                  <a:srgbClr val="35D29A"/>
+                </a:solidFill>
+              </a:rPr>
+              <a:t>HIP.markets hackathon submission  |  21</a:t>
+            </a:r>
+          </a:p>
+        </p:txBody>
+      </p:sp>
+    </p:spTree>
+  </p:cSld>
+  <p:clrMapOvr>
+    <a:masterClrMapping/>
+  </p:clrMapOvr>
+</p:sld>
+</file>
+
+<file path=ppt/slides/slide22.xml><?xml version="1.0" encoding="utf-8"?>
+<p:sld xmlns:a="http://schemas.openxmlformats.org/drawingml/2006/main" xmlns:r="http://schemas.openxmlformats.org/officeDocument/2006/relationships" xmlns:p="http://schemas.openxmlformats.org/presentationml/2006/main">
+  <p:cSld>
+    <p:bg>
+      <p:bgPr>
+        <a:solidFill>
+          <a:srgbClr val="080A0D"/>
+        </a:solidFill>
+      </p:bgPr>
+    </p:bg>
+    <p:spTree>
+      <p:nvGrpSpPr>
+        <p:cNvPr id="1" name=""/>
+        <p:cNvGrpSpPr/>
+        <p:nvPr/>
+      </p:nvGrpSpPr>
+      <p:grpSpPr>
+        <a:xfrm>
+          <a:off x="0" y="0"/>
+          <a:ext cx="0" cy="0"/>
+          <a:chOff x="0" y="0"/>
+          <a:chExt cx="0" cy="0"/>
+        </a:xfrm>
+      </p:grpSpPr>
+      <p:sp>
+        <p:nvSpPr>
+          <p:cNvPr id="2" name="Title"/>
+          <p:cNvSpPr txBox="1"/>
+          <p:nvPr/>
+        </p:nvSpPr>
+        <p:spPr>
+          <a:xfrm>
+            <a:off x="609600" y="610000"/>
+            <a:ext cx="10300000" cy="850000"/>
+          </a:xfrm>
+          <a:prstGeom prst="rect">
+            <a:avLst/>
+          </a:prstGeom>
+          <a:noFill/>
+        </p:spPr>
+        <p:txBody>
+          <a:bodyPr wrap="square"/>
+          <a:lstStyle/>
+          <a:p>
+            <a:r>
+              <a:rPr lang="en-US" sz="4100" b="1">
+                <a:solidFill>
+                  <a:srgbClr val="F4F7F8"/>
+                </a:solidFill>
+              </a:rPr>
+              <a:t>Closing</a:t>
+            </a:r>
+          </a:p>
+        </p:txBody>
+      </p:sp>
+      <p:sp>
+        <p:nvSpPr>
+          <p:cNvPr id="3" name="Body"/>
+          <p:cNvSpPr txBox="1"/>
+          <p:nvPr/>
+        </p:nvSpPr>
+        <p:spPr>
+          <a:xfrm>
+            <a:off x="914400" y="1905000"/>
+            <a:ext cx="9800000" cy="3900000"/>
+          </a:xfrm>
+          <a:prstGeom prst="rect">
+            <a:avLst/>
+          </a:prstGeom>
+          <a:noFill/>
+        </p:spPr>
+        <p:txBody>
+          <a:bodyPr wrap="square"/>
+          <a:lstStyle/>
+          <a:p>
+            <a:pPr marL="285750" indent="-171450">
+              <a:buChar char="•"/>
+            </a:pPr>
+            <a:r>
+              <a:rPr lang="en-US" sz="2100">
+                <a:solidFill>
+                  <a:srgbClr val="D7E3EA"/>
+                </a:solidFill>
+              </a:rPr>
+              <a:t>HIP.markets turns builder-deployed markets into a community-backed operator business.</a:t>
+            </a:r>
+          </a:p>
+          <a:p>
+            <a:pPr marL="285750" indent="-171450">
+              <a:buChar char="•"/>
+            </a:pPr>
+            <a:r>
+              <a:rPr lang="en-US" sz="2100">
+                <a:solidFill>
+                  <a:srgbClr val="D7E3EA"/>
+                </a:solidFill>
+              </a:rPr>
+              <a:t>The first job is operating markets safely.</a:t>
+            </a:r>
+          </a:p>
+        </p:txBody>
+      </p:sp>
+      <p:sp>
+        <p:nvSpPr>
+          <p:cNvPr id="4" name="Footer"/>
+          <p:cNvSpPr txBox="1"/>
+          <p:nvPr/>
+        </p:nvSpPr>
+        <p:spPr>
+          <a:xfrm>
+            <a:off x="609600" y="6400800"/>
+            <a:ext cx="10500000" cy="300000"/>
+          </a:xfrm>
+          <a:prstGeom prst="rect">
+            <a:avLst/>
+          </a:prstGeom>
+          <a:noFill/>
+        </p:spPr>
+        <p:txBody>
+          <a:bodyPr wrap="square"/>
+          <a:lstStyle/>
+          <a:p>
+            <a:r>
+              <a:rPr lang="en-US" sz="1000">
+                <a:solidFill>
+                  <a:srgbClr val="35D29A"/>
+                </a:solidFill>
+              </a:rPr>
+              <a:t>HIP.markets hackathon submission  |  22</a:t>
             </a:r>
           </a:p>
         </p:txBody>
@@ -1859,20 +2484,20 @@
         </p:nvSpPr>
         <p:spPr>
           <a:xfrm>
-            <a:off x="609600" y="640080"/>
-            <a:ext cx="7924800" cy="1005840"/>
-          </a:xfrm>
-          <a:prstGeom prst="rect">
-            <a:avLst/>
-          </a:prstGeom>
-          <a:noFill/>
-        </p:spPr>
-        <p:txBody>
-          <a:bodyPr wrap="square"/>
-          <a:lstStyle/>
-          <a:p>
-            <a:r>
-              <a:rPr lang="en-US" sz="4300" b="1">
+            <a:off x="609600" y="610000"/>
+            <a:ext cx="10300000" cy="850000"/>
+          </a:xfrm>
+          <a:prstGeom prst="rect">
+            <a:avLst/>
+          </a:prstGeom>
+          <a:noFill/>
+        </p:spPr>
+        <p:txBody>
+          <a:bodyPr wrap="square"/>
+          <a:lstStyle/>
+          <a:p>
+            <a:r>
+              <a:rPr lang="en-US" sz="4100" b="1">
                 <a:solidFill>
                   <a:srgbClr val="F4F7F8"/>
                 </a:solidFill>
@@ -1891,7 +2516,7 @@
         <p:spPr>
           <a:xfrm>
             <a:off x="914400" y="1905000"/>
-            <a:ext cx="7924800" cy="3657600"/>
+            <a:ext cx="9800000" cy="3900000"/>
           </a:xfrm>
           <a:prstGeom prst="rect">
             <a:avLst/>
@@ -1951,7 +2576,7 @@
         <p:spPr>
           <a:xfrm>
             <a:off x="609600" y="6400800"/>
-            <a:ext cx="7924800" cy="300000"/>
+            <a:ext cx="10500000" cy="300000"/>
           </a:xfrm>
           <a:prstGeom prst="rect">
             <a:avLst/>
@@ -2013,25 +2638,25 @@
         </p:nvSpPr>
         <p:spPr>
           <a:xfrm>
-            <a:off x="609600" y="640080"/>
-            <a:ext cx="7924800" cy="1005840"/>
-          </a:xfrm>
-          <a:prstGeom prst="rect">
-            <a:avLst/>
-          </a:prstGeom>
-          <a:noFill/>
-        </p:spPr>
-        <p:txBody>
-          <a:bodyPr wrap="square"/>
-          <a:lstStyle/>
-          <a:p>
-            <a:r>
-              <a:rPr lang="en-US" sz="4300" b="1">
+            <a:off x="609600" y="610000"/>
+            <a:ext cx="10300000" cy="850000"/>
+          </a:xfrm>
+          <a:prstGeom prst="rect">
+            <a:avLst/>
+          </a:prstGeom>
+          <a:noFill/>
+        </p:spPr>
+        <p:txBody>
+          <a:bodyPr wrap="square"/>
+          <a:lstStyle/>
+          <a:p>
+            <a:r>
+              <a:rPr lang="en-US" sz="4100" b="1">
                 <a:solidFill>
                   <a:srgbClr val="F4F7F8"/>
                 </a:solidFill>
               </a:rPr>
-              <a:t>Why Trade.xyz Matters</a:t>
+              <a:t>Why Now</a:t>
             </a:r>
           </a:p>
         </p:txBody>
@@ -2045,40 +2670,53 @@
         <p:spPr>
           <a:xfrm>
             <a:off x="914400" y="1905000"/>
-            <a:ext cx="7924800" cy="3657600"/>
-          </a:xfrm>
-          <a:prstGeom prst="rect">
-            <a:avLst/>
-          </a:prstGeom>
-          <a:noFill/>
-        </p:spPr>
-        <p:txBody>
-          <a:bodyPr wrap="square"/>
-          <a:lstStyle/>
-          <a:p>
-            <a:pPr marL="285750" indent="-171450">
-              <a:buChar char="•"/>
-            </a:pPr>
-            <a:r>
-              <a:rPr lang="en-US" sz="2100">
-                <a:solidFill>
-                  <a:srgbClr val="D7E3EA"/>
-                </a:solidFill>
-              </a:rPr>
-              <a:t>trade.xyz proves HIP-3 can support serious market operators.</a:t>
-            </a:r>
-          </a:p>
-          <a:p>
-            <a:pPr marL="285750" indent="-171450">
-              <a:buChar char="•"/>
-            </a:pPr>
-            <a:r>
-              <a:rPr lang="en-US" sz="2100">
-                <a:solidFill>
-                  <a:srgbClr val="D7E3EA"/>
-                </a:solidFill>
-              </a:rPr>
-              <a:t>Useful UI patterns: market rail, order ticket, positions tabs, account modes, Ghost Mode observability, explicit warnings.</a:t>
+            <a:ext cx="9800000" cy="3900000"/>
+          </a:xfrm>
+          <a:prstGeom prst="rect">
+            <a:avLst/>
+          </a:prstGeom>
+          <a:noFill/>
+        </p:spPr>
+        <p:txBody>
+          <a:bodyPr wrap="square"/>
+          <a:lstStyle/>
+          <a:p>
+            <a:pPr marL="285750" indent="-171450">
+              <a:buChar char="•"/>
+            </a:pPr>
+            <a:r>
+              <a:rPr lang="en-US" sz="2100">
+                <a:solidFill>
+                  <a:srgbClr val="D7E3EA"/>
+                </a:solidFill>
+              </a:rPr>
+              <a:t>Hyperliquid has moved from one exchange into market infrastructure.</a:t>
+            </a:r>
+          </a:p>
+          <a:p>
+            <a:pPr marL="285750" indent="-171450">
+              <a:buChar char="•"/>
+            </a:pPr>
+            <a:r>
+              <a:rPr lang="en-US" sz="2100">
+                <a:solidFill>
+                  <a:srgbClr val="D7E3EA"/>
+                </a:solidFill>
+              </a:rPr>
+              <a:t>HIP-3 lets specialist operators list new perpetual markets while HyperCore provides execution rails.</a:t>
+            </a:r>
+          </a:p>
+          <a:p>
+            <a:pPr marL="285750" indent="-171450">
+              <a:buChar char="•"/>
+            </a:pPr>
+            <a:r>
+              <a:rPr lang="en-US" sz="2100">
+                <a:solidFill>
+                  <a:srgbClr val="D7E3EA"/>
+                </a:solidFill>
+              </a:rPr>
+              <a:t>The bottleneck shifts to capital, oracle operations, and operator credibility.</a:t>
             </a:r>
           </a:p>
         </p:txBody>
@@ -2092,7 +2730,7 @@
         <p:spPr>
           <a:xfrm>
             <a:off x="609600" y="6400800"/>
-            <a:ext cx="7924800" cy="300000"/>
+            <a:ext cx="10500000" cy="300000"/>
           </a:xfrm>
           <a:prstGeom prst="rect">
             <a:avLst/>
@@ -2154,25 +2792,25 @@
         </p:nvSpPr>
         <p:spPr>
           <a:xfrm>
-            <a:off x="609600" y="640080"/>
-            <a:ext cx="7924800" cy="1005840"/>
-          </a:xfrm>
-          <a:prstGeom prst="rect">
-            <a:avLst/>
-          </a:prstGeom>
-          <a:noFill/>
-        </p:spPr>
-        <p:txBody>
-          <a:bodyPr wrap="square"/>
-          <a:lstStyle/>
-          <a:p>
-            <a:r>
-              <a:rPr lang="en-US" sz="4300" b="1">
+            <a:off x="609600" y="610000"/>
+            <a:ext cx="10300000" cy="850000"/>
+          </a:xfrm>
+          <a:prstGeom prst="rect">
+            <a:avLst/>
+          </a:prstGeom>
+          <a:noFill/>
+        </p:spPr>
+        <p:txBody>
+          <a:bodyPr wrap="square"/>
+          <a:lstStyle/>
+          <a:p>
+            <a:r>
+              <a:rPr lang="en-US" sz="4100" b="1">
                 <a:solidFill>
                   <a:srgbClr val="F4F7F8"/>
                 </a:solidFill>
               </a:rPr>
-              <a:t>UX Translation</a:t>
+              <a:t>Trade.xyz Reference</a:t>
             </a:r>
           </a:p>
         </p:txBody>
@@ -2185,71 +2823,80 @@
         </p:nvSpPr>
         <p:spPr>
           <a:xfrm>
-            <a:off x="914400" y="1905000"/>
-            <a:ext cx="7924800" cy="3657600"/>
-          </a:xfrm>
-          <a:prstGeom prst="rect">
-            <a:avLst/>
-          </a:prstGeom>
-          <a:noFill/>
-        </p:spPr>
-        <p:txBody>
-          <a:bodyPr wrap="square"/>
-          <a:lstStyle/>
-          <a:p>
-            <a:pPr marL="285750" indent="-171450">
-              <a:buChar char="•"/>
-            </a:pPr>
-            <a:r>
-              <a:rPr lang="en-US" sz="2100">
-                <a:solidFill>
-                  <a:srgbClr val="D7E3EA"/>
-                </a:solidFill>
-              </a:rPr>
-              <a:t>Market rail -&gt; first-three-market launch rail.</a:t>
-            </a:r>
-          </a:p>
-          <a:p>
-            <a:pPr marL="285750" indent="-171450">
-              <a:buChar char="•"/>
-            </a:pPr>
-            <a:r>
-              <a:rPr lang="en-US" sz="2100">
-                <a:solidFill>
-                  <a:srgbClr val="D7E3EA"/>
-                </a:solidFill>
-              </a:rPr>
-              <a:t>Order ticket -&gt; HYPE deposit ticket.</a:t>
-            </a:r>
-          </a:p>
-          <a:p>
-            <a:pPr marL="285750" indent="-171450">
-              <a:buChar char="•"/>
-            </a:pPr>
-            <a:r>
-              <a:rPr lang="en-US" sz="2100">
-                <a:solidFill>
-                  <a:srgbClr val="D7E3EA"/>
-                </a:solidFill>
-              </a:rPr>
-              <a:t>Positions panel -&gt; vault shares, fee history, oracle updates, market launches.</a:t>
-            </a:r>
-          </a:p>
-          <a:p>
-            <a:pPr marL="285750" indent="-171450">
-              <a:buChar char="•"/>
-            </a:pPr>
-            <a:r>
-              <a:rPr lang="en-US" sz="2100">
-                <a:solidFill>
-                  <a:srgbClr val="D7E3EA"/>
-                </a:solidFill>
-              </a:rPr>
-              <a:t>Ghost Mode -&gt; operator monitor.</a:t>
-            </a:r>
-          </a:p>
-        </p:txBody>
-      </p:sp>
+            <a:off x="609600" y="1630000"/>
+            <a:ext cx="4600000" cy="4400000"/>
+          </a:xfrm>
+          <a:prstGeom prst="rect">
+            <a:avLst/>
+          </a:prstGeom>
+          <a:noFill/>
+        </p:spPr>
+        <p:txBody>
+          <a:bodyPr wrap="square"/>
+          <a:lstStyle/>
+          <a:p>
+            <a:pPr marL="285750" indent="-171450">
+              <a:buChar char="•"/>
+            </a:pPr>
+            <a:r>
+              <a:rPr lang="en-US" sz="2100">
+                <a:solidFill>
+                  <a:srgbClr val="D7E3EA"/>
+                </a:solidFill>
+              </a:rPr>
+              <a:t>60 markets, $2.50B 30-day volume, and $121.98K total 30-day fees.</a:t>
+            </a:r>
+          </a:p>
+          <a:p>
+            <a:pPr marL="285750" indent="-171450">
+              <a:buChar char="•"/>
+            </a:pPr>
+            <a:r>
+              <a:rPr lang="en-US" sz="2100">
+                <a:solidFill>
+                  <a:srgbClr val="D7E3EA"/>
+                </a:solidFill>
+              </a:rPr>
+              <a:t>Estimated deployer revenue: $60.99K over 30 days before operating costs.</a:t>
+            </a:r>
+          </a:p>
+          <a:p>
+            <a:pPr marL="285750" indent="-171450">
+              <a:buChar char="•"/>
+            </a:pPr>
+            <a:r>
+              <a:rPr lang="en-US" sz="2100">
+                <a:solidFill>
+                  <a:srgbClr val="D7E3EA"/>
+                </a:solidFill>
+              </a:rPr>
+              <a:t>Gross implied APR: 3.47% on the 500k HYPE minimum stake at $42.8085 HYPE.</a:t>
+            </a:r>
+          </a:p>
+        </p:txBody>
+      </p:sp>
+      <p:pic>
+        <p:nvPicPr>
+          <p:cNvPr id="5" name="tradexyz-reference.png"/>
+          <p:cNvPicPr/>
+          <p:nvPr/>
+        </p:nvPicPr>
+        <p:blipFill>
+          <a:blip r:embed="rId1"/>
+          <a:stretch>
+            <a:fillRect/>
+          </a:stretch>
+        </p:blipFill>
+        <p:spPr>
+          <a:xfrm>
+            <a:off x="5450000" y="1500000"/>
+            <a:ext cx="6130000" cy="3450000"/>
+          </a:xfrm>
+          <a:prstGeom prst="rect">
+            <a:avLst/>
+          </a:prstGeom>
+        </p:spPr>
+      </p:pic>
       <p:sp>
         <p:nvSpPr>
           <p:cNvPr id="4" name="Footer"/>
@@ -2259,7 +2906,7 @@
         <p:spPr>
           <a:xfrm>
             <a:off x="609600" y="6400800"/>
-            <a:ext cx="7924800" cy="300000"/>
+            <a:ext cx="10500000" cy="300000"/>
           </a:xfrm>
           <a:prstGeom prst="rect">
             <a:avLst/>
@@ -2321,25 +2968,25 @@
         </p:nvSpPr>
         <p:spPr>
           <a:xfrm>
-            <a:off x="609600" y="640080"/>
-            <a:ext cx="7924800" cy="1005840"/>
-          </a:xfrm>
-          <a:prstGeom prst="rect">
-            <a:avLst/>
-          </a:prstGeom>
-          <a:noFill/>
-        </p:spPr>
-        <p:txBody>
-          <a:bodyPr wrap="square"/>
-          <a:lstStyle/>
-          <a:p>
-            <a:r>
-              <a:rPr lang="en-US" sz="4300" b="1">
+            <a:off x="609600" y="610000"/>
+            <a:ext cx="10300000" cy="850000"/>
+          </a:xfrm>
+          <a:prstGeom prst="rect">
+            <a:avLst/>
+          </a:prstGeom>
+          <a:noFill/>
+        </p:spPr>
+        <p:txBody>
+          <a:bodyPr wrap="square"/>
+          <a:lstStyle/>
+          <a:p>
+            <a:r>
+              <a:rPr lang="en-US" sz="4100" b="1">
                 <a:solidFill>
                   <a:srgbClr val="F4F7F8"/>
                 </a:solidFill>
               </a:rPr>
-              <a:t>Demo 1: Operator Vault</a:t>
+              <a:t>Successful Market Pattern</a:t>
             </a:r>
           </a:p>
         </p:txBody>
@@ -2353,40 +3000,66 @@
         <p:spPr>
           <a:xfrm>
             <a:off x="914400" y="1905000"/>
-            <a:ext cx="7924800" cy="3657600"/>
-          </a:xfrm>
-          <a:prstGeom prst="rect">
-            <a:avLst/>
-          </a:prstGeom>
-          <a:noFill/>
-        </p:spPr>
-        <p:txBody>
-          <a:bodyPr wrap="square"/>
-          <a:lstStyle/>
-          <a:p>
-            <a:pPr marL="285750" indent="-171450">
-              <a:buChar char="•"/>
-            </a:pPr>
-            <a:r>
-              <a:rPr lang="en-US" sz="2100">
-                <a:solidFill>
-                  <a:srgbClr val="D7E3EA"/>
-                </a:solidFill>
-              </a:rPr>
-              <a:t>First screen is the usable operator console, not a landing page.</a:t>
-            </a:r>
-          </a:p>
-          <a:p>
-            <a:pPr marL="285750" indent="-171450">
-              <a:buChar char="•"/>
-            </a:pPr>
-            <a:r>
-              <a:rPr lang="en-US" sz="2100">
-                <a:solidFill>
-                  <a:srgbClr val="D7E3EA"/>
-                </a:solidFill>
-              </a:rPr>
-              <a:t>Shows vault capacity, APR, oracle cadence, risk state, and 500k HYPE requirement.</a:t>
+            <a:ext cx="9800000" cy="3900000"/>
+          </a:xfrm>
+          <a:prstGeom prst="rect">
+            <a:avLst/>
+          </a:prstGeom>
+          <a:noFill/>
+        </p:spPr>
+        <p:txBody>
+          <a:bodyPr wrap="square"/>
+          <a:lstStyle/>
+          <a:p>
+            <a:pPr marL="285750" indent="-171450">
+              <a:buChar char="•"/>
+            </a:pPr>
+            <a:r>
+              <a:rPr lang="en-US" sz="2100">
+                <a:solidFill>
+                  <a:srgbClr val="D7E3EA"/>
+                </a:solidFill>
+              </a:rPr>
+              <a:t>Trade.xyz's highest-volume tickers are not only crypto assets.</a:t>
+            </a:r>
+          </a:p>
+          <a:p>
+            <a:pPr marL="285750" indent="-171450">
+              <a:buChar char="•"/>
+            </a:pPr>
+            <a:r>
+              <a:rPr lang="en-US" sz="2100">
+                <a:solidFill>
+                  <a:srgbClr val="D7E3EA"/>
+                </a:solidFill>
+              </a:rPr>
+              <a:t>XYZ100 and SP500: roughly $444M each over 30 days.</a:t>
+            </a:r>
+          </a:p>
+          <a:p>
+            <a:pPr marL="285750" indent="-171450">
+              <a:buChar char="•"/>
+            </a:pPr>
+            <a:r>
+              <a:rPr lang="en-US" sz="2100">
+                <a:solidFill>
+                  <a:srgbClr val="D7E3EA"/>
+                </a:solidFill>
+              </a:rPr>
+              <a:t>SILVER, CL, SNDK, MU, NVDA, BRENTOIL, CBRS, INTC, and GOLD show RWA-style breadth.</a:t>
+            </a:r>
+          </a:p>
+          <a:p>
+            <a:pPr marL="285750" indent="-171450">
+              <a:buChar char="•"/>
+            </a:pPr>
+            <a:r>
+              <a:rPr lang="en-US" sz="2100">
+                <a:solidFill>
+                  <a:srgbClr val="D7E3EA"/>
+                </a:solidFill>
+              </a:rPr>
+              <a:t>HIP.markets should launch where oracle confidence, liquidity, and narrative demand overlap.</a:t>
             </a:r>
           </a:p>
         </p:txBody>
@@ -2400,7 +3073,7 @@
         <p:spPr>
           <a:xfrm>
             <a:off x="609600" y="6400800"/>
-            <a:ext cx="7924800" cy="300000"/>
+            <a:ext cx="10500000" cy="300000"/>
           </a:xfrm>
           <a:prstGeom prst="rect">
             <a:avLst/>
@@ -2462,25 +3135,25 @@
         </p:nvSpPr>
         <p:spPr>
           <a:xfrm>
-            <a:off x="609600" y="640080"/>
-            <a:ext cx="7924800" cy="1005840"/>
-          </a:xfrm>
-          <a:prstGeom prst="rect">
-            <a:avLst/>
-          </a:prstGeom>
-          <a:noFill/>
-        </p:spPr>
-        <p:txBody>
-          <a:bodyPr wrap="square"/>
-          <a:lstStyle/>
-          <a:p>
-            <a:r>
-              <a:rPr lang="en-US" sz="4300" b="1">
+            <a:off x="609600" y="610000"/>
+            <a:ext cx="10300000" cy="850000"/>
+          </a:xfrm>
+          <a:prstGeom prst="rect">
+            <a:avLst/>
+          </a:prstGeom>
+          <a:noFill/>
+        </p:spPr>
+        <p:txBody>
+          <a:bodyPr wrap="square"/>
+          <a:lstStyle/>
+          <a:p>
+            <a:r>
+              <a:rPr lang="en-US" sz="4100" b="1">
                 <a:solidFill>
                   <a:srgbClr val="F4F7F8"/>
                 </a:solidFill>
               </a:rPr>
-              <a:t>Demo 2: Fee Model</a:t>
+              <a:t>Revenue Interpretation</a:t>
             </a:r>
           </a:p>
         </p:txBody>
@@ -2494,40 +3167,53 @@
         <p:spPr>
           <a:xfrm>
             <a:off x="914400" y="1905000"/>
-            <a:ext cx="7924800" cy="3657600"/>
-          </a:xfrm>
-          <a:prstGeom prst="rect">
-            <a:avLst/>
-          </a:prstGeom>
-          <a:noFill/>
-        </p:spPr>
-        <p:txBody>
-          <a:bodyPr wrap="square"/>
-          <a:lstStyle/>
-          <a:p>
-            <a:pPr marL="285750" indent="-171450">
-              <a:buChar char="•"/>
-            </a:pPr>
-            <a:r>
-              <a:rPr lang="en-US" sz="2100">
-                <a:solidFill>
-                  <a:srgbClr val="D7E3EA"/>
-                </a:solidFill>
-              </a:rPr>
-              <a:t>Judges can change HYPE price, staked HYPE, daily volume, fee bps, builder share, operating fee, protocol fee, and reserve.</a:t>
-            </a:r>
-          </a:p>
-          <a:p>
-            <a:pPr marL="285750" indent="-171450">
-              <a:buChar char="•"/>
-            </a:pPr>
-            <a:r>
-              <a:rPr lang="en-US" sz="2100">
-                <a:solidFill>
-                  <a:srgbClr val="D7E3EA"/>
-                </a:solidFill>
-              </a:rPr>
-              <a:t>APR updates instantly.</a:t>
+            <a:ext cx="9800000" cy="3900000"/>
+          </a:xfrm>
+          <a:prstGeom prst="rect">
+            <a:avLst/>
+          </a:prstGeom>
+          <a:noFill/>
+        </p:spPr>
+        <p:txBody>
+          <a:bodyPr wrap="square"/>
+          <a:lstStyle/>
+          <a:p>
+            <a:pPr marL="285750" indent="-171450">
+              <a:buChar char="•"/>
+            </a:pPr>
+            <a:r>
+              <a:rPr lang="en-US" sz="2100">
+                <a:solidFill>
+                  <a:srgbClr val="D7E3EA"/>
+                </a:solidFill>
+              </a:rPr>
+              <a:t>HIP-3 deployer share is fixed at 50% from the deployer perspective.</a:t>
+            </a:r>
+          </a:p>
+          <a:p>
+            <a:pPr marL="285750" indent="-171450">
+              <a:buChar char="•"/>
+            </a:pPr>
+            <a:r>
+              <a:rPr lang="en-US" sz="2100">
+                <a:solidFill>
+                  <a:srgbClr val="D7E3EA"/>
+                </a:solidFill>
+              </a:rPr>
+              <a:t>Trade.xyz reports deployerFeeScale = 1.0.</a:t>
+            </a:r>
+          </a:p>
+          <a:p>
+            <a:pPr marL="285750" indent="-171450">
+              <a:buChar char="•"/>
+            </a:pPr>
+            <a:r>
+              <a:rPr lang="en-US" sz="2100">
+                <a:solidFill>
+                  <a:srgbClr val="D7E3EA"/>
+                </a:solidFill>
+              </a:rPr>
+              <a:t>Gross revenue is not distributable profit until oracle, data, maker, legal, reserve, and incident costs are deducted.</a:t>
             </a:r>
           </a:p>
         </p:txBody>
@@ -2541,7 +3227,7 @@
         <p:spPr>
           <a:xfrm>
             <a:off x="609600" y="6400800"/>
-            <a:ext cx="7924800" cy="300000"/>
+            <a:ext cx="10500000" cy="300000"/>
           </a:xfrm>
           <a:prstGeom prst="rect">
             <a:avLst/>
@@ -2603,25 +3289,25 @@
         </p:nvSpPr>
         <p:spPr>
           <a:xfrm>
-            <a:off x="609600" y="640080"/>
-            <a:ext cx="7924800" cy="1005840"/>
-          </a:xfrm>
-          <a:prstGeom prst="rect">
-            <a:avLst/>
-          </a:prstGeom>
-          <a:noFill/>
-        </p:spPr>
-        <p:txBody>
-          <a:bodyPr wrap="square"/>
-          <a:lstStyle/>
-          <a:p>
-            <a:r>
-              <a:rPr lang="en-US" sz="4300" b="1">
+            <a:off x="609600" y="610000"/>
+            <a:ext cx="10300000" cy="850000"/>
+          </a:xfrm>
+          <a:prstGeom prst="rect">
+            <a:avLst/>
+          </a:prstGeom>
+          <a:noFill/>
+        </p:spPr>
+        <p:txBody>
+          <a:bodyPr wrap="square"/>
+          <a:lstStyle/>
+          <a:p>
+            <a:r>
+              <a:rPr lang="en-US" sz="4100" b="1">
                 <a:solidFill>
                   <a:srgbClr val="F4F7F8"/>
                 </a:solidFill>
               </a:rPr>
-              <a:t>Demo 3: Deposit Ticket</a:t>
+              <a:t>UI Benchmark</a:t>
             </a:r>
           </a:p>
         </p:txBody>
@@ -2635,40 +3321,40 @@
         <p:spPr>
           <a:xfrm>
             <a:off x="914400" y="1905000"/>
-            <a:ext cx="7924800" cy="3657600"/>
-          </a:xfrm>
-          <a:prstGeom prst="rect">
-            <a:avLst/>
-          </a:prstGeom>
-          <a:noFill/>
-        </p:spPr>
-        <p:txBody>
-          <a:bodyPr wrap="square"/>
-          <a:lstStyle/>
-          <a:p>
-            <a:pPr marL="285750" indent="-171450">
-              <a:buChar char="•"/>
-            </a:pPr>
-            <a:r>
-              <a:rPr lang="en-US" sz="2100">
-                <a:solidFill>
-                  <a:srgbClr val="D7E3EA"/>
-                </a:solidFill>
-              </a:rPr>
-              <a:t>Mirrors a trading order pane.</a:t>
-            </a:r>
-          </a:p>
-          <a:p>
-            <a:pPr marL="285750" indent="-171450">
-              <a:buChar char="•"/>
-            </a:pPr>
-            <a:r>
-              <a:rPr lang="en-US" sz="2100">
-                <a:solidFill>
-                  <a:srgbClr val="D7E3EA"/>
-                </a:solidFill>
-              </a:rPr>
-              <a:t>Amount input, deposit/withdraw mode, fee summary, user rewards estimate, and slashing warning.</a:t>
+            <a:ext cx="9800000" cy="3900000"/>
+          </a:xfrm>
+          <a:prstGeom prst="rect">
+            <a:avLst/>
+          </a:prstGeom>
+          <a:noFill/>
+        </p:spPr>
+        <p:txBody>
+          <a:bodyPr wrap="square"/>
+          <a:lstStyle/>
+          <a:p>
+            <a:pPr marL="285750" indent="-171450">
+              <a:buChar char="•"/>
+            </a:pPr>
+            <a:r>
+              <a:rPr lang="en-US" sz="2100">
+                <a:solidFill>
+                  <a:srgbClr val="D7E3EA"/>
+                </a:solidFill>
+              </a:rPr>
+              <a:t>trade.xyz proves serious HIP-3 markets need trading-terminal density.</a:t>
+            </a:r>
+          </a:p>
+          <a:p>
+            <a:pPr marL="285750" indent="-171450">
+              <a:buChar char="•"/>
+            </a:pPr>
+            <a:r>
+              <a:rPr lang="en-US" sz="2100">
+                <a:solidFill>
+                  <a:srgbClr val="D7E3EA"/>
+                </a:solidFill>
+              </a:rPr>
+              <a:t>Useful patterns: market rail, order ticket, positions tabs, account modes, Ghost Mode observability, explicit warnings.</a:t>
             </a:r>
           </a:p>
         </p:txBody>
@@ -2682,7 +3368,7 @@
         <p:spPr>
           <a:xfrm>
             <a:off x="609600" y="6400800"/>
-            <a:ext cx="7924800" cy="300000"/>
+            <a:ext cx="10500000" cy="300000"/>
           </a:xfrm>
           <a:prstGeom prst="rect">
             <a:avLst/>
@@ -2744,25 +3430,25 @@
         </p:nvSpPr>
         <p:spPr>
           <a:xfrm>
-            <a:off x="609600" y="640080"/>
-            <a:ext cx="7924800" cy="1005840"/>
-          </a:xfrm>
-          <a:prstGeom prst="rect">
-            <a:avLst/>
-          </a:prstGeom>
-          <a:noFill/>
-        </p:spPr>
-        <p:txBody>
-          <a:bodyPr wrap="square"/>
-          <a:lstStyle/>
-          <a:p>
-            <a:r>
-              <a:rPr lang="en-US" sz="4300" b="1">
+            <a:off x="609600" y="610000"/>
+            <a:ext cx="10300000" cy="850000"/>
+          </a:xfrm>
+          <a:prstGeom prst="rect">
+            <a:avLst/>
+          </a:prstGeom>
+          <a:noFill/>
+        </p:spPr>
+        <p:txBody>
+          <a:bodyPr wrap="square"/>
+          <a:lstStyle/>
+          <a:p>
+            <a:r>
+              <a:rPr lang="en-US" sz="4100" b="1">
                 <a:solidFill>
                   <a:srgbClr val="F4F7F8"/>
                 </a:solidFill>
               </a:rPr>
-              <a:t>Demo 4: Audit Tabs</a:t>
+              <a:t>UX Translation</a:t>
             </a:r>
           </a:p>
         </p:txBody>
@@ -2776,53 +3462,66 @@
         <p:spPr>
           <a:xfrm>
             <a:off x="914400" y="1905000"/>
-            <a:ext cx="7924800" cy="3657600"/>
-          </a:xfrm>
-          <a:prstGeom prst="rect">
-            <a:avLst/>
-          </a:prstGeom>
-          <a:noFill/>
-        </p:spPr>
-        <p:txBody>
-          <a:bodyPr wrap="square"/>
-          <a:lstStyle/>
-          <a:p>
-            <a:pPr marL="285750" indent="-171450">
-              <a:buChar char="•"/>
-            </a:pPr>
-            <a:r>
-              <a:rPr lang="en-US" sz="2100">
-                <a:solidFill>
-                  <a:srgbClr val="D7E3EA"/>
-                </a:solidFill>
-              </a:rPr>
-              <a:t>Vault shares show depositor state.</a:t>
-            </a:r>
-          </a:p>
-          <a:p>
-            <a:pPr marL="285750" indent="-171450">
-              <a:buChar char="•"/>
-            </a:pPr>
-            <a:r>
-              <a:rPr lang="en-US" sz="2100">
-                <a:solidFill>
-                  <a:srgbClr val="D7E3EA"/>
-                </a:solidFill>
-              </a:rPr>
-              <a:t>Fee history shows how builder fees become distributions.</a:t>
-            </a:r>
-          </a:p>
-          <a:p>
-            <a:pPr marL="285750" indent="-171450">
-              <a:buChar char="•"/>
-            </a:pPr>
-            <a:r>
-              <a:rPr lang="en-US" sz="2100">
-                <a:solidFill>
-                  <a:srgbClr val="D7E3EA"/>
-                </a:solidFill>
-              </a:rPr>
-              <a:t>Oracle updates and market launches expose operator readiness.</a:t>
+            <a:ext cx="9800000" cy="3900000"/>
+          </a:xfrm>
+          <a:prstGeom prst="rect">
+            <a:avLst/>
+          </a:prstGeom>
+          <a:noFill/>
+        </p:spPr>
+        <p:txBody>
+          <a:bodyPr wrap="square"/>
+          <a:lstStyle/>
+          <a:p>
+            <a:pPr marL="285750" indent="-171450">
+              <a:buChar char="•"/>
+            </a:pPr>
+            <a:r>
+              <a:rPr lang="en-US" sz="2100">
+                <a:solidFill>
+                  <a:srgbClr val="D7E3EA"/>
+                </a:solidFill>
+              </a:rPr>
+              <a:t>Market rail -&gt; first-three-market launch rail.</a:t>
+            </a:r>
+          </a:p>
+          <a:p>
+            <a:pPr marL="285750" indent="-171450">
+              <a:buChar char="•"/>
+            </a:pPr>
+            <a:r>
+              <a:rPr lang="en-US" sz="2100">
+                <a:solidFill>
+                  <a:srgbClr val="D7E3EA"/>
+                </a:solidFill>
+              </a:rPr>
+              <a:t>Order ticket -&gt; HYPE deposit ticket.</a:t>
+            </a:r>
+          </a:p>
+          <a:p>
+            <a:pPr marL="285750" indent="-171450">
+              <a:buChar char="•"/>
+            </a:pPr>
+            <a:r>
+              <a:rPr lang="en-US" sz="2100">
+                <a:solidFill>
+                  <a:srgbClr val="D7E3EA"/>
+                </a:solidFill>
+              </a:rPr>
+              <a:t>Positions panel -&gt; vault shares, fee history, oracle updates, market launches.</a:t>
+            </a:r>
+          </a:p>
+          <a:p>
+            <a:pPr marL="285750" indent="-171450">
+              <a:buChar char="•"/>
+            </a:pPr>
+            <a:r>
+              <a:rPr lang="en-US" sz="2100">
+                <a:solidFill>
+                  <a:srgbClr val="D7E3EA"/>
+                </a:solidFill>
+              </a:rPr>
+              <a:t>Ghost Mode -&gt; operator monitor.</a:t>
             </a:r>
           </a:p>
         </p:txBody>
@@ -2836,7 +3535,7 @@
         <p:spPr>
           <a:xfrm>
             <a:off x="609600" y="6400800"/>
-            <a:ext cx="7924800" cy="300000"/>
+            <a:ext cx="10500000" cy="300000"/>
           </a:xfrm>
           <a:prstGeom prst="rect">
             <a:avLst/>

</xml_diff>

<commit_message>
Polish operator lifecycle and contract connectivity
</commit_message>
<xml_diff>
--- a/presentation/HIP_MARKETS_DECK.pptx
+++ b/presentation/HIP_MARKETS_DECK.pptx
@@ -27,6 +27,8 @@
     <p:sldId id="275" r:id="rId22"/>
     <p:sldId id="276" r:id="rId23"/>
     <p:sldId id="277" r:id="rId24"/>
+    <p:sldId id="278" r:id="rId25"/>
+    <p:sldId id="279" r:id="rId26"/>
   </p:sldIdLst>
   <p:sldSz cx="12192000" cy="6858000" type="wide"/>
   <p:notesSz cx="6858000" cy="9144000"/>
@@ -884,7 +886,7 @@
                   <a:srgbClr val="F4F7F8"/>
                 </a:solidFill>
               </a:rPr>
-              <a:t>System Flow</a:t>
+              <a:t>Demo: Contract Wiring</a:t>
             </a:r>
           </a:p>
         </p:txBody>
@@ -897,84 +899,67 @@
         </p:nvSpPr>
         <p:spPr>
           <a:xfrm>
-            <a:off x="914400" y="1905000"/>
-            <a:ext cx="9800000" cy="3900000"/>
-          </a:xfrm>
-          <a:prstGeom prst="rect">
-            <a:avLst/>
-          </a:prstGeom>
-          <a:noFill/>
-        </p:spPr>
-        <p:txBody>
-          <a:bodyPr wrap="square"/>
-          <a:lstStyle/>
-          <a:p>
-            <a:pPr marL="285750" indent="-171450">
-              <a:buChar char="•"/>
-            </a:pPr>
-            <a:r>
-              <a:rPr lang="en-US" sz="2100">
-                <a:solidFill>
-                  <a:srgbClr val="D7E3EA"/>
-                </a:solidFill>
-              </a:rPr>
-              <a:t>1. HYPE holders deposit into the HyperEVM vault.</a:t>
-            </a:r>
-          </a:p>
-          <a:p>
-            <a:pPr marL="285750" indent="-171450">
-              <a:buChar char="•"/>
-            </a:pPr>
-            <a:r>
-              <a:rPr lang="en-US" sz="2100">
-                <a:solidFill>
-                  <a:srgbClr val="D7E3EA"/>
-                </a:solidFill>
-              </a:rPr>
-              <a:t>2. Vault backs HIP.markets deployer stake.</a:t>
-            </a:r>
-          </a:p>
-          <a:p>
-            <a:pPr marL="285750" indent="-171450">
-              <a:buChar char="•"/>
-            </a:pPr>
-            <a:r>
-              <a:rPr lang="en-US" sz="2100">
-                <a:solidFill>
-                  <a:srgbClr val="D7E3EA"/>
-                </a:solidFill>
-              </a:rPr>
-              <a:t>3. HIP.markets launches the first three HIP-3 markets.</a:t>
-            </a:r>
-          </a:p>
-          <a:p>
-            <a:pPr marL="285750" indent="-171450">
-              <a:buChar char="•"/>
-            </a:pPr>
-            <a:r>
-              <a:rPr lang="en-US" sz="2100">
-                <a:solidFill>
-                  <a:srgbClr val="D7E3EA"/>
-                </a:solidFill>
-              </a:rPr>
-              <a:t>4. Traders generate fees.</a:t>
-            </a:r>
-          </a:p>
-          <a:p>
-            <a:pPr marL="285750" indent="-171450">
-              <a:buChar char="•"/>
-            </a:pPr>
-            <a:r>
-              <a:rPr lang="en-US" sz="2100">
-                <a:solidFill>
-                  <a:srgbClr val="D7E3EA"/>
-                </a:solidFill>
-              </a:rPr>
-              <a:t>5. Net fees distribute after operating, protocol, and reserve deductions.</a:t>
-            </a:r>
-          </a:p>
-        </p:txBody>
-      </p:sp>
+            <a:off x="609600" y="1630000"/>
+            <a:ext cx="4600000" cy="4400000"/>
+          </a:xfrm>
+          <a:prstGeom prst="rect">
+            <a:avLst/>
+          </a:prstGeom>
+          <a:noFill/>
+        </p:spPr>
+        <p:txBody>
+          <a:bodyPr wrap="square"/>
+          <a:lstStyle/>
+          <a:p>
+            <a:pPr marL="285750" indent="-171450">
+              <a:buChar char="•"/>
+            </a:pPr>
+            <a:r>
+              <a:rPr lang="en-US" sz="2100">
+                <a:solidFill>
+                  <a:srgbClr val="D7E3EA"/>
+                </a:solidFill>
+              </a:rPr>
+              <a:t>Wallet-aware flow: connect wallet, configure vault/token addresses, approve HYPE, deposit, and claim rewards.</a:t>
+            </a:r>
+          </a:p>
+          <a:p>
+            <a:pPr marL="285750" indent="-171450">
+              <a:buChar char="•"/>
+            </a:pPr>
+            <a:r>
+              <a:rPr lang="en-US" sz="2100">
+                <a:solidFill>
+                  <a:srgbClr val="D7E3EA"/>
+                </a:solidFill>
+              </a:rPr>
+              <a:t>The UI also shows which actions still require operator multisig and risk-council execution.</a:t>
+            </a:r>
+          </a:p>
+        </p:txBody>
+      </p:sp>
+      <p:pic>
+        <p:nvPicPr>
+          <p:cNvPr id="5" name="demo-contract-wiring.png"/>
+          <p:cNvPicPr/>
+          <p:nvPr/>
+        </p:nvPicPr>
+        <p:blipFill>
+          <a:blip r:embed="rId1"/>
+          <a:stretch>
+            <a:fillRect/>
+          </a:stretch>
+        </p:blipFill>
+        <p:spPr>
+          <a:xfrm>
+            <a:off x="5450000" y="1500000"/>
+            <a:ext cx="6130000" cy="3450000"/>
+          </a:xfrm>
+          <a:prstGeom prst="rect">
+            <a:avLst/>
+          </a:prstGeom>
+        </p:spPr>
+      </p:pic>
       <p:sp>
         <p:nvSpPr>
           <p:cNvPr id="4" name="Footer"/>
@@ -1064,7 +1049,7 @@
                   <a:srgbClr val="F4F7F8"/>
                 </a:solidFill>
               </a:rPr>
-              <a:t>Economics</a:t>
+              <a:t>Contract Depth</a:t>
             </a:r>
           </a:p>
         </p:txBody>
@@ -1098,46 +1083,33 @@
                   <a:srgbClr val="D7E3EA"/>
                 </a:solidFill>
               </a:rPr>
-              <a:t>Base model: 500k HYPE, $50M daily volume, 6 bps fee, 50% deployer share.</a:t>
-            </a:r>
-          </a:p>
-          <a:p>
-            <a:pPr marL="285750" indent="-171450">
-              <a:buChar char="•"/>
-            </a:pPr>
-            <a:r>
-              <a:rPr lang="en-US" sz="2100">
-                <a:solidFill>
-                  <a:srgbClr val="D7E3EA"/>
-                </a:solidFill>
-              </a:rPr>
-              <a:t>After 40% operating/protocol/reserve deductions: approximately 15% net APR.</a:t>
-            </a:r>
-          </a:p>
-          <a:p>
-            <a:pPr marL="285750" indent="-171450">
-              <a:buChar char="•"/>
-            </a:pPr>
-            <a:r>
-              <a:rPr lang="en-US" sz="2100">
-                <a:solidFill>
-                  <a:srgbClr val="D7E3EA"/>
-                </a:solidFill>
-              </a:rPr>
-              <a:t>Trade.xyz trailing fees imply approximately 3.47% gross APR on the minimum stake.</a:t>
-            </a:r>
-          </a:p>
-          <a:p>
-            <a:pPr marL="285750" indent="-171450">
-              <a:buChar char="•"/>
-            </a:pPr>
-            <a:r>
-              <a:rPr lang="en-US" sz="2100">
-                <a:solidFill>
-                  <a:srgbClr val="D7E3EA"/>
-                </a:solidFill>
-              </a:rPr>
-              <a:t>Sensitivity matters more than headline APR.</a:t>
+              <a:t>Vault now models vHIPM receipt shares, vault caps, withdrawal queues, reward accounting, and slash losses.</a:t>
+            </a:r>
+          </a:p>
+          <a:p>
+            <a:pPr marL="285750" indent="-171450">
+              <a:buChar char="•"/>
+            </a:pPr>
+            <a:r>
+              <a:rPr lang="en-US" sz="2100">
+                <a:solidFill>
+                  <a:srgbClr val="D7E3EA"/>
+                </a:solidFill>
+              </a:rPr>
+              <a:t>Operator lifecycle: funding, stake-ready, stake-escrowed, approved, live, wind-down, and slashed.</a:t>
+            </a:r>
+          </a:p>
+          <a:p>
+            <a:pPr marL="285750" indent="-171450">
+              <a:buChar char="•"/>
+            </a:pPr>
+            <a:r>
+              <a:rPr lang="en-US" sz="2100">
+                <a:solidFill>
+                  <a:srgbClr val="D7E3EA"/>
+                </a:solidFill>
+              </a:rPr>
+              <a:t>Registry tracks launch checklist, fee epochs, oracle health, market status, and risk state.</a:t>
             </a:r>
           </a:p>
         </p:txBody>
@@ -1231,7 +1203,7 @@
                   <a:srgbClr val="F4F7F8"/>
                 </a:solidFill>
               </a:rPr>
-              <a:t>Risk Controls</a:t>
+              <a:t>System Flow</a:t>
             </a:r>
           </a:p>
         </p:txBody>
@@ -1265,33 +1237,59 @@
                   <a:srgbClr val="D7E3EA"/>
                 </a:solidFill>
               </a:rPr>
-              <a:t>Start with oracle-simple markets.</a:t>
-            </a:r>
-          </a:p>
-          <a:p>
-            <a:pPr marL="285750" indent="-171450">
-              <a:buChar char="•"/>
-            </a:pPr>
-            <a:r>
-              <a:rPr lang="en-US" sz="2100">
-                <a:solidFill>
-                  <a:srgbClr val="D7E3EA"/>
-                </a:solidFill>
-              </a:rPr>
-              <a:t>Avoid extra ticker auction costs at launch.</a:t>
-            </a:r>
-          </a:p>
-          <a:p>
-            <a:pPr marL="285750" indent="-171450">
-              <a:buChar char="•"/>
-            </a:pPr>
-            <a:r>
-              <a:rPr lang="en-US" sz="2100">
-                <a:solidFill>
-                  <a:srgbClr val="D7E3EA"/>
-                </a:solidFill>
-              </a:rPr>
-              <a:t>Cap open interest, publish addresses, maintain reserve, pause deposits during incidents.</a:t>
+              <a:t>1. HYPE holders deposit into the HyperEVM vault.</a:t>
+            </a:r>
+          </a:p>
+          <a:p>
+            <a:pPr marL="285750" indent="-171450">
+              <a:buChar char="•"/>
+            </a:pPr>
+            <a:r>
+              <a:rPr lang="en-US" sz="2100">
+                <a:solidFill>
+                  <a:srgbClr val="D7E3EA"/>
+                </a:solidFill>
+              </a:rPr>
+              <a:t>2. Vault backs HIP.markets deployer stake.</a:t>
+            </a:r>
+          </a:p>
+          <a:p>
+            <a:pPr marL="285750" indent="-171450">
+              <a:buChar char="•"/>
+            </a:pPr>
+            <a:r>
+              <a:rPr lang="en-US" sz="2100">
+                <a:solidFill>
+                  <a:srgbClr val="D7E3EA"/>
+                </a:solidFill>
+              </a:rPr>
+              <a:t>3. Operator multisig escrows funded HYPE to the deployer stake controller.</a:t>
+            </a:r>
+          </a:p>
+          <a:p>
+            <a:pPr marL="285750" indent="-171450">
+              <a:buChar char="•"/>
+            </a:pPr>
+            <a:r>
+              <a:rPr lang="en-US" sz="2100">
+                <a:solidFill>
+                  <a:srgbClr val="D7E3EA"/>
+                </a:solidFill>
+              </a:rPr>
+              <a:t>4. Risk council records HIP-3 operator approval.</a:t>
+            </a:r>
+          </a:p>
+          <a:p>
+            <a:pPr marL="285750" indent="-171450">
+              <a:buChar char="•"/>
+            </a:pPr>
+            <a:r>
+              <a:rPr lang="en-US" sz="2100">
+                <a:solidFill>
+                  <a:srgbClr val="D7E3EA"/>
+                </a:solidFill>
+              </a:rPr>
+              <a:t>5. HIP.markets launches markets, traders generate fees, and net rewards distribute after deductions.</a:t>
             </a:r>
           </a:p>
         </p:txBody>
@@ -1385,7 +1383,7 @@
                   <a:srgbClr val="F4F7F8"/>
                 </a:solidFill>
               </a:rPr>
-              <a:t>Cost Stack</a:t>
+              <a:t>Economics</a:t>
             </a:r>
           </a:p>
         </p:txBody>
@@ -1419,20 +1417,46 @@
                   <a:srgbClr val="D7E3EA"/>
                 </a:solidFill>
               </a:rPr>
-              <a:t>The 500k HYPE stake is the entry ticket, not the full cost of business.</a:t>
-            </a:r>
-          </a:p>
-          <a:p>
-            <a:pPr marL="285750" indent="-171450">
-              <a:buChar char="•"/>
-            </a:pPr>
-            <a:r>
-              <a:rPr lang="en-US" sz="2100">
-                <a:solidFill>
-                  <a:srgbClr val="D7E3EA"/>
-                </a:solidFill>
-              </a:rPr>
-              <a:t>Budget for oracle relayers, licensed data, maker incentives, infrastructure, key management, audits, legal work, and incident reserves.</a:t>
+              <a:t>Base model: 500k HYPE, $50M daily volume, 6 bps fee, 50% deployer share.</a:t>
+            </a:r>
+          </a:p>
+          <a:p>
+            <a:pPr marL="285750" indent="-171450">
+              <a:buChar char="•"/>
+            </a:pPr>
+            <a:r>
+              <a:rPr lang="en-US" sz="2100">
+                <a:solidFill>
+                  <a:srgbClr val="D7E3EA"/>
+                </a:solidFill>
+              </a:rPr>
+              <a:t>After 40% operating/protocol/reserve deductions: approximately 15% net APR.</a:t>
+            </a:r>
+          </a:p>
+          <a:p>
+            <a:pPr marL="285750" indent="-171450">
+              <a:buChar char="•"/>
+            </a:pPr>
+            <a:r>
+              <a:rPr lang="en-US" sz="2100">
+                <a:solidFill>
+                  <a:srgbClr val="D7E3EA"/>
+                </a:solidFill>
+              </a:rPr>
+              <a:t>Trade.xyz trailing fees imply approximately 3.47% gross APR on the minimum stake.</a:t>
+            </a:r>
+          </a:p>
+          <a:p>
+            <a:pPr marL="285750" indent="-171450">
+              <a:buChar char="•"/>
+            </a:pPr>
+            <a:r>
+              <a:rPr lang="en-US" sz="2100">
+                <a:solidFill>
+                  <a:srgbClr val="D7E3EA"/>
+                </a:solidFill>
+              </a:rPr>
+              <a:t>Sensitivity matters more than headline APR.</a:t>
             </a:r>
           </a:p>
         </p:txBody>
@@ -1526,7 +1550,7 @@
                   <a:srgbClr val="F4F7F8"/>
                 </a:solidFill>
               </a:rPr>
-              <a:t>MVP</a:t>
+              <a:t>Risk Controls</a:t>
             </a:r>
           </a:p>
         </p:txBody>
@@ -1560,72 +1584,33 @@
                   <a:srgbClr val="D7E3EA"/>
                 </a:solidFill>
               </a:rPr>
-              <a:t>One HIP.markets-operated DEX.</a:t>
-            </a:r>
-          </a:p>
-          <a:p>
-            <a:pPr marL="285750" indent="-171450">
-              <a:buChar char="•"/>
-            </a:pPr>
-            <a:r>
-              <a:rPr lang="en-US" sz="2100">
-                <a:solidFill>
-                  <a:srgbClr val="D7E3EA"/>
-                </a:solidFill>
-              </a:rPr>
-              <a:t>One HYPE vault.</a:t>
-            </a:r>
-          </a:p>
-          <a:p>
-            <a:pPr marL="285750" indent="-171450">
-              <a:buChar char="•"/>
-            </a:pPr>
-            <a:r>
-              <a:rPr lang="en-US" sz="2100">
-                <a:solidFill>
-                  <a:srgbClr val="D7E3EA"/>
-                </a:solidFill>
-              </a:rPr>
-              <a:t>First three markets.</a:t>
-            </a:r>
-          </a:p>
-          <a:p>
-            <a:pPr marL="285750" indent="-171450">
-              <a:buChar char="•"/>
-            </a:pPr>
-            <a:r>
-              <a:rPr lang="en-US" sz="2100">
-                <a:solidFill>
-                  <a:srgbClr val="D7E3EA"/>
-                </a:solidFill>
-              </a:rPr>
-              <a:t>Weekly distributions.</a:t>
-            </a:r>
-          </a:p>
-          <a:p>
-            <a:pPr marL="285750" indent="-171450">
-              <a:buChar char="•"/>
-            </a:pPr>
-            <a:r>
-              <a:rPr lang="en-US" sz="2100">
-                <a:solidFill>
-                  <a:srgbClr val="D7E3EA"/>
-                </a:solidFill>
-              </a:rPr>
-              <a:t>Public dashboard.</a:t>
-            </a:r>
-          </a:p>
-          <a:p>
-            <a:pPr marL="285750" indent="-171450">
-              <a:buChar char="•"/>
-            </a:pPr>
-            <a:r>
-              <a:rPr lang="en-US" sz="2100">
-                <a:solidFill>
-                  <a:srgbClr val="D7E3EA"/>
-                </a:solidFill>
-              </a:rPr>
-              <a:t>No third-party operator financing.</a:t>
+              <a:t>Start with oracle-simple markets.</a:t>
+            </a:r>
+          </a:p>
+          <a:p>
+            <a:pPr marL="285750" indent="-171450">
+              <a:buChar char="•"/>
+            </a:pPr>
+            <a:r>
+              <a:rPr lang="en-US" sz="2100">
+                <a:solidFill>
+                  <a:srgbClr val="D7E3EA"/>
+                </a:solidFill>
+              </a:rPr>
+              <a:t>Avoid extra ticker auction costs at launch.</a:t>
+            </a:r>
+          </a:p>
+          <a:p>
+            <a:pPr marL="285750" indent="-171450">
+              <a:buChar char="•"/>
+            </a:pPr>
+            <a:r>
+              <a:rPr lang="en-US" sz="2100">
+                <a:solidFill>
+                  <a:srgbClr val="D7E3EA"/>
+                </a:solidFill>
+              </a:rPr>
+              <a:t>Cap open interest, publish addresses, maintain reserve, pause deposits during incidents.</a:t>
             </a:r>
           </a:p>
         </p:txBody>
@@ -1719,7 +1704,7 @@
                   <a:srgbClr val="F4F7F8"/>
                 </a:solidFill>
               </a:rPr>
-              <a:t>Roadmap</a:t>
+              <a:t>Cost Stack</a:t>
             </a:r>
           </a:p>
         </p:txBody>
@@ -1753,33 +1738,20 @@
                   <a:srgbClr val="D7E3EA"/>
                 </a:solidFill>
               </a:rPr>
-              <a:t>V1: prove operator vault and fee sharing.</a:t>
-            </a:r>
-          </a:p>
-          <a:p>
-            <a:pPr marL="285750" indent="-171450">
-              <a:buChar char="•"/>
-            </a:pPr>
-            <a:r>
-              <a:rPr lang="en-US" sz="2100">
-                <a:solidFill>
-                  <a:srgbClr val="D7E3EA"/>
-                </a:solidFill>
-              </a:rPr>
-              <a:t>V2: more HIP.markets market vaults and automated fee verification.</a:t>
-            </a:r>
-          </a:p>
-          <a:p>
-            <a:pPr marL="285750" indent="-171450">
-              <a:buChar char="•"/>
-            </a:pPr>
-            <a:r>
-              <a:rPr lang="en-US" sz="2100">
-                <a:solidFill>
-                  <a:srgbClr val="D7E3EA"/>
-                </a:solidFill>
-              </a:rPr>
-              <a:t>V3: risk tranching, secondary shares, HIP-4, possible third-party financing once the trust model is mature.</a:t>
+              <a:t>The 500k HYPE stake is the entry ticket, not the full cost of business.</a:t>
+            </a:r>
+          </a:p>
+          <a:p>
+            <a:pPr marL="285750" indent="-171450">
+              <a:buChar char="•"/>
+            </a:pPr>
+            <a:r>
+              <a:rPr lang="en-US" sz="2100">
+                <a:solidFill>
+                  <a:srgbClr val="D7E3EA"/>
+                </a:solidFill>
+              </a:rPr>
+              <a:t>Budget for oracle relayers, licensed data, maker incentives, infrastructure, key management, audits, legal work, and incident reserves.</a:t>
             </a:r>
           </a:p>
         </p:txBody>
@@ -2027,7 +1999,7 @@
                   <a:srgbClr val="F4F7F8"/>
                 </a:solidFill>
               </a:rPr>
-              <a:t>Competitive Position</a:t>
+              <a:t>MVP</a:t>
             </a:r>
           </a:p>
         </p:txBody>
@@ -2061,33 +2033,72 @@
                   <a:srgbClr val="D7E3EA"/>
                 </a:solidFill>
               </a:rPr>
-              <a:t>trade.xyz and HyENA operate markets directly.</a:t>
-            </a:r>
-          </a:p>
-          <a:p>
-            <a:pPr marL="285750" indent="-171450">
-              <a:buChar char="•"/>
-            </a:pPr>
-            <a:r>
-              <a:rPr lang="en-US" sz="2100">
-                <a:solidFill>
-                  <a:srgbClr val="D7E3EA"/>
-                </a:solidFill>
-              </a:rPr>
-              <a:t>HIP.markets also operates markets directly, but adds user-funded HYPE stake and transparent fee sharing.</a:t>
-            </a:r>
-          </a:p>
-          <a:p>
-            <a:pPr marL="285750" indent="-171450">
-              <a:buChar char="•"/>
-            </a:pPr>
-            <a:r>
-              <a:rPr lang="en-US" sz="2100">
-                <a:solidFill>
-                  <a:srgbClr val="D7E3EA"/>
-                </a:solidFill>
-              </a:rPr>
-              <a:t>The wedge is making HYPE holders economic backers of the operator.</a:t>
+              <a:t>One HIP.markets-operated DEX.</a:t>
+            </a:r>
+          </a:p>
+          <a:p>
+            <a:pPr marL="285750" indent="-171450">
+              <a:buChar char="•"/>
+            </a:pPr>
+            <a:r>
+              <a:rPr lang="en-US" sz="2100">
+                <a:solidFill>
+                  <a:srgbClr val="D7E3EA"/>
+                </a:solidFill>
+              </a:rPr>
+              <a:t>One HYPE vault.</a:t>
+            </a:r>
+          </a:p>
+          <a:p>
+            <a:pPr marL="285750" indent="-171450">
+              <a:buChar char="•"/>
+            </a:pPr>
+            <a:r>
+              <a:rPr lang="en-US" sz="2100">
+                <a:solidFill>
+                  <a:srgbClr val="D7E3EA"/>
+                </a:solidFill>
+              </a:rPr>
+              <a:t>First three markets.</a:t>
+            </a:r>
+          </a:p>
+          <a:p>
+            <a:pPr marL="285750" indent="-171450">
+              <a:buChar char="•"/>
+            </a:pPr>
+            <a:r>
+              <a:rPr lang="en-US" sz="2100">
+                <a:solidFill>
+                  <a:srgbClr val="D7E3EA"/>
+                </a:solidFill>
+              </a:rPr>
+              <a:t>Weekly distributions.</a:t>
+            </a:r>
+          </a:p>
+          <a:p>
+            <a:pPr marL="285750" indent="-171450">
+              <a:buChar char="•"/>
+            </a:pPr>
+            <a:r>
+              <a:rPr lang="en-US" sz="2100">
+                <a:solidFill>
+                  <a:srgbClr val="D7E3EA"/>
+                </a:solidFill>
+              </a:rPr>
+              <a:t>Public dashboard.</a:t>
+            </a:r>
+          </a:p>
+          <a:p>
+            <a:pPr marL="285750" indent="-171450">
+              <a:buChar char="•"/>
+            </a:pPr>
+            <a:r>
+              <a:rPr lang="en-US" sz="2100">
+                <a:solidFill>
+                  <a:srgbClr val="D7E3EA"/>
+                </a:solidFill>
+              </a:rPr>
+              <a:t>No third-party operator financing.</a:t>
             </a:r>
           </a:p>
         </p:txBody>
@@ -2181,7 +2192,7 @@
                   <a:srgbClr val="F4F7F8"/>
                 </a:solidFill>
               </a:rPr>
-              <a:t>Ask</a:t>
+              <a:t>Roadmap</a:t>
             </a:r>
           </a:p>
         </p:txBody>
@@ -2215,59 +2226,33 @@
                   <a:srgbClr val="D7E3EA"/>
                 </a:solidFill>
               </a:rPr>
-              <a:t>HYPE holders for capped beta.</a:t>
-            </a:r>
-          </a:p>
-          <a:p>
-            <a:pPr marL="285750" indent="-171450">
-              <a:buChar char="•"/>
-            </a:pPr>
-            <a:r>
-              <a:rPr lang="en-US" sz="2100">
-                <a:solidFill>
-                  <a:srgbClr val="D7E3EA"/>
-                </a:solidFill>
-              </a:rPr>
-              <a:t>Market makers for first markets.</a:t>
-            </a:r>
-          </a:p>
-          <a:p>
-            <a:pPr marL="285750" indent="-171450">
-              <a:buChar char="•"/>
-            </a:pPr>
-            <a:r>
-              <a:rPr lang="en-US" sz="2100">
-                <a:solidFill>
-                  <a:srgbClr val="D7E3EA"/>
-                </a:solidFill>
-              </a:rPr>
-              <a:t>Oracle and data partners.</a:t>
-            </a:r>
-          </a:p>
-          <a:p>
-            <a:pPr marL="285750" indent="-171450">
-              <a:buChar char="•"/>
-            </a:pPr>
-            <a:r>
-              <a:rPr lang="en-US" sz="2100">
-                <a:solidFill>
-                  <a:srgbClr val="D7E3EA"/>
-                </a:solidFill>
-              </a:rPr>
-              <a:t>Security reviewers.</a:t>
-            </a:r>
-          </a:p>
-          <a:p>
-            <a:pPr marL="285750" indent="-171450">
-              <a:buChar char="•"/>
-            </a:pPr>
-            <a:r>
-              <a:rPr lang="en-US" sz="2100">
-                <a:solidFill>
-                  <a:srgbClr val="D7E3EA"/>
-                </a:solidFill>
-              </a:rPr>
-              <a:t>Hyperliquid feedback on custody and fee routing.</a:t>
+              <a:t>V1: prove operator vault and fee sharing.</a:t>
+            </a:r>
+          </a:p>
+          <a:p>
+            <a:pPr marL="285750" indent="-171450">
+              <a:buChar char="•"/>
+            </a:pPr>
+            <a:r>
+              <a:rPr lang="en-US" sz="2100">
+                <a:solidFill>
+                  <a:srgbClr val="D7E3EA"/>
+                </a:solidFill>
+              </a:rPr>
+              <a:t>V2: more HIP.markets market vaults and automated fee verification.</a:t>
+            </a:r>
+          </a:p>
+          <a:p>
+            <a:pPr marL="285750" indent="-171450">
+              <a:buChar char="•"/>
+            </a:pPr>
+            <a:r>
+              <a:rPr lang="en-US" sz="2100">
+                <a:solidFill>
+                  <a:srgbClr val="D7E3EA"/>
+                </a:solidFill>
+              </a:rPr>
+              <a:t>V3: risk tranching, secondary shares, HIP-4, possible third-party financing once the trust model is mature.</a:t>
             </a:r>
           </a:p>
         </p:txBody>
@@ -2361,7 +2346,7 @@
                   <a:srgbClr val="F4F7F8"/>
                 </a:solidFill>
               </a:rPr>
-              <a:t>Closing</a:t>
+              <a:t>Competitive Position</a:t>
             </a:r>
           </a:p>
         </p:txBody>
@@ -2395,20 +2380,33 @@
                   <a:srgbClr val="D7E3EA"/>
                 </a:solidFill>
               </a:rPr>
-              <a:t>HIP.markets turns builder-deployed markets into a community-backed operator business.</a:t>
-            </a:r>
-          </a:p>
-          <a:p>
-            <a:pPr marL="285750" indent="-171450">
-              <a:buChar char="•"/>
-            </a:pPr>
-            <a:r>
-              <a:rPr lang="en-US" sz="2100">
-                <a:solidFill>
-                  <a:srgbClr val="D7E3EA"/>
-                </a:solidFill>
-              </a:rPr>
-              <a:t>The first job is operating markets safely.</a:t>
+              <a:t>trade.xyz and HyENA operate markets directly.</a:t>
+            </a:r>
+          </a:p>
+          <a:p>
+            <a:pPr marL="285750" indent="-171450">
+              <a:buChar char="•"/>
+            </a:pPr>
+            <a:r>
+              <a:rPr lang="en-US" sz="2100">
+                <a:solidFill>
+                  <a:srgbClr val="D7E3EA"/>
+                </a:solidFill>
+              </a:rPr>
+              <a:t>HIP.markets also operates markets directly, but adds user-funded HYPE stake and transparent fee sharing.</a:t>
+            </a:r>
+          </a:p>
+          <a:p>
+            <a:pPr marL="285750" indent="-171450">
+              <a:buChar char="•"/>
+            </a:pPr>
+            <a:r>
+              <a:rPr lang="en-US" sz="2100">
+                <a:solidFill>
+                  <a:srgbClr val="D7E3EA"/>
+                </a:solidFill>
+              </a:rPr>
+              <a:t>The wedge is making HYPE holders economic backers of the operator.</a:t>
             </a:r>
           </a:p>
         </p:txBody>
@@ -2440,6 +2438,327 @@
                 </a:solidFill>
               </a:rPr>
               <a:t>HIP.markets hackathon submission  |  22</a:t>
+            </a:r>
+          </a:p>
+        </p:txBody>
+      </p:sp>
+    </p:spTree>
+  </p:cSld>
+  <p:clrMapOvr>
+    <a:masterClrMapping/>
+  </p:clrMapOvr>
+</p:sld>
+</file>
+
+<file path=ppt/slides/slide23.xml><?xml version="1.0" encoding="utf-8"?>
+<p:sld xmlns:a="http://schemas.openxmlformats.org/drawingml/2006/main" xmlns:r="http://schemas.openxmlformats.org/officeDocument/2006/relationships" xmlns:p="http://schemas.openxmlformats.org/presentationml/2006/main">
+  <p:cSld>
+    <p:bg>
+      <p:bgPr>
+        <a:solidFill>
+          <a:srgbClr val="080A0D"/>
+        </a:solidFill>
+      </p:bgPr>
+    </p:bg>
+    <p:spTree>
+      <p:nvGrpSpPr>
+        <p:cNvPr id="1" name=""/>
+        <p:cNvGrpSpPr/>
+        <p:nvPr/>
+      </p:nvGrpSpPr>
+      <p:grpSpPr>
+        <a:xfrm>
+          <a:off x="0" y="0"/>
+          <a:ext cx="0" cy="0"/>
+          <a:chOff x="0" y="0"/>
+          <a:chExt cx="0" cy="0"/>
+        </a:xfrm>
+      </p:grpSpPr>
+      <p:sp>
+        <p:nvSpPr>
+          <p:cNvPr id="2" name="Title"/>
+          <p:cNvSpPr txBox="1"/>
+          <p:nvPr/>
+        </p:nvSpPr>
+        <p:spPr>
+          <a:xfrm>
+            <a:off x="609600" y="610000"/>
+            <a:ext cx="10300000" cy="850000"/>
+          </a:xfrm>
+          <a:prstGeom prst="rect">
+            <a:avLst/>
+          </a:prstGeom>
+          <a:noFill/>
+        </p:spPr>
+        <p:txBody>
+          <a:bodyPr wrap="square"/>
+          <a:lstStyle/>
+          <a:p>
+            <a:r>
+              <a:rPr lang="en-US" sz="4100" b="1">
+                <a:solidFill>
+                  <a:srgbClr val="F4F7F8"/>
+                </a:solidFill>
+              </a:rPr>
+              <a:t>Ask</a:t>
+            </a:r>
+          </a:p>
+        </p:txBody>
+      </p:sp>
+      <p:sp>
+        <p:nvSpPr>
+          <p:cNvPr id="3" name="Body"/>
+          <p:cNvSpPr txBox="1"/>
+          <p:nvPr/>
+        </p:nvSpPr>
+        <p:spPr>
+          <a:xfrm>
+            <a:off x="914400" y="1905000"/>
+            <a:ext cx="9800000" cy="3900000"/>
+          </a:xfrm>
+          <a:prstGeom prst="rect">
+            <a:avLst/>
+          </a:prstGeom>
+          <a:noFill/>
+        </p:spPr>
+        <p:txBody>
+          <a:bodyPr wrap="square"/>
+          <a:lstStyle/>
+          <a:p>
+            <a:pPr marL="285750" indent="-171450">
+              <a:buChar char="•"/>
+            </a:pPr>
+            <a:r>
+              <a:rPr lang="en-US" sz="2100">
+                <a:solidFill>
+                  <a:srgbClr val="D7E3EA"/>
+                </a:solidFill>
+              </a:rPr>
+              <a:t>HYPE holders for capped beta.</a:t>
+            </a:r>
+          </a:p>
+          <a:p>
+            <a:pPr marL="285750" indent="-171450">
+              <a:buChar char="•"/>
+            </a:pPr>
+            <a:r>
+              <a:rPr lang="en-US" sz="2100">
+                <a:solidFill>
+                  <a:srgbClr val="D7E3EA"/>
+                </a:solidFill>
+              </a:rPr>
+              <a:t>Market makers for first markets.</a:t>
+            </a:r>
+          </a:p>
+          <a:p>
+            <a:pPr marL="285750" indent="-171450">
+              <a:buChar char="•"/>
+            </a:pPr>
+            <a:r>
+              <a:rPr lang="en-US" sz="2100">
+                <a:solidFill>
+                  <a:srgbClr val="D7E3EA"/>
+                </a:solidFill>
+              </a:rPr>
+              <a:t>Oracle and data partners.</a:t>
+            </a:r>
+          </a:p>
+          <a:p>
+            <a:pPr marL="285750" indent="-171450">
+              <a:buChar char="•"/>
+            </a:pPr>
+            <a:r>
+              <a:rPr lang="en-US" sz="2100">
+                <a:solidFill>
+                  <a:srgbClr val="D7E3EA"/>
+                </a:solidFill>
+              </a:rPr>
+              <a:t>Security reviewers.</a:t>
+            </a:r>
+          </a:p>
+          <a:p>
+            <a:pPr marL="285750" indent="-171450">
+              <a:buChar char="•"/>
+            </a:pPr>
+            <a:r>
+              <a:rPr lang="en-US" sz="2100">
+                <a:solidFill>
+                  <a:srgbClr val="D7E3EA"/>
+                </a:solidFill>
+              </a:rPr>
+              <a:t>Hyperliquid feedback on custody and fee routing.</a:t>
+            </a:r>
+          </a:p>
+        </p:txBody>
+      </p:sp>
+      <p:sp>
+        <p:nvSpPr>
+          <p:cNvPr id="4" name="Footer"/>
+          <p:cNvSpPr txBox="1"/>
+          <p:nvPr/>
+        </p:nvSpPr>
+        <p:spPr>
+          <a:xfrm>
+            <a:off x="609600" y="6400800"/>
+            <a:ext cx="10500000" cy="300000"/>
+          </a:xfrm>
+          <a:prstGeom prst="rect">
+            <a:avLst/>
+          </a:prstGeom>
+          <a:noFill/>
+        </p:spPr>
+        <p:txBody>
+          <a:bodyPr wrap="square"/>
+          <a:lstStyle/>
+          <a:p>
+            <a:r>
+              <a:rPr lang="en-US" sz="1000">
+                <a:solidFill>
+                  <a:srgbClr val="35D29A"/>
+                </a:solidFill>
+              </a:rPr>
+              <a:t>HIP.markets hackathon submission  |  23</a:t>
+            </a:r>
+          </a:p>
+        </p:txBody>
+      </p:sp>
+    </p:spTree>
+  </p:cSld>
+  <p:clrMapOvr>
+    <a:masterClrMapping/>
+  </p:clrMapOvr>
+</p:sld>
+</file>
+
+<file path=ppt/slides/slide24.xml><?xml version="1.0" encoding="utf-8"?>
+<p:sld xmlns:a="http://schemas.openxmlformats.org/drawingml/2006/main" xmlns:r="http://schemas.openxmlformats.org/officeDocument/2006/relationships" xmlns:p="http://schemas.openxmlformats.org/presentationml/2006/main">
+  <p:cSld>
+    <p:bg>
+      <p:bgPr>
+        <a:solidFill>
+          <a:srgbClr val="080A0D"/>
+        </a:solidFill>
+      </p:bgPr>
+    </p:bg>
+    <p:spTree>
+      <p:nvGrpSpPr>
+        <p:cNvPr id="1" name=""/>
+        <p:cNvGrpSpPr/>
+        <p:nvPr/>
+      </p:nvGrpSpPr>
+      <p:grpSpPr>
+        <a:xfrm>
+          <a:off x="0" y="0"/>
+          <a:ext cx="0" cy="0"/>
+          <a:chOff x="0" y="0"/>
+          <a:chExt cx="0" cy="0"/>
+        </a:xfrm>
+      </p:grpSpPr>
+      <p:sp>
+        <p:nvSpPr>
+          <p:cNvPr id="2" name="Title"/>
+          <p:cNvSpPr txBox="1"/>
+          <p:nvPr/>
+        </p:nvSpPr>
+        <p:spPr>
+          <a:xfrm>
+            <a:off x="609600" y="610000"/>
+            <a:ext cx="10300000" cy="850000"/>
+          </a:xfrm>
+          <a:prstGeom prst="rect">
+            <a:avLst/>
+          </a:prstGeom>
+          <a:noFill/>
+        </p:spPr>
+        <p:txBody>
+          <a:bodyPr wrap="square"/>
+          <a:lstStyle/>
+          <a:p>
+            <a:r>
+              <a:rPr lang="en-US" sz="4100" b="1">
+                <a:solidFill>
+                  <a:srgbClr val="F4F7F8"/>
+                </a:solidFill>
+              </a:rPr>
+              <a:t>Closing</a:t>
+            </a:r>
+          </a:p>
+        </p:txBody>
+      </p:sp>
+      <p:sp>
+        <p:nvSpPr>
+          <p:cNvPr id="3" name="Body"/>
+          <p:cNvSpPr txBox="1"/>
+          <p:nvPr/>
+        </p:nvSpPr>
+        <p:spPr>
+          <a:xfrm>
+            <a:off x="914400" y="1905000"/>
+            <a:ext cx="9800000" cy="3900000"/>
+          </a:xfrm>
+          <a:prstGeom prst="rect">
+            <a:avLst/>
+          </a:prstGeom>
+          <a:noFill/>
+        </p:spPr>
+        <p:txBody>
+          <a:bodyPr wrap="square"/>
+          <a:lstStyle/>
+          <a:p>
+            <a:pPr marL="285750" indent="-171450">
+              <a:buChar char="•"/>
+            </a:pPr>
+            <a:r>
+              <a:rPr lang="en-US" sz="2100">
+                <a:solidFill>
+                  <a:srgbClr val="D7E3EA"/>
+                </a:solidFill>
+              </a:rPr>
+              <a:t>HIP.markets turns builder-deployed markets into a community-backed operator business.</a:t>
+            </a:r>
+          </a:p>
+          <a:p>
+            <a:pPr marL="285750" indent="-171450">
+              <a:buChar char="•"/>
+            </a:pPr>
+            <a:r>
+              <a:rPr lang="en-US" sz="2100">
+                <a:solidFill>
+                  <a:srgbClr val="D7E3EA"/>
+                </a:solidFill>
+              </a:rPr>
+              <a:t>The first job is operating markets safely.</a:t>
+            </a:r>
+          </a:p>
+        </p:txBody>
+      </p:sp>
+      <p:sp>
+        <p:nvSpPr>
+          <p:cNvPr id="4" name="Footer"/>
+          <p:cNvSpPr txBox="1"/>
+          <p:nvPr/>
+        </p:nvSpPr>
+        <p:spPr>
+          <a:xfrm>
+            <a:off x="609600" y="6400800"/>
+            <a:ext cx="10500000" cy="300000"/>
+          </a:xfrm>
+          <a:prstGeom prst="rect">
+            <a:avLst/>
+          </a:prstGeom>
+          <a:noFill/>
+        </p:spPr>
+        <p:txBody>
+          <a:bodyPr wrap="square"/>
+          <a:lstStyle/>
+          <a:p>
+            <a:r>
+              <a:rPr lang="en-US" sz="1000">
+                <a:solidFill>
+                  <a:srgbClr val="35D29A"/>
+                </a:solidFill>
+              </a:rPr>
+              <a:t>HIP.markets hackathon submission  |  24</a:t>
             </a:r>
           </a:p>
         </p:txBody>

</xml_diff>

<commit_message>
Add branded mascot and polish presentation
</commit_message>
<xml_diff>
--- a/presentation/HIP_MARKETS_DECK.pptx
+++ b/presentation/HIP_MARKETS_DECK.pptx
@@ -29,6 +29,7 @@
     <p:sldId id="277" r:id="rId24"/>
     <p:sldId id="278" r:id="rId25"/>
     <p:sldId id="279" r:id="rId26"/>
+    <p:sldId id="280" r:id="rId27"/>
   </p:sldIdLst>
   <p:sldSz cx="12192000" cy="6858000" type="wide"/>
   <p:notesSz cx="6858000" cy="9144000"/>
@@ -278,7 +279,7 @@
                   <a:srgbClr val="F4F7F8"/>
                 </a:solidFill>
               </a:rPr>
-              <a:t>Demo Walkthrough</a:t>
+              <a:t>UX Translation</a:t>
             </a:r>
           </a:p>
         </p:txBody>
@@ -291,67 +292,71 @@
         </p:nvSpPr>
         <p:spPr>
           <a:xfrm>
-            <a:off x="609600" y="1630000"/>
-            <a:ext cx="4600000" cy="4400000"/>
-          </a:xfrm>
-          <a:prstGeom prst="rect">
-            <a:avLst/>
-          </a:prstGeom>
-          <a:noFill/>
-        </p:spPr>
-        <p:txBody>
-          <a:bodyPr wrap="square"/>
-          <a:lstStyle/>
-          <a:p>
-            <a:pPr marL="285750" indent="-171450">
-              <a:buChar char="•"/>
-            </a:pPr>
-            <a:r>
-              <a:rPr lang="en-US" sz="2100">
-                <a:solidFill>
-                  <a:srgbClr val="D7E3EA"/>
-                </a:solidFill>
-              </a:rPr>
-              <a:t>The first screen is the usable operator console, not a landing page.</a:t>
-            </a:r>
-          </a:p>
-          <a:p>
-            <a:pPr marL="285750" indent="-171450">
-              <a:buChar char="•"/>
-            </a:pPr>
-            <a:r>
-              <a:rPr lang="en-US" sz="2100">
-                <a:solidFill>
-                  <a:srgbClr val="D7E3EA"/>
-                </a:solidFill>
-              </a:rPr>
-              <a:t>Vault capacity, APR, oracle cadence, risk state, market rail, fee model, deposit ticket, and monitor are visible in one workflow.</a:t>
-            </a:r>
-          </a:p>
-        </p:txBody>
-      </p:sp>
-      <p:pic>
-        <p:nvPicPr>
-          <p:cNvPr id="5" name="demo-dashboard.png"/>
-          <p:cNvPicPr/>
-          <p:nvPr/>
-        </p:nvPicPr>
-        <p:blipFill>
-          <a:blip r:embed="rId1"/>
-          <a:stretch>
-            <a:fillRect/>
-          </a:stretch>
-        </p:blipFill>
-        <p:spPr>
-          <a:xfrm>
-            <a:off x="5450000" y="1500000"/>
-            <a:ext cx="6130000" cy="3450000"/>
-          </a:xfrm>
-          <a:prstGeom prst="rect">
-            <a:avLst/>
-          </a:prstGeom>
-        </p:spPr>
-      </p:pic>
+            <a:off x="914400" y="1905000"/>
+            <a:ext cx="9800000" cy="3900000"/>
+          </a:xfrm>
+          <a:prstGeom prst="rect">
+            <a:avLst/>
+          </a:prstGeom>
+          <a:noFill/>
+        </p:spPr>
+        <p:txBody>
+          <a:bodyPr wrap="square"/>
+          <a:lstStyle/>
+          <a:p>
+            <a:pPr marL="285750" indent="-171450">
+              <a:buChar char="•"/>
+            </a:pPr>
+            <a:r>
+              <a:rPr lang="en-US" sz="2100">
+                <a:solidFill>
+                  <a:srgbClr val="D7E3EA"/>
+                </a:solidFill>
+              </a:rPr>
+              <a:t>Market rail -&gt; first-three-market launch rail.</a:t>
+            </a:r>
+          </a:p>
+          <a:p>
+            <a:pPr marL="285750" indent="-171450">
+              <a:buChar char="•"/>
+            </a:pPr>
+            <a:r>
+              <a:rPr lang="en-US" sz="2100">
+                <a:solidFill>
+                  <a:srgbClr val="D7E3EA"/>
+                </a:solidFill>
+              </a:rPr>
+              <a:t>Order ticket -&gt; HYPE deposit ticket.</a:t>
+            </a:r>
+          </a:p>
+          <a:p>
+            <a:pPr marL="285750" indent="-171450">
+              <a:buChar char="•"/>
+            </a:pPr>
+            <a:r>
+              <a:rPr lang="en-US" sz="2100">
+                <a:solidFill>
+                  <a:srgbClr val="D7E3EA"/>
+                </a:solidFill>
+              </a:rPr>
+              <a:t>Positions panel -&gt; vault shares, fee history, oracle updates, market launches.</a:t>
+            </a:r>
+          </a:p>
+          <a:p>
+            <a:pPr marL="285750" indent="-171450">
+              <a:buChar char="•"/>
+            </a:pPr>
+            <a:r>
+              <a:rPr lang="en-US" sz="2100">
+                <a:solidFill>
+                  <a:srgbClr val="D7E3EA"/>
+                </a:solidFill>
+              </a:rPr>
+              <a:t>Ghost Mode -&gt; operator monitor.</a:t>
+            </a:r>
+          </a:p>
+        </p:txBody>
+      </p:sp>
       <p:sp>
         <p:nvSpPr>
           <p:cNvPr id="4" name="Footer"/>
@@ -441,7 +446,7 @@
                   <a:srgbClr val="F4F7F8"/>
                 </a:solidFill>
               </a:rPr>
-              <a:t>Demo: Fee Model</a:t>
+              <a:t>Demo Walkthrough</a:t>
             </a:r>
           </a:p>
         </p:txBody>
@@ -454,45 +459,67 @@
         </p:nvSpPr>
         <p:spPr>
           <a:xfrm>
-            <a:off x="914400" y="1905000"/>
-            <a:ext cx="9800000" cy="3900000"/>
-          </a:xfrm>
-          <a:prstGeom prst="rect">
-            <a:avLst/>
-          </a:prstGeom>
-          <a:noFill/>
-        </p:spPr>
-        <p:txBody>
-          <a:bodyPr wrap="square"/>
-          <a:lstStyle/>
-          <a:p>
-            <a:pPr marL="285750" indent="-171450">
-              <a:buChar char="•"/>
-            </a:pPr>
-            <a:r>
-              <a:rPr lang="en-US" sz="2100">
-                <a:solidFill>
-                  <a:srgbClr val="D7E3EA"/>
-                </a:solidFill>
-              </a:rPr>
-              <a:t>Judges can change HYPE price, staked HYPE, daily volume, fee bps, builder share, operating fee, protocol fee, and reserve.</a:t>
-            </a:r>
-          </a:p>
-          <a:p>
-            <a:pPr marL="285750" indent="-171450">
-              <a:buChar char="•"/>
-            </a:pPr>
-            <a:r>
-              <a:rPr lang="en-US" sz="2100">
-                <a:solidFill>
-                  <a:srgbClr val="D7E3EA"/>
-                </a:solidFill>
-              </a:rPr>
-              <a:t>APR updates instantly.</a:t>
-            </a:r>
-          </a:p>
-        </p:txBody>
-      </p:sp>
+            <a:off x="609600" y="1630000"/>
+            <a:ext cx="4600000" cy="4400000"/>
+          </a:xfrm>
+          <a:prstGeom prst="rect">
+            <a:avLst/>
+          </a:prstGeom>
+          <a:noFill/>
+        </p:spPr>
+        <p:txBody>
+          <a:bodyPr wrap="square"/>
+          <a:lstStyle/>
+          <a:p>
+            <a:pPr marL="285750" indent="-171450">
+              <a:buChar char="•"/>
+            </a:pPr>
+            <a:r>
+              <a:rPr lang="en-US" sz="2100">
+                <a:solidFill>
+                  <a:srgbClr val="D7E3EA"/>
+                </a:solidFill>
+              </a:rPr>
+              <a:t>The first screen is the usable operator console, not a landing page.</a:t>
+            </a:r>
+          </a:p>
+          <a:p>
+            <a:pPr marL="285750" indent="-171450">
+              <a:buChar char="•"/>
+            </a:pPr>
+            <a:r>
+              <a:rPr lang="en-US" sz="2100">
+                <a:solidFill>
+                  <a:srgbClr val="D7E3EA"/>
+                </a:solidFill>
+              </a:rPr>
+              <a:t>Vault capacity, APR, oracle cadence, risk state, market rail, fee model, deposit ticket, and monitor are visible in one workflow.</a:t>
+            </a:r>
+          </a:p>
+        </p:txBody>
+      </p:sp>
+      <p:pic>
+        <p:nvPicPr>
+          <p:cNvPr id="5" name="demo-dashboard.png"/>
+          <p:cNvPicPr/>
+          <p:nvPr/>
+        </p:nvPicPr>
+        <p:blipFill>
+          <a:blip r:embed="rId1"/>
+          <a:stretch>
+            <a:fillRect/>
+          </a:stretch>
+        </p:blipFill>
+        <p:spPr>
+          <a:xfrm>
+            <a:off x="5450000" y="1500000"/>
+            <a:ext cx="6130000" cy="3450000"/>
+          </a:xfrm>
+          <a:prstGeom prst="rect">
+            <a:avLst/>
+          </a:prstGeom>
+        </p:spPr>
+      </p:pic>
       <p:sp>
         <p:nvSpPr>
           <p:cNvPr id="4" name="Footer"/>
@@ -582,7 +609,7 @@
                   <a:srgbClr val="F4F7F8"/>
                 </a:solidFill>
               </a:rPr>
-              <a:t>Demo: Deposit Ticket</a:t>
+              <a:t>Demo: Fee Model</a:t>
             </a:r>
           </a:p>
         </p:txBody>
@@ -616,20 +643,20 @@
                   <a:srgbClr val="D7E3EA"/>
                 </a:solidFill>
               </a:rPr>
-              <a:t>Mirrors a trading order pane.</a:t>
-            </a:r>
-          </a:p>
-          <a:p>
-            <a:pPr marL="285750" indent="-171450">
-              <a:buChar char="•"/>
-            </a:pPr>
-            <a:r>
-              <a:rPr lang="en-US" sz="2100">
-                <a:solidFill>
-                  <a:srgbClr val="D7E3EA"/>
-                </a:solidFill>
-              </a:rPr>
-              <a:t>Amount input, deposit/withdraw mode, fee summary, user rewards estimate, and slashing warning.</a:t>
+              <a:t>Judges can change HYPE price, staked HYPE, daily volume, fee bps, builder share, operating fee, protocol fee, and reserve.</a:t>
+            </a:r>
+          </a:p>
+          <a:p>
+            <a:pPr marL="285750" indent="-171450">
+              <a:buChar char="•"/>
+            </a:pPr>
+            <a:r>
+              <a:rPr lang="en-US" sz="2100">
+                <a:solidFill>
+                  <a:srgbClr val="D7E3EA"/>
+                </a:solidFill>
+              </a:rPr>
+              <a:t>APR updates instantly.</a:t>
             </a:r>
           </a:p>
         </p:txBody>
@@ -723,7 +750,7 @@
                   <a:srgbClr val="F4F7F8"/>
                 </a:solidFill>
               </a:rPr>
-              <a:t>Demo: Audit Ledger</a:t>
+              <a:t>Demo: Deposit Ticket</a:t>
             </a:r>
           </a:p>
         </p:txBody>
@@ -736,67 +763,45 @@
         </p:nvSpPr>
         <p:spPr>
           <a:xfrm>
-            <a:off x="609600" y="1630000"/>
-            <a:ext cx="4600000" cy="4400000"/>
-          </a:xfrm>
-          <a:prstGeom prst="rect">
-            <a:avLst/>
-          </a:prstGeom>
-          <a:noFill/>
-        </p:spPr>
-        <p:txBody>
-          <a:bodyPr wrap="square"/>
-          <a:lstStyle/>
-          <a:p>
-            <a:pPr marL="285750" indent="-171450">
-              <a:buChar char="•"/>
-            </a:pPr>
-            <a:r>
-              <a:rPr lang="en-US" sz="2100">
-                <a:solidFill>
-                  <a:srgbClr val="D7E3EA"/>
-                </a:solidFill>
-              </a:rPr>
-              <a:t>Fee sharing becomes an inspectable ledger.</a:t>
-            </a:r>
-          </a:p>
-          <a:p>
-            <a:pPr marL="285750" indent="-171450">
-              <a:buChar char="•"/>
-            </a:pPr>
-            <a:r>
-              <a:rPr lang="en-US" sz="2100">
-                <a:solidFill>
-                  <a:srgbClr val="D7E3EA"/>
-                </a:solidFill>
-              </a:rPr>
-              <a:t>Vault shares, fee history, oracle updates, and market launch readiness expose operator behavior.</a:t>
-            </a:r>
-          </a:p>
-        </p:txBody>
-      </p:sp>
-      <p:pic>
-        <p:nvPicPr>
-          <p:cNvPr id="5" name="demo-fee-ledger-view.png"/>
-          <p:cNvPicPr/>
-          <p:nvPr/>
-        </p:nvPicPr>
-        <p:blipFill>
-          <a:blip r:embed="rId1"/>
-          <a:stretch>
-            <a:fillRect/>
-          </a:stretch>
-        </p:blipFill>
-        <p:spPr>
-          <a:xfrm>
-            <a:off x="5450000" y="1500000"/>
-            <a:ext cx="6130000" cy="3450000"/>
-          </a:xfrm>
-          <a:prstGeom prst="rect">
-            <a:avLst/>
-          </a:prstGeom>
-        </p:spPr>
-      </p:pic>
+            <a:off x="914400" y="1905000"/>
+            <a:ext cx="9800000" cy="3900000"/>
+          </a:xfrm>
+          <a:prstGeom prst="rect">
+            <a:avLst/>
+          </a:prstGeom>
+          <a:noFill/>
+        </p:spPr>
+        <p:txBody>
+          <a:bodyPr wrap="square"/>
+          <a:lstStyle/>
+          <a:p>
+            <a:pPr marL="285750" indent="-171450">
+              <a:buChar char="•"/>
+            </a:pPr>
+            <a:r>
+              <a:rPr lang="en-US" sz="2100">
+                <a:solidFill>
+                  <a:srgbClr val="D7E3EA"/>
+                </a:solidFill>
+              </a:rPr>
+              <a:t>Mirrors a trading order pane.</a:t>
+            </a:r>
+          </a:p>
+          <a:p>
+            <a:pPr marL="285750" indent="-171450">
+              <a:buChar char="•"/>
+            </a:pPr>
+            <a:r>
+              <a:rPr lang="en-US" sz="2100">
+                <a:solidFill>
+                  <a:srgbClr val="D7E3EA"/>
+                </a:solidFill>
+              </a:rPr>
+              <a:t>Amount input, deposit/withdraw mode, fee summary, user rewards estimate, and slashing warning.</a:t>
+            </a:r>
+          </a:p>
+        </p:txBody>
+      </p:sp>
       <p:sp>
         <p:nvSpPr>
           <p:cNvPr id="4" name="Footer"/>
@@ -886,7 +891,7 @@
                   <a:srgbClr val="F4F7F8"/>
                 </a:solidFill>
               </a:rPr>
-              <a:t>Demo: Contract Wiring</a:t>
+              <a:t>Demo: Audit Ledger</a:t>
             </a:r>
           </a:p>
         </p:txBody>
@@ -920,27 +925,27 @@
                   <a:srgbClr val="D7E3EA"/>
                 </a:solidFill>
               </a:rPr>
-              <a:t>Wallet-aware flow: connect wallet, configure vault/token addresses, approve HYPE, deposit, and claim rewards.</a:t>
-            </a:r>
-          </a:p>
-          <a:p>
-            <a:pPr marL="285750" indent="-171450">
-              <a:buChar char="•"/>
-            </a:pPr>
-            <a:r>
-              <a:rPr lang="en-US" sz="2100">
-                <a:solidFill>
-                  <a:srgbClr val="D7E3EA"/>
-                </a:solidFill>
-              </a:rPr>
-              <a:t>The UI also shows which actions still require operator multisig and risk-council execution.</a:t>
+              <a:t>Fee sharing becomes an inspectable ledger.</a:t>
+            </a:r>
+          </a:p>
+          <a:p>
+            <a:pPr marL="285750" indent="-171450">
+              <a:buChar char="•"/>
+            </a:pPr>
+            <a:r>
+              <a:rPr lang="en-US" sz="2100">
+                <a:solidFill>
+                  <a:srgbClr val="D7E3EA"/>
+                </a:solidFill>
+              </a:rPr>
+              <a:t>Vault shares, fee history, oracle updates, and market launch readiness expose operator behavior.</a:t>
             </a:r>
           </a:p>
         </p:txBody>
       </p:sp>
       <p:pic>
         <p:nvPicPr>
-          <p:cNvPr id="5" name="demo-contract-wiring.png"/>
+          <p:cNvPr id="5" name="demo-fee-ledger-view.png"/>
           <p:cNvPicPr/>
           <p:nvPr/>
         </p:nvPicPr>
@@ -1049,7 +1054,7 @@
                   <a:srgbClr val="F4F7F8"/>
                 </a:solidFill>
               </a:rPr>
-              <a:t>Contract Depth</a:t>
+              <a:t>Demo: Contract Wiring</a:t>
             </a:r>
           </a:p>
         </p:txBody>
@@ -1062,58 +1067,67 @@
         </p:nvSpPr>
         <p:spPr>
           <a:xfrm>
-            <a:off x="914400" y="1905000"/>
-            <a:ext cx="9800000" cy="3900000"/>
-          </a:xfrm>
-          <a:prstGeom prst="rect">
-            <a:avLst/>
-          </a:prstGeom>
-          <a:noFill/>
-        </p:spPr>
-        <p:txBody>
-          <a:bodyPr wrap="square"/>
-          <a:lstStyle/>
-          <a:p>
-            <a:pPr marL="285750" indent="-171450">
-              <a:buChar char="•"/>
-            </a:pPr>
-            <a:r>
-              <a:rPr lang="en-US" sz="2100">
-                <a:solidFill>
-                  <a:srgbClr val="D7E3EA"/>
-                </a:solidFill>
-              </a:rPr>
-              <a:t>Vault now models vHIPM receipt shares, vault caps, withdrawal queues, reward accounting, and slash losses.</a:t>
-            </a:r>
-          </a:p>
-          <a:p>
-            <a:pPr marL="285750" indent="-171450">
-              <a:buChar char="•"/>
-            </a:pPr>
-            <a:r>
-              <a:rPr lang="en-US" sz="2100">
-                <a:solidFill>
-                  <a:srgbClr val="D7E3EA"/>
-                </a:solidFill>
-              </a:rPr>
-              <a:t>Operator lifecycle: funding, stake-ready, stake-escrowed, approved, live, wind-down, and slashed.</a:t>
-            </a:r>
-          </a:p>
-          <a:p>
-            <a:pPr marL="285750" indent="-171450">
-              <a:buChar char="•"/>
-            </a:pPr>
-            <a:r>
-              <a:rPr lang="en-US" sz="2100">
-                <a:solidFill>
-                  <a:srgbClr val="D7E3EA"/>
-                </a:solidFill>
-              </a:rPr>
-              <a:t>Registry tracks launch checklist, fee epochs, oracle health, market status, and risk state.</a:t>
-            </a:r>
-          </a:p>
-        </p:txBody>
-      </p:sp>
+            <a:off x="609600" y="1630000"/>
+            <a:ext cx="4600000" cy="4400000"/>
+          </a:xfrm>
+          <a:prstGeom prst="rect">
+            <a:avLst/>
+          </a:prstGeom>
+          <a:noFill/>
+        </p:spPr>
+        <p:txBody>
+          <a:bodyPr wrap="square"/>
+          <a:lstStyle/>
+          <a:p>
+            <a:pPr marL="285750" indent="-171450">
+              <a:buChar char="•"/>
+            </a:pPr>
+            <a:r>
+              <a:rPr lang="en-US" sz="2100">
+                <a:solidFill>
+                  <a:srgbClr val="D7E3EA"/>
+                </a:solidFill>
+              </a:rPr>
+              <a:t>Wallet-aware flow: connect wallet, configure vault/token addresses, approve HYPE, deposit, and claim rewards.</a:t>
+            </a:r>
+          </a:p>
+          <a:p>
+            <a:pPr marL="285750" indent="-171450">
+              <a:buChar char="•"/>
+            </a:pPr>
+            <a:r>
+              <a:rPr lang="en-US" sz="2100">
+                <a:solidFill>
+                  <a:srgbClr val="D7E3EA"/>
+                </a:solidFill>
+              </a:rPr>
+              <a:t>The UI also shows which actions still require operator multisig and risk-council execution.</a:t>
+            </a:r>
+          </a:p>
+        </p:txBody>
+      </p:sp>
+      <p:pic>
+        <p:nvPicPr>
+          <p:cNvPr id="5" name="demo-contract-wiring.png"/>
+          <p:cNvPicPr/>
+          <p:nvPr/>
+        </p:nvPicPr>
+        <p:blipFill>
+          <a:blip r:embed="rId1"/>
+          <a:stretch>
+            <a:fillRect/>
+          </a:stretch>
+        </p:blipFill>
+        <p:spPr>
+          <a:xfrm>
+            <a:off x="5450000" y="1500000"/>
+            <a:ext cx="6130000" cy="3450000"/>
+          </a:xfrm>
+          <a:prstGeom prst="rect">
+            <a:avLst/>
+          </a:prstGeom>
+        </p:spPr>
+      </p:pic>
       <p:sp>
         <p:nvSpPr>
           <p:cNvPr id="4" name="Footer"/>
@@ -1203,7 +1217,7 @@
                   <a:srgbClr val="F4F7F8"/>
                 </a:solidFill>
               </a:rPr>
-              <a:t>System Flow</a:t>
+              <a:t>Contract Depth</a:t>
             </a:r>
           </a:p>
         </p:txBody>
@@ -1237,59 +1251,33 @@
                   <a:srgbClr val="D7E3EA"/>
                 </a:solidFill>
               </a:rPr>
-              <a:t>1. HYPE holders deposit into the HyperEVM vault.</a:t>
-            </a:r>
-          </a:p>
-          <a:p>
-            <a:pPr marL="285750" indent="-171450">
-              <a:buChar char="•"/>
-            </a:pPr>
-            <a:r>
-              <a:rPr lang="en-US" sz="2100">
-                <a:solidFill>
-                  <a:srgbClr val="D7E3EA"/>
-                </a:solidFill>
-              </a:rPr>
-              <a:t>2. Vault backs HIP.markets deployer stake.</a:t>
-            </a:r>
-          </a:p>
-          <a:p>
-            <a:pPr marL="285750" indent="-171450">
-              <a:buChar char="•"/>
-            </a:pPr>
-            <a:r>
-              <a:rPr lang="en-US" sz="2100">
-                <a:solidFill>
-                  <a:srgbClr val="D7E3EA"/>
-                </a:solidFill>
-              </a:rPr>
-              <a:t>3. Operator multisig escrows funded HYPE to the deployer stake controller.</a:t>
-            </a:r>
-          </a:p>
-          <a:p>
-            <a:pPr marL="285750" indent="-171450">
-              <a:buChar char="•"/>
-            </a:pPr>
-            <a:r>
-              <a:rPr lang="en-US" sz="2100">
-                <a:solidFill>
-                  <a:srgbClr val="D7E3EA"/>
-                </a:solidFill>
-              </a:rPr>
-              <a:t>4. Risk council records HIP-3 operator approval.</a:t>
-            </a:r>
-          </a:p>
-          <a:p>
-            <a:pPr marL="285750" indent="-171450">
-              <a:buChar char="•"/>
-            </a:pPr>
-            <a:r>
-              <a:rPr lang="en-US" sz="2100">
-                <a:solidFill>
-                  <a:srgbClr val="D7E3EA"/>
-                </a:solidFill>
-              </a:rPr>
-              <a:t>5. HIP.markets launches markets, traders generate fees, and net rewards distribute after deductions.</a:t>
+              <a:t>Vault now models vHIPM receipt shares, vault caps, withdrawal queues, reward accounting, and slash losses.</a:t>
+            </a:r>
+          </a:p>
+          <a:p>
+            <a:pPr marL="285750" indent="-171450">
+              <a:buChar char="•"/>
+            </a:pPr>
+            <a:r>
+              <a:rPr lang="en-US" sz="2100">
+                <a:solidFill>
+                  <a:srgbClr val="D7E3EA"/>
+                </a:solidFill>
+              </a:rPr>
+              <a:t>Operator lifecycle: funding, stake-ready, stake-escrowed, approved, live, wind-down, and slashed.</a:t>
+            </a:r>
+          </a:p>
+          <a:p>
+            <a:pPr marL="285750" indent="-171450">
+              <a:buChar char="•"/>
+            </a:pPr>
+            <a:r>
+              <a:rPr lang="en-US" sz="2100">
+                <a:solidFill>
+                  <a:srgbClr val="D7E3EA"/>
+                </a:solidFill>
+              </a:rPr>
+              <a:t>Registry tracks launch checklist, fee epochs, oracle health, market status, and risk state.</a:t>
             </a:r>
           </a:p>
         </p:txBody>
@@ -1383,7 +1371,7 @@
                   <a:srgbClr val="F4F7F8"/>
                 </a:solidFill>
               </a:rPr>
-              <a:t>Economics</a:t>
+              <a:t>System Flow</a:t>
             </a:r>
           </a:p>
         </p:txBody>
@@ -1417,46 +1405,59 @@
                   <a:srgbClr val="D7E3EA"/>
                 </a:solidFill>
               </a:rPr>
-              <a:t>Base model: 500k HYPE, $50M daily volume, 6 bps fee, 50% deployer share.</a:t>
-            </a:r>
-          </a:p>
-          <a:p>
-            <a:pPr marL="285750" indent="-171450">
-              <a:buChar char="•"/>
-            </a:pPr>
-            <a:r>
-              <a:rPr lang="en-US" sz="2100">
-                <a:solidFill>
-                  <a:srgbClr val="D7E3EA"/>
-                </a:solidFill>
-              </a:rPr>
-              <a:t>After 40% operating/protocol/reserve deductions: approximately 15% net APR.</a:t>
-            </a:r>
-          </a:p>
-          <a:p>
-            <a:pPr marL="285750" indent="-171450">
-              <a:buChar char="•"/>
-            </a:pPr>
-            <a:r>
-              <a:rPr lang="en-US" sz="2100">
-                <a:solidFill>
-                  <a:srgbClr val="D7E3EA"/>
-                </a:solidFill>
-              </a:rPr>
-              <a:t>Trade.xyz trailing fees imply approximately 3.47% gross APR on the minimum stake.</a:t>
-            </a:r>
-          </a:p>
-          <a:p>
-            <a:pPr marL="285750" indent="-171450">
-              <a:buChar char="•"/>
-            </a:pPr>
-            <a:r>
-              <a:rPr lang="en-US" sz="2100">
-                <a:solidFill>
-                  <a:srgbClr val="D7E3EA"/>
-                </a:solidFill>
-              </a:rPr>
-              <a:t>Sensitivity matters more than headline APR.</a:t>
+              <a:t>1. HYPE holders deposit into the HyperEVM vault.</a:t>
+            </a:r>
+          </a:p>
+          <a:p>
+            <a:pPr marL="285750" indent="-171450">
+              <a:buChar char="•"/>
+            </a:pPr>
+            <a:r>
+              <a:rPr lang="en-US" sz="2100">
+                <a:solidFill>
+                  <a:srgbClr val="D7E3EA"/>
+                </a:solidFill>
+              </a:rPr>
+              <a:t>2. Vault backs HIP.markets deployer stake.</a:t>
+            </a:r>
+          </a:p>
+          <a:p>
+            <a:pPr marL="285750" indent="-171450">
+              <a:buChar char="•"/>
+            </a:pPr>
+            <a:r>
+              <a:rPr lang="en-US" sz="2100">
+                <a:solidFill>
+                  <a:srgbClr val="D7E3EA"/>
+                </a:solidFill>
+              </a:rPr>
+              <a:t>3. Operator multisig escrows funded HYPE to the deployer stake controller.</a:t>
+            </a:r>
+          </a:p>
+          <a:p>
+            <a:pPr marL="285750" indent="-171450">
+              <a:buChar char="•"/>
+            </a:pPr>
+            <a:r>
+              <a:rPr lang="en-US" sz="2100">
+                <a:solidFill>
+                  <a:srgbClr val="D7E3EA"/>
+                </a:solidFill>
+              </a:rPr>
+              <a:t>4. Risk council records HIP-3 operator approval.</a:t>
+            </a:r>
+          </a:p>
+          <a:p>
+            <a:pPr marL="285750" indent="-171450">
+              <a:buChar char="•"/>
+            </a:pPr>
+            <a:r>
+              <a:rPr lang="en-US" sz="2100">
+                <a:solidFill>
+                  <a:srgbClr val="D7E3EA"/>
+                </a:solidFill>
+              </a:rPr>
+              <a:t>5. HIP.markets launches markets, traders generate fees, and net rewards distribute after deductions.</a:t>
             </a:r>
           </a:p>
         </p:txBody>
@@ -1550,7 +1551,7 @@
                   <a:srgbClr val="F4F7F8"/>
                 </a:solidFill>
               </a:rPr>
-              <a:t>Risk Controls</a:t>
+              <a:t>Economics</a:t>
             </a:r>
           </a:p>
         </p:txBody>
@@ -1584,33 +1585,46 @@
                   <a:srgbClr val="D7E3EA"/>
                 </a:solidFill>
               </a:rPr>
-              <a:t>Start with oracle-simple markets.</a:t>
-            </a:r>
-          </a:p>
-          <a:p>
-            <a:pPr marL="285750" indent="-171450">
-              <a:buChar char="•"/>
-            </a:pPr>
-            <a:r>
-              <a:rPr lang="en-US" sz="2100">
-                <a:solidFill>
-                  <a:srgbClr val="D7E3EA"/>
-                </a:solidFill>
-              </a:rPr>
-              <a:t>Avoid extra ticker auction costs at launch.</a:t>
-            </a:r>
-          </a:p>
-          <a:p>
-            <a:pPr marL="285750" indent="-171450">
-              <a:buChar char="•"/>
-            </a:pPr>
-            <a:r>
-              <a:rPr lang="en-US" sz="2100">
-                <a:solidFill>
-                  <a:srgbClr val="D7E3EA"/>
-                </a:solidFill>
-              </a:rPr>
-              <a:t>Cap open interest, publish addresses, maintain reserve, pause deposits during incidents.</a:t>
+              <a:t>Base model: 500k HYPE, $50M daily volume, 6 bps fee, 50% deployer share.</a:t>
+            </a:r>
+          </a:p>
+          <a:p>
+            <a:pPr marL="285750" indent="-171450">
+              <a:buChar char="•"/>
+            </a:pPr>
+            <a:r>
+              <a:rPr lang="en-US" sz="2100">
+                <a:solidFill>
+                  <a:srgbClr val="D7E3EA"/>
+                </a:solidFill>
+              </a:rPr>
+              <a:t>After 40% operating/protocol/reserve deductions: approximately 15% net APR.</a:t>
+            </a:r>
+          </a:p>
+          <a:p>
+            <a:pPr marL="285750" indent="-171450">
+              <a:buChar char="•"/>
+            </a:pPr>
+            <a:r>
+              <a:rPr lang="en-US" sz="2100">
+                <a:solidFill>
+                  <a:srgbClr val="D7E3EA"/>
+                </a:solidFill>
+              </a:rPr>
+              <a:t>Trade.xyz trailing fees imply approximately 3.47% gross APR on the minimum stake.</a:t>
+            </a:r>
+          </a:p>
+          <a:p>
+            <a:pPr marL="285750" indent="-171450">
+              <a:buChar char="•"/>
+            </a:pPr>
+            <a:r>
+              <a:rPr lang="en-US" sz="2100">
+                <a:solidFill>
+                  <a:srgbClr val="D7E3EA"/>
+                </a:solidFill>
+              </a:rPr>
+              <a:t>Sensitivity matters more than headline APR.</a:t>
             </a:r>
           </a:p>
         </p:txBody>
@@ -1704,7 +1718,7 @@
                   <a:srgbClr val="F4F7F8"/>
                 </a:solidFill>
               </a:rPr>
-              <a:t>Cost Stack</a:t>
+              <a:t>Risk Controls</a:t>
             </a:r>
           </a:p>
         </p:txBody>
@@ -1738,20 +1752,33 @@
                   <a:srgbClr val="D7E3EA"/>
                 </a:solidFill>
               </a:rPr>
-              <a:t>The 500k HYPE stake is the entry ticket, not the full cost of business.</a:t>
-            </a:r>
-          </a:p>
-          <a:p>
-            <a:pPr marL="285750" indent="-171450">
-              <a:buChar char="•"/>
-            </a:pPr>
-            <a:r>
-              <a:rPr lang="en-US" sz="2100">
-                <a:solidFill>
-                  <a:srgbClr val="D7E3EA"/>
-                </a:solidFill>
-              </a:rPr>
-              <a:t>Budget for oracle relayers, licensed data, maker incentives, infrastructure, key management, audits, legal work, and incident reserves.</a:t>
+              <a:t>Start with oracle-simple markets.</a:t>
+            </a:r>
+          </a:p>
+          <a:p>
+            <a:pPr marL="285750" indent="-171450">
+              <a:buChar char="•"/>
+            </a:pPr>
+            <a:r>
+              <a:rPr lang="en-US" sz="2100">
+                <a:solidFill>
+                  <a:srgbClr val="D7E3EA"/>
+                </a:solidFill>
+              </a:rPr>
+              <a:t>Avoid extra ticker auction costs at launch.</a:t>
+            </a:r>
+          </a:p>
+          <a:p>
+            <a:pPr marL="285750" indent="-171450">
+              <a:buChar char="•"/>
+            </a:pPr>
+            <a:r>
+              <a:rPr lang="en-US" sz="2100">
+                <a:solidFill>
+                  <a:srgbClr val="D7E3EA"/>
+                </a:solidFill>
+              </a:rPr>
+              <a:t>Cap open interest, publish addresses, maintain reserve, pause deposits during incidents.</a:t>
             </a:r>
           </a:p>
         </p:txBody>
@@ -1845,7 +1872,7 @@
                   <a:srgbClr val="F4F7F8"/>
                 </a:solidFill>
               </a:rPr>
-              <a:t>The Problem</a:t>
+              <a:t>Brand System</a:t>
             </a:r>
           </a:p>
         </p:txBody>
@@ -1858,58 +1885,80 @@
         </p:nvSpPr>
         <p:spPr>
           <a:xfrm>
-            <a:off x="914400" y="1905000"/>
-            <a:ext cx="9800000" cy="3900000"/>
-          </a:xfrm>
-          <a:prstGeom prst="rect">
-            <a:avLst/>
-          </a:prstGeom>
-          <a:noFill/>
-        </p:spPr>
-        <p:txBody>
-          <a:bodyPr wrap="square"/>
-          <a:lstStyle/>
-          <a:p>
-            <a:pPr marL="285750" indent="-171450">
-              <a:buChar char="•"/>
-            </a:pPr>
-            <a:r>
-              <a:rPr lang="en-US" sz="2100">
-                <a:solidFill>
-                  <a:srgbClr val="D7E3EA"/>
-                </a:solidFill>
-              </a:rPr>
-              <a:t>HIP-3 DEXs need 500,000 HYPE staked.</a:t>
-            </a:r>
-          </a:p>
-          <a:p>
-            <a:pPr marL="285750" indent="-171450">
-              <a:buChar char="•"/>
-            </a:pPr>
-            <a:r>
-              <a:rPr lang="en-US" sz="2100">
-                <a:solidFill>
-                  <a:srgbClr val="D7E3EA"/>
-                </a:solidFill>
-              </a:rPr>
-              <a:t>Stake is only the start: operators also need oracles, liquidity, risk controls, and fee accounting.</a:t>
-            </a:r>
-          </a:p>
-          <a:p>
-            <a:pPr marL="285750" indent="-171450">
-              <a:buChar char="•"/>
-            </a:pPr>
-            <a:r>
-              <a:rPr lang="en-US" sz="2100">
-                <a:solidFill>
-                  <a:srgbClr val="D7E3EA"/>
-                </a:solidFill>
-              </a:rPr>
-              <a:t>Stakers need slashing risk beside APR.</a:t>
-            </a:r>
-          </a:p>
-        </p:txBody>
-      </p:sp>
+            <a:off x="609600" y="1630000"/>
+            <a:ext cx="4600000" cy="4400000"/>
+          </a:xfrm>
+          <a:prstGeom prst="rect">
+            <a:avLst/>
+          </a:prstGeom>
+          <a:noFill/>
+        </p:spPr>
+        <p:txBody>
+          <a:bodyPr wrap="square"/>
+          <a:lstStyle/>
+          <a:p>
+            <a:pPr marL="285750" indent="-171450">
+              <a:buChar char="•"/>
+            </a:pPr>
+            <a:r>
+              <a:rPr lang="en-US" sz="2100">
+                <a:solidFill>
+                  <a:srgbClr val="D7E3EA"/>
+                </a:solidFill>
+              </a:rPr>
+              <a:t>Original terminal-native brand for an operator-vault product.</a:t>
+            </a:r>
+          </a:p>
+          <a:p>
+            <a:pPr marL="285750" indent="-171450">
+              <a:buChar char="•"/>
+            </a:pPr>
+            <a:r>
+              <a:rPr lang="en-US" sz="2100">
+                <a:solidFill>
+                  <a:srgbClr val="D7E3EA"/>
+                </a:solidFill>
+              </a:rPr>
+              <a:t>HIP Cat is a risk sentinel, not a yield mascot.</a:t>
+            </a:r>
+          </a:p>
+          <a:p>
+            <a:pPr marL="285750" indent="-171450">
+              <a:buChar char="•"/>
+            </a:pPr>
+            <a:r>
+              <a:rPr lang="en-US" sz="2100">
+                <a:solidFill>
+                  <a:srgbClr val="D7E3EA"/>
+                </a:solidFill>
+              </a:rPr>
+              <a:t>Mint = execution, blue = oracle data, amber = risk.</a:t>
+            </a:r>
+          </a:p>
+        </p:txBody>
+      </p:sp>
+      <p:pic>
+        <p:nvPicPr>
+          <p:cNvPr id="5" name="brand-system.png"/>
+          <p:cNvPicPr/>
+          <p:nvPr/>
+        </p:nvPicPr>
+        <p:blipFill>
+          <a:blip r:embed="rId1"/>
+          <a:stretch>
+            <a:fillRect/>
+          </a:stretch>
+        </p:blipFill>
+        <p:spPr>
+          <a:xfrm>
+            <a:off x="5450000" y="1500000"/>
+            <a:ext cx="6130000" cy="3450000"/>
+          </a:xfrm>
+          <a:prstGeom prst="rect">
+            <a:avLst/>
+          </a:prstGeom>
+        </p:spPr>
+      </p:pic>
       <p:sp>
         <p:nvSpPr>
           <p:cNvPr id="4" name="Footer"/>
@@ -1999,7 +2048,7 @@
                   <a:srgbClr val="F4F7F8"/>
                 </a:solidFill>
               </a:rPr>
-              <a:t>MVP</a:t>
+              <a:t>Cost Stack</a:t>
             </a:r>
           </a:p>
         </p:txBody>
@@ -2033,72 +2082,20 @@
                   <a:srgbClr val="D7E3EA"/>
                 </a:solidFill>
               </a:rPr>
-              <a:t>One HIP.markets-operated DEX.</a:t>
-            </a:r>
-          </a:p>
-          <a:p>
-            <a:pPr marL="285750" indent="-171450">
-              <a:buChar char="•"/>
-            </a:pPr>
-            <a:r>
-              <a:rPr lang="en-US" sz="2100">
-                <a:solidFill>
-                  <a:srgbClr val="D7E3EA"/>
-                </a:solidFill>
-              </a:rPr>
-              <a:t>One HYPE vault.</a:t>
-            </a:r>
-          </a:p>
-          <a:p>
-            <a:pPr marL="285750" indent="-171450">
-              <a:buChar char="•"/>
-            </a:pPr>
-            <a:r>
-              <a:rPr lang="en-US" sz="2100">
-                <a:solidFill>
-                  <a:srgbClr val="D7E3EA"/>
-                </a:solidFill>
-              </a:rPr>
-              <a:t>First three markets.</a:t>
-            </a:r>
-          </a:p>
-          <a:p>
-            <a:pPr marL="285750" indent="-171450">
-              <a:buChar char="•"/>
-            </a:pPr>
-            <a:r>
-              <a:rPr lang="en-US" sz="2100">
-                <a:solidFill>
-                  <a:srgbClr val="D7E3EA"/>
-                </a:solidFill>
-              </a:rPr>
-              <a:t>Weekly distributions.</a:t>
-            </a:r>
-          </a:p>
-          <a:p>
-            <a:pPr marL="285750" indent="-171450">
-              <a:buChar char="•"/>
-            </a:pPr>
-            <a:r>
-              <a:rPr lang="en-US" sz="2100">
-                <a:solidFill>
-                  <a:srgbClr val="D7E3EA"/>
-                </a:solidFill>
-              </a:rPr>
-              <a:t>Public dashboard.</a:t>
-            </a:r>
-          </a:p>
-          <a:p>
-            <a:pPr marL="285750" indent="-171450">
-              <a:buChar char="•"/>
-            </a:pPr>
-            <a:r>
-              <a:rPr lang="en-US" sz="2100">
-                <a:solidFill>
-                  <a:srgbClr val="D7E3EA"/>
-                </a:solidFill>
-              </a:rPr>
-              <a:t>No third-party operator financing.</a:t>
+              <a:t>The 500k HYPE stake is the entry ticket, not the full cost of business.</a:t>
+            </a:r>
+          </a:p>
+          <a:p>
+            <a:pPr marL="285750" indent="-171450">
+              <a:buChar char="•"/>
+            </a:pPr>
+            <a:r>
+              <a:rPr lang="en-US" sz="2100">
+                <a:solidFill>
+                  <a:srgbClr val="D7E3EA"/>
+                </a:solidFill>
+              </a:rPr>
+              <a:t>Budget for oracle relayers, licensed data, maker incentives, infrastructure, key management, audits, legal work, and incident reserves.</a:t>
             </a:r>
           </a:p>
         </p:txBody>
@@ -2192,7 +2189,7 @@
                   <a:srgbClr val="F4F7F8"/>
                 </a:solidFill>
               </a:rPr>
-              <a:t>Roadmap</a:t>
+              <a:t>MVP</a:t>
             </a:r>
           </a:p>
         </p:txBody>
@@ -2226,33 +2223,72 @@
                   <a:srgbClr val="D7E3EA"/>
                 </a:solidFill>
               </a:rPr>
-              <a:t>V1: prove operator vault and fee sharing.</a:t>
-            </a:r>
-          </a:p>
-          <a:p>
-            <a:pPr marL="285750" indent="-171450">
-              <a:buChar char="•"/>
-            </a:pPr>
-            <a:r>
-              <a:rPr lang="en-US" sz="2100">
-                <a:solidFill>
-                  <a:srgbClr val="D7E3EA"/>
-                </a:solidFill>
-              </a:rPr>
-              <a:t>V2: more HIP.markets market vaults and automated fee verification.</a:t>
-            </a:r>
-          </a:p>
-          <a:p>
-            <a:pPr marL="285750" indent="-171450">
-              <a:buChar char="•"/>
-            </a:pPr>
-            <a:r>
-              <a:rPr lang="en-US" sz="2100">
-                <a:solidFill>
-                  <a:srgbClr val="D7E3EA"/>
-                </a:solidFill>
-              </a:rPr>
-              <a:t>V3: risk tranching, secondary shares, HIP-4, possible third-party financing once the trust model is mature.</a:t>
+              <a:t>One HIP.markets-operated DEX.</a:t>
+            </a:r>
+          </a:p>
+          <a:p>
+            <a:pPr marL="285750" indent="-171450">
+              <a:buChar char="•"/>
+            </a:pPr>
+            <a:r>
+              <a:rPr lang="en-US" sz="2100">
+                <a:solidFill>
+                  <a:srgbClr val="D7E3EA"/>
+                </a:solidFill>
+              </a:rPr>
+              <a:t>One HYPE vault.</a:t>
+            </a:r>
+          </a:p>
+          <a:p>
+            <a:pPr marL="285750" indent="-171450">
+              <a:buChar char="•"/>
+            </a:pPr>
+            <a:r>
+              <a:rPr lang="en-US" sz="2100">
+                <a:solidFill>
+                  <a:srgbClr val="D7E3EA"/>
+                </a:solidFill>
+              </a:rPr>
+              <a:t>First three markets.</a:t>
+            </a:r>
+          </a:p>
+          <a:p>
+            <a:pPr marL="285750" indent="-171450">
+              <a:buChar char="•"/>
+            </a:pPr>
+            <a:r>
+              <a:rPr lang="en-US" sz="2100">
+                <a:solidFill>
+                  <a:srgbClr val="D7E3EA"/>
+                </a:solidFill>
+              </a:rPr>
+              <a:t>Weekly distributions.</a:t>
+            </a:r>
+          </a:p>
+          <a:p>
+            <a:pPr marL="285750" indent="-171450">
+              <a:buChar char="•"/>
+            </a:pPr>
+            <a:r>
+              <a:rPr lang="en-US" sz="2100">
+                <a:solidFill>
+                  <a:srgbClr val="D7E3EA"/>
+                </a:solidFill>
+              </a:rPr>
+              <a:t>Public dashboard.</a:t>
+            </a:r>
+          </a:p>
+          <a:p>
+            <a:pPr marL="285750" indent="-171450">
+              <a:buChar char="•"/>
+            </a:pPr>
+            <a:r>
+              <a:rPr lang="en-US" sz="2100">
+                <a:solidFill>
+                  <a:srgbClr val="D7E3EA"/>
+                </a:solidFill>
+              </a:rPr>
+              <a:t>No third-party operator financing.</a:t>
             </a:r>
           </a:p>
         </p:txBody>
@@ -2346,7 +2382,7 @@
                   <a:srgbClr val="F4F7F8"/>
                 </a:solidFill>
               </a:rPr>
-              <a:t>Competitive Position</a:t>
+              <a:t>Roadmap</a:t>
             </a:r>
           </a:p>
         </p:txBody>
@@ -2380,33 +2416,33 @@
                   <a:srgbClr val="D7E3EA"/>
                 </a:solidFill>
               </a:rPr>
-              <a:t>trade.xyz and HyENA operate markets directly.</a:t>
-            </a:r>
-          </a:p>
-          <a:p>
-            <a:pPr marL="285750" indent="-171450">
-              <a:buChar char="•"/>
-            </a:pPr>
-            <a:r>
-              <a:rPr lang="en-US" sz="2100">
-                <a:solidFill>
-                  <a:srgbClr val="D7E3EA"/>
-                </a:solidFill>
-              </a:rPr>
-              <a:t>HIP.markets also operates markets directly, but adds user-funded HYPE stake and transparent fee sharing.</a:t>
-            </a:r>
-          </a:p>
-          <a:p>
-            <a:pPr marL="285750" indent="-171450">
-              <a:buChar char="•"/>
-            </a:pPr>
-            <a:r>
-              <a:rPr lang="en-US" sz="2100">
-                <a:solidFill>
-                  <a:srgbClr val="D7E3EA"/>
-                </a:solidFill>
-              </a:rPr>
-              <a:t>The wedge is making HYPE holders economic backers of the operator.</a:t>
+              <a:t>V1: prove operator vault and fee sharing.</a:t>
+            </a:r>
+          </a:p>
+          <a:p>
+            <a:pPr marL="285750" indent="-171450">
+              <a:buChar char="•"/>
+            </a:pPr>
+            <a:r>
+              <a:rPr lang="en-US" sz="2100">
+                <a:solidFill>
+                  <a:srgbClr val="D7E3EA"/>
+                </a:solidFill>
+              </a:rPr>
+              <a:t>V2: more HIP.markets market vaults and automated fee verification.</a:t>
+            </a:r>
+          </a:p>
+          <a:p>
+            <a:pPr marL="285750" indent="-171450">
+              <a:buChar char="•"/>
+            </a:pPr>
+            <a:r>
+              <a:rPr lang="en-US" sz="2100">
+                <a:solidFill>
+                  <a:srgbClr val="D7E3EA"/>
+                </a:solidFill>
+              </a:rPr>
+              <a:t>V3: risk tranching, secondary shares, HIP-4, possible third-party financing once the trust model is mature.</a:t>
             </a:r>
           </a:p>
         </p:txBody>
@@ -2500,7 +2536,7 @@
                   <a:srgbClr val="F4F7F8"/>
                 </a:solidFill>
               </a:rPr>
-              <a:t>Ask</a:t>
+              <a:t>Competitive Position</a:t>
             </a:r>
           </a:p>
         </p:txBody>
@@ -2534,59 +2570,33 @@
                   <a:srgbClr val="D7E3EA"/>
                 </a:solidFill>
               </a:rPr>
-              <a:t>HYPE holders for capped beta.</a:t>
-            </a:r>
-          </a:p>
-          <a:p>
-            <a:pPr marL="285750" indent="-171450">
-              <a:buChar char="•"/>
-            </a:pPr>
-            <a:r>
-              <a:rPr lang="en-US" sz="2100">
-                <a:solidFill>
-                  <a:srgbClr val="D7E3EA"/>
-                </a:solidFill>
-              </a:rPr>
-              <a:t>Market makers for first markets.</a:t>
-            </a:r>
-          </a:p>
-          <a:p>
-            <a:pPr marL="285750" indent="-171450">
-              <a:buChar char="•"/>
-            </a:pPr>
-            <a:r>
-              <a:rPr lang="en-US" sz="2100">
-                <a:solidFill>
-                  <a:srgbClr val="D7E3EA"/>
-                </a:solidFill>
-              </a:rPr>
-              <a:t>Oracle and data partners.</a:t>
-            </a:r>
-          </a:p>
-          <a:p>
-            <a:pPr marL="285750" indent="-171450">
-              <a:buChar char="•"/>
-            </a:pPr>
-            <a:r>
-              <a:rPr lang="en-US" sz="2100">
-                <a:solidFill>
-                  <a:srgbClr val="D7E3EA"/>
-                </a:solidFill>
-              </a:rPr>
-              <a:t>Security reviewers.</a:t>
-            </a:r>
-          </a:p>
-          <a:p>
-            <a:pPr marL="285750" indent="-171450">
-              <a:buChar char="•"/>
-            </a:pPr>
-            <a:r>
-              <a:rPr lang="en-US" sz="2100">
-                <a:solidFill>
-                  <a:srgbClr val="D7E3EA"/>
-                </a:solidFill>
-              </a:rPr>
-              <a:t>Hyperliquid feedback on custody and fee routing.</a:t>
+              <a:t>trade.xyz and HyENA operate markets directly.</a:t>
+            </a:r>
+          </a:p>
+          <a:p>
+            <a:pPr marL="285750" indent="-171450">
+              <a:buChar char="•"/>
+            </a:pPr>
+            <a:r>
+              <a:rPr lang="en-US" sz="2100">
+                <a:solidFill>
+                  <a:srgbClr val="D7E3EA"/>
+                </a:solidFill>
+              </a:rPr>
+              <a:t>HIP.markets also operates markets directly, but adds user-funded HYPE stake and transparent fee sharing.</a:t>
+            </a:r>
+          </a:p>
+          <a:p>
+            <a:pPr marL="285750" indent="-171450">
+              <a:buChar char="•"/>
+            </a:pPr>
+            <a:r>
+              <a:rPr lang="en-US" sz="2100">
+                <a:solidFill>
+                  <a:srgbClr val="D7E3EA"/>
+                </a:solidFill>
+              </a:rPr>
+              <a:t>The wedge is making HYPE holders economic backers of the operator.</a:t>
             </a:r>
           </a:p>
         </p:txBody>
@@ -2680,7 +2690,7 @@
                   <a:srgbClr val="F4F7F8"/>
                 </a:solidFill>
               </a:rPr>
-              <a:t>Closing</a:t>
+              <a:t>Ask</a:t>
             </a:r>
           </a:p>
         </p:txBody>
@@ -2714,20 +2724,59 @@
                   <a:srgbClr val="D7E3EA"/>
                 </a:solidFill>
               </a:rPr>
-              <a:t>HIP.markets turns builder-deployed markets into a community-backed operator business.</a:t>
-            </a:r>
-          </a:p>
-          <a:p>
-            <a:pPr marL="285750" indent="-171450">
-              <a:buChar char="•"/>
-            </a:pPr>
-            <a:r>
-              <a:rPr lang="en-US" sz="2100">
-                <a:solidFill>
-                  <a:srgbClr val="D7E3EA"/>
-                </a:solidFill>
-              </a:rPr>
-              <a:t>The first job is operating markets safely.</a:t>
+              <a:t>HYPE holders for capped beta.</a:t>
+            </a:r>
+          </a:p>
+          <a:p>
+            <a:pPr marL="285750" indent="-171450">
+              <a:buChar char="•"/>
+            </a:pPr>
+            <a:r>
+              <a:rPr lang="en-US" sz="2100">
+                <a:solidFill>
+                  <a:srgbClr val="D7E3EA"/>
+                </a:solidFill>
+              </a:rPr>
+              <a:t>Market makers for first markets.</a:t>
+            </a:r>
+          </a:p>
+          <a:p>
+            <a:pPr marL="285750" indent="-171450">
+              <a:buChar char="•"/>
+            </a:pPr>
+            <a:r>
+              <a:rPr lang="en-US" sz="2100">
+                <a:solidFill>
+                  <a:srgbClr val="D7E3EA"/>
+                </a:solidFill>
+              </a:rPr>
+              <a:t>Oracle and data partners.</a:t>
+            </a:r>
+          </a:p>
+          <a:p>
+            <a:pPr marL="285750" indent="-171450">
+              <a:buChar char="•"/>
+            </a:pPr>
+            <a:r>
+              <a:rPr lang="en-US" sz="2100">
+                <a:solidFill>
+                  <a:srgbClr val="D7E3EA"/>
+                </a:solidFill>
+              </a:rPr>
+              <a:t>Security reviewers.</a:t>
+            </a:r>
+          </a:p>
+          <a:p>
+            <a:pPr marL="285750" indent="-171450">
+              <a:buChar char="•"/>
+            </a:pPr>
+            <a:r>
+              <a:rPr lang="en-US" sz="2100">
+                <a:solidFill>
+                  <a:srgbClr val="D7E3EA"/>
+                </a:solidFill>
+              </a:rPr>
+              <a:t>Hyperliquid feedback on custody and fee routing.</a:t>
             </a:r>
           </a:p>
         </p:txBody>
@@ -2759,6 +2808,147 @@
                 </a:solidFill>
               </a:rPr>
               <a:t>HIP.markets hackathon submission  |  24</a:t>
+            </a:r>
+          </a:p>
+        </p:txBody>
+      </p:sp>
+    </p:spTree>
+  </p:cSld>
+  <p:clrMapOvr>
+    <a:masterClrMapping/>
+  </p:clrMapOvr>
+</p:sld>
+</file>
+
+<file path=ppt/slides/slide25.xml><?xml version="1.0" encoding="utf-8"?>
+<p:sld xmlns:a="http://schemas.openxmlformats.org/drawingml/2006/main" xmlns:r="http://schemas.openxmlformats.org/officeDocument/2006/relationships" xmlns:p="http://schemas.openxmlformats.org/presentationml/2006/main">
+  <p:cSld>
+    <p:bg>
+      <p:bgPr>
+        <a:solidFill>
+          <a:srgbClr val="080A0D"/>
+        </a:solidFill>
+      </p:bgPr>
+    </p:bg>
+    <p:spTree>
+      <p:nvGrpSpPr>
+        <p:cNvPr id="1" name=""/>
+        <p:cNvGrpSpPr/>
+        <p:nvPr/>
+      </p:nvGrpSpPr>
+      <p:grpSpPr>
+        <a:xfrm>
+          <a:off x="0" y="0"/>
+          <a:ext cx="0" cy="0"/>
+          <a:chOff x="0" y="0"/>
+          <a:chExt cx="0" cy="0"/>
+        </a:xfrm>
+      </p:grpSpPr>
+      <p:sp>
+        <p:nvSpPr>
+          <p:cNvPr id="2" name="Title"/>
+          <p:cNvSpPr txBox="1"/>
+          <p:nvPr/>
+        </p:nvSpPr>
+        <p:spPr>
+          <a:xfrm>
+            <a:off x="609600" y="610000"/>
+            <a:ext cx="10300000" cy="850000"/>
+          </a:xfrm>
+          <a:prstGeom prst="rect">
+            <a:avLst/>
+          </a:prstGeom>
+          <a:noFill/>
+        </p:spPr>
+        <p:txBody>
+          <a:bodyPr wrap="square"/>
+          <a:lstStyle/>
+          <a:p>
+            <a:r>
+              <a:rPr lang="en-US" sz="4100" b="1">
+                <a:solidFill>
+                  <a:srgbClr val="F4F7F8"/>
+                </a:solidFill>
+              </a:rPr>
+              <a:t>Closing</a:t>
+            </a:r>
+          </a:p>
+        </p:txBody>
+      </p:sp>
+      <p:sp>
+        <p:nvSpPr>
+          <p:cNvPr id="3" name="Body"/>
+          <p:cNvSpPr txBox="1"/>
+          <p:nvPr/>
+        </p:nvSpPr>
+        <p:spPr>
+          <a:xfrm>
+            <a:off x="914400" y="1905000"/>
+            <a:ext cx="9800000" cy="3900000"/>
+          </a:xfrm>
+          <a:prstGeom prst="rect">
+            <a:avLst/>
+          </a:prstGeom>
+          <a:noFill/>
+        </p:spPr>
+        <p:txBody>
+          <a:bodyPr wrap="square"/>
+          <a:lstStyle/>
+          <a:p>
+            <a:pPr marL="285750" indent="-171450">
+              <a:buChar char="•"/>
+            </a:pPr>
+            <a:r>
+              <a:rPr lang="en-US" sz="2100">
+                <a:solidFill>
+                  <a:srgbClr val="D7E3EA"/>
+                </a:solidFill>
+              </a:rPr>
+              <a:t>HIP.markets turns builder-deployed markets into a community-backed operator business.</a:t>
+            </a:r>
+          </a:p>
+          <a:p>
+            <a:pPr marL="285750" indent="-171450">
+              <a:buChar char="•"/>
+            </a:pPr>
+            <a:r>
+              <a:rPr lang="en-US" sz="2100">
+                <a:solidFill>
+                  <a:srgbClr val="D7E3EA"/>
+                </a:solidFill>
+              </a:rPr>
+              <a:t>The first job is operating markets safely.</a:t>
+            </a:r>
+          </a:p>
+        </p:txBody>
+      </p:sp>
+      <p:sp>
+        <p:nvSpPr>
+          <p:cNvPr id="4" name="Footer"/>
+          <p:cNvSpPr txBox="1"/>
+          <p:nvPr/>
+        </p:nvSpPr>
+        <p:spPr>
+          <a:xfrm>
+            <a:off x="609600" y="6400800"/>
+            <a:ext cx="10500000" cy="300000"/>
+          </a:xfrm>
+          <a:prstGeom prst="rect">
+            <a:avLst/>
+          </a:prstGeom>
+          <a:noFill/>
+        </p:spPr>
+        <p:txBody>
+          <a:bodyPr wrap="square"/>
+          <a:lstStyle/>
+          <a:p>
+            <a:r>
+              <a:rPr lang="en-US" sz="1000">
+                <a:solidFill>
+                  <a:srgbClr val="35D29A"/>
+                </a:solidFill>
+              </a:rPr>
+              <a:t>HIP.markets hackathon submission  |  25</a:t>
             </a:r>
           </a:p>
         </p:txBody>
@@ -2821,7 +3011,7 @@
                   <a:srgbClr val="F4F7F8"/>
                 </a:solidFill>
               </a:rPr>
-              <a:t>Product Thesis</a:t>
+              <a:t>The Problem</a:t>
             </a:r>
           </a:p>
         </p:txBody>
@@ -2855,33 +3045,33 @@
                   <a:srgbClr val="D7E3EA"/>
                 </a:solidFill>
               </a:rPr>
-              <a:t>HIP.markets is not passive liquid staking.</a:t>
-            </a:r>
-          </a:p>
-          <a:p>
-            <a:pPr marL="285750" indent="-171450">
-              <a:buChar char="•"/>
-            </a:pPr>
-            <a:r>
-              <a:rPr lang="en-US" sz="2100">
-                <a:solidFill>
-                  <a:srgbClr val="D7E3EA"/>
-                </a:solidFill>
-              </a:rPr>
-              <a:t>HIP.markets is the operator.</a:t>
-            </a:r>
-          </a:p>
-          <a:p>
-            <a:pPr marL="285750" indent="-171450">
-              <a:buChar char="•"/>
-            </a:pPr>
-            <a:r>
-              <a:rPr lang="en-US" sz="2100">
-                <a:solidFill>
-                  <a:srgbClr val="D7E3EA"/>
-                </a:solidFill>
-              </a:rPr>
-              <a:t>Users back the HIP.markets deployer stake and share net deployer fees.</a:t>
+              <a:t>HIP-3 DEXs need 500,000 HYPE staked.</a:t>
+            </a:r>
+          </a:p>
+          <a:p>
+            <a:pPr marL="285750" indent="-171450">
+              <a:buChar char="•"/>
+            </a:pPr>
+            <a:r>
+              <a:rPr lang="en-US" sz="2100">
+                <a:solidFill>
+                  <a:srgbClr val="D7E3EA"/>
+                </a:solidFill>
+              </a:rPr>
+              <a:t>Stake is only the start: operators also need oracles, liquidity, risk controls, and fee accounting.</a:t>
+            </a:r>
+          </a:p>
+          <a:p>
+            <a:pPr marL="285750" indent="-171450">
+              <a:buChar char="•"/>
+            </a:pPr>
+            <a:r>
+              <a:rPr lang="en-US" sz="2100">
+                <a:solidFill>
+                  <a:srgbClr val="D7E3EA"/>
+                </a:solidFill>
+              </a:rPr>
+              <a:t>Stakers need slashing risk beside APR.</a:t>
             </a:r>
           </a:p>
         </p:txBody>
@@ -2975,7 +3165,7 @@
                   <a:srgbClr val="F4F7F8"/>
                 </a:solidFill>
               </a:rPr>
-              <a:t>Why Now</a:t>
+              <a:t>Product Thesis</a:t>
             </a:r>
           </a:p>
         </p:txBody>
@@ -3009,33 +3199,33 @@
                   <a:srgbClr val="D7E3EA"/>
                 </a:solidFill>
               </a:rPr>
-              <a:t>Hyperliquid has moved from one exchange into market infrastructure.</a:t>
-            </a:r>
-          </a:p>
-          <a:p>
-            <a:pPr marL="285750" indent="-171450">
-              <a:buChar char="•"/>
-            </a:pPr>
-            <a:r>
-              <a:rPr lang="en-US" sz="2100">
-                <a:solidFill>
-                  <a:srgbClr val="D7E3EA"/>
-                </a:solidFill>
-              </a:rPr>
-              <a:t>HIP-3 lets specialist operators list new perpetual markets while HyperCore provides execution rails.</a:t>
-            </a:r>
-          </a:p>
-          <a:p>
-            <a:pPr marL="285750" indent="-171450">
-              <a:buChar char="•"/>
-            </a:pPr>
-            <a:r>
-              <a:rPr lang="en-US" sz="2100">
-                <a:solidFill>
-                  <a:srgbClr val="D7E3EA"/>
-                </a:solidFill>
-              </a:rPr>
-              <a:t>The bottleneck shifts to capital, oracle operations, and operator credibility.</a:t>
+              <a:t>HIP.markets is not passive liquid staking.</a:t>
+            </a:r>
+          </a:p>
+          <a:p>
+            <a:pPr marL="285750" indent="-171450">
+              <a:buChar char="•"/>
+            </a:pPr>
+            <a:r>
+              <a:rPr lang="en-US" sz="2100">
+                <a:solidFill>
+                  <a:srgbClr val="D7E3EA"/>
+                </a:solidFill>
+              </a:rPr>
+              <a:t>HIP.markets is the operator.</a:t>
+            </a:r>
+          </a:p>
+          <a:p>
+            <a:pPr marL="285750" indent="-171450">
+              <a:buChar char="•"/>
+            </a:pPr>
+            <a:r>
+              <a:rPr lang="en-US" sz="2100">
+                <a:solidFill>
+                  <a:srgbClr val="D7E3EA"/>
+                </a:solidFill>
+              </a:rPr>
+              <a:t>Users back the HIP.markets deployer stake and share net deployer fees.</a:t>
             </a:r>
           </a:p>
         </p:txBody>
@@ -3129,7 +3319,7 @@
                   <a:srgbClr val="F4F7F8"/>
                 </a:solidFill>
               </a:rPr>
-              <a:t>Trade.xyz Reference</a:t>
+              <a:t>Why Now</a:t>
             </a:r>
           </a:p>
         </p:txBody>
@@ -3142,80 +3332,58 @@
         </p:nvSpPr>
         <p:spPr>
           <a:xfrm>
-            <a:off x="609600" y="1630000"/>
-            <a:ext cx="4600000" cy="4400000"/>
-          </a:xfrm>
-          <a:prstGeom prst="rect">
-            <a:avLst/>
-          </a:prstGeom>
-          <a:noFill/>
-        </p:spPr>
-        <p:txBody>
-          <a:bodyPr wrap="square"/>
-          <a:lstStyle/>
-          <a:p>
-            <a:pPr marL="285750" indent="-171450">
-              <a:buChar char="•"/>
-            </a:pPr>
-            <a:r>
-              <a:rPr lang="en-US" sz="2100">
-                <a:solidFill>
-                  <a:srgbClr val="D7E3EA"/>
-                </a:solidFill>
-              </a:rPr>
-              <a:t>60 markets, $2.50B 30-day volume, and $121.98K total 30-day fees.</a:t>
-            </a:r>
-          </a:p>
-          <a:p>
-            <a:pPr marL="285750" indent="-171450">
-              <a:buChar char="•"/>
-            </a:pPr>
-            <a:r>
-              <a:rPr lang="en-US" sz="2100">
-                <a:solidFill>
-                  <a:srgbClr val="D7E3EA"/>
-                </a:solidFill>
-              </a:rPr>
-              <a:t>Estimated deployer revenue: $60.99K over 30 days before operating costs.</a:t>
-            </a:r>
-          </a:p>
-          <a:p>
-            <a:pPr marL="285750" indent="-171450">
-              <a:buChar char="•"/>
-            </a:pPr>
-            <a:r>
-              <a:rPr lang="en-US" sz="2100">
-                <a:solidFill>
-                  <a:srgbClr val="D7E3EA"/>
-                </a:solidFill>
-              </a:rPr>
-              <a:t>Gross implied APR: 3.47% on the 500k HYPE minimum stake at $42.8085 HYPE.</a:t>
-            </a:r>
-          </a:p>
-        </p:txBody>
-      </p:sp>
-      <p:pic>
-        <p:nvPicPr>
-          <p:cNvPr id="5" name="tradexyz-reference.png"/>
-          <p:cNvPicPr/>
-          <p:nvPr/>
-        </p:nvPicPr>
-        <p:blipFill>
-          <a:blip r:embed="rId1"/>
-          <a:stretch>
-            <a:fillRect/>
-          </a:stretch>
-        </p:blipFill>
-        <p:spPr>
-          <a:xfrm>
-            <a:off x="5450000" y="1500000"/>
-            <a:ext cx="6130000" cy="3450000"/>
-          </a:xfrm>
-          <a:prstGeom prst="rect">
-            <a:avLst/>
-          </a:prstGeom>
-        </p:spPr>
-      </p:pic>
+            <a:off x="914400" y="1905000"/>
+            <a:ext cx="9800000" cy="3900000"/>
+          </a:xfrm>
+          <a:prstGeom prst="rect">
+            <a:avLst/>
+          </a:prstGeom>
+          <a:noFill/>
+        </p:spPr>
+        <p:txBody>
+          <a:bodyPr wrap="square"/>
+          <a:lstStyle/>
+          <a:p>
+            <a:pPr marL="285750" indent="-171450">
+              <a:buChar char="•"/>
+            </a:pPr>
+            <a:r>
+              <a:rPr lang="en-US" sz="2100">
+                <a:solidFill>
+                  <a:srgbClr val="D7E3EA"/>
+                </a:solidFill>
+              </a:rPr>
+              <a:t>Hyperliquid has moved from one exchange into market infrastructure.</a:t>
+            </a:r>
+          </a:p>
+          <a:p>
+            <a:pPr marL="285750" indent="-171450">
+              <a:buChar char="•"/>
+            </a:pPr>
+            <a:r>
+              <a:rPr lang="en-US" sz="2100">
+                <a:solidFill>
+                  <a:srgbClr val="D7E3EA"/>
+                </a:solidFill>
+              </a:rPr>
+              <a:t>HIP-3 lets specialist operators list new perpetual markets while HyperCore provides execution rails.</a:t>
+            </a:r>
+          </a:p>
+          <a:p>
+            <a:pPr marL="285750" indent="-171450">
+              <a:buChar char="•"/>
+            </a:pPr>
+            <a:r>
+              <a:rPr lang="en-US" sz="2100">
+                <a:solidFill>
+                  <a:srgbClr val="D7E3EA"/>
+                </a:solidFill>
+              </a:rPr>
+              <a:t>The bottleneck shifts to capital, oracle operations, and operator credibility.</a:t>
+            </a:r>
+          </a:p>
+        </p:txBody>
+      </p:sp>
       <p:sp>
         <p:nvSpPr>
           <p:cNvPr id="4" name="Footer"/>
@@ -3305,7 +3473,7 @@
                   <a:srgbClr val="F4F7F8"/>
                 </a:solidFill>
               </a:rPr>
-              <a:t>Successful Market Pattern</a:t>
+              <a:t>Trade.xyz Reference</a:t>
             </a:r>
           </a:p>
         </p:txBody>
@@ -3318,71 +3486,80 @@
         </p:nvSpPr>
         <p:spPr>
           <a:xfrm>
-            <a:off x="914400" y="1905000"/>
-            <a:ext cx="9800000" cy="3900000"/>
-          </a:xfrm>
-          <a:prstGeom prst="rect">
-            <a:avLst/>
-          </a:prstGeom>
-          <a:noFill/>
-        </p:spPr>
-        <p:txBody>
-          <a:bodyPr wrap="square"/>
-          <a:lstStyle/>
-          <a:p>
-            <a:pPr marL="285750" indent="-171450">
-              <a:buChar char="•"/>
-            </a:pPr>
-            <a:r>
-              <a:rPr lang="en-US" sz="2100">
-                <a:solidFill>
-                  <a:srgbClr val="D7E3EA"/>
-                </a:solidFill>
-              </a:rPr>
-              <a:t>Trade.xyz's highest-volume tickers are not only crypto assets.</a:t>
-            </a:r>
-          </a:p>
-          <a:p>
-            <a:pPr marL="285750" indent="-171450">
-              <a:buChar char="•"/>
-            </a:pPr>
-            <a:r>
-              <a:rPr lang="en-US" sz="2100">
-                <a:solidFill>
-                  <a:srgbClr val="D7E3EA"/>
-                </a:solidFill>
-              </a:rPr>
-              <a:t>XYZ100 and SP500: roughly $444M each over 30 days.</a:t>
-            </a:r>
-          </a:p>
-          <a:p>
-            <a:pPr marL="285750" indent="-171450">
-              <a:buChar char="•"/>
-            </a:pPr>
-            <a:r>
-              <a:rPr lang="en-US" sz="2100">
-                <a:solidFill>
-                  <a:srgbClr val="D7E3EA"/>
-                </a:solidFill>
-              </a:rPr>
-              <a:t>SILVER, CL, SNDK, MU, NVDA, BRENTOIL, CBRS, INTC, and GOLD show RWA-style breadth.</a:t>
-            </a:r>
-          </a:p>
-          <a:p>
-            <a:pPr marL="285750" indent="-171450">
-              <a:buChar char="•"/>
-            </a:pPr>
-            <a:r>
-              <a:rPr lang="en-US" sz="2100">
-                <a:solidFill>
-                  <a:srgbClr val="D7E3EA"/>
-                </a:solidFill>
-              </a:rPr>
-              <a:t>HIP.markets should launch where oracle confidence, liquidity, and narrative demand overlap.</a:t>
-            </a:r>
-          </a:p>
-        </p:txBody>
-      </p:sp>
+            <a:off x="609600" y="1630000"/>
+            <a:ext cx="4600000" cy="4400000"/>
+          </a:xfrm>
+          <a:prstGeom prst="rect">
+            <a:avLst/>
+          </a:prstGeom>
+          <a:noFill/>
+        </p:spPr>
+        <p:txBody>
+          <a:bodyPr wrap="square"/>
+          <a:lstStyle/>
+          <a:p>
+            <a:pPr marL="285750" indent="-171450">
+              <a:buChar char="•"/>
+            </a:pPr>
+            <a:r>
+              <a:rPr lang="en-US" sz="2100">
+                <a:solidFill>
+                  <a:srgbClr val="D7E3EA"/>
+                </a:solidFill>
+              </a:rPr>
+              <a:t>60 markets, $2.50B 30-day volume, and $121.98K total 30-day fees.</a:t>
+            </a:r>
+          </a:p>
+          <a:p>
+            <a:pPr marL="285750" indent="-171450">
+              <a:buChar char="•"/>
+            </a:pPr>
+            <a:r>
+              <a:rPr lang="en-US" sz="2100">
+                <a:solidFill>
+                  <a:srgbClr val="D7E3EA"/>
+                </a:solidFill>
+              </a:rPr>
+              <a:t>Estimated deployer revenue: $60.99K over 30 days before operating costs.</a:t>
+            </a:r>
+          </a:p>
+          <a:p>
+            <a:pPr marL="285750" indent="-171450">
+              <a:buChar char="•"/>
+            </a:pPr>
+            <a:r>
+              <a:rPr lang="en-US" sz="2100">
+                <a:solidFill>
+                  <a:srgbClr val="D7E3EA"/>
+                </a:solidFill>
+              </a:rPr>
+              <a:t>Gross implied APR: 3.47% on the 500k HYPE minimum stake at $42.8085 HYPE.</a:t>
+            </a:r>
+          </a:p>
+        </p:txBody>
+      </p:sp>
+      <p:pic>
+        <p:nvPicPr>
+          <p:cNvPr id="5" name="tradexyz-reference.png"/>
+          <p:cNvPicPr/>
+          <p:nvPr/>
+        </p:nvPicPr>
+        <p:blipFill>
+          <a:blip r:embed="rId1"/>
+          <a:stretch>
+            <a:fillRect/>
+          </a:stretch>
+        </p:blipFill>
+        <p:spPr>
+          <a:xfrm>
+            <a:off x="5450000" y="1500000"/>
+            <a:ext cx="6130000" cy="3450000"/>
+          </a:xfrm>
+          <a:prstGeom prst="rect">
+            <a:avLst/>
+          </a:prstGeom>
+        </p:spPr>
+      </p:pic>
       <p:sp>
         <p:nvSpPr>
           <p:cNvPr id="4" name="Footer"/>
@@ -3472,7 +3649,7 @@
                   <a:srgbClr val="F4F7F8"/>
                 </a:solidFill>
               </a:rPr>
-              <a:t>Revenue Interpretation</a:t>
+              <a:t>Successful Market Pattern</a:t>
             </a:r>
           </a:p>
         </p:txBody>
@@ -3506,33 +3683,46 @@
                   <a:srgbClr val="D7E3EA"/>
                 </a:solidFill>
               </a:rPr>
-              <a:t>HIP-3 deployer share is fixed at 50% from the deployer perspective.</a:t>
-            </a:r>
-          </a:p>
-          <a:p>
-            <a:pPr marL="285750" indent="-171450">
-              <a:buChar char="•"/>
-            </a:pPr>
-            <a:r>
-              <a:rPr lang="en-US" sz="2100">
-                <a:solidFill>
-                  <a:srgbClr val="D7E3EA"/>
-                </a:solidFill>
-              </a:rPr>
-              <a:t>Trade.xyz reports deployerFeeScale = 1.0.</a:t>
-            </a:r>
-          </a:p>
-          <a:p>
-            <a:pPr marL="285750" indent="-171450">
-              <a:buChar char="•"/>
-            </a:pPr>
-            <a:r>
-              <a:rPr lang="en-US" sz="2100">
-                <a:solidFill>
-                  <a:srgbClr val="D7E3EA"/>
-                </a:solidFill>
-              </a:rPr>
-              <a:t>Gross revenue is not distributable profit until oracle, data, maker, legal, reserve, and incident costs are deducted.</a:t>
+              <a:t>Trade.xyz's highest-volume tickers are not only crypto assets.</a:t>
+            </a:r>
+          </a:p>
+          <a:p>
+            <a:pPr marL="285750" indent="-171450">
+              <a:buChar char="•"/>
+            </a:pPr>
+            <a:r>
+              <a:rPr lang="en-US" sz="2100">
+                <a:solidFill>
+                  <a:srgbClr val="D7E3EA"/>
+                </a:solidFill>
+              </a:rPr>
+              <a:t>XYZ100 and SP500: roughly $444M each over 30 days.</a:t>
+            </a:r>
+          </a:p>
+          <a:p>
+            <a:pPr marL="285750" indent="-171450">
+              <a:buChar char="•"/>
+            </a:pPr>
+            <a:r>
+              <a:rPr lang="en-US" sz="2100">
+                <a:solidFill>
+                  <a:srgbClr val="D7E3EA"/>
+                </a:solidFill>
+              </a:rPr>
+              <a:t>SILVER, CL, SNDK, MU, NVDA, BRENTOIL, CBRS, INTC, and GOLD show RWA-style breadth.</a:t>
+            </a:r>
+          </a:p>
+          <a:p>
+            <a:pPr marL="285750" indent="-171450">
+              <a:buChar char="•"/>
+            </a:pPr>
+            <a:r>
+              <a:rPr lang="en-US" sz="2100">
+                <a:solidFill>
+                  <a:srgbClr val="D7E3EA"/>
+                </a:solidFill>
+              </a:rPr>
+              <a:t>HIP.markets should launch where oracle confidence, liquidity, and narrative demand overlap.</a:t>
             </a:r>
           </a:p>
         </p:txBody>
@@ -3626,7 +3816,7 @@
                   <a:srgbClr val="F4F7F8"/>
                 </a:solidFill>
               </a:rPr>
-              <a:t>UI Benchmark</a:t>
+              <a:t>Revenue Interpretation</a:t>
             </a:r>
           </a:p>
         </p:txBody>
@@ -3660,20 +3850,33 @@
                   <a:srgbClr val="D7E3EA"/>
                 </a:solidFill>
               </a:rPr>
-              <a:t>trade.xyz proves serious HIP-3 markets need trading-terminal density.</a:t>
-            </a:r>
-          </a:p>
-          <a:p>
-            <a:pPr marL="285750" indent="-171450">
-              <a:buChar char="•"/>
-            </a:pPr>
-            <a:r>
-              <a:rPr lang="en-US" sz="2100">
-                <a:solidFill>
-                  <a:srgbClr val="D7E3EA"/>
-                </a:solidFill>
-              </a:rPr>
-              <a:t>Useful patterns: market rail, order ticket, positions tabs, account modes, Ghost Mode observability, explicit warnings.</a:t>
+              <a:t>HIP-3 deployer share is fixed at 50% from the deployer perspective.</a:t>
+            </a:r>
+          </a:p>
+          <a:p>
+            <a:pPr marL="285750" indent="-171450">
+              <a:buChar char="•"/>
+            </a:pPr>
+            <a:r>
+              <a:rPr lang="en-US" sz="2100">
+                <a:solidFill>
+                  <a:srgbClr val="D7E3EA"/>
+                </a:solidFill>
+              </a:rPr>
+              <a:t>Trade.xyz reports deployerFeeScale = 1.0.</a:t>
+            </a:r>
+          </a:p>
+          <a:p>
+            <a:pPr marL="285750" indent="-171450">
+              <a:buChar char="•"/>
+            </a:pPr>
+            <a:r>
+              <a:rPr lang="en-US" sz="2100">
+                <a:solidFill>
+                  <a:srgbClr val="D7E3EA"/>
+                </a:solidFill>
+              </a:rPr>
+              <a:t>Gross revenue is not distributable profit until oracle, data, maker, legal, reserve, and incident costs are deducted.</a:t>
             </a:r>
           </a:p>
         </p:txBody>
@@ -3767,7 +3970,7 @@
                   <a:srgbClr val="F4F7F8"/>
                 </a:solidFill>
               </a:rPr>
-              <a:t>UX Translation</a:t>
+              <a:t>UI Benchmark</a:t>
             </a:r>
           </a:p>
         </p:txBody>
@@ -3801,46 +4004,20 @@
                   <a:srgbClr val="D7E3EA"/>
                 </a:solidFill>
               </a:rPr>
-              <a:t>Market rail -&gt; first-three-market launch rail.</a:t>
-            </a:r>
-          </a:p>
-          <a:p>
-            <a:pPr marL="285750" indent="-171450">
-              <a:buChar char="•"/>
-            </a:pPr>
-            <a:r>
-              <a:rPr lang="en-US" sz="2100">
-                <a:solidFill>
-                  <a:srgbClr val="D7E3EA"/>
-                </a:solidFill>
-              </a:rPr>
-              <a:t>Order ticket -&gt; HYPE deposit ticket.</a:t>
-            </a:r>
-          </a:p>
-          <a:p>
-            <a:pPr marL="285750" indent="-171450">
-              <a:buChar char="•"/>
-            </a:pPr>
-            <a:r>
-              <a:rPr lang="en-US" sz="2100">
-                <a:solidFill>
-                  <a:srgbClr val="D7E3EA"/>
-                </a:solidFill>
-              </a:rPr>
-              <a:t>Positions panel -&gt; vault shares, fee history, oracle updates, market launches.</a:t>
-            </a:r>
-          </a:p>
-          <a:p>
-            <a:pPr marL="285750" indent="-171450">
-              <a:buChar char="•"/>
-            </a:pPr>
-            <a:r>
-              <a:rPr lang="en-US" sz="2100">
-                <a:solidFill>
-                  <a:srgbClr val="D7E3EA"/>
-                </a:solidFill>
-              </a:rPr>
-              <a:t>Ghost Mode -&gt; operator monitor.</a:t>
+              <a:t>trade.xyz proves serious HIP-3 markets need trading-terminal density.</a:t>
+            </a:r>
+          </a:p>
+          <a:p>
+            <a:pPr marL="285750" indent="-171450">
+              <a:buChar char="•"/>
+            </a:pPr>
+            <a:r>
+              <a:rPr lang="en-US" sz="2100">
+                <a:solidFill>
+                  <a:srgbClr val="D7E3EA"/>
+                </a:solidFill>
+              </a:rPr>
+              <a:t>Useful patterns: market rail, order ticket, positions tabs, account modes, Ghost Mode observability, explicit warnings.</a:t>
             </a:r>
           </a:p>
         </p:txBody>

</xml_diff>

<commit_message>
Strengthen HIP markets judge narrative
</commit_message>
<xml_diff>
--- a/presentation/HIP_MARKETS_DECK.pptx
+++ b/presentation/HIP_MARKETS_DECK.pptx
@@ -30,6 +30,11 @@
     <p:sldId id="278" r:id="rId25"/>
     <p:sldId id="279" r:id="rId26"/>
     <p:sldId id="280" r:id="rId27"/>
+    <p:sldId id="281" r:id="rId28"/>
+    <p:sldId id="282" r:id="rId29"/>
+    <p:sldId id="283" r:id="rId30"/>
+    <p:sldId id="284" r:id="rId31"/>
+    <p:sldId id="285" r:id="rId32"/>
   </p:sldIdLst>
   <p:sldSz cx="12192000" cy="6858000" type="wide"/>
   <p:notesSz cx="6858000" cy="9144000"/>
@@ -279,7 +284,7 @@
                   <a:srgbClr val="F4F7F8"/>
                 </a:solidFill>
               </a:rPr>
-              <a:t>UX Translation</a:t>
+              <a:t>Why Now</a:t>
             </a:r>
           </a:p>
         </p:txBody>
@@ -313,46 +318,33 @@
                   <a:srgbClr val="D7E3EA"/>
                 </a:solidFill>
               </a:rPr>
-              <a:t>Market rail -&gt; first-three-market launch rail.</a:t>
-            </a:r>
-          </a:p>
-          <a:p>
-            <a:pPr marL="285750" indent="-171450">
-              <a:buChar char="•"/>
-            </a:pPr>
-            <a:r>
-              <a:rPr lang="en-US" sz="2100">
-                <a:solidFill>
-                  <a:srgbClr val="D7E3EA"/>
-                </a:solidFill>
-              </a:rPr>
-              <a:t>Order ticket -&gt; HYPE deposit ticket.</a:t>
-            </a:r>
-          </a:p>
-          <a:p>
-            <a:pPr marL="285750" indent="-171450">
-              <a:buChar char="•"/>
-            </a:pPr>
-            <a:r>
-              <a:rPr lang="en-US" sz="2100">
-                <a:solidFill>
-                  <a:srgbClr val="D7E3EA"/>
-                </a:solidFill>
-              </a:rPr>
-              <a:t>Positions panel -&gt; vault shares, fee history, oracle updates, market launches.</a:t>
-            </a:r>
-          </a:p>
-          <a:p>
-            <a:pPr marL="285750" indent="-171450">
-              <a:buChar char="•"/>
-            </a:pPr>
-            <a:r>
-              <a:rPr lang="en-US" sz="2100">
-                <a:solidFill>
-                  <a:srgbClr val="D7E3EA"/>
-                </a:solidFill>
-              </a:rPr>
-              <a:t>Ghost Mode -&gt; operator monitor.</a:t>
+              <a:t>Hyperliquid has moved from one exchange into market infrastructure.</a:t>
+            </a:r>
+          </a:p>
+          <a:p>
+            <a:pPr marL="285750" indent="-171450">
+              <a:buChar char="•"/>
+            </a:pPr>
+            <a:r>
+              <a:rPr lang="en-US" sz="2100">
+                <a:solidFill>
+                  <a:srgbClr val="D7E3EA"/>
+                </a:solidFill>
+              </a:rPr>
+              <a:t>HIP-3 lets specialist operators list new perpetual markets while HyperCore provides execution rails.</a:t>
+            </a:r>
+          </a:p>
+          <a:p>
+            <a:pPr marL="285750" indent="-171450">
+              <a:buChar char="•"/>
+            </a:pPr>
+            <a:r>
+              <a:rPr lang="en-US" sz="2100">
+                <a:solidFill>
+                  <a:srgbClr val="D7E3EA"/>
+                </a:solidFill>
+              </a:rPr>
+              <a:t>The bottleneck shifts to capital, oracle operations, and operator credibility.</a:t>
             </a:r>
           </a:p>
         </p:txBody>
@@ -446,7 +438,7 @@
                   <a:srgbClr val="F4F7F8"/>
                 </a:solidFill>
               </a:rPr>
-              <a:t>Demo Walkthrough</a:t>
+              <a:t>Trade.xyz Reference</a:t>
             </a:r>
           </a:p>
         </p:txBody>
@@ -480,27 +472,40 @@
                   <a:srgbClr val="D7E3EA"/>
                 </a:solidFill>
               </a:rPr>
-              <a:t>The first screen is the usable operator console, not a landing page.</a:t>
-            </a:r>
-          </a:p>
-          <a:p>
-            <a:pPr marL="285750" indent="-171450">
-              <a:buChar char="•"/>
-            </a:pPr>
-            <a:r>
-              <a:rPr lang="en-US" sz="2100">
-                <a:solidFill>
-                  <a:srgbClr val="D7E3EA"/>
-                </a:solidFill>
-              </a:rPr>
-              <a:t>Vault capacity, APR, oracle cadence, risk state, market rail, fee model, deposit ticket, and monitor are visible in one workflow.</a:t>
+              <a:t>60 markets, $2.50B 30-day volume, and $121.98K total 30-day fees.</a:t>
+            </a:r>
+          </a:p>
+          <a:p>
+            <a:pPr marL="285750" indent="-171450">
+              <a:buChar char="•"/>
+            </a:pPr>
+            <a:r>
+              <a:rPr lang="en-US" sz="2100">
+                <a:solidFill>
+                  <a:srgbClr val="D7E3EA"/>
+                </a:solidFill>
+              </a:rPr>
+              <a:t>Estimated deployer revenue: $60.99K over 30 days before operating costs.</a:t>
+            </a:r>
+          </a:p>
+          <a:p>
+            <a:pPr marL="285750" indent="-171450">
+              <a:buChar char="•"/>
+            </a:pPr>
+            <a:r>
+              <a:rPr lang="en-US" sz="2100">
+                <a:solidFill>
+                  <a:srgbClr val="D7E3EA"/>
+                </a:solidFill>
+              </a:rPr>
+              <a:t>Gross implied APR: 3.47% on the 500k HYPE minimum stake at $42.8085 HYPE.</a:t>
             </a:r>
           </a:p>
         </p:txBody>
       </p:sp>
       <p:pic>
         <p:nvPicPr>
-          <p:cNvPr id="5" name="demo-dashboard.png"/>
+          <p:cNvPr id="5" name="tradexyz-reference.png"/>
           <p:cNvPicPr/>
           <p:nvPr/>
         </p:nvPicPr>
@@ -609,7 +614,7 @@
                   <a:srgbClr val="F4F7F8"/>
                 </a:solidFill>
               </a:rPr>
-              <a:t>Demo: Fee Model</a:t>
+              <a:t>Successful Market Pattern</a:t>
             </a:r>
           </a:p>
         </p:txBody>
@@ -643,20 +648,46 @@
                   <a:srgbClr val="D7E3EA"/>
                 </a:solidFill>
               </a:rPr>
-              <a:t>Judges can change HYPE price, staked HYPE, daily volume, fee bps, builder share, operating fee, protocol fee, and reserve.</a:t>
-            </a:r>
-          </a:p>
-          <a:p>
-            <a:pPr marL="285750" indent="-171450">
-              <a:buChar char="•"/>
-            </a:pPr>
-            <a:r>
-              <a:rPr lang="en-US" sz="2100">
-                <a:solidFill>
-                  <a:srgbClr val="D7E3EA"/>
-                </a:solidFill>
-              </a:rPr>
-              <a:t>APR updates instantly.</a:t>
+              <a:t>Trade.xyz's highest-volume tickers are not only crypto assets.</a:t>
+            </a:r>
+          </a:p>
+          <a:p>
+            <a:pPr marL="285750" indent="-171450">
+              <a:buChar char="•"/>
+            </a:pPr>
+            <a:r>
+              <a:rPr lang="en-US" sz="2100">
+                <a:solidFill>
+                  <a:srgbClr val="D7E3EA"/>
+                </a:solidFill>
+              </a:rPr>
+              <a:t>XYZ100 and SP500: roughly $444M each over 30 days.</a:t>
+            </a:r>
+          </a:p>
+          <a:p>
+            <a:pPr marL="285750" indent="-171450">
+              <a:buChar char="•"/>
+            </a:pPr>
+            <a:r>
+              <a:rPr lang="en-US" sz="2100">
+                <a:solidFill>
+                  <a:srgbClr val="D7E3EA"/>
+                </a:solidFill>
+              </a:rPr>
+              <a:t>SILVER, CL, SNDK, MU, NVDA, BRENTOIL, CBRS, INTC, and GOLD show RWA-style breadth.</a:t>
+            </a:r>
+          </a:p>
+          <a:p>
+            <a:pPr marL="285750" indent="-171450">
+              <a:buChar char="•"/>
+            </a:pPr>
+            <a:r>
+              <a:rPr lang="en-US" sz="2100">
+                <a:solidFill>
+                  <a:srgbClr val="D7E3EA"/>
+                </a:solidFill>
+              </a:rPr>
+              <a:t>HIP.markets should launch where oracle confidence, liquidity, and narrative demand overlap.</a:t>
             </a:r>
           </a:p>
         </p:txBody>
@@ -750,7 +781,7 @@
                   <a:srgbClr val="F4F7F8"/>
                 </a:solidFill>
               </a:rPr>
-              <a:t>Demo: Deposit Ticket</a:t>
+              <a:t>Revenue Interpretation</a:t>
             </a:r>
           </a:p>
         </p:txBody>
@@ -784,20 +815,33 @@
                   <a:srgbClr val="D7E3EA"/>
                 </a:solidFill>
               </a:rPr>
-              <a:t>Mirrors a trading order pane.</a:t>
-            </a:r>
-          </a:p>
-          <a:p>
-            <a:pPr marL="285750" indent="-171450">
-              <a:buChar char="•"/>
-            </a:pPr>
-            <a:r>
-              <a:rPr lang="en-US" sz="2100">
-                <a:solidFill>
-                  <a:srgbClr val="D7E3EA"/>
-                </a:solidFill>
-              </a:rPr>
-              <a:t>Amount input, deposit/withdraw mode, fee summary, user rewards estimate, and slashing warning.</a:t>
+              <a:t>HIP-3 deployer share is fixed at 50% from the deployer perspective.</a:t>
+            </a:r>
+          </a:p>
+          <a:p>
+            <a:pPr marL="285750" indent="-171450">
+              <a:buChar char="•"/>
+            </a:pPr>
+            <a:r>
+              <a:rPr lang="en-US" sz="2100">
+                <a:solidFill>
+                  <a:srgbClr val="D7E3EA"/>
+                </a:solidFill>
+              </a:rPr>
+              <a:t>Trade.xyz reports deployerFeeScale = 1.0.</a:t>
+            </a:r>
+          </a:p>
+          <a:p>
+            <a:pPr marL="285750" indent="-171450">
+              <a:buChar char="•"/>
+            </a:pPr>
+            <a:r>
+              <a:rPr lang="en-US" sz="2100">
+                <a:solidFill>
+                  <a:srgbClr val="D7E3EA"/>
+                </a:solidFill>
+              </a:rPr>
+              <a:t>Gross revenue is not distributable profit until oracle, data, maker, legal, reserve, and incident costs are deducted.</a:t>
             </a:r>
           </a:p>
         </p:txBody>
@@ -891,7 +935,7 @@
                   <a:srgbClr val="F4F7F8"/>
                 </a:solidFill>
               </a:rPr>
-              <a:t>Demo: Audit Ledger</a:t>
+              <a:t>UI Benchmark</a:t>
             </a:r>
           </a:p>
         </p:txBody>
@@ -904,67 +948,45 @@
         </p:nvSpPr>
         <p:spPr>
           <a:xfrm>
-            <a:off x="609600" y="1630000"/>
-            <a:ext cx="4600000" cy="4400000"/>
-          </a:xfrm>
-          <a:prstGeom prst="rect">
-            <a:avLst/>
-          </a:prstGeom>
-          <a:noFill/>
-        </p:spPr>
-        <p:txBody>
-          <a:bodyPr wrap="square"/>
-          <a:lstStyle/>
-          <a:p>
-            <a:pPr marL="285750" indent="-171450">
-              <a:buChar char="•"/>
-            </a:pPr>
-            <a:r>
-              <a:rPr lang="en-US" sz="2100">
-                <a:solidFill>
-                  <a:srgbClr val="D7E3EA"/>
-                </a:solidFill>
-              </a:rPr>
-              <a:t>Fee sharing becomes an inspectable ledger.</a:t>
-            </a:r>
-          </a:p>
-          <a:p>
-            <a:pPr marL="285750" indent="-171450">
-              <a:buChar char="•"/>
-            </a:pPr>
-            <a:r>
-              <a:rPr lang="en-US" sz="2100">
-                <a:solidFill>
-                  <a:srgbClr val="D7E3EA"/>
-                </a:solidFill>
-              </a:rPr>
-              <a:t>Vault shares, fee history, oracle updates, and market launch readiness expose operator behavior.</a:t>
-            </a:r>
-          </a:p>
-        </p:txBody>
-      </p:sp>
-      <p:pic>
-        <p:nvPicPr>
-          <p:cNvPr id="5" name="demo-fee-ledger-view.png"/>
-          <p:cNvPicPr/>
-          <p:nvPr/>
-        </p:nvPicPr>
-        <p:blipFill>
-          <a:blip r:embed="rId1"/>
-          <a:stretch>
-            <a:fillRect/>
-          </a:stretch>
-        </p:blipFill>
-        <p:spPr>
-          <a:xfrm>
-            <a:off x="5450000" y="1500000"/>
-            <a:ext cx="6130000" cy="3450000"/>
-          </a:xfrm>
-          <a:prstGeom prst="rect">
-            <a:avLst/>
-          </a:prstGeom>
-        </p:spPr>
-      </p:pic>
+            <a:off x="914400" y="1905000"/>
+            <a:ext cx="9800000" cy="3900000"/>
+          </a:xfrm>
+          <a:prstGeom prst="rect">
+            <a:avLst/>
+          </a:prstGeom>
+          <a:noFill/>
+        </p:spPr>
+        <p:txBody>
+          <a:bodyPr wrap="square"/>
+          <a:lstStyle/>
+          <a:p>
+            <a:pPr marL="285750" indent="-171450">
+              <a:buChar char="•"/>
+            </a:pPr>
+            <a:r>
+              <a:rPr lang="en-US" sz="2100">
+                <a:solidFill>
+                  <a:srgbClr val="D7E3EA"/>
+                </a:solidFill>
+              </a:rPr>
+              <a:t>trade.xyz proves serious HIP-3 markets need trading-terminal density.</a:t>
+            </a:r>
+          </a:p>
+          <a:p>
+            <a:pPr marL="285750" indent="-171450">
+              <a:buChar char="•"/>
+            </a:pPr>
+            <a:r>
+              <a:rPr lang="en-US" sz="2100">
+                <a:solidFill>
+                  <a:srgbClr val="D7E3EA"/>
+                </a:solidFill>
+              </a:rPr>
+              <a:t>Useful patterns: market rail, order ticket, positions tabs, account modes, Ghost Mode observability, explicit warnings.</a:t>
+            </a:r>
+          </a:p>
+        </p:txBody>
+      </p:sp>
       <p:sp>
         <p:nvSpPr>
           <p:cNvPr id="4" name="Footer"/>
@@ -1054,7 +1076,7 @@
                   <a:srgbClr val="F4F7F8"/>
                 </a:solidFill>
               </a:rPr>
-              <a:t>Demo: Contract Wiring</a:t>
+              <a:t>UX Translation</a:t>
             </a:r>
           </a:p>
         </p:txBody>
@@ -1067,67 +1089,71 @@
         </p:nvSpPr>
         <p:spPr>
           <a:xfrm>
-            <a:off x="609600" y="1630000"/>
-            <a:ext cx="4600000" cy="4400000"/>
-          </a:xfrm>
-          <a:prstGeom prst="rect">
-            <a:avLst/>
-          </a:prstGeom>
-          <a:noFill/>
-        </p:spPr>
-        <p:txBody>
-          <a:bodyPr wrap="square"/>
-          <a:lstStyle/>
-          <a:p>
-            <a:pPr marL="285750" indent="-171450">
-              <a:buChar char="•"/>
-            </a:pPr>
-            <a:r>
-              <a:rPr lang="en-US" sz="2100">
-                <a:solidFill>
-                  <a:srgbClr val="D7E3EA"/>
-                </a:solidFill>
-              </a:rPr>
-              <a:t>Wallet-aware flow: connect wallet, configure vault/token addresses, approve HYPE, deposit, and claim rewards.</a:t>
-            </a:r>
-          </a:p>
-          <a:p>
-            <a:pPr marL="285750" indent="-171450">
-              <a:buChar char="•"/>
-            </a:pPr>
-            <a:r>
-              <a:rPr lang="en-US" sz="2100">
-                <a:solidFill>
-                  <a:srgbClr val="D7E3EA"/>
-                </a:solidFill>
-              </a:rPr>
-              <a:t>The UI also shows which actions still require operator multisig and risk-council execution.</a:t>
-            </a:r>
-          </a:p>
-        </p:txBody>
-      </p:sp>
-      <p:pic>
-        <p:nvPicPr>
-          <p:cNvPr id="5" name="demo-contract-wiring.png"/>
-          <p:cNvPicPr/>
-          <p:nvPr/>
-        </p:nvPicPr>
-        <p:blipFill>
-          <a:blip r:embed="rId1"/>
-          <a:stretch>
-            <a:fillRect/>
-          </a:stretch>
-        </p:blipFill>
-        <p:spPr>
-          <a:xfrm>
-            <a:off x="5450000" y="1500000"/>
-            <a:ext cx="6130000" cy="3450000"/>
-          </a:xfrm>
-          <a:prstGeom prst="rect">
-            <a:avLst/>
-          </a:prstGeom>
-        </p:spPr>
-      </p:pic>
+            <a:off x="914400" y="1905000"/>
+            <a:ext cx="9800000" cy="3900000"/>
+          </a:xfrm>
+          <a:prstGeom prst="rect">
+            <a:avLst/>
+          </a:prstGeom>
+          <a:noFill/>
+        </p:spPr>
+        <p:txBody>
+          <a:bodyPr wrap="square"/>
+          <a:lstStyle/>
+          <a:p>
+            <a:pPr marL="285750" indent="-171450">
+              <a:buChar char="•"/>
+            </a:pPr>
+            <a:r>
+              <a:rPr lang="en-US" sz="2100">
+                <a:solidFill>
+                  <a:srgbClr val="D7E3EA"/>
+                </a:solidFill>
+              </a:rPr>
+              <a:t>Market rail -&gt; first-three-market launch rail.</a:t>
+            </a:r>
+          </a:p>
+          <a:p>
+            <a:pPr marL="285750" indent="-171450">
+              <a:buChar char="•"/>
+            </a:pPr>
+            <a:r>
+              <a:rPr lang="en-US" sz="2100">
+                <a:solidFill>
+                  <a:srgbClr val="D7E3EA"/>
+                </a:solidFill>
+              </a:rPr>
+              <a:t>Order ticket -&gt; HYPE deposit ticket.</a:t>
+            </a:r>
+          </a:p>
+          <a:p>
+            <a:pPr marL="285750" indent="-171450">
+              <a:buChar char="•"/>
+            </a:pPr>
+            <a:r>
+              <a:rPr lang="en-US" sz="2100">
+                <a:solidFill>
+                  <a:srgbClr val="D7E3EA"/>
+                </a:solidFill>
+              </a:rPr>
+              <a:t>Positions panel -&gt; vault shares, fee history, oracle updates, market launches.</a:t>
+            </a:r>
+          </a:p>
+          <a:p>
+            <a:pPr marL="285750" indent="-171450">
+              <a:buChar char="•"/>
+            </a:pPr>
+            <a:r>
+              <a:rPr lang="en-US" sz="2100">
+                <a:solidFill>
+                  <a:srgbClr val="D7E3EA"/>
+                </a:solidFill>
+              </a:rPr>
+              <a:t>Ghost Mode -&gt; operator monitor.</a:t>
+            </a:r>
+          </a:p>
+        </p:txBody>
+      </p:sp>
       <p:sp>
         <p:nvSpPr>
           <p:cNvPr id="4" name="Footer"/>
@@ -1217,7 +1243,7 @@
                   <a:srgbClr val="F4F7F8"/>
                 </a:solidFill>
               </a:rPr>
-              <a:t>Contract Depth</a:t>
+              <a:t>Demo Walkthrough</a:t>
             </a:r>
           </a:p>
         </p:txBody>
@@ -1230,58 +1256,67 @@
         </p:nvSpPr>
         <p:spPr>
           <a:xfrm>
-            <a:off x="914400" y="1905000"/>
-            <a:ext cx="9800000" cy="3900000"/>
-          </a:xfrm>
-          <a:prstGeom prst="rect">
-            <a:avLst/>
-          </a:prstGeom>
-          <a:noFill/>
-        </p:spPr>
-        <p:txBody>
-          <a:bodyPr wrap="square"/>
-          <a:lstStyle/>
-          <a:p>
-            <a:pPr marL="285750" indent="-171450">
-              <a:buChar char="•"/>
-            </a:pPr>
-            <a:r>
-              <a:rPr lang="en-US" sz="2100">
-                <a:solidFill>
-                  <a:srgbClr val="D7E3EA"/>
-                </a:solidFill>
-              </a:rPr>
-              <a:t>Vault now models vHIPM receipt shares, vault caps, withdrawal queues, reward accounting, and slash losses.</a:t>
-            </a:r>
-          </a:p>
-          <a:p>
-            <a:pPr marL="285750" indent="-171450">
-              <a:buChar char="•"/>
-            </a:pPr>
-            <a:r>
-              <a:rPr lang="en-US" sz="2100">
-                <a:solidFill>
-                  <a:srgbClr val="D7E3EA"/>
-                </a:solidFill>
-              </a:rPr>
-              <a:t>Operator lifecycle: funding, stake-ready, stake-escrowed, approved, live, wind-down, and slashed.</a:t>
-            </a:r>
-          </a:p>
-          <a:p>
-            <a:pPr marL="285750" indent="-171450">
-              <a:buChar char="•"/>
-            </a:pPr>
-            <a:r>
-              <a:rPr lang="en-US" sz="2100">
-                <a:solidFill>
-                  <a:srgbClr val="D7E3EA"/>
-                </a:solidFill>
-              </a:rPr>
-              <a:t>Registry tracks launch checklist, fee epochs, oracle health, market status, and risk state.</a:t>
-            </a:r>
-          </a:p>
-        </p:txBody>
-      </p:sp>
+            <a:off x="609600" y="1630000"/>
+            <a:ext cx="4600000" cy="4400000"/>
+          </a:xfrm>
+          <a:prstGeom prst="rect">
+            <a:avLst/>
+          </a:prstGeom>
+          <a:noFill/>
+        </p:spPr>
+        <p:txBody>
+          <a:bodyPr wrap="square"/>
+          <a:lstStyle/>
+          <a:p>
+            <a:pPr marL="285750" indent="-171450">
+              <a:buChar char="•"/>
+            </a:pPr>
+            <a:r>
+              <a:rPr lang="en-US" sz="2100">
+                <a:solidFill>
+                  <a:srgbClr val="D7E3EA"/>
+                </a:solidFill>
+              </a:rPr>
+              <a:t>The first screen is the usable operator console, not a landing page.</a:t>
+            </a:r>
+          </a:p>
+          <a:p>
+            <a:pPr marL="285750" indent="-171450">
+              <a:buChar char="•"/>
+            </a:pPr>
+            <a:r>
+              <a:rPr lang="en-US" sz="2100">
+                <a:solidFill>
+                  <a:srgbClr val="D7E3EA"/>
+                </a:solidFill>
+              </a:rPr>
+              <a:t>Vault capacity, APR, oracle cadence, risk state, market rail, fee model, deposit ticket, and monitor are visible in one workflow.</a:t>
+            </a:r>
+          </a:p>
+        </p:txBody>
+      </p:sp>
+      <p:pic>
+        <p:nvPicPr>
+          <p:cNvPr id="5" name="demo-dashboard.png"/>
+          <p:cNvPicPr/>
+          <p:nvPr/>
+        </p:nvPicPr>
+        <p:blipFill>
+          <a:blip r:embed="rId1"/>
+          <a:stretch>
+            <a:fillRect/>
+          </a:stretch>
+        </p:blipFill>
+        <p:spPr>
+          <a:xfrm>
+            <a:off x="5450000" y="1500000"/>
+            <a:ext cx="6130000" cy="3450000"/>
+          </a:xfrm>
+          <a:prstGeom prst="rect">
+            <a:avLst/>
+          </a:prstGeom>
+        </p:spPr>
+      </p:pic>
       <p:sp>
         <p:nvSpPr>
           <p:cNvPr id="4" name="Footer"/>
@@ -1371,7 +1406,7 @@
                   <a:srgbClr val="F4F7F8"/>
                 </a:solidFill>
               </a:rPr>
-              <a:t>System Flow</a:t>
+              <a:t>Demo: Fee Model</a:t>
             </a:r>
           </a:p>
         </p:txBody>
@@ -1405,59 +1440,20 @@
                   <a:srgbClr val="D7E3EA"/>
                 </a:solidFill>
               </a:rPr>
-              <a:t>1. HYPE holders deposit into the HyperEVM vault.</a:t>
-            </a:r>
-          </a:p>
-          <a:p>
-            <a:pPr marL="285750" indent="-171450">
-              <a:buChar char="•"/>
-            </a:pPr>
-            <a:r>
-              <a:rPr lang="en-US" sz="2100">
-                <a:solidFill>
-                  <a:srgbClr val="D7E3EA"/>
-                </a:solidFill>
-              </a:rPr>
-              <a:t>2. Vault backs HIP.markets deployer stake.</a:t>
-            </a:r>
-          </a:p>
-          <a:p>
-            <a:pPr marL="285750" indent="-171450">
-              <a:buChar char="•"/>
-            </a:pPr>
-            <a:r>
-              <a:rPr lang="en-US" sz="2100">
-                <a:solidFill>
-                  <a:srgbClr val="D7E3EA"/>
-                </a:solidFill>
-              </a:rPr>
-              <a:t>3. Operator multisig escrows funded HYPE to the deployer stake controller.</a:t>
-            </a:r>
-          </a:p>
-          <a:p>
-            <a:pPr marL="285750" indent="-171450">
-              <a:buChar char="•"/>
-            </a:pPr>
-            <a:r>
-              <a:rPr lang="en-US" sz="2100">
-                <a:solidFill>
-                  <a:srgbClr val="D7E3EA"/>
-                </a:solidFill>
-              </a:rPr>
-              <a:t>4. Risk council records HIP-3 operator approval.</a:t>
-            </a:r>
-          </a:p>
-          <a:p>
-            <a:pPr marL="285750" indent="-171450">
-              <a:buChar char="•"/>
-            </a:pPr>
-            <a:r>
-              <a:rPr lang="en-US" sz="2100">
-                <a:solidFill>
-                  <a:srgbClr val="D7E3EA"/>
-                </a:solidFill>
-              </a:rPr>
-              <a:t>5. HIP.markets launches markets, traders generate fees, and net rewards distribute after deductions.</a:t>
+              <a:t>Judges can change HYPE price, staked HYPE, daily volume, fee bps, builder share, operating fee, protocol fee, and reserve.</a:t>
+            </a:r>
+          </a:p>
+          <a:p>
+            <a:pPr marL="285750" indent="-171450">
+              <a:buChar char="•"/>
+            </a:pPr>
+            <a:r>
+              <a:rPr lang="en-US" sz="2100">
+                <a:solidFill>
+                  <a:srgbClr val="D7E3EA"/>
+                </a:solidFill>
+              </a:rPr>
+              <a:t>APR updates instantly.</a:t>
             </a:r>
           </a:p>
         </p:txBody>
@@ -1551,7 +1547,7 @@
                   <a:srgbClr val="F4F7F8"/>
                 </a:solidFill>
               </a:rPr>
-              <a:t>Economics</a:t>
+              <a:t>Demo: Deposit Ticket</a:t>
             </a:r>
           </a:p>
         </p:txBody>
@@ -1585,46 +1581,20 @@
                   <a:srgbClr val="D7E3EA"/>
                 </a:solidFill>
               </a:rPr>
-              <a:t>Base model: 500k HYPE, $50M daily volume, 6 bps fee, 50% deployer share.</a:t>
-            </a:r>
-          </a:p>
-          <a:p>
-            <a:pPr marL="285750" indent="-171450">
-              <a:buChar char="•"/>
-            </a:pPr>
-            <a:r>
-              <a:rPr lang="en-US" sz="2100">
-                <a:solidFill>
-                  <a:srgbClr val="D7E3EA"/>
-                </a:solidFill>
-              </a:rPr>
-              <a:t>After 40% operating/protocol/reserve deductions: approximately 15% net APR.</a:t>
-            </a:r>
-          </a:p>
-          <a:p>
-            <a:pPr marL="285750" indent="-171450">
-              <a:buChar char="•"/>
-            </a:pPr>
-            <a:r>
-              <a:rPr lang="en-US" sz="2100">
-                <a:solidFill>
-                  <a:srgbClr val="D7E3EA"/>
-                </a:solidFill>
-              </a:rPr>
-              <a:t>Trade.xyz trailing fees imply approximately 3.47% gross APR on the minimum stake.</a:t>
-            </a:r>
-          </a:p>
-          <a:p>
-            <a:pPr marL="285750" indent="-171450">
-              <a:buChar char="•"/>
-            </a:pPr>
-            <a:r>
-              <a:rPr lang="en-US" sz="2100">
-                <a:solidFill>
-                  <a:srgbClr val="D7E3EA"/>
-                </a:solidFill>
-              </a:rPr>
-              <a:t>Sensitivity matters more than headline APR.</a:t>
+              <a:t>Mirrors a trading order pane.</a:t>
+            </a:r>
+          </a:p>
+          <a:p>
+            <a:pPr marL="285750" indent="-171450">
+              <a:buChar char="•"/>
+            </a:pPr>
+            <a:r>
+              <a:rPr lang="en-US" sz="2100">
+                <a:solidFill>
+                  <a:srgbClr val="D7E3EA"/>
+                </a:solidFill>
+              </a:rPr>
+              <a:t>Amount input, deposit/withdraw mode, fee summary, user rewards estimate, and slashing warning.</a:t>
             </a:r>
           </a:p>
         </p:txBody>
@@ -1718,7 +1688,7 @@
                   <a:srgbClr val="F4F7F8"/>
                 </a:solidFill>
               </a:rPr>
-              <a:t>Risk Controls</a:t>
+              <a:t>Demo: Audit Ledger</a:t>
             </a:r>
           </a:p>
         </p:txBody>
@@ -1731,58 +1701,67 @@
         </p:nvSpPr>
         <p:spPr>
           <a:xfrm>
-            <a:off x="914400" y="1905000"/>
-            <a:ext cx="9800000" cy="3900000"/>
-          </a:xfrm>
-          <a:prstGeom prst="rect">
-            <a:avLst/>
-          </a:prstGeom>
-          <a:noFill/>
-        </p:spPr>
-        <p:txBody>
-          <a:bodyPr wrap="square"/>
-          <a:lstStyle/>
-          <a:p>
-            <a:pPr marL="285750" indent="-171450">
-              <a:buChar char="•"/>
-            </a:pPr>
-            <a:r>
-              <a:rPr lang="en-US" sz="2100">
-                <a:solidFill>
-                  <a:srgbClr val="D7E3EA"/>
-                </a:solidFill>
-              </a:rPr>
-              <a:t>Start with oracle-simple markets.</a:t>
-            </a:r>
-          </a:p>
-          <a:p>
-            <a:pPr marL="285750" indent="-171450">
-              <a:buChar char="•"/>
-            </a:pPr>
-            <a:r>
-              <a:rPr lang="en-US" sz="2100">
-                <a:solidFill>
-                  <a:srgbClr val="D7E3EA"/>
-                </a:solidFill>
-              </a:rPr>
-              <a:t>Avoid extra ticker auction costs at launch.</a:t>
-            </a:r>
-          </a:p>
-          <a:p>
-            <a:pPr marL="285750" indent="-171450">
-              <a:buChar char="•"/>
-            </a:pPr>
-            <a:r>
-              <a:rPr lang="en-US" sz="2100">
-                <a:solidFill>
-                  <a:srgbClr val="D7E3EA"/>
-                </a:solidFill>
-              </a:rPr>
-              <a:t>Cap open interest, publish addresses, maintain reserve, pause deposits during incidents.</a:t>
-            </a:r>
-          </a:p>
-        </p:txBody>
-      </p:sp>
+            <a:off x="609600" y="1630000"/>
+            <a:ext cx="4600000" cy="4400000"/>
+          </a:xfrm>
+          <a:prstGeom prst="rect">
+            <a:avLst/>
+          </a:prstGeom>
+          <a:noFill/>
+        </p:spPr>
+        <p:txBody>
+          <a:bodyPr wrap="square"/>
+          <a:lstStyle/>
+          <a:p>
+            <a:pPr marL="285750" indent="-171450">
+              <a:buChar char="•"/>
+            </a:pPr>
+            <a:r>
+              <a:rPr lang="en-US" sz="2100">
+                <a:solidFill>
+                  <a:srgbClr val="D7E3EA"/>
+                </a:solidFill>
+              </a:rPr>
+              <a:t>Fee sharing becomes an inspectable ledger.</a:t>
+            </a:r>
+          </a:p>
+          <a:p>
+            <a:pPr marL="285750" indent="-171450">
+              <a:buChar char="•"/>
+            </a:pPr>
+            <a:r>
+              <a:rPr lang="en-US" sz="2100">
+                <a:solidFill>
+                  <a:srgbClr val="D7E3EA"/>
+                </a:solidFill>
+              </a:rPr>
+              <a:t>Vault shares, fee history, oracle updates, and market launch readiness expose operator behavior.</a:t>
+            </a:r>
+          </a:p>
+        </p:txBody>
+      </p:sp>
+      <p:pic>
+        <p:nvPicPr>
+          <p:cNvPr id="5" name="demo-fee-ledger-view.png"/>
+          <p:cNvPicPr/>
+          <p:nvPr/>
+        </p:nvPicPr>
+        <p:blipFill>
+          <a:blip r:embed="rId1"/>
+          <a:stretch>
+            <a:fillRect/>
+          </a:stretch>
+        </p:blipFill>
+        <p:spPr>
+          <a:xfrm>
+            <a:off x="5450000" y="1500000"/>
+            <a:ext cx="6130000" cy="3450000"/>
+          </a:xfrm>
+          <a:prstGeom prst="rect">
+            <a:avLst/>
+          </a:prstGeom>
+        </p:spPr>
+      </p:pic>
       <p:sp>
         <p:nvSpPr>
           <p:cNvPr id="4" name="Footer"/>
@@ -2048,7 +2027,7 @@
                   <a:srgbClr val="F4F7F8"/>
                 </a:solidFill>
               </a:rPr>
-              <a:t>Cost Stack</a:t>
+              <a:t>Demo: Contract Wiring</a:t>
             </a:r>
           </a:p>
         </p:txBody>
@@ -2061,45 +2040,67 @@
         </p:nvSpPr>
         <p:spPr>
           <a:xfrm>
-            <a:off x="914400" y="1905000"/>
-            <a:ext cx="9800000" cy="3900000"/>
-          </a:xfrm>
-          <a:prstGeom prst="rect">
-            <a:avLst/>
-          </a:prstGeom>
-          <a:noFill/>
-        </p:spPr>
-        <p:txBody>
-          <a:bodyPr wrap="square"/>
-          <a:lstStyle/>
-          <a:p>
-            <a:pPr marL="285750" indent="-171450">
-              <a:buChar char="•"/>
-            </a:pPr>
-            <a:r>
-              <a:rPr lang="en-US" sz="2100">
-                <a:solidFill>
-                  <a:srgbClr val="D7E3EA"/>
-                </a:solidFill>
-              </a:rPr>
-              <a:t>The 500k HYPE stake is the entry ticket, not the full cost of business.</a:t>
-            </a:r>
-          </a:p>
-          <a:p>
-            <a:pPr marL="285750" indent="-171450">
-              <a:buChar char="•"/>
-            </a:pPr>
-            <a:r>
-              <a:rPr lang="en-US" sz="2100">
-                <a:solidFill>
-                  <a:srgbClr val="D7E3EA"/>
-                </a:solidFill>
-              </a:rPr>
-              <a:t>Budget for oracle relayers, licensed data, maker incentives, infrastructure, key management, audits, legal work, and incident reserves.</a:t>
-            </a:r>
-          </a:p>
-        </p:txBody>
-      </p:sp>
+            <a:off x="609600" y="1630000"/>
+            <a:ext cx="4600000" cy="4400000"/>
+          </a:xfrm>
+          <a:prstGeom prst="rect">
+            <a:avLst/>
+          </a:prstGeom>
+          <a:noFill/>
+        </p:spPr>
+        <p:txBody>
+          <a:bodyPr wrap="square"/>
+          <a:lstStyle/>
+          <a:p>
+            <a:pPr marL="285750" indent="-171450">
+              <a:buChar char="•"/>
+            </a:pPr>
+            <a:r>
+              <a:rPr lang="en-US" sz="2100">
+                <a:solidFill>
+                  <a:srgbClr val="D7E3EA"/>
+                </a:solidFill>
+              </a:rPr>
+              <a:t>Wallet-aware flow: connect wallet, configure vault/token addresses, approve HYPE, deposit, and claim rewards.</a:t>
+            </a:r>
+          </a:p>
+          <a:p>
+            <a:pPr marL="285750" indent="-171450">
+              <a:buChar char="•"/>
+            </a:pPr>
+            <a:r>
+              <a:rPr lang="en-US" sz="2100">
+                <a:solidFill>
+                  <a:srgbClr val="D7E3EA"/>
+                </a:solidFill>
+              </a:rPr>
+              <a:t>The UI also shows which actions still require operator multisig and risk-council execution.</a:t>
+            </a:r>
+          </a:p>
+        </p:txBody>
+      </p:sp>
+      <p:pic>
+        <p:nvPicPr>
+          <p:cNvPr id="5" name="demo-contract-wiring.png"/>
+          <p:cNvPicPr/>
+          <p:nvPr/>
+        </p:nvPicPr>
+        <p:blipFill>
+          <a:blip r:embed="rId1"/>
+          <a:stretch>
+            <a:fillRect/>
+          </a:stretch>
+        </p:blipFill>
+        <p:spPr>
+          <a:xfrm>
+            <a:off x="5450000" y="1500000"/>
+            <a:ext cx="6130000" cy="3450000"/>
+          </a:xfrm>
+          <a:prstGeom prst="rect">
+            <a:avLst/>
+          </a:prstGeom>
+        </p:spPr>
+      </p:pic>
       <p:sp>
         <p:nvSpPr>
           <p:cNvPr id="4" name="Footer"/>
@@ -2189,7 +2190,7 @@
                   <a:srgbClr val="F4F7F8"/>
                 </a:solidFill>
               </a:rPr>
-              <a:t>MVP</a:t>
+              <a:t>Contract Depth</a:t>
             </a:r>
           </a:p>
         </p:txBody>
@@ -2223,72 +2224,33 @@
                   <a:srgbClr val="D7E3EA"/>
                 </a:solidFill>
               </a:rPr>
-              <a:t>One HIP.markets-operated DEX.</a:t>
-            </a:r>
-          </a:p>
-          <a:p>
-            <a:pPr marL="285750" indent="-171450">
-              <a:buChar char="•"/>
-            </a:pPr>
-            <a:r>
-              <a:rPr lang="en-US" sz="2100">
-                <a:solidFill>
-                  <a:srgbClr val="D7E3EA"/>
-                </a:solidFill>
-              </a:rPr>
-              <a:t>One HYPE vault.</a:t>
-            </a:r>
-          </a:p>
-          <a:p>
-            <a:pPr marL="285750" indent="-171450">
-              <a:buChar char="•"/>
-            </a:pPr>
-            <a:r>
-              <a:rPr lang="en-US" sz="2100">
-                <a:solidFill>
-                  <a:srgbClr val="D7E3EA"/>
-                </a:solidFill>
-              </a:rPr>
-              <a:t>First three markets.</a:t>
-            </a:r>
-          </a:p>
-          <a:p>
-            <a:pPr marL="285750" indent="-171450">
-              <a:buChar char="•"/>
-            </a:pPr>
-            <a:r>
-              <a:rPr lang="en-US" sz="2100">
-                <a:solidFill>
-                  <a:srgbClr val="D7E3EA"/>
-                </a:solidFill>
-              </a:rPr>
-              <a:t>Weekly distributions.</a:t>
-            </a:r>
-          </a:p>
-          <a:p>
-            <a:pPr marL="285750" indent="-171450">
-              <a:buChar char="•"/>
-            </a:pPr>
-            <a:r>
-              <a:rPr lang="en-US" sz="2100">
-                <a:solidFill>
-                  <a:srgbClr val="D7E3EA"/>
-                </a:solidFill>
-              </a:rPr>
-              <a:t>Public dashboard.</a:t>
-            </a:r>
-          </a:p>
-          <a:p>
-            <a:pPr marL="285750" indent="-171450">
-              <a:buChar char="•"/>
-            </a:pPr>
-            <a:r>
-              <a:rPr lang="en-US" sz="2100">
-                <a:solidFill>
-                  <a:srgbClr val="D7E3EA"/>
-                </a:solidFill>
-              </a:rPr>
-              <a:t>No third-party operator financing.</a:t>
+              <a:t>Vault now models vHIPM receipt shares, vault caps, withdrawal queues, reward accounting, and slash losses.</a:t>
+            </a:r>
+          </a:p>
+          <a:p>
+            <a:pPr marL="285750" indent="-171450">
+              <a:buChar char="•"/>
+            </a:pPr>
+            <a:r>
+              <a:rPr lang="en-US" sz="2100">
+                <a:solidFill>
+                  <a:srgbClr val="D7E3EA"/>
+                </a:solidFill>
+              </a:rPr>
+              <a:t>Operator lifecycle: funding, stake-ready, stake-escrowed, approved, live, wind-down, and slashed.</a:t>
+            </a:r>
+          </a:p>
+          <a:p>
+            <a:pPr marL="285750" indent="-171450">
+              <a:buChar char="•"/>
+            </a:pPr>
+            <a:r>
+              <a:rPr lang="en-US" sz="2100">
+                <a:solidFill>
+                  <a:srgbClr val="D7E3EA"/>
+                </a:solidFill>
+              </a:rPr>
+              <a:t>Registry tracks launch checklist, fee epochs, oracle health, market status, and risk state.</a:t>
             </a:r>
           </a:p>
         </p:txBody>
@@ -2382,7 +2344,7 @@
                   <a:srgbClr val="F4F7F8"/>
                 </a:solidFill>
               </a:rPr>
-              <a:t>Roadmap</a:t>
+              <a:t>System Flow</a:t>
             </a:r>
           </a:p>
         </p:txBody>
@@ -2416,33 +2378,59 @@
                   <a:srgbClr val="D7E3EA"/>
                 </a:solidFill>
               </a:rPr>
-              <a:t>V1: prove operator vault and fee sharing.</a:t>
-            </a:r>
-          </a:p>
-          <a:p>
-            <a:pPr marL="285750" indent="-171450">
-              <a:buChar char="•"/>
-            </a:pPr>
-            <a:r>
-              <a:rPr lang="en-US" sz="2100">
-                <a:solidFill>
-                  <a:srgbClr val="D7E3EA"/>
-                </a:solidFill>
-              </a:rPr>
-              <a:t>V2: more HIP.markets market vaults and automated fee verification.</a:t>
-            </a:r>
-          </a:p>
-          <a:p>
-            <a:pPr marL="285750" indent="-171450">
-              <a:buChar char="•"/>
-            </a:pPr>
-            <a:r>
-              <a:rPr lang="en-US" sz="2100">
-                <a:solidFill>
-                  <a:srgbClr val="D7E3EA"/>
-                </a:solidFill>
-              </a:rPr>
-              <a:t>V3: risk tranching, secondary shares, HIP-4, possible third-party financing once the trust model is mature.</a:t>
+              <a:t>1. HYPE holders deposit into the HyperEVM vault.</a:t>
+            </a:r>
+          </a:p>
+          <a:p>
+            <a:pPr marL="285750" indent="-171450">
+              <a:buChar char="•"/>
+            </a:pPr>
+            <a:r>
+              <a:rPr lang="en-US" sz="2100">
+                <a:solidFill>
+                  <a:srgbClr val="D7E3EA"/>
+                </a:solidFill>
+              </a:rPr>
+              <a:t>2. Vault backs HIP.markets deployer stake.</a:t>
+            </a:r>
+          </a:p>
+          <a:p>
+            <a:pPr marL="285750" indent="-171450">
+              <a:buChar char="•"/>
+            </a:pPr>
+            <a:r>
+              <a:rPr lang="en-US" sz="2100">
+                <a:solidFill>
+                  <a:srgbClr val="D7E3EA"/>
+                </a:solidFill>
+              </a:rPr>
+              <a:t>3. Operator multisig escrows funded HYPE to the deployer stake controller.</a:t>
+            </a:r>
+          </a:p>
+          <a:p>
+            <a:pPr marL="285750" indent="-171450">
+              <a:buChar char="•"/>
+            </a:pPr>
+            <a:r>
+              <a:rPr lang="en-US" sz="2100">
+                <a:solidFill>
+                  <a:srgbClr val="D7E3EA"/>
+                </a:solidFill>
+              </a:rPr>
+              <a:t>4. Risk council records HIP-3 operator approval.</a:t>
+            </a:r>
+          </a:p>
+          <a:p>
+            <a:pPr marL="285750" indent="-171450">
+              <a:buChar char="•"/>
+            </a:pPr>
+            <a:r>
+              <a:rPr lang="en-US" sz="2100">
+                <a:solidFill>
+                  <a:srgbClr val="D7E3EA"/>
+                </a:solidFill>
+              </a:rPr>
+              <a:t>5. HIP.markets launches markets, traders generate fees, and net rewards distribute after deductions.</a:t>
             </a:r>
           </a:p>
         </p:txBody>
@@ -2536,7 +2524,7 @@
                   <a:srgbClr val="F4F7F8"/>
                 </a:solidFill>
               </a:rPr>
-              <a:t>Competitive Position</a:t>
+              <a:t>Economics</a:t>
             </a:r>
           </a:p>
         </p:txBody>
@@ -2570,33 +2558,46 @@
                   <a:srgbClr val="D7E3EA"/>
                 </a:solidFill>
               </a:rPr>
-              <a:t>trade.xyz and HyENA operate markets directly.</a:t>
-            </a:r>
-          </a:p>
-          <a:p>
-            <a:pPr marL="285750" indent="-171450">
-              <a:buChar char="•"/>
-            </a:pPr>
-            <a:r>
-              <a:rPr lang="en-US" sz="2100">
-                <a:solidFill>
-                  <a:srgbClr val="D7E3EA"/>
-                </a:solidFill>
-              </a:rPr>
-              <a:t>HIP.markets also operates markets directly, but adds user-funded HYPE stake and transparent fee sharing.</a:t>
-            </a:r>
-          </a:p>
-          <a:p>
-            <a:pPr marL="285750" indent="-171450">
-              <a:buChar char="•"/>
-            </a:pPr>
-            <a:r>
-              <a:rPr lang="en-US" sz="2100">
-                <a:solidFill>
-                  <a:srgbClr val="D7E3EA"/>
-                </a:solidFill>
-              </a:rPr>
-              <a:t>The wedge is making HYPE holders economic backers of the operator.</a:t>
+              <a:t>Base model: 500k HYPE, $50M daily volume, 6 bps fee, 50% deployer share.</a:t>
+            </a:r>
+          </a:p>
+          <a:p>
+            <a:pPr marL="285750" indent="-171450">
+              <a:buChar char="•"/>
+            </a:pPr>
+            <a:r>
+              <a:rPr lang="en-US" sz="2100">
+                <a:solidFill>
+                  <a:srgbClr val="D7E3EA"/>
+                </a:solidFill>
+              </a:rPr>
+              <a:t>After 40% operating/protocol/reserve deductions: approximately 15% net APR.</a:t>
+            </a:r>
+          </a:p>
+          <a:p>
+            <a:pPr marL="285750" indent="-171450">
+              <a:buChar char="•"/>
+            </a:pPr>
+            <a:r>
+              <a:rPr lang="en-US" sz="2100">
+                <a:solidFill>
+                  <a:srgbClr val="D7E3EA"/>
+                </a:solidFill>
+              </a:rPr>
+              <a:t>Trade.xyz trailing fees imply approximately 3.47% gross APR on the minimum stake.</a:t>
+            </a:r>
+          </a:p>
+          <a:p>
+            <a:pPr marL="285750" indent="-171450">
+              <a:buChar char="•"/>
+            </a:pPr>
+            <a:r>
+              <a:rPr lang="en-US" sz="2100">
+                <a:solidFill>
+                  <a:srgbClr val="D7E3EA"/>
+                </a:solidFill>
+              </a:rPr>
+              <a:t>Sensitivity matters more than headline APR.</a:t>
             </a:r>
           </a:p>
         </p:txBody>
@@ -2690,7 +2691,7 @@
                   <a:srgbClr val="F4F7F8"/>
                 </a:solidFill>
               </a:rPr>
-              <a:t>Ask</a:t>
+              <a:t>Risk Controls</a:t>
             </a:r>
           </a:p>
         </p:txBody>
@@ -2724,59 +2725,33 @@
                   <a:srgbClr val="D7E3EA"/>
                 </a:solidFill>
               </a:rPr>
-              <a:t>HYPE holders for capped beta.</a:t>
-            </a:r>
-          </a:p>
-          <a:p>
-            <a:pPr marL="285750" indent="-171450">
-              <a:buChar char="•"/>
-            </a:pPr>
-            <a:r>
-              <a:rPr lang="en-US" sz="2100">
-                <a:solidFill>
-                  <a:srgbClr val="D7E3EA"/>
-                </a:solidFill>
-              </a:rPr>
-              <a:t>Market makers for first markets.</a:t>
-            </a:r>
-          </a:p>
-          <a:p>
-            <a:pPr marL="285750" indent="-171450">
-              <a:buChar char="•"/>
-            </a:pPr>
-            <a:r>
-              <a:rPr lang="en-US" sz="2100">
-                <a:solidFill>
-                  <a:srgbClr val="D7E3EA"/>
-                </a:solidFill>
-              </a:rPr>
-              <a:t>Oracle and data partners.</a:t>
-            </a:r>
-          </a:p>
-          <a:p>
-            <a:pPr marL="285750" indent="-171450">
-              <a:buChar char="•"/>
-            </a:pPr>
-            <a:r>
-              <a:rPr lang="en-US" sz="2100">
-                <a:solidFill>
-                  <a:srgbClr val="D7E3EA"/>
-                </a:solidFill>
-              </a:rPr>
-              <a:t>Security reviewers.</a:t>
-            </a:r>
-          </a:p>
-          <a:p>
-            <a:pPr marL="285750" indent="-171450">
-              <a:buChar char="•"/>
-            </a:pPr>
-            <a:r>
-              <a:rPr lang="en-US" sz="2100">
-                <a:solidFill>
-                  <a:srgbClr val="D7E3EA"/>
-                </a:solidFill>
-              </a:rPr>
-              <a:t>Hyperliquid feedback on custody and fee routing.</a:t>
+              <a:t>Start with oracle-simple markets.</a:t>
+            </a:r>
+          </a:p>
+          <a:p>
+            <a:pPr marL="285750" indent="-171450">
+              <a:buChar char="•"/>
+            </a:pPr>
+            <a:r>
+              <a:rPr lang="en-US" sz="2100">
+                <a:solidFill>
+                  <a:srgbClr val="D7E3EA"/>
+                </a:solidFill>
+              </a:rPr>
+              <a:t>Avoid extra ticker auction costs at launch.</a:t>
+            </a:r>
+          </a:p>
+          <a:p>
+            <a:pPr marL="285750" indent="-171450">
+              <a:buChar char="•"/>
+            </a:pPr>
+            <a:r>
+              <a:rPr lang="en-US" sz="2100">
+                <a:solidFill>
+                  <a:srgbClr val="D7E3EA"/>
+                </a:solidFill>
+              </a:rPr>
+              <a:t>Cap open interest, publish addresses, maintain reserve, pause deposits during incidents.</a:t>
             </a:r>
           </a:p>
         </p:txBody>
@@ -2870,7 +2845,7 @@
                   <a:srgbClr val="F4F7F8"/>
                 </a:solidFill>
               </a:rPr>
-              <a:t>Closing</a:t>
+              <a:t>Cost Stack</a:t>
             </a:r>
           </a:p>
         </p:txBody>
@@ -2904,20 +2879,20 @@
                   <a:srgbClr val="D7E3EA"/>
                 </a:solidFill>
               </a:rPr>
-              <a:t>HIP.markets turns builder-deployed markets into a community-backed operator business.</a:t>
-            </a:r>
-          </a:p>
-          <a:p>
-            <a:pPr marL="285750" indent="-171450">
-              <a:buChar char="•"/>
-            </a:pPr>
-            <a:r>
-              <a:rPr lang="en-US" sz="2100">
-                <a:solidFill>
-                  <a:srgbClr val="D7E3EA"/>
-                </a:solidFill>
-              </a:rPr>
-              <a:t>The first job is operating markets safely.</a:t>
+              <a:t>The 500k HYPE stake is the entry ticket, not the full cost of business.</a:t>
+            </a:r>
+          </a:p>
+          <a:p>
+            <a:pPr marL="285750" indent="-171450">
+              <a:buChar char="•"/>
+            </a:pPr>
+            <a:r>
+              <a:rPr lang="en-US" sz="2100">
+                <a:solidFill>
+                  <a:srgbClr val="D7E3EA"/>
+                </a:solidFill>
+              </a:rPr>
+              <a:t>Budget for oracle relayers, licensed data, maker incentives, infrastructure, key management, audits, legal work, and incident reserves.</a:t>
             </a:r>
           </a:p>
         </p:txBody>
@@ -2949,6 +2924,687 @@
                 </a:solidFill>
               </a:rPr>
               <a:t>HIP.markets hackathon submission  |  25</a:t>
+            </a:r>
+          </a:p>
+        </p:txBody>
+      </p:sp>
+    </p:spTree>
+  </p:cSld>
+  <p:clrMapOvr>
+    <a:masterClrMapping/>
+  </p:clrMapOvr>
+</p:sld>
+</file>
+
+<file path=ppt/slides/slide26.xml><?xml version="1.0" encoding="utf-8"?>
+<p:sld xmlns:a="http://schemas.openxmlformats.org/drawingml/2006/main" xmlns:r="http://schemas.openxmlformats.org/officeDocument/2006/relationships" xmlns:p="http://schemas.openxmlformats.org/presentationml/2006/main">
+  <p:cSld>
+    <p:bg>
+      <p:bgPr>
+        <a:solidFill>
+          <a:srgbClr val="080A0D"/>
+        </a:solidFill>
+      </p:bgPr>
+    </p:bg>
+    <p:spTree>
+      <p:nvGrpSpPr>
+        <p:cNvPr id="1" name=""/>
+        <p:cNvGrpSpPr/>
+        <p:nvPr/>
+      </p:nvGrpSpPr>
+      <p:grpSpPr>
+        <a:xfrm>
+          <a:off x="0" y="0"/>
+          <a:ext cx="0" cy="0"/>
+          <a:chOff x="0" y="0"/>
+          <a:chExt cx="0" cy="0"/>
+        </a:xfrm>
+      </p:grpSpPr>
+      <p:sp>
+        <p:nvSpPr>
+          <p:cNvPr id="2" name="Title"/>
+          <p:cNvSpPr txBox="1"/>
+          <p:nvPr/>
+        </p:nvSpPr>
+        <p:spPr>
+          <a:xfrm>
+            <a:off x="609600" y="610000"/>
+            <a:ext cx="10300000" cy="850000"/>
+          </a:xfrm>
+          <a:prstGeom prst="rect">
+            <a:avLst/>
+          </a:prstGeom>
+          <a:noFill/>
+        </p:spPr>
+        <p:txBody>
+          <a:bodyPr wrap="square"/>
+          <a:lstStyle/>
+          <a:p>
+            <a:r>
+              <a:rPr lang="en-US" sz="4100" b="1">
+                <a:solidFill>
+                  <a:srgbClr val="F4F7F8"/>
+                </a:solidFill>
+              </a:rPr>
+              <a:t>MVP</a:t>
+            </a:r>
+          </a:p>
+        </p:txBody>
+      </p:sp>
+      <p:sp>
+        <p:nvSpPr>
+          <p:cNvPr id="3" name="Body"/>
+          <p:cNvSpPr txBox="1"/>
+          <p:nvPr/>
+        </p:nvSpPr>
+        <p:spPr>
+          <a:xfrm>
+            <a:off x="914400" y="1905000"/>
+            <a:ext cx="9800000" cy="3900000"/>
+          </a:xfrm>
+          <a:prstGeom prst="rect">
+            <a:avLst/>
+          </a:prstGeom>
+          <a:noFill/>
+        </p:spPr>
+        <p:txBody>
+          <a:bodyPr wrap="square"/>
+          <a:lstStyle/>
+          <a:p>
+            <a:pPr marL="285750" indent="-171450">
+              <a:buChar char="•"/>
+            </a:pPr>
+            <a:r>
+              <a:rPr lang="en-US" sz="2100">
+                <a:solidFill>
+                  <a:srgbClr val="D7E3EA"/>
+                </a:solidFill>
+              </a:rPr>
+              <a:t>One HIP.markets-operated DEX.</a:t>
+            </a:r>
+          </a:p>
+          <a:p>
+            <a:pPr marL="285750" indent="-171450">
+              <a:buChar char="•"/>
+            </a:pPr>
+            <a:r>
+              <a:rPr lang="en-US" sz="2100">
+                <a:solidFill>
+                  <a:srgbClr val="D7E3EA"/>
+                </a:solidFill>
+              </a:rPr>
+              <a:t>One HYPE vault.</a:t>
+            </a:r>
+          </a:p>
+          <a:p>
+            <a:pPr marL="285750" indent="-171450">
+              <a:buChar char="•"/>
+            </a:pPr>
+            <a:r>
+              <a:rPr lang="en-US" sz="2100">
+                <a:solidFill>
+                  <a:srgbClr val="D7E3EA"/>
+                </a:solidFill>
+              </a:rPr>
+              <a:t>First three markets.</a:t>
+            </a:r>
+          </a:p>
+          <a:p>
+            <a:pPr marL="285750" indent="-171450">
+              <a:buChar char="•"/>
+            </a:pPr>
+            <a:r>
+              <a:rPr lang="en-US" sz="2100">
+                <a:solidFill>
+                  <a:srgbClr val="D7E3EA"/>
+                </a:solidFill>
+              </a:rPr>
+              <a:t>Weekly distributions.</a:t>
+            </a:r>
+          </a:p>
+          <a:p>
+            <a:pPr marL="285750" indent="-171450">
+              <a:buChar char="•"/>
+            </a:pPr>
+            <a:r>
+              <a:rPr lang="en-US" sz="2100">
+                <a:solidFill>
+                  <a:srgbClr val="D7E3EA"/>
+                </a:solidFill>
+              </a:rPr>
+              <a:t>Public dashboard.</a:t>
+            </a:r>
+          </a:p>
+          <a:p>
+            <a:pPr marL="285750" indent="-171450">
+              <a:buChar char="•"/>
+            </a:pPr>
+            <a:r>
+              <a:rPr lang="en-US" sz="2100">
+                <a:solidFill>
+                  <a:srgbClr val="D7E3EA"/>
+                </a:solidFill>
+              </a:rPr>
+              <a:t>No third-party operator financing.</a:t>
+            </a:r>
+          </a:p>
+        </p:txBody>
+      </p:sp>
+      <p:sp>
+        <p:nvSpPr>
+          <p:cNvPr id="4" name="Footer"/>
+          <p:cNvSpPr txBox="1"/>
+          <p:nvPr/>
+        </p:nvSpPr>
+        <p:spPr>
+          <a:xfrm>
+            <a:off x="609600" y="6400800"/>
+            <a:ext cx="10500000" cy="300000"/>
+          </a:xfrm>
+          <a:prstGeom prst="rect">
+            <a:avLst/>
+          </a:prstGeom>
+          <a:noFill/>
+        </p:spPr>
+        <p:txBody>
+          <a:bodyPr wrap="square"/>
+          <a:lstStyle/>
+          <a:p>
+            <a:r>
+              <a:rPr lang="en-US" sz="1000">
+                <a:solidFill>
+                  <a:srgbClr val="35D29A"/>
+                </a:solidFill>
+              </a:rPr>
+              <a:t>HIP.markets hackathon submission  |  26</a:t>
+            </a:r>
+          </a:p>
+        </p:txBody>
+      </p:sp>
+    </p:spTree>
+  </p:cSld>
+  <p:clrMapOvr>
+    <a:masterClrMapping/>
+  </p:clrMapOvr>
+</p:sld>
+</file>
+
+<file path=ppt/slides/slide27.xml><?xml version="1.0" encoding="utf-8"?>
+<p:sld xmlns:a="http://schemas.openxmlformats.org/drawingml/2006/main" xmlns:r="http://schemas.openxmlformats.org/officeDocument/2006/relationships" xmlns:p="http://schemas.openxmlformats.org/presentationml/2006/main">
+  <p:cSld>
+    <p:bg>
+      <p:bgPr>
+        <a:solidFill>
+          <a:srgbClr val="080A0D"/>
+        </a:solidFill>
+      </p:bgPr>
+    </p:bg>
+    <p:spTree>
+      <p:nvGrpSpPr>
+        <p:cNvPr id="1" name=""/>
+        <p:cNvGrpSpPr/>
+        <p:nvPr/>
+      </p:nvGrpSpPr>
+      <p:grpSpPr>
+        <a:xfrm>
+          <a:off x="0" y="0"/>
+          <a:ext cx="0" cy="0"/>
+          <a:chOff x="0" y="0"/>
+          <a:chExt cx="0" cy="0"/>
+        </a:xfrm>
+      </p:grpSpPr>
+      <p:sp>
+        <p:nvSpPr>
+          <p:cNvPr id="2" name="Title"/>
+          <p:cNvSpPr txBox="1"/>
+          <p:nvPr/>
+        </p:nvSpPr>
+        <p:spPr>
+          <a:xfrm>
+            <a:off x="609600" y="610000"/>
+            <a:ext cx="10300000" cy="850000"/>
+          </a:xfrm>
+          <a:prstGeom prst="rect">
+            <a:avLst/>
+          </a:prstGeom>
+          <a:noFill/>
+        </p:spPr>
+        <p:txBody>
+          <a:bodyPr wrap="square"/>
+          <a:lstStyle/>
+          <a:p>
+            <a:r>
+              <a:rPr lang="en-US" sz="4100" b="1">
+                <a:solidFill>
+                  <a:srgbClr val="F4F7F8"/>
+                </a:solidFill>
+              </a:rPr>
+              <a:t>Roadmap</a:t>
+            </a:r>
+          </a:p>
+        </p:txBody>
+      </p:sp>
+      <p:sp>
+        <p:nvSpPr>
+          <p:cNvPr id="3" name="Body"/>
+          <p:cNvSpPr txBox="1"/>
+          <p:nvPr/>
+        </p:nvSpPr>
+        <p:spPr>
+          <a:xfrm>
+            <a:off x="914400" y="1905000"/>
+            <a:ext cx="9800000" cy="3900000"/>
+          </a:xfrm>
+          <a:prstGeom prst="rect">
+            <a:avLst/>
+          </a:prstGeom>
+          <a:noFill/>
+        </p:spPr>
+        <p:txBody>
+          <a:bodyPr wrap="square"/>
+          <a:lstStyle/>
+          <a:p>
+            <a:pPr marL="285750" indent="-171450">
+              <a:buChar char="•"/>
+            </a:pPr>
+            <a:r>
+              <a:rPr lang="en-US" sz="2100">
+                <a:solidFill>
+                  <a:srgbClr val="D7E3EA"/>
+                </a:solidFill>
+              </a:rPr>
+              <a:t>V1: prove operator vault and fee sharing.</a:t>
+            </a:r>
+          </a:p>
+          <a:p>
+            <a:pPr marL="285750" indent="-171450">
+              <a:buChar char="•"/>
+            </a:pPr>
+            <a:r>
+              <a:rPr lang="en-US" sz="2100">
+                <a:solidFill>
+                  <a:srgbClr val="D7E3EA"/>
+                </a:solidFill>
+              </a:rPr>
+              <a:t>V2: more HIP.markets market vaults and automated fee verification.</a:t>
+            </a:r>
+          </a:p>
+          <a:p>
+            <a:pPr marL="285750" indent="-171450">
+              <a:buChar char="•"/>
+            </a:pPr>
+            <a:r>
+              <a:rPr lang="en-US" sz="2100">
+                <a:solidFill>
+                  <a:srgbClr val="D7E3EA"/>
+                </a:solidFill>
+              </a:rPr>
+              <a:t>V3: risk tranching, secondary shares, HIP-4, possible third-party financing once the trust model is mature.</a:t>
+            </a:r>
+          </a:p>
+        </p:txBody>
+      </p:sp>
+      <p:sp>
+        <p:nvSpPr>
+          <p:cNvPr id="4" name="Footer"/>
+          <p:cNvSpPr txBox="1"/>
+          <p:nvPr/>
+        </p:nvSpPr>
+        <p:spPr>
+          <a:xfrm>
+            <a:off x="609600" y="6400800"/>
+            <a:ext cx="10500000" cy="300000"/>
+          </a:xfrm>
+          <a:prstGeom prst="rect">
+            <a:avLst/>
+          </a:prstGeom>
+          <a:noFill/>
+        </p:spPr>
+        <p:txBody>
+          <a:bodyPr wrap="square"/>
+          <a:lstStyle/>
+          <a:p>
+            <a:r>
+              <a:rPr lang="en-US" sz="1000">
+                <a:solidFill>
+                  <a:srgbClr val="35D29A"/>
+                </a:solidFill>
+              </a:rPr>
+              <a:t>HIP.markets hackathon submission  |  27</a:t>
+            </a:r>
+          </a:p>
+        </p:txBody>
+      </p:sp>
+    </p:spTree>
+  </p:cSld>
+  <p:clrMapOvr>
+    <a:masterClrMapping/>
+  </p:clrMapOvr>
+</p:sld>
+</file>
+
+<file path=ppt/slides/slide28.xml><?xml version="1.0" encoding="utf-8"?>
+<p:sld xmlns:a="http://schemas.openxmlformats.org/drawingml/2006/main" xmlns:r="http://schemas.openxmlformats.org/officeDocument/2006/relationships" xmlns:p="http://schemas.openxmlformats.org/presentationml/2006/main">
+  <p:cSld>
+    <p:bg>
+      <p:bgPr>
+        <a:solidFill>
+          <a:srgbClr val="080A0D"/>
+        </a:solidFill>
+      </p:bgPr>
+    </p:bg>
+    <p:spTree>
+      <p:nvGrpSpPr>
+        <p:cNvPr id="1" name=""/>
+        <p:cNvGrpSpPr/>
+        <p:nvPr/>
+      </p:nvGrpSpPr>
+      <p:grpSpPr>
+        <a:xfrm>
+          <a:off x="0" y="0"/>
+          <a:ext cx="0" cy="0"/>
+          <a:chOff x="0" y="0"/>
+          <a:chExt cx="0" cy="0"/>
+        </a:xfrm>
+      </p:grpSpPr>
+      <p:sp>
+        <p:nvSpPr>
+          <p:cNvPr id="2" name="Title"/>
+          <p:cNvSpPr txBox="1"/>
+          <p:nvPr/>
+        </p:nvSpPr>
+        <p:spPr>
+          <a:xfrm>
+            <a:off x="609600" y="610000"/>
+            <a:ext cx="10300000" cy="850000"/>
+          </a:xfrm>
+          <a:prstGeom prst="rect">
+            <a:avLst/>
+          </a:prstGeom>
+          <a:noFill/>
+        </p:spPr>
+        <p:txBody>
+          <a:bodyPr wrap="square"/>
+          <a:lstStyle/>
+          <a:p>
+            <a:r>
+              <a:rPr lang="en-US" sz="4100" b="1">
+                <a:solidFill>
+                  <a:srgbClr val="F4F7F8"/>
+                </a:solidFill>
+              </a:rPr>
+              <a:t>Competitive Position</a:t>
+            </a:r>
+          </a:p>
+        </p:txBody>
+      </p:sp>
+      <p:sp>
+        <p:nvSpPr>
+          <p:cNvPr id="3" name="Body"/>
+          <p:cNvSpPr txBox="1"/>
+          <p:nvPr/>
+        </p:nvSpPr>
+        <p:spPr>
+          <a:xfrm>
+            <a:off x="914400" y="1905000"/>
+            <a:ext cx="9800000" cy="3900000"/>
+          </a:xfrm>
+          <a:prstGeom prst="rect">
+            <a:avLst/>
+          </a:prstGeom>
+          <a:noFill/>
+        </p:spPr>
+        <p:txBody>
+          <a:bodyPr wrap="square"/>
+          <a:lstStyle/>
+          <a:p>
+            <a:pPr marL="285750" indent="-171450">
+              <a:buChar char="•"/>
+            </a:pPr>
+            <a:r>
+              <a:rPr lang="en-US" sz="2100">
+                <a:solidFill>
+                  <a:srgbClr val="D7E3EA"/>
+                </a:solidFill>
+              </a:rPr>
+              <a:t>trade.xyz and HyENA operate markets directly.</a:t>
+            </a:r>
+          </a:p>
+          <a:p>
+            <a:pPr marL="285750" indent="-171450">
+              <a:buChar char="•"/>
+            </a:pPr>
+            <a:r>
+              <a:rPr lang="en-US" sz="2100">
+                <a:solidFill>
+                  <a:srgbClr val="D7E3EA"/>
+                </a:solidFill>
+              </a:rPr>
+              <a:t>HIP.markets also operates markets directly, but adds user-funded HYPE stake and transparent fee sharing.</a:t>
+            </a:r>
+          </a:p>
+          <a:p>
+            <a:pPr marL="285750" indent="-171450">
+              <a:buChar char="•"/>
+            </a:pPr>
+            <a:r>
+              <a:rPr lang="en-US" sz="2100">
+                <a:solidFill>
+                  <a:srgbClr val="D7E3EA"/>
+                </a:solidFill>
+              </a:rPr>
+              <a:t>The wedge is making HYPE holders economic backers of the operator.</a:t>
+            </a:r>
+          </a:p>
+        </p:txBody>
+      </p:sp>
+      <p:sp>
+        <p:nvSpPr>
+          <p:cNvPr id="4" name="Footer"/>
+          <p:cNvSpPr txBox="1"/>
+          <p:nvPr/>
+        </p:nvSpPr>
+        <p:spPr>
+          <a:xfrm>
+            <a:off x="609600" y="6400800"/>
+            <a:ext cx="10500000" cy="300000"/>
+          </a:xfrm>
+          <a:prstGeom prst="rect">
+            <a:avLst/>
+          </a:prstGeom>
+          <a:noFill/>
+        </p:spPr>
+        <p:txBody>
+          <a:bodyPr wrap="square"/>
+          <a:lstStyle/>
+          <a:p>
+            <a:r>
+              <a:rPr lang="en-US" sz="1000">
+                <a:solidFill>
+                  <a:srgbClr val="35D29A"/>
+                </a:solidFill>
+              </a:rPr>
+              <a:t>HIP.markets hackathon submission  |  28</a:t>
+            </a:r>
+          </a:p>
+        </p:txBody>
+      </p:sp>
+    </p:spTree>
+  </p:cSld>
+  <p:clrMapOvr>
+    <a:masterClrMapping/>
+  </p:clrMapOvr>
+</p:sld>
+</file>
+
+<file path=ppt/slides/slide29.xml><?xml version="1.0" encoding="utf-8"?>
+<p:sld xmlns:a="http://schemas.openxmlformats.org/drawingml/2006/main" xmlns:r="http://schemas.openxmlformats.org/officeDocument/2006/relationships" xmlns:p="http://schemas.openxmlformats.org/presentationml/2006/main">
+  <p:cSld>
+    <p:bg>
+      <p:bgPr>
+        <a:solidFill>
+          <a:srgbClr val="080A0D"/>
+        </a:solidFill>
+      </p:bgPr>
+    </p:bg>
+    <p:spTree>
+      <p:nvGrpSpPr>
+        <p:cNvPr id="1" name=""/>
+        <p:cNvGrpSpPr/>
+        <p:nvPr/>
+      </p:nvGrpSpPr>
+      <p:grpSpPr>
+        <a:xfrm>
+          <a:off x="0" y="0"/>
+          <a:ext cx="0" cy="0"/>
+          <a:chOff x="0" y="0"/>
+          <a:chExt cx="0" cy="0"/>
+        </a:xfrm>
+      </p:grpSpPr>
+      <p:sp>
+        <p:nvSpPr>
+          <p:cNvPr id="2" name="Title"/>
+          <p:cNvSpPr txBox="1"/>
+          <p:nvPr/>
+        </p:nvSpPr>
+        <p:spPr>
+          <a:xfrm>
+            <a:off x="609600" y="610000"/>
+            <a:ext cx="10300000" cy="850000"/>
+          </a:xfrm>
+          <a:prstGeom prst="rect">
+            <a:avLst/>
+          </a:prstGeom>
+          <a:noFill/>
+        </p:spPr>
+        <p:txBody>
+          <a:bodyPr wrap="square"/>
+          <a:lstStyle/>
+          <a:p>
+            <a:r>
+              <a:rPr lang="en-US" sz="4100" b="1">
+                <a:solidFill>
+                  <a:srgbClr val="F4F7F8"/>
+                </a:solidFill>
+              </a:rPr>
+              <a:t>Ask</a:t>
+            </a:r>
+          </a:p>
+        </p:txBody>
+      </p:sp>
+      <p:sp>
+        <p:nvSpPr>
+          <p:cNvPr id="3" name="Body"/>
+          <p:cNvSpPr txBox="1"/>
+          <p:nvPr/>
+        </p:nvSpPr>
+        <p:spPr>
+          <a:xfrm>
+            <a:off x="914400" y="1905000"/>
+            <a:ext cx="9800000" cy="3900000"/>
+          </a:xfrm>
+          <a:prstGeom prst="rect">
+            <a:avLst/>
+          </a:prstGeom>
+          <a:noFill/>
+        </p:spPr>
+        <p:txBody>
+          <a:bodyPr wrap="square"/>
+          <a:lstStyle/>
+          <a:p>
+            <a:pPr marL="285750" indent="-171450">
+              <a:buChar char="•"/>
+            </a:pPr>
+            <a:r>
+              <a:rPr lang="en-US" sz="2100">
+                <a:solidFill>
+                  <a:srgbClr val="D7E3EA"/>
+                </a:solidFill>
+              </a:rPr>
+              <a:t>HYPE holders for capped beta.</a:t>
+            </a:r>
+          </a:p>
+          <a:p>
+            <a:pPr marL="285750" indent="-171450">
+              <a:buChar char="•"/>
+            </a:pPr>
+            <a:r>
+              <a:rPr lang="en-US" sz="2100">
+                <a:solidFill>
+                  <a:srgbClr val="D7E3EA"/>
+                </a:solidFill>
+              </a:rPr>
+              <a:t>Market makers for first markets.</a:t>
+            </a:r>
+          </a:p>
+          <a:p>
+            <a:pPr marL="285750" indent="-171450">
+              <a:buChar char="•"/>
+            </a:pPr>
+            <a:r>
+              <a:rPr lang="en-US" sz="2100">
+                <a:solidFill>
+                  <a:srgbClr val="D7E3EA"/>
+                </a:solidFill>
+              </a:rPr>
+              <a:t>Oracle and data partners.</a:t>
+            </a:r>
+          </a:p>
+          <a:p>
+            <a:pPr marL="285750" indent="-171450">
+              <a:buChar char="•"/>
+            </a:pPr>
+            <a:r>
+              <a:rPr lang="en-US" sz="2100">
+                <a:solidFill>
+                  <a:srgbClr val="D7E3EA"/>
+                </a:solidFill>
+              </a:rPr>
+              <a:t>Security reviewers.</a:t>
+            </a:r>
+          </a:p>
+          <a:p>
+            <a:pPr marL="285750" indent="-171450">
+              <a:buChar char="•"/>
+            </a:pPr>
+            <a:r>
+              <a:rPr lang="en-US" sz="2100">
+                <a:solidFill>
+                  <a:srgbClr val="D7E3EA"/>
+                </a:solidFill>
+              </a:rPr>
+              <a:t>Hyperliquid feedback on custody and fee routing.</a:t>
+            </a:r>
+          </a:p>
+        </p:txBody>
+      </p:sp>
+      <p:sp>
+        <p:nvSpPr>
+          <p:cNvPr id="4" name="Footer"/>
+          <p:cNvSpPr txBox="1"/>
+          <p:nvPr/>
+        </p:nvSpPr>
+        <p:spPr>
+          <a:xfrm>
+            <a:off x="609600" y="6400800"/>
+            <a:ext cx="10500000" cy="300000"/>
+          </a:xfrm>
+          <a:prstGeom prst="rect">
+            <a:avLst/>
+          </a:prstGeom>
+          <a:noFill/>
+        </p:spPr>
+        <p:txBody>
+          <a:bodyPr wrap="square"/>
+          <a:lstStyle/>
+          <a:p>
+            <a:r>
+              <a:rPr lang="en-US" sz="1000">
+                <a:solidFill>
+                  <a:srgbClr val="35D29A"/>
+                </a:solidFill>
+              </a:rPr>
+              <a:t>HIP.markets hackathon submission  |  29</a:t>
             </a:r>
           </a:p>
         </p:txBody>
@@ -3011,7 +3667,183 @@
                   <a:srgbClr val="F4F7F8"/>
                 </a:solidFill>
               </a:rPr>
-              <a:t>The Problem</a:t>
+              <a:t>Hyperliquid Is Already Exchange-Scale</a:t>
+            </a:r>
+          </a:p>
+        </p:txBody>
+      </p:sp>
+      <p:sp>
+        <p:nvSpPr>
+          <p:cNvPr id="3" name="Body"/>
+          <p:cNvSpPr txBox="1"/>
+          <p:nvPr/>
+        </p:nvSpPr>
+        <p:spPr>
+          <a:xfrm>
+            <a:off x="609600" y="1630000"/>
+            <a:ext cx="4600000" cy="4400000"/>
+          </a:xfrm>
+          <a:prstGeom prst="rect">
+            <a:avLst/>
+          </a:prstGeom>
+          <a:noFill/>
+        </p:spPr>
+        <p:txBody>
+          <a:bodyPr wrap="square"/>
+          <a:lstStyle/>
+          <a:p>
+            <a:pPr marL="285750" indent="-171450">
+              <a:buChar char="•"/>
+            </a:pPr>
+            <a:r>
+              <a:rPr lang="en-US" sz="2100">
+                <a:solidFill>
+                  <a:srgbClr val="D7E3EA"/>
+                </a:solidFill>
+              </a:rPr>
+              <a:t>DefiLlama reference: $307.3B 30d perp volume, $15.6B 24h perp volume, and $13.3B open interest.</a:t>
+            </a:r>
+          </a:p>
+          <a:p>
+            <a:pPr marL="285750" indent="-171450">
+              <a:buChar char="•"/>
+            </a:pPr>
+            <a:r>
+              <a:rPr lang="en-US" sz="2100">
+                <a:solidFill>
+                  <a:srgbClr val="D7E3EA"/>
+                </a:solidFill>
+              </a:rPr>
+              <a:t>HIP-3 builders are plugging into proven exchange-scale flow, not an empty ecosystem.</a:t>
+            </a:r>
+          </a:p>
+          <a:p>
+            <a:pPr marL="285750" indent="-171450">
+              <a:buChar char="•"/>
+            </a:pPr>
+            <a:r>
+              <a:rPr lang="en-US" sz="2100">
+                <a:solidFill>
+                  <a:srgbClr val="D7E3EA"/>
+                </a:solidFill>
+              </a:rPr>
+              <a:t>The question is who can finance, operate, and risk-manage new markets.</a:t>
+            </a:r>
+          </a:p>
+        </p:txBody>
+      </p:sp>
+      <p:pic>
+        <p:nvPicPr>
+          <p:cNvPr id="5" name="market-context.png"/>
+          <p:cNvPicPr/>
+          <p:nvPr/>
+        </p:nvPicPr>
+        <p:blipFill>
+          <a:blip r:embed="rId1"/>
+          <a:stretch>
+            <a:fillRect/>
+          </a:stretch>
+        </p:blipFill>
+        <p:spPr>
+          <a:xfrm>
+            <a:off x="5450000" y="1500000"/>
+            <a:ext cx="6130000" cy="3450000"/>
+          </a:xfrm>
+          <a:prstGeom prst="rect">
+            <a:avLst/>
+          </a:prstGeom>
+        </p:spPr>
+      </p:pic>
+      <p:sp>
+        <p:nvSpPr>
+          <p:cNvPr id="4" name="Footer"/>
+          <p:cNvSpPr txBox="1"/>
+          <p:nvPr/>
+        </p:nvSpPr>
+        <p:spPr>
+          <a:xfrm>
+            <a:off x="609600" y="6400800"/>
+            <a:ext cx="10500000" cy="300000"/>
+          </a:xfrm>
+          <a:prstGeom prst="rect">
+            <a:avLst/>
+          </a:prstGeom>
+          <a:noFill/>
+        </p:spPr>
+        <p:txBody>
+          <a:bodyPr wrap="square"/>
+          <a:lstStyle/>
+          <a:p>
+            <a:r>
+              <a:rPr lang="en-US" sz="1000">
+                <a:solidFill>
+                  <a:srgbClr val="35D29A"/>
+                </a:solidFill>
+              </a:rPr>
+              <a:t>HIP.markets hackathon submission  |  03</a:t>
+            </a:r>
+          </a:p>
+        </p:txBody>
+      </p:sp>
+    </p:spTree>
+  </p:cSld>
+  <p:clrMapOvr>
+    <a:masterClrMapping/>
+  </p:clrMapOvr>
+</p:sld>
+</file>
+
+<file path=ppt/slides/slide30.xml><?xml version="1.0" encoding="utf-8"?>
+<p:sld xmlns:a="http://schemas.openxmlformats.org/drawingml/2006/main" xmlns:r="http://schemas.openxmlformats.org/officeDocument/2006/relationships" xmlns:p="http://schemas.openxmlformats.org/presentationml/2006/main">
+  <p:cSld>
+    <p:bg>
+      <p:bgPr>
+        <a:solidFill>
+          <a:srgbClr val="080A0D"/>
+        </a:solidFill>
+      </p:bgPr>
+    </p:bg>
+    <p:spTree>
+      <p:nvGrpSpPr>
+        <p:cNvPr id="1" name=""/>
+        <p:cNvGrpSpPr/>
+        <p:nvPr/>
+      </p:nvGrpSpPr>
+      <p:grpSpPr>
+        <a:xfrm>
+          <a:off x="0" y="0"/>
+          <a:ext cx="0" cy="0"/>
+          <a:chOff x="0" y="0"/>
+          <a:chExt cx="0" cy="0"/>
+        </a:xfrm>
+      </p:grpSpPr>
+      <p:sp>
+        <p:nvSpPr>
+          <p:cNvPr id="2" name="Title"/>
+          <p:cNvSpPr txBox="1"/>
+          <p:nvPr/>
+        </p:nvSpPr>
+        <p:spPr>
+          <a:xfrm>
+            <a:off x="609600" y="610000"/>
+            <a:ext cx="10300000" cy="850000"/>
+          </a:xfrm>
+          <a:prstGeom prst="rect">
+            <a:avLst/>
+          </a:prstGeom>
+          <a:noFill/>
+        </p:spPr>
+        <p:txBody>
+          <a:bodyPr wrap="square"/>
+          <a:lstStyle/>
+          <a:p>
+            <a:r>
+              <a:rPr lang="en-US" sz="4100" b="1">
+                <a:solidFill>
+                  <a:srgbClr val="F4F7F8"/>
+                </a:solidFill>
+              </a:rPr>
+              <a:t>Closing</a:t>
             </a:r>
           </a:p>
         </p:txBody>
@@ -3045,33 +3877,20 @@
                   <a:srgbClr val="D7E3EA"/>
                 </a:solidFill>
               </a:rPr>
-              <a:t>HIP-3 DEXs need 500,000 HYPE staked.</a:t>
-            </a:r>
-          </a:p>
-          <a:p>
-            <a:pPr marL="285750" indent="-171450">
-              <a:buChar char="•"/>
-            </a:pPr>
-            <a:r>
-              <a:rPr lang="en-US" sz="2100">
-                <a:solidFill>
-                  <a:srgbClr val="D7E3EA"/>
-                </a:solidFill>
-              </a:rPr>
-              <a:t>Stake is only the start: operators also need oracles, liquidity, risk controls, and fee accounting.</a:t>
-            </a:r>
-          </a:p>
-          <a:p>
-            <a:pPr marL="285750" indent="-171450">
-              <a:buChar char="•"/>
-            </a:pPr>
-            <a:r>
-              <a:rPr lang="en-US" sz="2100">
-                <a:solidFill>
-                  <a:srgbClr val="D7E3EA"/>
-                </a:solidFill>
-              </a:rPr>
-              <a:t>Stakers need slashing risk beside APR.</a:t>
+              <a:t>HIP.markets turns builder-deployed markets into a community-backed operator business.</a:t>
+            </a:r>
+          </a:p>
+          <a:p>
+            <a:pPr marL="285750" indent="-171450">
+              <a:buChar char="•"/>
+            </a:pPr>
+            <a:r>
+              <a:rPr lang="en-US" sz="2100">
+                <a:solidFill>
+                  <a:srgbClr val="D7E3EA"/>
+                </a:solidFill>
+              </a:rPr>
+              <a:t>The first job is operating markets safely.</a:t>
             </a:r>
           </a:p>
         </p:txBody>
@@ -3102,7 +3921,7 @@
                   <a:srgbClr val="35D29A"/>
                 </a:solidFill>
               </a:rPr>
-              <a:t>HIP.markets hackathon submission  |  03</a:t>
+              <a:t>HIP.markets hackathon submission  |  30</a:t>
             </a:r>
           </a:p>
         </p:txBody>
@@ -3165,7 +3984,7 @@
                   <a:srgbClr val="F4F7F8"/>
                 </a:solidFill>
               </a:rPr>
-              <a:t>Product Thesis</a:t>
+              <a:t>The 500k HYPE Blocker</a:t>
             </a:r>
           </a:p>
         </p:txBody>
@@ -3199,33 +4018,33 @@
                   <a:srgbClr val="D7E3EA"/>
                 </a:solidFill>
               </a:rPr>
-              <a:t>HIP.markets is not passive liquid staking.</a:t>
-            </a:r>
-          </a:p>
-          <a:p>
-            <a:pPr marL="285750" indent="-171450">
-              <a:buChar char="•"/>
-            </a:pPr>
-            <a:r>
-              <a:rPr lang="en-US" sz="2100">
-                <a:solidFill>
-                  <a:srgbClr val="D7E3EA"/>
-                </a:solidFill>
-              </a:rPr>
-              <a:t>HIP.markets is the operator.</a:t>
-            </a:r>
-          </a:p>
-          <a:p>
-            <a:pPr marL="285750" indent="-171450">
-              <a:buChar char="•"/>
-            </a:pPr>
-            <a:r>
-              <a:rPr lang="en-US" sz="2100">
-                <a:solidFill>
-                  <a:srgbClr val="D7E3EA"/>
-                </a:solidFill>
-              </a:rPr>
-              <a:t>Users back the HIP.markets deployer stake and share net deployer fees.</a:t>
+              <a:t>HIP-3 mainnet requires 500,000 HYPE staked per perp DEX.</a:t>
+            </a:r>
+          </a:p>
+          <a:p>
+            <a:pPr marL="285750" indent="-171450">
+              <a:buChar char="•"/>
+            </a:pPr>
+            <a:r>
+              <a:rPr lang="en-US" sz="2100">
+                <a:solidFill>
+                  <a:srgbClr val="D7E3EA"/>
+                </a:solidFill>
+              </a:rPr>
+              <a:t>At $42.7015 HYPE, that is roughly $21.35M before oracle, maker, data, legal, audit, and incident costs.</a:t>
+            </a:r>
+          </a:p>
+          <a:p>
+            <a:pPr marL="285750" indent="-171450">
+              <a:buChar char="•"/>
+            </a:pPr>
+            <a:r>
+              <a:rPr lang="en-US" sz="2100">
+                <a:solidFill>
+                  <a:srgbClr val="D7E3EA"/>
+                </a:solidFill>
+              </a:rPr>
+              <a:t>HIP.markets turns that blocker into a community-backed operator stake.</a:t>
             </a:r>
           </a:p>
         </p:txBody>
@@ -3319,7 +4138,7 @@
                   <a:srgbClr val="F4F7F8"/>
                 </a:solidFill>
               </a:rPr>
-              <a:t>Why Now</a:t>
+              <a:t>Why HYPE Holders Care</a:t>
             </a:r>
           </a:p>
         </p:txBody>
@@ -3353,33 +4172,33 @@
                   <a:srgbClr val="D7E3EA"/>
                 </a:solidFill>
               </a:rPr>
-              <a:t>Hyperliquid has moved from one exchange into market infrastructure.</a:t>
-            </a:r>
-          </a:p>
-          <a:p>
-            <a:pPr marL="285750" indent="-171450">
-              <a:buChar char="•"/>
-            </a:pPr>
-            <a:r>
-              <a:rPr lang="en-US" sz="2100">
-                <a:solidFill>
-                  <a:srgbClr val="D7E3EA"/>
-                </a:solidFill>
-              </a:rPr>
-              <a:t>HIP-3 lets specialist operators list new perpetual markets while HyperCore provides execution rails.</a:t>
-            </a:r>
-          </a:p>
-          <a:p>
-            <a:pPr marL="285750" indent="-171450">
-              <a:buChar char="•"/>
-            </a:pPr>
-            <a:r>
-              <a:rPr lang="en-US" sz="2100">
-                <a:solidFill>
-                  <a:srgbClr val="D7E3EA"/>
-                </a:solidFill>
-              </a:rPr>
-              <a:t>The bottleneck shifts to capital, oracle operations, and operator credibility.</a:t>
+              <a:t>Current HYPE staking references are around 2.37% APY.</a:t>
+            </a:r>
+          </a:p>
+          <a:p>
+            <a:pPr marL="285750" indent="-171450">
+              <a:buChar char="•"/>
+            </a:pPr>
+            <a:r>
+              <a:rPr lang="en-US" sz="2100">
+                <a:solidFill>
+                  <a:srgbClr val="D7E3EA"/>
+                </a:solidFill>
+              </a:rPr>
+              <a:t>HIP.markets offers higher-risk exposure to net deployer fees from markets that stakers help enable.</a:t>
+            </a:r>
+          </a:p>
+          <a:p>
+            <a:pPr marL="285750" indent="-171450">
+              <a:buChar char="•"/>
+            </a:pPr>
+            <a:r>
+              <a:rPr lang="en-US" sz="2100">
+                <a:solidFill>
+                  <a:srgbClr val="D7E3EA"/>
+                </a:solidFill>
+              </a:rPr>
+              <a:t>This is exchange-operator underwriting, not passive liquid staking.</a:t>
             </a:r>
           </a:p>
         </p:txBody>
@@ -3473,7 +4292,7 @@
                   <a:srgbClr val="F4F7F8"/>
                 </a:solidFill>
               </a:rPr>
-              <a:t>Trade.xyz Reference</a:t>
+              <a:t>Operator Fees Should Not Be Invisible</a:t>
             </a:r>
           </a:p>
         </p:txBody>
@@ -3486,80 +4305,58 @@
         </p:nvSpPr>
         <p:spPr>
           <a:xfrm>
-            <a:off x="609600" y="1630000"/>
-            <a:ext cx="4600000" cy="4400000"/>
-          </a:xfrm>
-          <a:prstGeom prst="rect">
-            <a:avLst/>
-          </a:prstGeom>
-          <a:noFill/>
-        </p:spPr>
-        <p:txBody>
-          <a:bodyPr wrap="square"/>
-          <a:lstStyle/>
-          <a:p>
-            <a:pPr marL="285750" indent="-171450">
-              <a:buChar char="•"/>
-            </a:pPr>
-            <a:r>
-              <a:rPr lang="en-US" sz="2100">
-                <a:solidFill>
-                  <a:srgbClr val="D7E3EA"/>
-                </a:solidFill>
-              </a:rPr>
-              <a:t>60 markets, $2.50B 30-day volume, and $121.98K total 30-day fees.</a:t>
-            </a:r>
-          </a:p>
-          <a:p>
-            <a:pPr marL="285750" indent="-171450">
-              <a:buChar char="•"/>
-            </a:pPr>
-            <a:r>
-              <a:rPr lang="en-US" sz="2100">
-                <a:solidFill>
-                  <a:srgbClr val="D7E3EA"/>
-                </a:solidFill>
-              </a:rPr>
-              <a:t>Estimated deployer revenue: $60.99K over 30 days before operating costs.</a:t>
-            </a:r>
-          </a:p>
-          <a:p>
-            <a:pPr marL="285750" indent="-171450">
-              <a:buChar char="•"/>
-            </a:pPr>
-            <a:r>
-              <a:rPr lang="en-US" sz="2100">
-                <a:solidFill>
-                  <a:srgbClr val="D7E3EA"/>
-                </a:solidFill>
-              </a:rPr>
-              <a:t>Gross implied APR: 3.47% on the 500k HYPE minimum stake at $42.8085 HYPE.</a:t>
-            </a:r>
-          </a:p>
-        </p:txBody>
-      </p:sp>
-      <p:pic>
-        <p:nvPicPr>
-          <p:cNvPr id="5" name="tradexyz-reference.png"/>
-          <p:cNvPicPr/>
-          <p:nvPr/>
-        </p:nvPicPr>
-        <p:blipFill>
-          <a:blip r:embed="rId1"/>
-          <a:stretch>
-            <a:fillRect/>
-          </a:stretch>
-        </p:blipFill>
-        <p:spPr>
-          <a:xfrm>
-            <a:off x="5450000" y="1500000"/>
-            <a:ext cx="6130000" cy="3450000"/>
-          </a:xfrm>
-          <a:prstGeom prst="rect">
-            <a:avLst/>
-          </a:prstGeom>
-        </p:spPr>
-      </p:pic>
+            <a:off x="914400" y="1905000"/>
+            <a:ext cx="9800000" cy="3900000"/>
+          </a:xfrm>
+          <a:prstGeom prst="rect">
+            <a:avLst/>
+          </a:prstGeom>
+          <a:noFill/>
+        </p:spPr>
+        <p:txBody>
+          <a:bodyPr wrap="square"/>
+          <a:lstStyle/>
+          <a:p>
+            <a:pPr marL="285750" indent="-171450">
+              <a:buChar char="•"/>
+            </a:pPr>
+            <a:r>
+              <a:rPr lang="en-US" sz="2100">
+                <a:solidFill>
+                  <a:srgbClr val="D7E3EA"/>
+                </a:solidFill>
+              </a:rPr>
+              <a:t>Trade.xyz proves HIP-3 can attract real demand.</a:t>
+            </a:r>
+          </a:p>
+          <a:p>
+            <a:pPr marL="285750" indent="-171450">
+              <a:buChar char="•"/>
+            </a:pPr>
+            <a:r>
+              <a:rPr lang="en-US" sz="2100">
+                <a:solidFill>
+                  <a:srgbClr val="D7E3EA"/>
+                </a:solidFill>
+              </a:rPr>
+              <a:t>Under the standard operator model, deployer fees accrue to the operator fee recipient.</a:t>
+            </a:r>
+          </a:p>
+          <a:p>
+            <a:pPr marL="285750" indent="-171450">
+              <a:buChar char="•"/>
+            </a:pPr>
+            <a:r>
+              <a:rPr lang="en-US" sz="2100">
+                <a:solidFill>
+                  <a:srgbClr val="D7E3EA"/>
+                </a:solidFill>
+              </a:rPr>
+              <a:t>HIP.markets changes the design: community HYPE funds the stake, HIP.markets operates the DEX, and net deployer fees can flow back to stakers.</a:t>
+            </a:r>
+          </a:p>
+        </p:txBody>
+      </p:sp>
       <p:sp>
         <p:nvSpPr>
           <p:cNvPr id="4" name="Footer"/>
@@ -3649,7 +4446,7 @@
                   <a:srgbClr val="F4F7F8"/>
                 </a:solidFill>
               </a:rPr>
-              <a:t>Successful Market Pattern</a:t>
+              <a:t>Jeff Yan-Inspired Product Bar</a:t>
             </a:r>
           </a:p>
         </p:txBody>
@@ -3683,46 +4480,33 @@
                   <a:srgbClr val="D7E3EA"/>
                 </a:solidFill>
               </a:rPr>
-              <a:t>Trade.xyz's highest-volume tickers are not only crypto assets.</a:t>
-            </a:r>
-          </a:p>
-          <a:p>
-            <a:pPr marL="285750" indent="-171450">
-              <a:buChar char="•"/>
-            </a:pPr>
-            <a:r>
-              <a:rPr lang="en-US" sz="2100">
-                <a:solidFill>
-                  <a:srgbClr val="D7E3EA"/>
-                </a:solidFill>
-              </a:rPr>
-              <a:t>XYZ100 and SP500: roughly $444M each over 30 days.</a:t>
-            </a:r>
-          </a:p>
-          <a:p>
-            <a:pPr marL="285750" indent="-171450">
-              <a:buChar char="•"/>
-            </a:pPr>
-            <a:r>
-              <a:rPr lang="en-US" sz="2100">
-                <a:solidFill>
-                  <a:srgbClr val="D7E3EA"/>
-                </a:solidFill>
-              </a:rPr>
-              <a:t>SILVER, CL, SNDK, MU, NVDA, BRENTOIL, CBRS, INTC, and GOLD show RWA-style breadth.</a:t>
-            </a:r>
-          </a:p>
-          <a:p>
-            <a:pPr marL="285750" indent="-171450">
-              <a:buChar char="•"/>
-            </a:pPr>
-            <a:r>
-              <a:rPr lang="en-US" sz="2100">
-                <a:solidFill>
-                  <a:srgbClr val="D7E3EA"/>
-                </a:solidFill>
-              </a:rPr>
-              <a:t>HIP.markets should launch where oracle confidence, liquidity, and narrative demand overlap.</a:t>
+              <a:t>Do not look like a yield wrapper; look like an underwriting and operator business.</a:t>
+            </a:r>
+          </a:p>
+          <a:p>
+            <a:pPr marL="285750" indent="-171450">
+              <a:buChar char="•"/>
+            </a:pPr>
+            <a:r>
+              <a:rPr lang="en-US" sz="2100">
+                <a:solidFill>
+                  <a:srgbClr val="D7E3EA"/>
+                </a:solidFill>
+              </a:rPr>
+              <a:t>Treat 500k HYPE as a quality filter, not a loophole.</a:t>
+            </a:r>
+          </a:p>
+          <a:p>
+            <a:pPr marL="285750" indent="-171450">
+              <a:buChar char="•"/>
+            </a:pPr>
+            <a:r>
+              <a:rPr lang="en-US" sz="2100">
+                <a:solidFill>
+                  <a:srgbClr val="D7E3EA"/>
+                </a:solidFill>
+              </a:rPr>
+              <a:t>Reliability beats launch count: fewer markets, better oracles, clearer fee accounting.</a:t>
             </a:r>
           </a:p>
         </p:txBody>
@@ -3816,7 +4600,7 @@
                   <a:srgbClr val="F4F7F8"/>
                 </a:solidFill>
               </a:rPr>
-              <a:t>Revenue Interpretation</a:t>
+              <a:t>The Problem</a:t>
             </a:r>
           </a:p>
         </p:txBody>
@@ -3850,33 +4634,33 @@
                   <a:srgbClr val="D7E3EA"/>
                 </a:solidFill>
               </a:rPr>
-              <a:t>HIP-3 deployer share is fixed at 50% from the deployer perspective.</a:t>
-            </a:r>
-          </a:p>
-          <a:p>
-            <a:pPr marL="285750" indent="-171450">
-              <a:buChar char="•"/>
-            </a:pPr>
-            <a:r>
-              <a:rPr lang="en-US" sz="2100">
-                <a:solidFill>
-                  <a:srgbClr val="D7E3EA"/>
-                </a:solidFill>
-              </a:rPr>
-              <a:t>Trade.xyz reports deployerFeeScale = 1.0.</a:t>
-            </a:r>
-          </a:p>
-          <a:p>
-            <a:pPr marL="285750" indent="-171450">
-              <a:buChar char="•"/>
-            </a:pPr>
-            <a:r>
-              <a:rPr lang="en-US" sz="2100">
-                <a:solidFill>
-                  <a:srgbClr val="D7E3EA"/>
-                </a:solidFill>
-              </a:rPr>
-              <a:t>Gross revenue is not distributable profit until oracle, data, maker, legal, reserve, and incident costs are deducted.</a:t>
+              <a:t>HIP-3 DEXs need 500,000 HYPE staked.</a:t>
+            </a:r>
+          </a:p>
+          <a:p>
+            <a:pPr marL="285750" indent="-171450">
+              <a:buChar char="•"/>
+            </a:pPr>
+            <a:r>
+              <a:rPr lang="en-US" sz="2100">
+                <a:solidFill>
+                  <a:srgbClr val="D7E3EA"/>
+                </a:solidFill>
+              </a:rPr>
+              <a:t>Stake is only the start: operators also need oracles, liquidity, risk controls, and fee accounting.</a:t>
+            </a:r>
+          </a:p>
+          <a:p>
+            <a:pPr marL="285750" indent="-171450">
+              <a:buChar char="•"/>
+            </a:pPr>
+            <a:r>
+              <a:rPr lang="en-US" sz="2100">
+                <a:solidFill>
+                  <a:srgbClr val="D7E3EA"/>
+                </a:solidFill>
+              </a:rPr>
+              <a:t>Stakers need slashing risk beside APR.</a:t>
             </a:r>
           </a:p>
         </p:txBody>
@@ -3970,7 +4754,7 @@
                   <a:srgbClr val="F4F7F8"/>
                 </a:solidFill>
               </a:rPr>
-              <a:t>UI Benchmark</a:t>
+              <a:t>Product Thesis</a:t>
             </a:r>
           </a:p>
         </p:txBody>
@@ -4004,20 +4788,33 @@
                   <a:srgbClr val="D7E3EA"/>
                 </a:solidFill>
               </a:rPr>
-              <a:t>trade.xyz proves serious HIP-3 markets need trading-terminal density.</a:t>
-            </a:r>
-          </a:p>
-          <a:p>
-            <a:pPr marL="285750" indent="-171450">
-              <a:buChar char="•"/>
-            </a:pPr>
-            <a:r>
-              <a:rPr lang="en-US" sz="2100">
-                <a:solidFill>
-                  <a:srgbClr val="D7E3EA"/>
-                </a:solidFill>
-              </a:rPr>
-              <a:t>Useful patterns: market rail, order ticket, positions tabs, account modes, Ghost Mode observability, explicit warnings.</a:t>
+              <a:t>HIP.markets is not passive liquid staking.</a:t>
+            </a:r>
+          </a:p>
+          <a:p>
+            <a:pPr marL="285750" indent="-171450">
+              <a:buChar char="•"/>
+            </a:pPr>
+            <a:r>
+              <a:rPr lang="en-US" sz="2100">
+                <a:solidFill>
+                  <a:srgbClr val="D7E3EA"/>
+                </a:solidFill>
+              </a:rPr>
+              <a:t>HIP.markets is the operator.</a:t>
+            </a:r>
+          </a:p>
+          <a:p>
+            <a:pPr marL="285750" indent="-171450">
+              <a:buChar char="•"/>
+            </a:pPr>
+            <a:r>
+              <a:rPr lang="en-US" sz="2100">
+                <a:solidFill>
+                  <a:srgbClr val="D7E3EA"/>
+                </a:solidFill>
+              </a:rPr>
+              <a:t>Users back the HIP.markets deployer stake and share net deployer fees.</a:t>
             </a:r>
           </a:p>
         </p:txBody>

</xml_diff>

<commit_message>
Execute investor action plan phase zero
</commit_message>
<xml_diff>
--- a/presentation/HIP_MARKETS_DECK.pptx
+++ b/presentation/HIP_MARKETS_DECK.pptx
@@ -35,6 +35,7 @@
     <p:sldId id="283" r:id="rId30"/>
     <p:sldId id="284" r:id="rId31"/>
     <p:sldId id="285" r:id="rId32"/>
+    <p:sldId id="286" r:id="rId33"/>
   </p:sldIdLst>
   <p:sldSz cx="12192000" cy="6858000" type="wide"/>
   <p:notesSz cx="6858000" cy="9144000"/>
@@ -284,7 +285,7 @@
                   <a:srgbClr val="F4F7F8"/>
                 </a:solidFill>
               </a:rPr>
-              <a:t>Why Now</a:t>
+              <a:t>Product Thesis</a:t>
             </a:r>
           </a:p>
         </p:txBody>
@@ -318,33 +319,33 @@
                   <a:srgbClr val="D7E3EA"/>
                 </a:solidFill>
               </a:rPr>
-              <a:t>Hyperliquid has moved from one exchange into market infrastructure.</a:t>
-            </a:r>
-          </a:p>
-          <a:p>
-            <a:pPr marL="285750" indent="-171450">
-              <a:buChar char="•"/>
-            </a:pPr>
-            <a:r>
-              <a:rPr lang="en-US" sz="2100">
-                <a:solidFill>
-                  <a:srgbClr val="D7E3EA"/>
-                </a:solidFill>
-              </a:rPr>
-              <a:t>HIP-3 lets specialist operators list new perpetual markets while HyperCore provides execution rails.</a:t>
-            </a:r>
-          </a:p>
-          <a:p>
-            <a:pPr marL="285750" indent="-171450">
-              <a:buChar char="•"/>
-            </a:pPr>
-            <a:r>
-              <a:rPr lang="en-US" sz="2100">
-                <a:solidFill>
-                  <a:srgbClr val="D7E3EA"/>
-                </a:solidFill>
-              </a:rPr>
-              <a:t>The bottleneck shifts to capital, oracle operations, and operator credibility.</a:t>
+              <a:t>HIP.markets is not passive liquid staking.</a:t>
+            </a:r>
+          </a:p>
+          <a:p>
+            <a:pPr marL="285750" indent="-171450">
+              <a:buChar char="•"/>
+            </a:pPr>
+            <a:r>
+              <a:rPr lang="en-US" sz="2100">
+                <a:solidFill>
+                  <a:srgbClr val="D7E3EA"/>
+                </a:solidFill>
+              </a:rPr>
+              <a:t>HIP.markets is the operator.</a:t>
+            </a:r>
+          </a:p>
+          <a:p>
+            <a:pPr marL="285750" indent="-171450">
+              <a:buChar char="•"/>
+            </a:pPr>
+            <a:r>
+              <a:rPr lang="en-US" sz="2100">
+                <a:solidFill>
+                  <a:srgbClr val="D7E3EA"/>
+                </a:solidFill>
+              </a:rPr>
+              <a:t>Users back the HIP.markets deployer stake and share net deployer fees.</a:t>
             </a:r>
           </a:p>
         </p:txBody>
@@ -438,7 +439,7 @@
                   <a:srgbClr val="F4F7F8"/>
                 </a:solidFill>
               </a:rPr>
-              <a:t>Trade.xyz Reference</a:t>
+              <a:t>Why Now</a:t>
             </a:r>
           </a:p>
         </p:txBody>
@@ -451,80 +452,58 @@
         </p:nvSpPr>
         <p:spPr>
           <a:xfrm>
-            <a:off x="609600" y="1630000"/>
-            <a:ext cx="4600000" cy="4400000"/>
-          </a:xfrm>
-          <a:prstGeom prst="rect">
-            <a:avLst/>
-          </a:prstGeom>
-          <a:noFill/>
-        </p:spPr>
-        <p:txBody>
-          <a:bodyPr wrap="square"/>
-          <a:lstStyle/>
-          <a:p>
-            <a:pPr marL="285750" indent="-171450">
-              <a:buChar char="•"/>
-            </a:pPr>
-            <a:r>
-              <a:rPr lang="en-US" sz="2100">
-                <a:solidFill>
-                  <a:srgbClr val="D7E3EA"/>
-                </a:solidFill>
-              </a:rPr>
-              <a:t>60 markets, $2.50B 30-day volume, and $121.98K total 30-day fees.</a:t>
-            </a:r>
-          </a:p>
-          <a:p>
-            <a:pPr marL="285750" indent="-171450">
-              <a:buChar char="•"/>
-            </a:pPr>
-            <a:r>
-              <a:rPr lang="en-US" sz="2100">
-                <a:solidFill>
-                  <a:srgbClr val="D7E3EA"/>
-                </a:solidFill>
-              </a:rPr>
-              <a:t>Estimated deployer revenue: $60.99K over 30 days before operating costs.</a:t>
-            </a:r>
-          </a:p>
-          <a:p>
-            <a:pPr marL="285750" indent="-171450">
-              <a:buChar char="•"/>
-            </a:pPr>
-            <a:r>
-              <a:rPr lang="en-US" sz="2100">
-                <a:solidFill>
-                  <a:srgbClr val="D7E3EA"/>
-                </a:solidFill>
-              </a:rPr>
-              <a:t>Gross implied APR: 3.47% on the 500k HYPE minimum stake at $42.8085 HYPE.</a:t>
-            </a:r>
-          </a:p>
-        </p:txBody>
-      </p:sp>
-      <p:pic>
-        <p:nvPicPr>
-          <p:cNvPr id="5" name="tradexyz-reference.png"/>
-          <p:cNvPicPr/>
-          <p:nvPr/>
-        </p:nvPicPr>
-        <p:blipFill>
-          <a:blip r:embed="rId1"/>
-          <a:stretch>
-            <a:fillRect/>
-          </a:stretch>
-        </p:blipFill>
-        <p:spPr>
-          <a:xfrm>
-            <a:off x="5450000" y="1500000"/>
-            <a:ext cx="6130000" cy="3450000"/>
-          </a:xfrm>
-          <a:prstGeom prst="rect">
-            <a:avLst/>
-          </a:prstGeom>
-        </p:spPr>
-      </p:pic>
+            <a:off x="914400" y="1905000"/>
+            <a:ext cx="9800000" cy="3900000"/>
+          </a:xfrm>
+          <a:prstGeom prst="rect">
+            <a:avLst/>
+          </a:prstGeom>
+          <a:noFill/>
+        </p:spPr>
+        <p:txBody>
+          <a:bodyPr wrap="square"/>
+          <a:lstStyle/>
+          <a:p>
+            <a:pPr marL="285750" indent="-171450">
+              <a:buChar char="•"/>
+            </a:pPr>
+            <a:r>
+              <a:rPr lang="en-US" sz="2100">
+                <a:solidFill>
+                  <a:srgbClr val="D7E3EA"/>
+                </a:solidFill>
+              </a:rPr>
+              <a:t>Hyperliquid has moved from one exchange into market infrastructure.</a:t>
+            </a:r>
+          </a:p>
+          <a:p>
+            <a:pPr marL="285750" indent="-171450">
+              <a:buChar char="•"/>
+            </a:pPr>
+            <a:r>
+              <a:rPr lang="en-US" sz="2100">
+                <a:solidFill>
+                  <a:srgbClr val="D7E3EA"/>
+                </a:solidFill>
+              </a:rPr>
+              <a:t>HIP-3 lets specialist operators list new perpetual markets while HyperCore provides execution rails.</a:t>
+            </a:r>
+          </a:p>
+          <a:p>
+            <a:pPr marL="285750" indent="-171450">
+              <a:buChar char="•"/>
+            </a:pPr>
+            <a:r>
+              <a:rPr lang="en-US" sz="2100">
+                <a:solidFill>
+                  <a:srgbClr val="D7E3EA"/>
+                </a:solidFill>
+              </a:rPr>
+              <a:t>The bottleneck shifts to capital, oracle operations, and operator credibility.</a:t>
+            </a:r>
+          </a:p>
+        </p:txBody>
+      </p:sp>
       <p:sp>
         <p:nvSpPr>
           <p:cNvPr id="4" name="Footer"/>
@@ -614,7 +593,7 @@
                   <a:srgbClr val="F4F7F8"/>
                 </a:solidFill>
               </a:rPr>
-              <a:t>Successful Market Pattern</a:t>
+              <a:t>Trade.xyz Reference</a:t>
             </a:r>
           </a:p>
         </p:txBody>
@@ -627,71 +606,80 @@
         </p:nvSpPr>
         <p:spPr>
           <a:xfrm>
-            <a:off x="914400" y="1905000"/>
-            <a:ext cx="9800000" cy="3900000"/>
-          </a:xfrm>
-          <a:prstGeom prst="rect">
-            <a:avLst/>
-          </a:prstGeom>
-          <a:noFill/>
-        </p:spPr>
-        <p:txBody>
-          <a:bodyPr wrap="square"/>
-          <a:lstStyle/>
-          <a:p>
-            <a:pPr marL="285750" indent="-171450">
-              <a:buChar char="•"/>
-            </a:pPr>
-            <a:r>
-              <a:rPr lang="en-US" sz="2100">
-                <a:solidFill>
-                  <a:srgbClr val="D7E3EA"/>
-                </a:solidFill>
-              </a:rPr>
-              <a:t>Trade.xyz's highest-volume tickers are not only crypto assets.</a:t>
-            </a:r>
-          </a:p>
-          <a:p>
-            <a:pPr marL="285750" indent="-171450">
-              <a:buChar char="•"/>
-            </a:pPr>
-            <a:r>
-              <a:rPr lang="en-US" sz="2100">
-                <a:solidFill>
-                  <a:srgbClr val="D7E3EA"/>
-                </a:solidFill>
-              </a:rPr>
-              <a:t>XYZ100 and SP500: roughly $444M each over 30 days.</a:t>
-            </a:r>
-          </a:p>
-          <a:p>
-            <a:pPr marL="285750" indent="-171450">
-              <a:buChar char="•"/>
-            </a:pPr>
-            <a:r>
-              <a:rPr lang="en-US" sz="2100">
-                <a:solidFill>
-                  <a:srgbClr val="D7E3EA"/>
-                </a:solidFill>
-              </a:rPr>
-              <a:t>SILVER, CL, SNDK, MU, NVDA, BRENTOIL, CBRS, INTC, and GOLD show RWA-style breadth.</a:t>
-            </a:r>
-          </a:p>
-          <a:p>
-            <a:pPr marL="285750" indent="-171450">
-              <a:buChar char="•"/>
-            </a:pPr>
-            <a:r>
-              <a:rPr lang="en-US" sz="2100">
-                <a:solidFill>
-                  <a:srgbClr val="D7E3EA"/>
-                </a:solidFill>
-              </a:rPr>
-              <a:t>HIP.markets should launch where oracle confidence, liquidity, and narrative demand overlap.</a:t>
-            </a:r>
-          </a:p>
-        </p:txBody>
-      </p:sp>
+            <a:off x="609600" y="1630000"/>
+            <a:ext cx="4600000" cy="4400000"/>
+          </a:xfrm>
+          <a:prstGeom prst="rect">
+            <a:avLst/>
+          </a:prstGeom>
+          <a:noFill/>
+        </p:spPr>
+        <p:txBody>
+          <a:bodyPr wrap="square"/>
+          <a:lstStyle/>
+          <a:p>
+            <a:pPr marL="285750" indent="-171450">
+              <a:buChar char="•"/>
+            </a:pPr>
+            <a:r>
+              <a:rPr lang="en-US" sz="2100">
+                <a:solidFill>
+                  <a:srgbClr val="D7E3EA"/>
+                </a:solidFill>
+              </a:rPr>
+              <a:t>60 markets, $2.50B 30-day volume, and $121.98K total 30-day fees.</a:t>
+            </a:r>
+          </a:p>
+          <a:p>
+            <a:pPr marL="285750" indent="-171450">
+              <a:buChar char="•"/>
+            </a:pPr>
+            <a:r>
+              <a:rPr lang="en-US" sz="2100">
+                <a:solidFill>
+                  <a:srgbClr val="D7E3EA"/>
+                </a:solidFill>
+              </a:rPr>
+              <a:t>Estimated deployer revenue: $60.99K over 30 days before operating costs.</a:t>
+            </a:r>
+          </a:p>
+          <a:p>
+            <a:pPr marL="285750" indent="-171450">
+              <a:buChar char="•"/>
+            </a:pPr>
+            <a:r>
+              <a:rPr lang="en-US" sz="2100">
+                <a:solidFill>
+                  <a:srgbClr val="D7E3EA"/>
+                </a:solidFill>
+              </a:rPr>
+              <a:t>Gross implied APR: 3.47% on the 500k HYPE minimum stake at $42.8085 HYPE.</a:t>
+            </a:r>
+          </a:p>
+        </p:txBody>
+      </p:sp>
+      <p:pic>
+        <p:nvPicPr>
+          <p:cNvPr id="5" name="tradexyz-reference.png"/>
+          <p:cNvPicPr/>
+          <p:nvPr/>
+        </p:nvPicPr>
+        <p:blipFill>
+          <a:blip r:embed="rId1"/>
+          <a:stretch>
+            <a:fillRect/>
+          </a:stretch>
+        </p:blipFill>
+        <p:spPr>
+          <a:xfrm>
+            <a:off x="5450000" y="1500000"/>
+            <a:ext cx="6130000" cy="3450000"/>
+          </a:xfrm>
+          <a:prstGeom prst="rect">
+            <a:avLst/>
+          </a:prstGeom>
+        </p:spPr>
+      </p:pic>
       <p:sp>
         <p:nvSpPr>
           <p:cNvPr id="4" name="Footer"/>
@@ -781,7 +769,7 @@
                   <a:srgbClr val="F4F7F8"/>
                 </a:solidFill>
               </a:rPr>
-              <a:t>Revenue Interpretation</a:t>
+              <a:t>Successful Market Pattern</a:t>
             </a:r>
           </a:p>
         </p:txBody>
@@ -815,33 +803,46 @@
                   <a:srgbClr val="D7E3EA"/>
                 </a:solidFill>
               </a:rPr>
-              <a:t>HIP-3 deployer share is fixed at 50% from the deployer perspective.</a:t>
-            </a:r>
-          </a:p>
-          <a:p>
-            <a:pPr marL="285750" indent="-171450">
-              <a:buChar char="•"/>
-            </a:pPr>
-            <a:r>
-              <a:rPr lang="en-US" sz="2100">
-                <a:solidFill>
-                  <a:srgbClr val="D7E3EA"/>
-                </a:solidFill>
-              </a:rPr>
-              <a:t>Trade.xyz reports deployerFeeScale = 1.0.</a:t>
-            </a:r>
-          </a:p>
-          <a:p>
-            <a:pPr marL="285750" indent="-171450">
-              <a:buChar char="•"/>
-            </a:pPr>
-            <a:r>
-              <a:rPr lang="en-US" sz="2100">
-                <a:solidFill>
-                  <a:srgbClr val="D7E3EA"/>
-                </a:solidFill>
-              </a:rPr>
-              <a:t>Gross revenue is not distributable profit until oracle, data, maker, legal, reserve, and incident costs are deducted.</a:t>
+              <a:t>Trade.xyz's highest-volume tickers are not only crypto assets.</a:t>
+            </a:r>
+          </a:p>
+          <a:p>
+            <a:pPr marL="285750" indent="-171450">
+              <a:buChar char="•"/>
+            </a:pPr>
+            <a:r>
+              <a:rPr lang="en-US" sz="2100">
+                <a:solidFill>
+                  <a:srgbClr val="D7E3EA"/>
+                </a:solidFill>
+              </a:rPr>
+              <a:t>XYZ100 and SP500: roughly $444M each over 30 days.</a:t>
+            </a:r>
+          </a:p>
+          <a:p>
+            <a:pPr marL="285750" indent="-171450">
+              <a:buChar char="•"/>
+            </a:pPr>
+            <a:r>
+              <a:rPr lang="en-US" sz="2100">
+                <a:solidFill>
+                  <a:srgbClr val="D7E3EA"/>
+                </a:solidFill>
+              </a:rPr>
+              <a:t>SILVER, CL, SNDK, MU, NVDA, BRENTOIL, CBRS, INTC, and GOLD show RWA-style breadth.</a:t>
+            </a:r>
+          </a:p>
+          <a:p>
+            <a:pPr marL="285750" indent="-171450">
+              <a:buChar char="•"/>
+            </a:pPr>
+            <a:r>
+              <a:rPr lang="en-US" sz="2100">
+                <a:solidFill>
+                  <a:srgbClr val="D7E3EA"/>
+                </a:solidFill>
+              </a:rPr>
+              <a:t>HIP.markets should launch where oracle confidence, liquidity, and narrative demand overlap.</a:t>
             </a:r>
           </a:p>
         </p:txBody>
@@ -935,7 +936,7 @@
                   <a:srgbClr val="F4F7F8"/>
                 </a:solidFill>
               </a:rPr>
-              <a:t>UI Benchmark</a:t>
+              <a:t>Revenue Interpretation</a:t>
             </a:r>
           </a:p>
         </p:txBody>
@@ -969,20 +970,33 @@
                   <a:srgbClr val="D7E3EA"/>
                 </a:solidFill>
               </a:rPr>
-              <a:t>trade.xyz proves serious HIP-3 markets need trading-terminal density.</a:t>
-            </a:r>
-          </a:p>
-          <a:p>
-            <a:pPr marL="285750" indent="-171450">
-              <a:buChar char="•"/>
-            </a:pPr>
-            <a:r>
-              <a:rPr lang="en-US" sz="2100">
-                <a:solidFill>
-                  <a:srgbClr val="D7E3EA"/>
-                </a:solidFill>
-              </a:rPr>
-              <a:t>Useful patterns: market rail, order ticket, positions tabs, account modes, Ghost Mode observability, explicit warnings.</a:t>
+              <a:t>HIP-3 deployer share is fixed at 50% from the deployer perspective.</a:t>
+            </a:r>
+          </a:p>
+          <a:p>
+            <a:pPr marL="285750" indent="-171450">
+              <a:buChar char="•"/>
+            </a:pPr>
+            <a:r>
+              <a:rPr lang="en-US" sz="2100">
+                <a:solidFill>
+                  <a:srgbClr val="D7E3EA"/>
+                </a:solidFill>
+              </a:rPr>
+              <a:t>Trade.xyz reports deployerFeeScale = 1.0.</a:t>
+            </a:r>
+          </a:p>
+          <a:p>
+            <a:pPr marL="285750" indent="-171450">
+              <a:buChar char="•"/>
+            </a:pPr>
+            <a:r>
+              <a:rPr lang="en-US" sz="2100">
+                <a:solidFill>
+                  <a:srgbClr val="D7E3EA"/>
+                </a:solidFill>
+              </a:rPr>
+              <a:t>Gross revenue is not distributable profit until oracle, data, maker, legal, reserve, and incident costs are deducted.</a:t>
             </a:r>
           </a:p>
         </p:txBody>
@@ -1076,7 +1090,7 @@
                   <a:srgbClr val="F4F7F8"/>
                 </a:solidFill>
               </a:rPr>
-              <a:t>UX Translation</a:t>
+              <a:t>UI Benchmark</a:t>
             </a:r>
           </a:p>
         </p:txBody>
@@ -1110,46 +1124,20 @@
                   <a:srgbClr val="D7E3EA"/>
                 </a:solidFill>
               </a:rPr>
-              <a:t>Market rail -&gt; first-three-market launch rail.</a:t>
-            </a:r>
-          </a:p>
-          <a:p>
-            <a:pPr marL="285750" indent="-171450">
-              <a:buChar char="•"/>
-            </a:pPr>
-            <a:r>
-              <a:rPr lang="en-US" sz="2100">
-                <a:solidFill>
-                  <a:srgbClr val="D7E3EA"/>
-                </a:solidFill>
-              </a:rPr>
-              <a:t>Order ticket -&gt; HYPE deposit ticket.</a:t>
-            </a:r>
-          </a:p>
-          <a:p>
-            <a:pPr marL="285750" indent="-171450">
-              <a:buChar char="•"/>
-            </a:pPr>
-            <a:r>
-              <a:rPr lang="en-US" sz="2100">
-                <a:solidFill>
-                  <a:srgbClr val="D7E3EA"/>
-                </a:solidFill>
-              </a:rPr>
-              <a:t>Positions panel -&gt; vault shares, fee history, oracle updates, market launches.</a:t>
-            </a:r>
-          </a:p>
-          <a:p>
-            <a:pPr marL="285750" indent="-171450">
-              <a:buChar char="•"/>
-            </a:pPr>
-            <a:r>
-              <a:rPr lang="en-US" sz="2100">
-                <a:solidFill>
-                  <a:srgbClr val="D7E3EA"/>
-                </a:solidFill>
-              </a:rPr>
-              <a:t>Ghost Mode -&gt; operator monitor.</a:t>
+              <a:t>trade.xyz proves serious HIP-3 markets need trading-terminal density.</a:t>
+            </a:r>
+          </a:p>
+          <a:p>
+            <a:pPr marL="285750" indent="-171450">
+              <a:buChar char="•"/>
+            </a:pPr>
+            <a:r>
+              <a:rPr lang="en-US" sz="2100">
+                <a:solidFill>
+                  <a:srgbClr val="D7E3EA"/>
+                </a:solidFill>
+              </a:rPr>
+              <a:t>Useful patterns: market rail, order ticket, positions tabs, account modes, Ghost Mode observability, explicit warnings.</a:t>
             </a:r>
           </a:p>
         </p:txBody>
@@ -1243,7 +1231,7 @@
                   <a:srgbClr val="F4F7F8"/>
                 </a:solidFill>
               </a:rPr>
-              <a:t>Demo Walkthrough</a:t>
+              <a:t>UX Translation</a:t>
             </a:r>
           </a:p>
         </p:txBody>
@@ -1256,67 +1244,71 @@
         </p:nvSpPr>
         <p:spPr>
           <a:xfrm>
-            <a:off x="609600" y="1630000"/>
-            <a:ext cx="4600000" cy="4400000"/>
-          </a:xfrm>
-          <a:prstGeom prst="rect">
-            <a:avLst/>
-          </a:prstGeom>
-          <a:noFill/>
-        </p:spPr>
-        <p:txBody>
-          <a:bodyPr wrap="square"/>
-          <a:lstStyle/>
-          <a:p>
-            <a:pPr marL="285750" indent="-171450">
-              <a:buChar char="•"/>
-            </a:pPr>
-            <a:r>
-              <a:rPr lang="en-US" sz="2100">
-                <a:solidFill>
-                  <a:srgbClr val="D7E3EA"/>
-                </a:solidFill>
-              </a:rPr>
-              <a:t>The first screen is the usable operator console, not a landing page.</a:t>
-            </a:r>
-          </a:p>
-          <a:p>
-            <a:pPr marL="285750" indent="-171450">
-              <a:buChar char="•"/>
-            </a:pPr>
-            <a:r>
-              <a:rPr lang="en-US" sz="2100">
-                <a:solidFill>
-                  <a:srgbClr val="D7E3EA"/>
-                </a:solidFill>
-              </a:rPr>
-              <a:t>Vault capacity, APR, oracle cadence, risk state, market rail, fee model, deposit ticket, and monitor are visible in one workflow.</a:t>
-            </a:r>
-          </a:p>
-        </p:txBody>
-      </p:sp>
-      <p:pic>
-        <p:nvPicPr>
-          <p:cNvPr id="5" name="demo-dashboard.png"/>
-          <p:cNvPicPr/>
-          <p:nvPr/>
-        </p:nvPicPr>
-        <p:blipFill>
-          <a:blip r:embed="rId1"/>
-          <a:stretch>
-            <a:fillRect/>
-          </a:stretch>
-        </p:blipFill>
-        <p:spPr>
-          <a:xfrm>
-            <a:off x="5450000" y="1500000"/>
-            <a:ext cx="6130000" cy="3450000"/>
-          </a:xfrm>
-          <a:prstGeom prst="rect">
-            <a:avLst/>
-          </a:prstGeom>
-        </p:spPr>
-      </p:pic>
+            <a:off x="914400" y="1905000"/>
+            <a:ext cx="9800000" cy="3900000"/>
+          </a:xfrm>
+          <a:prstGeom prst="rect">
+            <a:avLst/>
+          </a:prstGeom>
+          <a:noFill/>
+        </p:spPr>
+        <p:txBody>
+          <a:bodyPr wrap="square"/>
+          <a:lstStyle/>
+          <a:p>
+            <a:pPr marL="285750" indent="-171450">
+              <a:buChar char="•"/>
+            </a:pPr>
+            <a:r>
+              <a:rPr lang="en-US" sz="2100">
+                <a:solidFill>
+                  <a:srgbClr val="D7E3EA"/>
+                </a:solidFill>
+              </a:rPr>
+              <a:t>Market rail -&gt; first-three-market launch rail.</a:t>
+            </a:r>
+          </a:p>
+          <a:p>
+            <a:pPr marL="285750" indent="-171450">
+              <a:buChar char="•"/>
+            </a:pPr>
+            <a:r>
+              <a:rPr lang="en-US" sz="2100">
+                <a:solidFill>
+                  <a:srgbClr val="D7E3EA"/>
+                </a:solidFill>
+              </a:rPr>
+              <a:t>Order ticket -&gt; HYPE deposit ticket.</a:t>
+            </a:r>
+          </a:p>
+          <a:p>
+            <a:pPr marL="285750" indent="-171450">
+              <a:buChar char="•"/>
+            </a:pPr>
+            <a:r>
+              <a:rPr lang="en-US" sz="2100">
+                <a:solidFill>
+                  <a:srgbClr val="D7E3EA"/>
+                </a:solidFill>
+              </a:rPr>
+              <a:t>Positions panel -&gt; vault shares, fee history, oracle updates, market launches.</a:t>
+            </a:r>
+          </a:p>
+          <a:p>
+            <a:pPr marL="285750" indent="-171450">
+              <a:buChar char="•"/>
+            </a:pPr>
+            <a:r>
+              <a:rPr lang="en-US" sz="2100">
+                <a:solidFill>
+                  <a:srgbClr val="D7E3EA"/>
+                </a:solidFill>
+              </a:rPr>
+              <a:t>Ghost Mode -&gt; operator monitor.</a:t>
+            </a:r>
+          </a:p>
+        </p:txBody>
+      </p:sp>
       <p:sp>
         <p:nvSpPr>
           <p:cNvPr id="4" name="Footer"/>
@@ -1406,7 +1398,7 @@
                   <a:srgbClr val="F4F7F8"/>
                 </a:solidFill>
               </a:rPr>
-              <a:t>Demo: Fee Model</a:t>
+              <a:t>Demo Walkthrough</a:t>
             </a:r>
           </a:p>
         </p:txBody>
@@ -1419,45 +1411,67 @@
         </p:nvSpPr>
         <p:spPr>
           <a:xfrm>
-            <a:off x="914400" y="1905000"/>
-            <a:ext cx="9800000" cy="3900000"/>
-          </a:xfrm>
-          <a:prstGeom prst="rect">
-            <a:avLst/>
-          </a:prstGeom>
-          <a:noFill/>
-        </p:spPr>
-        <p:txBody>
-          <a:bodyPr wrap="square"/>
-          <a:lstStyle/>
-          <a:p>
-            <a:pPr marL="285750" indent="-171450">
-              <a:buChar char="•"/>
-            </a:pPr>
-            <a:r>
-              <a:rPr lang="en-US" sz="2100">
-                <a:solidFill>
-                  <a:srgbClr val="D7E3EA"/>
-                </a:solidFill>
-              </a:rPr>
-              <a:t>Judges can change HYPE price, staked HYPE, daily volume, fee bps, builder share, operating fee, protocol fee, and reserve.</a:t>
-            </a:r>
-          </a:p>
-          <a:p>
-            <a:pPr marL="285750" indent="-171450">
-              <a:buChar char="•"/>
-            </a:pPr>
-            <a:r>
-              <a:rPr lang="en-US" sz="2100">
-                <a:solidFill>
-                  <a:srgbClr val="D7E3EA"/>
-                </a:solidFill>
-              </a:rPr>
-              <a:t>APR updates instantly.</a:t>
-            </a:r>
-          </a:p>
-        </p:txBody>
-      </p:sp>
+            <a:off x="609600" y="1630000"/>
+            <a:ext cx="4600000" cy="4400000"/>
+          </a:xfrm>
+          <a:prstGeom prst="rect">
+            <a:avLst/>
+          </a:prstGeom>
+          <a:noFill/>
+        </p:spPr>
+        <p:txBody>
+          <a:bodyPr wrap="square"/>
+          <a:lstStyle/>
+          <a:p>
+            <a:pPr marL="285750" indent="-171450">
+              <a:buChar char="•"/>
+            </a:pPr>
+            <a:r>
+              <a:rPr lang="en-US" sz="2100">
+                <a:solidFill>
+                  <a:srgbClr val="D7E3EA"/>
+                </a:solidFill>
+              </a:rPr>
+              <a:t>The first screen is the usable operator console, not a landing page.</a:t>
+            </a:r>
+          </a:p>
+          <a:p>
+            <a:pPr marL="285750" indent="-171450">
+              <a:buChar char="•"/>
+            </a:pPr>
+            <a:r>
+              <a:rPr lang="en-US" sz="2100">
+                <a:solidFill>
+                  <a:srgbClr val="D7E3EA"/>
+                </a:solidFill>
+              </a:rPr>
+              <a:t>Vault capacity, APR, oracle cadence, risk state, market rail, fee model, deposit ticket, and monitor are visible in one workflow.</a:t>
+            </a:r>
+          </a:p>
+        </p:txBody>
+      </p:sp>
+      <p:pic>
+        <p:nvPicPr>
+          <p:cNvPr id="5" name="demo-dashboard.png"/>
+          <p:cNvPicPr/>
+          <p:nvPr/>
+        </p:nvPicPr>
+        <p:blipFill>
+          <a:blip r:embed="rId1"/>
+          <a:stretch>
+            <a:fillRect/>
+          </a:stretch>
+        </p:blipFill>
+        <p:spPr>
+          <a:xfrm>
+            <a:off x="5450000" y="1500000"/>
+            <a:ext cx="6130000" cy="3450000"/>
+          </a:xfrm>
+          <a:prstGeom prst="rect">
+            <a:avLst/>
+          </a:prstGeom>
+        </p:spPr>
+      </p:pic>
       <p:sp>
         <p:nvSpPr>
           <p:cNvPr id="4" name="Footer"/>
@@ -1547,7 +1561,7 @@
                   <a:srgbClr val="F4F7F8"/>
                 </a:solidFill>
               </a:rPr>
-              <a:t>Demo: Deposit Ticket</a:t>
+              <a:t>Demo: Fee Model</a:t>
             </a:r>
           </a:p>
         </p:txBody>
@@ -1581,20 +1595,20 @@
                   <a:srgbClr val="D7E3EA"/>
                 </a:solidFill>
               </a:rPr>
-              <a:t>Mirrors a trading order pane.</a:t>
-            </a:r>
-          </a:p>
-          <a:p>
-            <a:pPr marL="285750" indent="-171450">
-              <a:buChar char="•"/>
-            </a:pPr>
-            <a:r>
-              <a:rPr lang="en-US" sz="2100">
-                <a:solidFill>
-                  <a:srgbClr val="D7E3EA"/>
-                </a:solidFill>
-              </a:rPr>
-              <a:t>Amount input, deposit/withdraw mode, fee summary, user rewards estimate, and slashing warning.</a:t>
+              <a:t>Judges can change HYPE price, staked HYPE, daily volume, fee bps, builder share, operating fee, protocol fee, and reserve.</a:t>
+            </a:r>
+          </a:p>
+          <a:p>
+            <a:pPr marL="285750" indent="-171450">
+              <a:buChar char="•"/>
+            </a:pPr>
+            <a:r>
+              <a:rPr lang="en-US" sz="2100">
+                <a:solidFill>
+                  <a:srgbClr val="D7E3EA"/>
+                </a:solidFill>
+              </a:rPr>
+              <a:t>APR updates instantly.</a:t>
             </a:r>
           </a:p>
         </p:txBody>
@@ -1688,7 +1702,7 @@
                   <a:srgbClr val="F4F7F8"/>
                 </a:solidFill>
               </a:rPr>
-              <a:t>Demo: Audit Ledger</a:t>
+              <a:t>Demo: Deposit Ticket</a:t>
             </a:r>
           </a:p>
         </p:txBody>
@@ -1701,67 +1715,45 @@
         </p:nvSpPr>
         <p:spPr>
           <a:xfrm>
-            <a:off x="609600" y="1630000"/>
-            <a:ext cx="4600000" cy="4400000"/>
-          </a:xfrm>
-          <a:prstGeom prst="rect">
-            <a:avLst/>
-          </a:prstGeom>
-          <a:noFill/>
-        </p:spPr>
-        <p:txBody>
-          <a:bodyPr wrap="square"/>
-          <a:lstStyle/>
-          <a:p>
-            <a:pPr marL="285750" indent="-171450">
-              <a:buChar char="•"/>
-            </a:pPr>
-            <a:r>
-              <a:rPr lang="en-US" sz="2100">
-                <a:solidFill>
-                  <a:srgbClr val="D7E3EA"/>
-                </a:solidFill>
-              </a:rPr>
-              <a:t>Fee sharing becomes an inspectable ledger.</a:t>
-            </a:r>
-          </a:p>
-          <a:p>
-            <a:pPr marL="285750" indent="-171450">
-              <a:buChar char="•"/>
-            </a:pPr>
-            <a:r>
-              <a:rPr lang="en-US" sz="2100">
-                <a:solidFill>
-                  <a:srgbClr val="D7E3EA"/>
-                </a:solidFill>
-              </a:rPr>
-              <a:t>Vault shares, fee history, oracle updates, and market launch readiness expose operator behavior.</a:t>
-            </a:r>
-          </a:p>
-        </p:txBody>
-      </p:sp>
-      <p:pic>
-        <p:nvPicPr>
-          <p:cNvPr id="5" name="demo-fee-ledger-view.png"/>
-          <p:cNvPicPr/>
-          <p:nvPr/>
-        </p:nvPicPr>
-        <p:blipFill>
-          <a:blip r:embed="rId1"/>
-          <a:stretch>
-            <a:fillRect/>
-          </a:stretch>
-        </p:blipFill>
-        <p:spPr>
-          <a:xfrm>
-            <a:off x="5450000" y="1500000"/>
-            <a:ext cx="6130000" cy="3450000"/>
-          </a:xfrm>
-          <a:prstGeom prst="rect">
-            <a:avLst/>
-          </a:prstGeom>
-        </p:spPr>
-      </p:pic>
+            <a:off x="914400" y="1905000"/>
+            <a:ext cx="9800000" cy="3900000"/>
+          </a:xfrm>
+          <a:prstGeom prst="rect">
+            <a:avLst/>
+          </a:prstGeom>
+          <a:noFill/>
+        </p:spPr>
+        <p:txBody>
+          <a:bodyPr wrap="square"/>
+          <a:lstStyle/>
+          <a:p>
+            <a:pPr marL="285750" indent="-171450">
+              <a:buChar char="•"/>
+            </a:pPr>
+            <a:r>
+              <a:rPr lang="en-US" sz="2100">
+                <a:solidFill>
+                  <a:srgbClr val="D7E3EA"/>
+                </a:solidFill>
+              </a:rPr>
+              <a:t>Mirrors a trading order pane.</a:t>
+            </a:r>
+          </a:p>
+          <a:p>
+            <a:pPr marL="285750" indent="-171450">
+              <a:buChar char="•"/>
+            </a:pPr>
+            <a:r>
+              <a:rPr lang="en-US" sz="2100">
+                <a:solidFill>
+                  <a:srgbClr val="D7E3EA"/>
+                </a:solidFill>
+              </a:rPr>
+              <a:t>Amount input, deposit/withdraw mode, fee summary, user rewards estimate, and slashing warning.</a:t>
+            </a:r>
+          </a:p>
+        </p:txBody>
+      </p:sp>
       <p:sp>
         <p:nvSpPr>
           <p:cNvPr id="4" name="Footer"/>
@@ -2027,7 +2019,7 @@
                   <a:srgbClr val="F4F7F8"/>
                 </a:solidFill>
               </a:rPr>
-              <a:t>Demo: Contract Wiring</a:t>
+              <a:t>Demo: Audit Ledger</a:t>
             </a:r>
           </a:p>
         </p:txBody>
@@ -2061,27 +2053,27 @@
                   <a:srgbClr val="D7E3EA"/>
                 </a:solidFill>
               </a:rPr>
-              <a:t>Wallet-aware flow: connect wallet, configure vault/token addresses, approve HYPE, deposit, and claim rewards.</a:t>
-            </a:r>
-          </a:p>
-          <a:p>
-            <a:pPr marL="285750" indent="-171450">
-              <a:buChar char="•"/>
-            </a:pPr>
-            <a:r>
-              <a:rPr lang="en-US" sz="2100">
-                <a:solidFill>
-                  <a:srgbClr val="D7E3EA"/>
-                </a:solidFill>
-              </a:rPr>
-              <a:t>The UI also shows which actions still require operator multisig and risk-council execution.</a:t>
+              <a:t>Fee sharing becomes an inspectable ledger.</a:t>
+            </a:r>
+          </a:p>
+          <a:p>
+            <a:pPr marL="285750" indent="-171450">
+              <a:buChar char="•"/>
+            </a:pPr>
+            <a:r>
+              <a:rPr lang="en-US" sz="2100">
+                <a:solidFill>
+                  <a:srgbClr val="D7E3EA"/>
+                </a:solidFill>
+              </a:rPr>
+              <a:t>Vault shares, fee history, oracle updates, and market launch readiness expose operator behavior.</a:t>
             </a:r>
           </a:p>
         </p:txBody>
       </p:sp>
       <p:pic>
         <p:nvPicPr>
-          <p:cNvPr id="5" name="demo-contract-wiring.png"/>
+          <p:cNvPr id="5" name="demo-fee-ledger-view.png"/>
           <p:cNvPicPr/>
           <p:nvPr/>
         </p:nvPicPr>
@@ -2190,7 +2182,7 @@
                   <a:srgbClr val="F4F7F8"/>
                 </a:solidFill>
               </a:rPr>
-              <a:t>Contract Depth</a:t>
+              <a:t>Demo: Contract Wiring</a:t>
             </a:r>
           </a:p>
         </p:txBody>
@@ -2203,58 +2195,67 @@
         </p:nvSpPr>
         <p:spPr>
           <a:xfrm>
-            <a:off x="914400" y="1905000"/>
-            <a:ext cx="9800000" cy="3900000"/>
-          </a:xfrm>
-          <a:prstGeom prst="rect">
-            <a:avLst/>
-          </a:prstGeom>
-          <a:noFill/>
-        </p:spPr>
-        <p:txBody>
-          <a:bodyPr wrap="square"/>
-          <a:lstStyle/>
-          <a:p>
-            <a:pPr marL="285750" indent="-171450">
-              <a:buChar char="•"/>
-            </a:pPr>
-            <a:r>
-              <a:rPr lang="en-US" sz="2100">
-                <a:solidFill>
-                  <a:srgbClr val="D7E3EA"/>
-                </a:solidFill>
-              </a:rPr>
-              <a:t>Vault now models vHIPM receipt shares, vault caps, withdrawal queues, reward accounting, and slash losses.</a:t>
-            </a:r>
-          </a:p>
-          <a:p>
-            <a:pPr marL="285750" indent="-171450">
-              <a:buChar char="•"/>
-            </a:pPr>
-            <a:r>
-              <a:rPr lang="en-US" sz="2100">
-                <a:solidFill>
-                  <a:srgbClr val="D7E3EA"/>
-                </a:solidFill>
-              </a:rPr>
-              <a:t>Operator lifecycle: funding, stake-ready, stake-escrowed, approved, live, wind-down, and slashed.</a:t>
-            </a:r>
-          </a:p>
-          <a:p>
-            <a:pPr marL="285750" indent="-171450">
-              <a:buChar char="•"/>
-            </a:pPr>
-            <a:r>
-              <a:rPr lang="en-US" sz="2100">
-                <a:solidFill>
-                  <a:srgbClr val="D7E3EA"/>
-                </a:solidFill>
-              </a:rPr>
-              <a:t>Registry tracks launch checklist, fee epochs, oracle health, market status, and risk state.</a:t>
-            </a:r>
-          </a:p>
-        </p:txBody>
-      </p:sp>
+            <a:off x="609600" y="1630000"/>
+            <a:ext cx="4600000" cy="4400000"/>
+          </a:xfrm>
+          <a:prstGeom prst="rect">
+            <a:avLst/>
+          </a:prstGeom>
+          <a:noFill/>
+        </p:spPr>
+        <p:txBody>
+          <a:bodyPr wrap="square"/>
+          <a:lstStyle/>
+          <a:p>
+            <a:pPr marL="285750" indent="-171450">
+              <a:buChar char="•"/>
+            </a:pPr>
+            <a:r>
+              <a:rPr lang="en-US" sz="2100">
+                <a:solidFill>
+                  <a:srgbClr val="D7E3EA"/>
+                </a:solidFill>
+              </a:rPr>
+              <a:t>Wallet-aware flow: connect wallet, configure vault/token addresses, approve HYPE, deposit, and claim rewards.</a:t>
+            </a:r>
+          </a:p>
+          <a:p>
+            <a:pPr marL="285750" indent="-171450">
+              <a:buChar char="•"/>
+            </a:pPr>
+            <a:r>
+              <a:rPr lang="en-US" sz="2100">
+                <a:solidFill>
+                  <a:srgbClr val="D7E3EA"/>
+                </a:solidFill>
+              </a:rPr>
+              <a:t>The UI also shows which actions still require operator multisig and risk-council execution.</a:t>
+            </a:r>
+          </a:p>
+        </p:txBody>
+      </p:sp>
+      <p:pic>
+        <p:nvPicPr>
+          <p:cNvPr id="5" name="demo-contract-wiring.png"/>
+          <p:cNvPicPr/>
+          <p:nvPr/>
+        </p:nvPicPr>
+        <p:blipFill>
+          <a:blip r:embed="rId1"/>
+          <a:stretch>
+            <a:fillRect/>
+          </a:stretch>
+        </p:blipFill>
+        <p:spPr>
+          <a:xfrm>
+            <a:off x="5450000" y="1500000"/>
+            <a:ext cx="6130000" cy="3450000"/>
+          </a:xfrm>
+          <a:prstGeom prst="rect">
+            <a:avLst/>
+          </a:prstGeom>
+        </p:spPr>
+      </p:pic>
       <p:sp>
         <p:nvSpPr>
           <p:cNvPr id="4" name="Footer"/>
@@ -2344,7 +2345,7 @@
                   <a:srgbClr val="F4F7F8"/>
                 </a:solidFill>
               </a:rPr>
-              <a:t>System Flow</a:t>
+              <a:t>Contract Depth</a:t>
             </a:r>
           </a:p>
         </p:txBody>
@@ -2378,59 +2379,33 @@
                   <a:srgbClr val="D7E3EA"/>
                 </a:solidFill>
               </a:rPr>
-              <a:t>1. HYPE holders deposit into the HyperEVM vault.</a:t>
-            </a:r>
-          </a:p>
-          <a:p>
-            <a:pPr marL="285750" indent="-171450">
-              <a:buChar char="•"/>
-            </a:pPr>
-            <a:r>
-              <a:rPr lang="en-US" sz="2100">
-                <a:solidFill>
-                  <a:srgbClr val="D7E3EA"/>
-                </a:solidFill>
-              </a:rPr>
-              <a:t>2. Vault backs HIP.markets deployer stake.</a:t>
-            </a:r>
-          </a:p>
-          <a:p>
-            <a:pPr marL="285750" indent="-171450">
-              <a:buChar char="•"/>
-            </a:pPr>
-            <a:r>
-              <a:rPr lang="en-US" sz="2100">
-                <a:solidFill>
-                  <a:srgbClr val="D7E3EA"/>
-                </a:solidFill>
-              </a:rPr>
-              <a:t>3. Operator multisig escrows funded HYPE to the deployer stake controller.</a:t>
-            </a:r>
-          </a:p>
-          <a:p>
-            <a:pPr marL="285750" indent="-171450">
-              <a:buChar char="•"/>
-            </a:pPr>
-            <a:r>
-              <a:rPr lang="en-US" sz="2100">
-                <a:solidFill>
-                  <a:srgbClr val="D7E3EA"/>
-                </a:solidFill>
-              </a:rPr>
-              <a:t>4. Risk council records HIP-3 operator approval.</a:t>
-            </a:r>
-          </a:p>
-          <a:p>
-            <a:pPr marL="285750" indent="-171450">
-              <a:buChar char="•"/>
-            </a:pPr>
-            <a:r>
-              <a:rPr lang="en-US" sz="2100">
-                <a:solidFill>
-                  <a:srgbClr val="D7E3EA"/>
-                </a:solidFill>
-              </a:rPr>
-              <a:t>5. HIP.markets launches markets, traders generate fees, and net rewards distribute after deductions.</a:t>
+              <a:t>Vault now models vHIPM receipt shares, vault caps, withdrawal queues, reward accounting, and slash losses.</a:t>
+            </a:r>
+          </a:p>
+          <a:p>
+            <a:pPr marL="285750" indent="-171450">
+              <a:buChar char="•"/>
+            </a:pPr>
+            <a:r>
+              <a:rPr lang="en-US" sz="2100">
+                <a:solidFill>
+                  <a:srgbClr val="D7E3EA"/>
+                </a:solidFill>
+              </a:rPr>
+              <a:t>Operator lifecycle: funding, stake-ready, stake-escrowed, approved, live, wind-down, and slashed.</a:t>
+            </a:r>
+          </a:p>
+          <a:p>
+            <a:pPr marL="285750" indent="-171450">
+              <a:buChar char="•"/>
+            </a:pPr>
+            <a:r>
+              <a:rPr lang="en-US" sz="2100">
+                <a:solidFill>
+                  <a:srgbClr val="D7E3EA"/>
+                </a:solidFill>
+              </a:rPr>
+              <a:t>Registry tracks launch checklist, fee epochs, oracle health, market status, and risk state.</a:t>
             </a:r>
           </a:p>
         </p:txBody>
@@ -2524,7 +2499,7 @@
                   <a:srgbClr val="F4F7F8"/>
                 </a:solidFill>
               </a:rPr>
-              <a:t>Economics</a:t>
+              <a:t>System Flow</a:t>
             </a:r>
           </a:p>
         </p:txBody>
@@ -2558,46 +2533,59 @@
                   <a:srgbClr val="D7E3EA"/>
                 </a:solidFill>
               </a:rPr>
-              <a:t>Base model: 500k HYPE, $50M daily volume, 6 bps fee, 50% deployer share.</a:t>
-            </a:r>
-          </a:p>
-          <a:p>
-            <a:pPr marL="285750" indent="-171450">
-              <a:buChar char="•"/>
-            </a:pPr>
-            <a:r>
-              <a:rPr lang="en-US" sz="2100">
-                <a:solidFill>
-                  <a:srgbClr val="D7E3EA"/>
-                </a:solidFill>
-              </a:rPr>
-              <a:t>After 40% operating/protocol/reserve deductions: approximately 15% net APR.</a:t>
-            </a:r>
-          </a:p>
-          <a:p>
-            <a:pPr marL="285750" indent="-171450">
-              <a:buChar char="•"/>
-            </a:pPr>
-            <a:r>
-              <a:rPr lang="en-US" sz="2100">
-                <a:solidFill>
-                  <a:srgbClr val="D7E3EA"/>
-                </a:solidFill>
-              </a:rPr>
-              <a:t>Trade.xyz trailing fees imply approximately 3.47% gross APR on the minimum stake.</a:t>
-            </a:r>
-          </a:p>
-          <a:p>
-            <a:pPr marL="285750" indent="-171450">
-              <a:buChar char="•"/>
-            </a:pPr>
-            <a:r>
-              <a:rPr lang="en-US" sz="2100">
-                <a:solidFill>
-                  <a:srgbClr val="D7E3EA"/>
-                </a:solidFill>
-              </a:rPr>
-              <a:t>Sensitivity matters more than headline APR.</a:t>
+              <a:t>1. HYPE holders deposit into the HyperEVM vault.</a:t>
+            </a:r>
+          </a:p>
+          <a:p>
+            <a:pPr marL="285750" indent="-171450">
+              <a:buChar char="•"/>
+            </a:pPr>
+            <a:r>
+              <a:rPr lang="en-US" sz="2100">
+                <a:solidFill>
+                  <a:srgbClr val="D7E3EA"/>
+                </a:solidFill>
+              </a:rPr>
+              <a:t>2. Vault backs HIP.markets deployer stake.</a:t>
+            </a:r>
+          </a:p>
+          <a:p>
+            <a:pPr marL="285750" indent="-171450">
+              <a:buChar char="•"/>
+            </a:pPr>
+            <a:r>
+              <a:rPr lang="en-US" sz="2100">
+                <a:solidFill>
+                  <a:srgbClr val="D7E3EA"/>
+                </a:solidFill>
+              </a:rPr>
+              <a:t>3. Operator multisig escrows funded HYPE to the deployer stake controller.</a:t>
+            </a:r>
+          </a:p>
+          <a:p>
+            <a:pPr marL="285750" indent="-171450">
+              <a:buChar char="•"/>
+            </a:pPr>
+            <a:r>
+              <a:rPr lang="en-US" sz="2100">
+                <a:solidFill>
+                  <a:srgbClr val="D7E3EA"/>
+                </a:solidFill>
+              </a:rPr>
+              <a:t>4. Risk council records HIP-3 operator approval.</a:t>
+            </a:r>
+          </a:p>
+          <a:p>
+            <a:pPr marL="285750" indent="-171450">
+              <a:buChar char="•"/>
+            </a:pPr>
+            <a:r>
+              <a:rPr lang="en-US" sz="2100">
+                <a:solidFill>
+                  <a:srgbClr val="D7E3EA"/>
+                </a:solidFill>
+              </a:rPr>
+              <a:t>5. HIP.markets launches markets, traders generate fees, and net rewards distribute after deductions.</a:t>
             </a:r>
           </a:p>
         </p:txBody>
@@ -2691,7 +2679,7 @@
                   <a:srgbClr val="F4F7F8"/>
                 </a:solidFill>
               </a:rPr>
-              <a:t>Risk Controls</a:t>
+              <a:t>Economics</a:t>
             </a:r>
           </a:p>
         </p:txBody>
@@ -2725,33 +2713,46 @@
                   <a:srgbClr val="D7E3EA"/>
                 </a:solidFill>
               </a:rPr>
-              <a:t>Start with oracle-simple markets.</a:t>
-            </a:r>
-          </a:p>
-          <a:p>
-            <a:pPr marL="285750" indent="-171450">
-              <a:buChar char="•"/>
-            </a:pPr>
-            <a:r>
-              <a:rPr lang="en-US" sz="2100">
-                <a:solidFill>
-                  <a:srgbClr val="D7E3EA"/>
-                </a:solidFill>
-              </a:rPr>
-              <a:t>Avoid extra ticker auction costs at launch.</a:t>
-            </a:r>
-          </a:p>
-          <a:p>
-            <a:pPr marL="285750" indent="-171450">
-              <a:buChar char="•"/>
-            </a:pPr>
-            <a:r>
-              <a:rPr lang="en-US" sz="2100">
-                <a:solidFill>
-                  <a:srgbClr val="D7E3EA"/>
-                </a:solidFill>
-              </a:rPr>
-              <a:t>Cap open interest, publish addresses, maintain reserve, pause deposits during incidents.</a:t>
+              <a:t>Base model: 500k HYPE, $50M daily volume, 6 bps fee, 50% deployer share.</a:t>
+            </a:r>
+          </a:p>
+          <a:p>
+            <a:pPr marL="285750" indent="-171450">
+              <a:buChar char="•"/>
+            </a:pPr>
+            <a:r>
+              <a:rPr lang="en-US" sz="2100">
+                <a:solidFill>
+                  <a:srgbClr val="D7E3EA"/>
+                </a:solidFill>
+              </a:rPr>
+              <a:t>After 40% operating/protocol/reserve deductions: approximately 15% net APR.</a:t>
+            </a:r>
+          </a:p>
+          <a:p>
+            <a:pPr marL="285750" indent="-171450">
+              <a:buChar char="•"/>
+            </a:pPr>
+            <a:r>
+              <a:rPr lang="en-US" sz="2100">
+                <a:solidFill>
+                  <a:srgbClr val="D7E3EA"/>
+                </a:solidFill>
+              </a:rPr>
+              <a:t>Trade.xyz trailing fees imply approximately 3.47% gross APR on the minimum stake.</a:t>
+            </a:r>
+          </a:p>
+          <a:p>
+            <a:pPr marL="285750" indent="-171450">
+              <a:buChar char="•"/>
+            </a:pPr>
+            <a:r>
+              <a:rPr lang="en-US" sz="2100">
+                <a:solidFill>
+                  <a:srgbClr val="D7E3EA"/>
+                </a:solidFill>
+              </a:rPr>
+              <a:t>Sensitivity matters more than headline APR.</a:t>
             </a:r>
           </a:p>
         </p:txBody>
@@ -2845,7 +2846,7 @@
                   <a:srgbClr val="F4F7F8"/>
                 </a:solidFill>
               </a:rPr>
-              <a:t>Cost Stack</a:t>
+              <a:t>Risk Controls</a:t>
             </a:r>
           </a:p>
         </p:txBody>
@@ -2879,20 +2880,33 @@
                   <a:srgbClr val="D7E3EA"/>
                 </a:solidFill>
               </a:rPr>
-              <a:t>The 500k HYPE stake is the entry ticket, not the full cost of business.</a:t>
-            </a:r>
-          </a:p>
-          <a:p>
-            <a:pPr marL="285750" indent="-171450">
-              <a:buChar char="•"/>
-            </a:pPr>
-            <a:r>
-              <a:rPr lang="en-US" sz="2100">
-                <a:solidFill>
-                  <a:srgbClr val="D7E3EA"/>
-                </a:solidFill>
-              </a:rPr>
-              <a:t>Budget for oracle relayers, licensed data, maker incentives, infrastructure, key management, audits, legal work, and incident reserves.</a:t>
+              <a:t>Start with oracle-simple markets.</a:t>
+            </a:r>
+          </a:p>
+          <a:p>
+            <a:pPr marL="285750" indent="-171450">
+              <a:buChar char="•"/>
+            </a:pPr>
+            <a:r>
+              <a:rPr lang="en-US" sz="2100">
+                <a:solidFill>
+                  <a:srgbClr val="D7E3EA"/>
+                </a:solidFill>
+              </a:rPr>
+              <a:t>Avoid extra ticker auction costs at launch.</a:t>
+            </a:r>
+          </a:p>
+          <a:p>
+            <a:pPr marL="285750" indent="-171450">
+              <a:buChar char="•"/>
+            </a:pPr>
+            <a:r>
+              <a:rPr lang="en-US" sz="2100">
+                <a:solidFill>
+                  <a:srgbClr val="D7E3EA"/>
+                </a:solidFill>
+              </a:rPr>
+              <a:t>Cap open interest, publish addresses, maintain reserve, pause deposits during incidents.</a:t>
             </a:r>
           </a:p>
         </p:txBody>
@@ -2986,7 +3000,7 @@
                   <a:srgbClr val="F4F7F8"/>
                 </a:solidFill>
               </a:rPr>
-              <a:t>MVP</a:t>
+              <a:t>Cost Stack</a:t>
             </a:r>
           </a:p>
         </p:txBody>
@@ -3020,72 +3034,20 @@
                   <a:srgbClr val="D7E3EA"/>
                 </a:solidFill>
               </a:rPr>
-              <a:t>One HIP.markets-operated DEX.</a:t>
-            </a:r>
-          </a:p>
-          <a:p>
-            <a:pPr marL="285750" indent="-171450">
-              <a:buChar char="•"/>
-            </a:pPr>
-            <a:r>
-              <a:rPr lang="en-US" sz="2100">
-                <a:solidFill>
-                  <a:srgbClr val="D7E3EA"/>
-                </a:solidFill>
-              </a:rPr>
-              <a:t>One HYPE vault.</a:t>
-            </a:r>
-          </a:p>
-          <a:p>
-            <a:pPr marL="285750" indent="-171450">
-              <a:buChar char="•"/>
-            </a:pPr>
-            <a:r>
-              <a:rPr lang="en-US" sz="2100">
-                <a:solidFill>
-                  <a:srgbClr val="D7E3EA"/>
-                </a:solidFill>
-              </a:rPr>
-              <a:t>First three markets.</a:t>
-            </a:r>
-          </a:p>
-          <a:p>
-            <a:pPr marL="285750" indent="-171450">
-              <a:buChar char="•"/>
-            </a:pPr>
-            <a:r>
-              <a:rPr lang="en-US" sz="2100">
-                <a:solidFill>
-                  <a:srgbClr val="D7E3EA"/>
-                </a:solidFill>
-              </a:rPr>
-              <a:t>Weekly distributions.</a:t>
-            </a:r>
-          </a:p>
-          <a:p>
-            <a:pPr marL="285750" indent="-171450">
-              <a:buChar char="•"/>
-            </a:pPr>
-            <a:r>
-              <a:rPr lang="en-US" sz="2100">
-                <a:solidFill>
-                  <a:srgbClr val="D7E3EA"/>
-                </a:solidFill>
-              </a:rPr>
-              <a:t>Public dashboard.</a:t>
-            </a:r>
-          </a:p>
-          <a:p>
-            <a:pPr marL="285750" indent="-171450">
-              <a:buChar char="•"/>
-            </a:pPr>
-            <a:r>
-              <a:rPr lang="en-US" sz="2100">
-                <a:solidFill>
-                  <a:srgbClr val="D7E3EA"/>
-                </a:solidFill>
-              </a:rPr>
-              <a:t>No third-party operator financing.</a:t>
+              <a:t>The 500k HYPE stake is the entry ticket, not the full cost of business.</a:t>
+            </a:r>
+          </a:p>
+          <a:p>
+            <a:pPr marL="285750" indent="-171450">
+              <a:buChar char="•"/>
+            </a:pPr>
+            <a:r>
+              <a:rPr lang="en-US" sz="2100">
+                <a:solidFill>
+                  <a:srgbClr val="D7E3EA"/>
+                </a:solidFill>
+              </a:rPr>
+              <a:t>Budget for oracle relayers, licensed data, maker incentives, infrastructure, key management, audits, legal work, and incident reserves.</a:t>
             </a:r>
           </a:p>
         </p:txBody>
@@ -3179,7 +3141,7 @@
                   <a:srgbClr val="F4F7F8"/>
                 </a:solidFill>
               </a:rPr>
-              <a:t>Roadmap</a:t>
+              <a:t>MVP</a:t>
             </a:r>
           </a:p>
         </p:txBody>
@@ -3213,33 +3175,72 @@
                   <a:srgbClr val="D7E3EA"/>
                 </a:solidFill>
               </a:rPr>
-              <a:t>V1: prove operator vault and fee sharing.</a:t>
-            </a:r>
-          </a:p>
-          <a:p>
-            <a:pPr marL="285750" indent="-171450">
-              <a:buChar char="•"/>
-            </a:pPr>
-            <a:r>
-              <a:rPr lang="en-US" sz="2100">
-                <a:solidFill>
-                  <a:srgbClr val="D7E3EA"/>
-                </a:solidFill>
-              </a:rPr>
-              <a:t>V2: more HIP.markets market vaults and automated fee verification.</a:t>
-            </a:r>
-          </a:p>
-          <a:p>
-            <a:pPr marL="285750" indent="-171450">
-              <a:buChar char="•"/>
-            </a:pPr>
-            <a:r>
-              <a:rPr lang="en-US" sz="2100">
-                <a:solidFill>
-                  <a:srgbClr val="D7E3EA"/>
-                </a:solidFill>
-              </a:rPr>
-              <a:t>V3: risk tranching, secondary shares, HIP-4, possible third-party financing once the trust model is mature.</a:t>
+              <a:t>One HIP.markets-operated DEX.</a:t>
+            </a:r>
+          </a:p>
+          <a:p>
+            <a:pPr marL="285750" indent="-171450">
+              <a:buChar char="•"/>
+            </a:pPr>
+            <a:r>
+              <a:rPr lang="en-US" sz="2100">
+                <a:solidFill>
+                  <a:srgbClr val="D7E3EA"/>
+                </a:solidFill>
+              </a:rPr>
+              <a:t>One HYPE vault.</a:t>
+            </a:r>
+          </a:p>
+          <a:p>
+            <a:pPr marL="285750" indent="-171450">
+              <a:buChar char="•"/>
+            </a:pPr>
+            <a:r>
+              <a:rPr lang="en-US" sz="2100">
+                <a:solidFill>
+                  <a:srgbClr val="D7E3EA"/>
+                </a:solidFill>
+              </a:rPr>
+              <a:t>First three markets.</a:t>
+            </a:r>
+          </a:p>
+          <a:p>
+            <a:pPr marL="285750" indent="-171450">
+              <a:buChar char="•"/>
+            </a:pPr>
+            <a:r>
+              <a:rPr lang="en-US" sz="2100">
+                <a:solidFill>
+                  <a:srgbClr val="D7E3EA"/>
+                </a:solidFill>
+              </a:rPr>
+              <a:t>Weekly distributions.</a:t>
+            </a:r>
+          </a:p>
+          <a:p>
+            <a:pPr marL="285750" indent="-171450">
+              <a:buChar char="•"/>
+            </a:pPr>
+            <a:r>
+              <a:rPr lang="en-US" sz="2100">
+                <a:solidFill>
+                  <a:srgbClr val="D7E3EA"/>
+                </a:solidFill>
+              </a:rPr>
+              <a:t>Public dashboard.</a:t>
+            </a:r>
+          </a:p>
+          <a:p>
+            <a:pPr marL="285750" indent="-171450">
+              <a:buChar char="•"/>
+            </a:pPr>
+            <a:r>
+              <a:rPr lang="en-US" sz="2100">
+                <a:solidFill>
+                  <a:srgbClr val="D7E3EA"/>
+                </a:solidFill>
+              </a:rPr>
+              <a:t>No third-party operator financing.</a:t>
             </a:r>
           </a:p>
         </p:txBody>
@@ -3333,7 +3334,7 @@
                   <a:srgbClr val="F4F7F8"/>
                 </a:solidFill>
               </a:rPr>
-              <a:t>Competitive Position</a:t>
+              <a:t>Roadmap</a:t>
             </a:r>
           </a:p>
         </p:txBody>
@@ -3367,33 +3368,33 @@
                   <a:srgbClr val="D7E3EA"/>
                 </a:solidFill>
               </a:rPr>
-              <a:t>trade.xyz and HyENA operate markets directly.</a:t>
-            </a:r>
-          </a:p>
-          <a:p>
-            <a:pPr marL="285750" indent="-171450">
-              <a:buChar char="•"/>
-            </a:pPr>
-            <a:r>
-              <a:rPr lang="en-US" sz="2100">
-                <a:solidFill>
-                  <a:srgbClr val="D7E3EA"/>
-                </a:solidFill>
-              </a:rPr>
-              <a:t>HIP.markets also operates markets directly, but adds user-funded HYPE stake and transparent fee sharing.</a:t>
-            </a:r>
-          </a:p>
-          <a:p>
-            <a:pPr marL="285750" indent="-171450">
-              <a:buChar char="•"/>
-            </a:pPr>
-            <a:r>
-              <a:rPr lang="en-US" sz="2100">
-                <a:solidFill>
-                  <a:srgbClr val="D7E3EA"/>
-                </a:solidFill>
-              </a:rPr>
-              <a:t>The wedge is making HYPE holders economic backers of the operator.</a:t>
+              <a:t>V1: prove operator vault and fee sharing.</a:t>
+            </a:r>
+          </a:p>
+          <a:p>
+            <a:pPr marL="285750" indent="-171450">
+              <a:buChar char="•"/>
+            </a:pPr>
+            <a:r>
+              <a:rPr lang="en-US" sz="2100">
+                <a:solidFill>
+                  <a:srgbClr val="D7E3EA"/>
+                </a:solidFill>
+              </a:rPr>
+              <a:t>V2: more HIP.markets market vaults and automated fee verification.</a:t>
+            </a:r>
+          </a:p>
+          <a:p>
+            <a:pPr marL="285750" indent="-171450">
+              <a:buChar char="•"/>
+            </a:pPr>
+            <a:r>
+              <a:rPr lang="en-US" sz="2100">
+                <a:solidFill>
+                  <a:srgbClr val="D7E3EA"/>
+                </a:solidFill>
+              </a:rPr>
+              <a:t>V3: risk tranching, secondary shares, HIP-4, possible third-party financing once the trust model is mature.</a:t>
             </a:r>
           </a:p>
         </p:txBody>
@@ -3487,7 +3488,7 @@
                   <a:srgbClr val="F4F7F8"/>
                 </a:solidFill>
               </a:rPr>
-              <a:t>Ask</a:t>
+              <a:t>Competitive Position</a:t>
             </a:r>
           </a:p>
         </p:txBody>
@@ -3521,59 +3522,33 @@
                   <a:srgbClr val="D7E3EA"/>
                 </a:solidFill>
               </a:rPr>
-              <a:t>HYPE holders for capped beta.</a:t>
-            </a:r>
-          </a:p>
-          <a:p>
-            <a:pPr marL="285750" indent="-171450">
-              <a:buChar char="•"/>
-            </a:pPr>
-            <a:r>
-              <a:rPr lang="en-US" sz="2100">
-                <a:solidFill>
-                  <a:srgbClr val="D7E3EA"/>
-                </a:solidFill>
-              </a:rPr>
-              <a:t>Market makers for first markets.</a:t>
-            </a:r>
-          </a:p>
-          <a:p>
-            <a:pPr marL="285750" indent="-171450">
-              <a:buChar char="•"/>
-            </a:pPr>
-            <a:r>
-              <a:rPr lang="en-US" sz="2100">
-                <a:solidFill>
-                  <a:srgbClr val="D7E3EA"/>
-                </a:solidFill>
-              </a:rPr>
-              <a:t>Oracle and data partners.</a:t>
-            </a:r>
-          </a:p>
-          <a:p>
-            <a:pPr marL="285750" indent="-171450">
-              <a:buChar char="•"/>
-            </a:pPr>
-            <a:r>
-              <a:rPr lang="en-US" sz="2100">
-                <a:solidFill>
-                  <a:srgbClr val="D7E3EA"/>
-                </a:solidFill>
-              </a:rPr>
-              <a:t>Security reviewers.</a:t>
-            </a:r>
-          </a:p>
-          <a:p>
-            <a:pPr marL="285750" indent="-171450">
-              <a:buChar char="•"/>
-            </a:pPr>
-            <a:r>
-              <a:rPr lang="en-US" sz="2100">
-                <a:solidFill>
-                  <a:srgbClr val="D7E3EA"/>
-                </a:solidFill>
-              </a:rPr>
-              <a:t>Hyperliquid feedback on custody and fee routing.</a:t>
+              <a:t>trade.xyz and HyENA operate markets directly.</a:t>
+            </a:r>
+          </a:p>
+          <a:p>
+            <a:pPr marL="285750" indent="-171450">
+              <a:buChar char="•"/>
+            </a:pPr>
+            <a:r>
+              <a:rPr lang="en-US" sz="2100">
+                <a:solidFill>
+                  <a:srgbClr val="D7E3EA"/>
+                </a:solidFill>
+              </a:rPr>
+              <a:t>HIP.markets also operates markets directly, but adds user-funded HYPE stake and transparent fee sharing.</a:t>
+            </a:r>
+          </a:p>
+          <a:p>
+            <a:pPr marL="285750" indent="-171450">
+              <a:buChar char="•"/>
+            </a:pPr>
+            <a:r>
+              <a:rPr lang="en-US" sz="2100">
+                <a:solidFill>
+                  <a:srgbClr val="D7E3EA"/>
+                </a:solidFill>
+              </a:rPr>
+              <a:t>The wedge is making HYPE holders economic backers of the operator.</a:t>
             </a:r>
           </a:p>
         </p:txBody>
@@ -3701,7 +3676,7 @@
                   <a:srgbClr val="D7E3EA"/>
                 </a:solidFill>
               </a:rPr>
-              <a:t>DefiLlama reference: $307.3B 30d perp volume, $15.6B 24h perp volume, and $13.3B open interest.</a:t>
+              <a:t>DefiLlama reference: $164.2B 30d perp volume, $1.33B 24h perp volume, and $7.3B open interest.</a:t>
             </a:r>
           </a:p>
           <a:p>
@@ -3843,7 +3818,7 @@
                   <a:srgbClr val="F4F7F8"/>
                 </a:solidFill>
               </a:rPr>
-              <a:t>Closing</a:t>
+              <a:t>Ask</a:t>
             </a:r>
           </a:p>
         </p:txBody>
@@ -3877,20 +3852,59 @@
                   <a:srgbClr val="D7E3EA"/>
                 </a:solidFill>
               </a:rPr>
-              <a:t>HIP.markets turns builder-deployed markets into a community-backed operator business.</a:t>
-            </a:r>
-          </a:p>
-          <a:p>
-            <a:pPr marL="285750" indent="-171450">
-              <a:buChar char="•"/>
-            </a:pPr>
-            <a:r>
-              <a:rPr lang="en-US" sz="2100">
-                <a:solidFill>
-                  <a:srgbClr val="D7E3EA"/>
-                </a:solidFill>
-              </a:rPr>
-              <a:t>The first job is operating markets safely.</a:t>
+              <a:t>HYPE holders for capped beta.</a:t>
+            </a:r>
+          </a:p>
+          <a:p>
+            <a:pPr marL="285750" indent="-171450">
+              <a:buChar char="•"/>
+            </a:pPr>
+            <a:r>
+              <a:rPr lang="en-US" sz="2100">
+                <a:solidFill>
+                  <a:srgbClr val="D7E3EA"/>
+                </a:solidFill>
+              </a:rPr>
+              <a:t>Market makers for first markets.</a:t>
+            </a:r>
+          </a:p>
+          <a:p>
+            <a:pPr marL="285750" indent="-171450">
+              <a:buChar char="•"/>
+            </a:pPr>
+            <a:r>
+              <a:rPr lang="en-US" sz="2100">
+                <a:solidFill>
+                  <a:srgbClr val="D7E3EA"/>
+                </a:solidFill>
+              </a:rPr>
+              <a:t>Oracle and data partners.</a:t>
+            </a:r>
+          </a:p>
+          <a:p>
+            <a:pPr marL="285750" indent="-171450">
+              <a:buChar char="•"/>
+            </a:pPr>
+            <a:r>
+              <a:rPr lang="en-US" sz="2100">
+                <a:solidFill>
+                  <a:srgbClr val="D7E3EA"/>
+                </a:solidFill>
+              </a:rPr>
+              <a:t>Security reviewers.</a:t>
+            </a:r>
+          </a:p>
+          <a:p>
+            <a:pPr marL="285750" indent="-171450">
+              <a:buChar char="•"/>
+            </a:pPr>
+            <a:r>
+              <a:rPr lang="en-US" sz="2100">
+                <a:solidFill>
+                  <a:srgbClr val="D7E3EA"/>
+                </a:solidFill>
+              </a:rPr>
+              <a:t>Hyperliquid feedback on custody and fee routing.</a:t>
             </a:r>
           </a:p>
         </p:txBody>
@@ -3922,6 +3936,147 @@
                 </a:solidFill>
               </a:rPr>
               <a:t>HIP.markets hackathon submission  |  30</a:t>
+            </a:r>
+          </a:p>
+        </p:txBody>
+      </p:sp>
+    </p:spTree>
+  </p:cSld>
+  <p:clrMapOvr>
+    <a:masterClrMapping/>
+  </p:clrMapOvr>
+</p:sld>
+</file>
+
+<file path=ppt/slides/slide31.xml><?xml version="1.0" encoding="utf-8"?>
+<p:sld xmlns:a="http://schemas.openxmlformats.org/drawingml/2006/main" xmlns:r="http://schemas.openxmlformats.org/officeDocument/2006/relationships" xmlns:p="http://schemas.openxmlformats.org/presentationml/2006/main">
+  <p:cSld>
+    <p:bg>
+      <p:bgPr>
+        <a:solidFill>
+          <a:srgbClr val="080A0D"/>
+        </a:solidFill>
+      </p:bgPr>
+    </p:bg>
+    <p:spTree>
+      <p:nvGrpSpPr>
+        <p:cNvPr id="1" name=""/>
+        <p:cNvGrpSpPr/>
+        <p:nvPr/>
+      </p:nvGrpSpPr>
+      <p:grpSpPr>
+        <a:xfrm>
+          <a:off x="0" y="0"/>
+          <a:ext cx="0" cy="0"/>
+          <a:chOff x="0" y="0"/>
+          <a:chExt cx="0" cy="0"/>
+        </a:xfrm>
+      </p:grpSpPr>
+      <p:sp>
+        <p:nvSpPr>
+          <p:cNvPr id="2" name="Title"/>
+          <p:cNvSpPr txBox="1"/>
+          <p:nvPr/>
+        </p:nvSpPr>
+        <p:spPr>
+          <a:xfrm>
+            <a:off x="609600" y="610000"/>
+            <a:ext cx="10300000" cy="850000"/>
+          </a:xfrm>
+          <a:prstGeom prst="rect">
+            <a:avLst/>
+          </a:prstGeom>
+          <a:noFill/>
+        </p:spPr>
+        <p:txBody>
+          <a:bodyPr wrap="square"/>
+          <a:lstStyle/>
+          <a:p>
+            <a:r>
+              <a:rPr lang="en-US" sz="4100" b="1">
+                <a:solidFill>
+                  <a:srgbClr val="F4F7F8"/>
+                </a:solidFill>
+              </a:rPr>
+              <a:t>Closing</a:t>
+            </a:r>
+          </a:p>
+        </p:txBody>
+      </p:sp>
+      <p:sp>
+        <p:nvSpPr>
+          <p:cNvPr id="3" name="Body"/>
+          <p:cNvSpPr txBox="1"/>
+          <p:nvPr/>
+        </p:nvSpPr>
+        <p:spPr>
+          <a:xfrm>
+            <a:off x="914400" y="1905000"/>
+            <a:ext cx="9800000" cy="3900000"/>
+          </a:xfrm>
+          <a:prstGeom prst="rect">
+            <a:avLst/>
+          </a:prstGeom>
+          <a:noFill/>
+        </p:spPr>
+        <p:txBody>
+          <a:bodyPr wrap="square"/>
+          <a:lstStyle/>
+          <a:p>
+            <a:pPr marL="285750" indent="-171450">
+              <a:buChar char="•"/>
+            </a:pPr>
+            <a:r>
+              <a:rPr lang="en-US" sz="2100">
+                <a:solidFill>
+                  <a:srgbClr val="D7E3EA"/>
+                </a:solidFill>
+              </a:rPr>
+              <a:t>HIP.markets turns builder-deployed markets into a community-backed operator business.</a:t>
+            </a:r>
+          </a:p>
+          <a:p>
+            <a:pPr marL="285750" indent="-171450">
+              <a:buChar char="•"/>
+            </a:pPr>
+            <a:r>
+              <a:rPr lang="en-US" sz="2100">
+                <a:solidFill>
+                  <a:srgbClr val="D7E3EA"/>
+                </a:solidFill>
+              </a:rPr>
+              <a:t>The first job is operating markets safely.</a:t>
+            </a:r>
+          </a:p>
+        </p:txBody>
+      </p:sp>
+      <p:sp>
+        <p:nvSpPr>
+          <p:cNvPr id="4" name="Footer"/>
+          <p:cNvSpPr txBox="1"/>
+          <p:nvPr/>
+        </p:nvSpPr>
+        <p:spPr>
+          <a:xfrm>
+            <a:off x="609600" y="6400800"/>
+            <a:ext cx="10500000" cy="300000"/>
+          </a:xfrm>
+          <a:prstGeom prst="rect">
+            <a:avLst/>
+          </a:prstGeom>
+          <a:noFill/>
+        </p:spPr>
+        <p:txBody>
+          <a:bodyPr wrap="square"/>
+          <a:lstStyle/>
+          <a:p>
+            <a:r>
+              <a:rPr lang="en-US" sz="1000">
+                <a:solidFill>
+                  <a:srgbClr val="35D29A"/>
+                </a:solidFill>
+              </a:rPr>
+              <a:t>HIP.markets hackathon submission  |  31</a:t>
             </a:r>
           </a:p>
         </p:txBody>
@@ -4031,7 +4186,7 @@
                   <a:srgbClr val="D7E3EA"/>
                 </a:solidFill>
               </a:rPr>
-              <a:t>At $42.7015 HYPE, that is roughly $21.35M before oracle, maker, data, legal, audit, and incident costs.</a:t>
+              <a:t>At $42.848 HYPE, that is roughly $21.42M before oracle, maker, data, legal, audit, and incident costs.</a:t>
             </a:r>
           </a:p>
           <a:p>
@@ -4600,7 +4755,7 @@
                   <a:srgbClr val="F4F7F8"/>
                 </a:solidFill>
               </a:rPr>
-              <a:t>The Problem</a:t>
+              <a:t>Proof Flywheel</a:t>
             </a:r>
           </a:p>
         </p:txBody>
@@ -4634,33 +4789,46 @@
                   <a:srgbClr val="D7E3EA"/>
                 </a:solidFill>
               </a:rPr>
-              <a:t>HIP-3 DEXs need 500,000 HYPE staked.</a:t>
-            </a:r>
-          </a:p>
-          <a:p>
-            <a:pPr marL="285750" indent="-171450">
-              <a:buChar char="•"/>
-            </a:pPr>
-            <a:r>
-              <a:rPr lang="en-US" sz="2100">
-                <a:solidFill>
-                  <a:srgbClr val="D7E3EA"/>
-                </a:solidFill>
-              </a:rPr>
-              <a:t>Stake is only the start: operators also need oracles, liquidity, risk controls, and fee accounting.</a:t>
-            </a:r>
-          </a:p>
-          <a:p>
-            <a:pPr marL="285750" indent="-171450">
-              <a:buChar char="•"/>
-            </a:pPr>
-            <a:r>
-              <a:rPr lang="en-US" sz="2100">
-                <a:solidFill>
-                  <a:srgbClr val="D7E3EA"/>
-                </a:solidFill>
-              </a:rPr>
-              <a:t>Stakers need slashing risk beside APR.</a:t>
+              <a:t>Capped HYPE commitments prove depositor demand.</a:t>
+            </a:r>
+          </a:p>
+          <a:p>
+            <a:pPr marL="285750" indent="-171450">
+              <a:buChar char="•"/>
+            </a:pPr>
+            <a:r>
+              <a:rPr lang="en-US" sz="2100">
+                <a:solidFill>
+                  <a:srgbClr val="D7E3EA"/>
+                </a:solidFill>
+              </a:rPr>
+              <a:t>First-three-market readiness proves operator judgment.</a:t>
+            </a:r>
+          </a:p>
+          <a:p>
+            <a:pPr marL="285750" indent="-171450">
+              <a:buChar char="•"/>
+            </a:pPr>
+            <a:r>
+              <a:rPr lang="en-US" sz="2100">
+                <a:solidFill>
+                  <a:srgbClr val="D7E3EA"/>
+                </a:solidFill>
+              </a:rPr>
+              <a:t>Oracle uptime and fee epochs prove reliability.</a:t>
+            </a:r>
+          </a:p>
+          <a:p>
+            <a:pPr marL="285750" indent="-171450">
+              <a:buChar char="•"/>
+            </a:pPr>
+            <a:r>
+              <a:rPr lang="en-US" sz="2100">
+                <a:solidFill>
+                  <a:srgbClr val="D7E3EA"/>
+                </a:solidFill>
+              </a:rPr>
+              <a:t>Net deployer fees prove economic value and attract more HYPE and maker depth.</a:t>
             </a:r>
           </a:p>
         </p:txBody>
@@ -4754,7 +4922,7 @@
                   <a:srgbClr val="F4F7F8"/>
                 </a:solidFill>
               </a:rPr>
-              <a:t>Product Thesis</a:t>
+              <a:t>The Problem</a:t>
             </a:r>
           </a:p>
         </p:txBody>
@@ -4788,33 +4956,33 @@
                   <a:srgbClr val="D7E3EA"/>
                 </a:solidFill>
               </a:rPr>
-              <a:t>HIP.markets is not passive liquid staking.</a:t>
-            </a:r>
-          </a:p>
-          <a:p>
-            <a:pPr marL="285750" indent="-171450">
-              <a:buChar char="•"/>
-            </a:pPr>
-            <a:r>
-              <a:rPr lang="en-US" sz="2100">
-                <a:solidFill>
-                  <a:srgbClr val="D7E3EA"/>
-                </a:solidFill>
-              </a:rPr>
-              <a:t>HIP.markets is the operator.</a:t>
-            </a:r>
-          </a:p>
-          <a:p>
-            <a:pPr marL="285750" indent="-171450">
-              <a:buChar char="•"/>
-            </a:pPr>
-            <a:r>
-              <a:rPr lang="en-US" sz="2100">
-                <a:solidFill>
-                  <a:srgbClr val="D7E3EA"/>
-                </a:solidFill>
-              </a:rPr>
-              <a:t>Users back the HIP.markets deployer stake and share net deployer fees.</a:t>
+              <a:t>HIP-3 DEXs need 500,000 HYPE staked.</a:t>
+            </a:r>
+          </a:p>
+          <a:p>
+            <a:pPr marL="285750" indent="-171450">
+              <a:buChar char="•"/>
+            </a:pPr>
+            <a:r>
+              <a:rPr lang="en-US" sz="2100">
+                <a:solidFill>
+                  <a:srgbClr val="D7E3EA"/>
+                </a:solidFill>
+              </a:rPr>
+              <a:t>Stake is only the start: operators also need oracles, liquidity, risk controls, and fee accounting.</a:t>
+            </a:r>
+          </a:p>
+          <a:p>
+            <a:pPr marL="285750" indent="-171450">
+              <a:buChar char="•"/>
+            </a:pPr>
+            <a:r>
+              <a:rPr lang="en-US" sz="2100">
+                <a:solidFill>
+                  <a:srgbClr val="D7E3EA"/>
+                </a:solidFill>
+              </a:rPr>
+              <a:t>Stakers need slashing risk beside APR.</a:t>
             </a:r>
           </a:p>
         </p:txBody>

</xml_diff>